<commit_message>
deck_cophi: Dave's three edits -- block diagrams at 1.3x font (boxes widened), slide 4 rebuilt around the seven equations (figs/cophi_equations.png + deck_cophi_equations.tex) with 'integrating bucket' defined, slide 5 gets the engine's own layout renders (overview + node, cropped from bench_oap_vlayout.png)
Co-Authored-By: Claude Fable 5.1 <noreply@anthropic.com>
</commit_message>
<xml_diff>
--- a/demo_session/deck_cophi.pptx
+++ b/demo_session/deck_cophi.pptx
@@ -8700,8 +8700,8 @@
         </p:blipFill>
         <p:spPr>
           <a:xfrm>
-            <a:off x="2607310" y="1298448"/>
-            <a:ext cx="6977075" cy="4360672"/>
+            <a:off x="1779879" y="1298448"/>
+            <a:ext cx="8631936" cy="5394960"/>
           </a:xfrm>
           <a:prstGeom prst="rect">
             <a:avLst/>
@@ -8716,46 +8716,7 @@
         </p:nvSpPr>
         <p:spPr>
           <a:xfrm>
-            <a:off x="411480" y="5677408"/>
-            <a:ext cx="11368735" cy="394208"/>
-          </a:xfrm>
-          <a:prstGeom prst="rect">
-            <a:avLst/>
-          </a:prstGeom>
-          <a:noFill/>
-        </p:spPr>
-        <p:txBody>
-          <a:bodyPr wrap="square">
-            <a:spAutoFit/>
-          </a:bodyPr>
-          <a:lstStyle/>
-          <a:p>
-            <a:pPr algn="ctr">
-              <a:spcAft>
-                <a:spcPts val="0"/>
-              </a:spcAft>
-            </a:pPr>
-            <a:r>
-              <a:rPr sz="1000" b="0">
-                <a:solidFill>
-                  <a:srgbClr val="6E6E6E"/>
-                </a:solidFill>
-                <a:latin typeface="Arial"/>
-              </a:rPr>
-              <a:t>One color: the RF chain, the two PM fibers, the LO at the reference flat's seat, the bench, the camera, the four-bucket phase, the matrix estimator and the hold loop — every box a component of the bench or a stage of the gauge library; the model's error terms annotated</a:t>
-            </a:r>
-          </a:p>
-        </p:txBody>
-      </p:sp>
-      <p:sp>
-        <p:nvSpPr>
-          <p:cNvPr id="6" name="TextBox 5"/>
-          <p:cNvSpPr txBox="1"/>
-          <p:nvPr/>
-        </p:nvSpPr>
-        <p:spPr>
-          <a:xfrm>
-            <a:off x="411480" y="6108192"/>
+            <a:off x="411480" y="6693408"/>
             <a:ext cx="11368735" cy="274320"/>
           </a:xfrm>
           <a:prstGeom prst="rect">
@@ -8781,7 +8742,7 @@
                 </a:solidFill>
                 <a:latin typeface="Arial"/>
               </a:rPr>
-              <a:t>make_cophi_block_fig.py; the camera rows name the surveyed parts; the lock-in camera is the dashed alternative (slide 10).</a:t>
+              <a:t>One color: the RF chain, the two PM fibers, the LO at the reference flat's seat, the bench, the camera, the four-bucket phase, the matrix estimator and the hold loop — every box a component of the bench or a stage of the gauge library, the model's error terms annotated (make_cophi_block_fig.py; the lock-in camera is the dashed alternative, slide 10).</a:t>
             </a:r>
           </a:p>
         </p:txBody>
@@ -8854,7 +8815,7 @@
                 </a:solidFill>
                 <a:latin typeface="Arial"/>
               </a:rPr>
-              <a:t>The integrating bucket costs 10 % of contrast; more buckets do not cure a step error, knowing the steps does; the photon law has read noise in it</a:t>
+              <a:t>What the camera records, how the phase and the surface come out of it, and what the gate measured: the quarter-cycle integration costs 10 % of contrast, a step error is not cured by more frames, and the photon law carries read noise</a:t>
             </a:r>
           </a:p>
         </p:txBody>
@@ -8903,15 +8864,39 @@
           </a:p>
         </p:txBody>
       </p:sp>
-      <p:sp>
-        <p:nvSpPr>
-          <p:cNvPr id="4" name="TextBox 3"/>
+      <p:pic>
+        <p:nvPicPr>
+          <p:cNvPr id="4" name="Picture 3" descr="cophi_equations.png"/>
+          <p:cNvPicPr>
+            <a:picLocks noChangeAspect="1"/>
+          </p:cNvPicPr>
+          <p:nvPr/>
+        </p:nvPicPr>
+        <p:blipFill>
+          <a:blip r:embed="rId2"/>
+          <a:stretch>
+            <a:fillRect/>
+          </a:stretch>
+        </p:blipFill>
+        <p:spPr>
+          <a:xfrm>
+            <a:off x="761847" y="1298448"/>
+            <a:ext cx="10668000" cy="3200400"/>
+          </a:xfrm>
+          <a:prstGeom prst="rect">
+            <a:avLst/>
+          </a:prstGeom>
+        </p:spPr>
+      </p:pic>
+      <p:sp>
+        <p:nvSpPr>
+          <p:cNvPr id="5" name="TextBox 4"/>
           <p:cNvSpPr txBox="1"/>
           <p:nvPr/>
         </p:nvSpPr>
         <p:spPr>
           <a:xfrm>
-            <a:off x="411480" y="1298448"/>
+            <a:off x="411480" y="4498848"/>
             <a:ext cx="5806440" cy="274320"/>
           </a:xfrm>
           <a:prstGeom prst="rect">
@@ -8946,7 +8931,7 @@
                 </a:solidFill>
                 <a:latin typeface="Arial"/>
               </a:rPr>
-              <a:t>Frames:</a:t>
+              <a:t>"Integrating bucket" (1)–(2):</a:t>
             </a:r>
             <a:r>
               <a:rPr sz="1200" b="0">
@@ -8955,7 +8940,25 @@
                 </a:solidFill>
                 <a:latin typeface="Arial"/>
               </a:rPr>
-              <a:t> I_k = I₀ [1 + γ sinc(π/N) cos(φ − α_k)], the bucket centers α_k; for N = 4 the contrast is γ × 0.900 — the "integrating bucket" penalty, nothing else changes.  The N-bucket least squares is the four-step atan2 for N = 4 (to 1e-12).</a:t>
+              <a:t> a frame cannot sample the beat at an instant; it integrates while the LO phase advances through a quarter of the cycle.  Averaging a cosine over a window D = 2π/N keeps its phase (referred to the window's center ᾱ_k) and shrinks its amplitude by sinc(D/2): </a:t>
+            </a:r>
+            <a:r>
+              <a:rPr sz="1200" b="1">
+                <a:solidFill>
+                  <a:srgbClr val="282828"/>
+                </a:solidFill>
+                <a:latin typeface="Arial"/>
+              </a:rPr>
+              <a:t>0.900 for four frames per beat</a:t>
+            </a:r>
+            <a:r>
+              <a:rPr sz="1200" b="0">
+                <a:solidFill>
+                  <a:srgbClr val="282828"/>
+                </a:solidFill>
+                <a:latin typeface="Arial"/>
+              </a:rPr>
+              <a:t> — nothing else changes.</a:t>
             </a:r>
           </a:p>
           <a:p>
@@ -8980,7 +8983,7 @@
                 </a:solidFill>
                 <a:latin typeface="Arial"/>
               </a:rPr>
-              <a:t>Step error:</a:t>
+              <a:t>The phase (3)</a:t>
             </a:r>
             <a:r>
               <a:rPr sz="1200" b="0">
@@ -8989,56 +8992,20 @@
                 </a:solidFill>
                 <a:latin typeface="Arial"/>
               </a:rPr>
-              <a:t> a 1° per-step error puts the textbook (ε/2) sin 2φ ripple on the four-bucket phase.  </a:t>
-            </a:r>
-            <a:r>
-              <a:rPr sz="1200" b="1">
-                <a:solidFill>
-                  <a:srgbClr val="282828"/>
-                </a:solidFill>
-                <a:latin typeface="Arial"/>
-              </a:rPr>
-              <a:t>Measured: the plain 8-bucket least squares with the same per-step error is 1.43× worse</a:t>
-            </a:r>
-            <a:r>
-              <a:rPr sz="1200" b="0">
-                <a:solidFill>
-                  <a:srgbClr val="282828"/>
-                </a:solidFill>
-                <a:latin typeface="Arial"/>
-              </a:rPr>
-              <a:t> (the ramp accumulates over seven steps); </a:t>
-            </a:r>
-            <a:r>
-              <a:rPr sz="1200" b="1">
-                <a:solidFill>
-                  <a:srgbClr val="282828"/>
-                </a:solidFill>
-                <a:latin typeface="Arial"/>
-              </a:rPr>
-              <a:t>knowing the steps is the cure</a:t>
-            </a:r>
-            <a:r>
-              <a:rPr sz="1200" b="0">
-                <a:solidFill>
-                  <a:srgbClr val="282828"/>
-                </a:solidFill>
-                <a:latin typeface="Arial"/>
-              </a:rPr>
-              <a:t> (the LSQ with the true bucket centers is exact) — exactly what a Rb-clocked, frequency-set scan provides.  Feng's N-frame backup earns its keep against harmonics and noise, not step miscalibration.</a:t>
-            </a:r>
-          </a:p>
-        </p:txBody>
-      </p:sp>
-      <p:sp>
-        <p:nvSpPr>
-          <p:cNvPr id="5" name="TextBox 4"/>
+              <a:t> is a least-squares fit of the N frames to a + b cos ᾱ_k + c sin ᾱ_k; for N = 4 it reduces exactly to the four-step atan2, the same algorithm as Feng's (his sign is for cos(φ + 2πft)).</a:t>
+            </a:r>
+          </a:p>
+        </p:txBody>
+      </p:sp>
+      <p:sp>
+        <p:nvSpPr>
+          <p:cNvPr id="6" name="TextBox 5"/>
           <p:cNvSpPr txBox="1"/>
           <p:nvPr/>
         </p:nvSpPr>
         <p:spPr>
           <a:xfrm>
-            <a:off x="6400800" y="1298448"/>
+            <a:off x="6400800" y="4498848"/>
             <a:ext cx="5394960" cy="274320"/>
           </a:xfrm>
           <a:prstGeom prst="rect">
@@ -9073,7 +9040,7 @@
                 </a:solidFill>
                 <a:latin typeface="Arial"/>
               </a:rPr>
-              <a:t>Photons:</a:t>
+              <a:t>A step error (5)</a:t>
             </a:r>
             <a:r>
               <a:rPr sz="1200" b="0">
@@ -9082,7 +9049,43 @@
                 </a:solidFill>
                 <a:latin typeface="Arial"/>
               </a:rPr>
-              <a:t> per pixel, σ_φ² = 2 (I₀ + r²) / (N I₀² g′²) with I₀ the electrons per frame, r the read noise, g′ the bucket contrast: shot noise ∝ 1/√I₀ over two decades (slope −0.500 ± 0.02), read noise added in quadrature to the shot term.  Surface = φ λ/4π.</a:t>
+              <a:t> — every step D(1 + ε) — puts the textbook (ε/2) sin 2φ on the four-bucket phase.  </a:t>
+            </a:r>
+            <a:r>
+              <a:rPr sz="1200" b="1">
+                <a:solidFill>
+                  <a:srgbClr val="282828"/>
+                </a:solidFill>
+                <a:latin typeface="Arial"/>
+              </a:rPr>
+              <a:t>Measured: more buckets do not cure it</a:t>
+            </a:r>
+            <a:r>
+              <a:rPr sz="1200" b="0">
+                <a:solidFill>
+                  <a:srgbClr val="282828"/>
+                </a:solidFill>
+                <a:latin typeface="Arial"/>
+              </a:rPr>
+              <a:t> (the plain 8-bucket fit with the same per-step error is 1.43× worse; the ramp accumulates); </a:t>
+            </a:r>
+            <a:r>
+              <a:rPr sz="1200" b="1">
+                <a:solidFill>
+                  <a:srgbClr val="282828"/>
+                </a:solidFill>
+                <a:latin typeface="Arial"/>
+              </a:rPr>
+              <a:t>knowing the steps does</a:t>
+            </a:r>
+            <a:r>
+              <a:rPr sz="1200" b="0">
+                <a:solidFill>
+                  <a:srgbClr val="282828"/>
+                </a:solidFill>
+                <a:latin typeface="Arial"/>
+              </a:rPr>
+              <a:t> (the fit at the true ᾱ_k is exact) — a Rb-clocked scan knows them.</a:t>
             </a:r>
           </a:p>
           <a:p>
@@ -9107,7 +9110,7 @@
                 </a:solidFill>
                 <a:latin typeface="Arial"/>
               </a:rPr>
-              <a:t>Within a scan:</a:t>
+              <a:t>Photons (6):</a:t>
             </a:r>
             <a:r>
               <a:rPr sz="1200" b="0">
@@ -9116,54 +9119,20 @@
                 </a:solidFill>
                 <a:latin typeface="Arial"/>
               </a:rPr>
-              <a:t> a differential fiber-phase walk or a trigger jitter is a phase-dependent error of a fixed fraction of its size (0.13 w rms over the map for w = 0.05 rad/frame), no better with 8 buckets — the intra-scan drift has no algorithmic cure.</a:t>
-            </a:r>
-          </a:p>
-          <a:p>
-            <a:pPr>
-              <a:spcAft>
-                <a:spcPts val="600"/>
-              </a:spcAft>
-            </a:pPr>
-            <a:r>
-              <a:rPr sz="1200" b="0">
-                <a:solidFill>
-                  <a:srgbClr val="282828"/>
-                </a:solidFill>
-                <a:latin typeface="Arial"/>
-              </a:rPr>
-              <a:t>•  </a:t>
-            </a:r>
-            <a:r>
-              <a:rPr sz="1200" b="1">
-                <a:solidFill>
-                  <a:srgbClr val="282828"/>
-                </a:solidFill>
-                <a:latin typeface="Arial"/>
-              </a:rPr>
-              <a:t>Gate tCophi</a:t>
-            </a:r>
-            <a:r>
-              <a:rPr sz="1200" b="0">
-                <a:solidFill>
-                  <a:srgbClr val="282828"/>
-                </a:solidFill>
-                <a:latin typeface="Arial"/>
-              </a:rPr>
-              <a:t> (8 tests, pure MATLAB, in the fast suite) pins every line above; the bench stages consume these routines unchanged.</a:t>
-            </a:r>
-          </a:p>
-        </p:txBody>
-      </p:sp>
-      <p:sp>
-        <p:nvSpPr>
-          <p:cNvPr id="6" name="TextBox 5"/>
+              <a:t> shot noise ∝ 1/√I₀ (slope −0.500 ± 0.02 over two decades), read noise in quadrature.  A fiber walk or trigger jitter within a scan is a fixed fraction of its size (0.13 w), no better with 8 buckets — no algorithmic cure.</a:t>
+            </a:r>
+          </a:p>
+        </p:txBody>
+      </p:sp>
+      <p:sp>
+        <p:nvSpPr>
+          <p:cNvPr id="7" name="TextBox 6"/>
           <p:cNvSpPr txBox="1"/>
           <p:nvPr/>
         </p:nvSpPr>
         <p:spPr>
           <a:xfrm>
-            <a:off x="6400800" y="3736848"/>
+            <a:off x="6400800" y="6598919"/>
             <a:ext cx="5394960" cy="274320"/>
           </a:xfrm>
           <a:prstGeom prst="rect">
@@ -9189,7 +9158,7 @@
                 </a:solidFill>
                 <a:latin typeface="Arial"/>
               </a:rPr>
-              <a:t>dm_gauge_lib/dmg_cophi_frames / _recon / _camera; the sign convention is the record interferometer's (I₀(1 + γ cos(φ − α))): Feng's atan2(I₄ − I₂, I₁ − I₃) is the same algorithm for cos(φ + 2πft).</a:t>
+              <a:t>Gate tCophi (8 tests) pins each line; dm_gauge_lib/dmg_cophi_*; TeX source deck_cophi_equations.tex.</a:t>
             </a:r>
           </a:p>
         </p:txBody>
@@ -9311,15 +9280,78 @@
           </a:p>
         </p:txBody>
       </p:sp>
-      <p:sp>
-        <p:nvSpPr>
-          <p:cNvPr id="4" name="TextBox 3"/>
+      <p:pic>
+        <p:nvPicPr>
+          <p:cNvPr id="4" name="Picture 3" descr="cophi_layout_oap.png"/>
+          <p:cNvPicPr>
+            <a:picLocks noChangeAspect="1"/>
+          </p:cNvPicPr>
+          <p:nvPr/>
+        </p:nvPicPr>
+        <p:blipFill>
+          <a:blip r:embed="rId2"/>
+          <a:stretch>
+            <a:fillRect/>
+          </a:stretch>
+        </p:blipFill>
+        <p:spPr>
+          <a:xfrm>
+            <a:off x="1380587" y="1298448"/>
+            <a:ext cx="3868224" cy="2092451"/>
+          </a:xfrm>
+          <a:prstGeom prst="rect">
+            <a:avLst/>
+          </a:prstGeom>
+        </p:spPr>
+      </p:pic>
+      <p:sp>
+        <p:nvSpPr>
+          <p:cNvPr id="5" name="TextBox 4"/>
           <p:cNvSpPr txBox="1"/>
           <p:nvPr/>
         </p:nvSpPr>
         <p:spPr>
           <a:xfrm>
-            <a:off x="411480" y="1298448"/>
+            <a:off x="411480" y="3409187"/>
+            <a:ext cx="5806440" cy="559307"/>
+          </a:xfrm>
+          <a:prstGeom prst="rect">
+            <a:avLst/>
+          </a:prstGeom>
+          <a:noFill/>
+        </p:spPr>
+        <p:txBody>
+          <a:bodyPr wrap="square">
+            <a:spAutoFit/>
+          </a:bodyPr>
+          <a:lstStyle/>
+          <a:p>
+            <a:pPr algn="ctr">
+              <a:spcAft>
+                <a:spcPts val="0"/>
+              </a:spcAft>
+            </a:pPr>
+            <a:r>
+              <a:rPr sz="1000" b="0">
+                <a:solidFill>
+                  <a:srgbClr val="6E6E6E"/>
+                </a:solidFill>
+                <a:latin typeface="Arial"/>
+              </a:rPr>
+              <a:t>The mirror rig from above with the LO arm in place: source arm red, LO arm purple (fiber tip at right, collimator at the reference flat's seat), test arm to the DM blue, camera leg green</a:t>
+            </a:r>
+          </a:p>
+        </p:txBody>
+      </p:sp>
+      <p:sp>
+        <p:nvSpPr>
+          <p:cNvPr id="6" name="TextBox 5"/>
+          <p:cNvSpPr txBox="1"/>
+          <p:nvPr/>
+        </p:nvSpPr>
+        <p:spPr>
+          <a:xfrm>
+            <a:off x="411480" y="4005072"/>
             <a:ext cx="5806440" cy="274320"/>
           </a:xfrm>
           <a:prstGeom prst="rect">
@@ -9436,15 +9468,78 @@
           </a:p>
         </p:txBody>
       </p:sp>
-      <p:sp>
-        <p:nvSpPr>
-          <p:cNvPr id="5" name="TextBox 4"/>
+      <p:pic>
+        <p:nvPicPr>
+          <p:cNvPr id="7" name="Picture 6" descr="cophi_layout_node.png"/>
+          <p:cNvPicPr>
+            <a:picLocks noChangeAspect="1"/>
+          </p:cNvPicPr>
+          <p:nvPr/>
+        </p:nvPicPr>
+        <p:blipFill>
+          <a:blip r:embed="rId3"/>
+          <a:stretch>
+            <a:fillRect/>
+          </a:stretch>
+        </p:blipFill>
+        <p:spPr>
+          <a:xfrm>
+            <a:off x="8120752" y="1298448"/>
+            <a:ext cx="1955054" cy="2092451"/>
+          </a:xfrm>
+          <a:prstGeom prst="rect">
+            <a:avLst/>
+          </a:prstGeom>
+        </p:spPr>
+      </p:pic>
+      <p:sp>
+        <p:nvSpPr>
+          <p:cNvPr id="8" name="TextBox 7"/>
           <p:cNvSpPr txBox="1"/>
           <p:nvPr/>
         </p:nvSpPr>
         <p:spPr>
           <a:xfrm>
-            <a:off x="6400800" y="1298448"/>
+            <a:off x="6400800" y="3409187"/>
+            <a:ext cx="5394960" cy="559307"/>
+          </a:xfrm>
+          <a:prstGeom prst="rect">
+            <a:avLst/>
+          </a:prstGeom>
+          <a:noFill/>
+        </p:spPr>
+        <p:txBody>
+          <a:bodyPr wrap="square">
+            <a:spAutoFit/>
+          </a:bodyPr>
+          <a:lstStyle/>
+          <a:p>
+            <a:pPr algn="ctr">
+              <a:spcAft>
+                <a:spcPts val="0"/>
+              </a:spcAft>
+            </a:pPr>
+            <a:r>
+              <a:rPr sz="1000" b="0">
+                <a:solidFill>
+                  <a:srgbClr val="6E6E6E"/>
+                </a:solidFill>
+                <a:latin typeface="Arial"/>
+              </a:rPr>
+              <a:t>The node: the beamsplitter and compensator, the LO entering where the reference flat's return did, the recombination into the camera leg (the record's polarizing elements shown; the plain-splitter train is scored)</a:t>
+            </a:r>
+          </a:p>
+        </p:txBody>
+      </p:sp>
+      <p:sp>
+        <p:nvSpPr>
+          <p:cNvPr id="9" name="TextBox 8"/>
+          <p:cNvSpPr txBox="1"/>
+          <p:nvPr/>
+        </p:nvSpPr>
+        <p:spPr>
+          <a:xfrm>
+            <a:off x="6400800" y="4005072"/>
             <a:ext cx="5394960" cy="274320"/>
           </a:xfrm>
           <a:prstGeom prst="rect">
@@ -9529,13 +9624,13 @@
       </p:sp>
       <p:sp>
         <p:nvSpPr>
-          <p:cNvPr id="6" name="TextBox 5"/>
+          <p:cNvPr id="10" name="TextBox 9"/>
           <p:cNvSpPr txBox="1"/>
           <p:nvPr/>
         </p:nvSpPr>
         <p:spPr>
           <a:xfrm>
-            <a:off x="6400800" y="3794759"/>
+            <a:off x="6400800" y="6501384"/>
             <a:ext cx="5394960" cy="274320"/>
           </a:xfrm>
           <a:prstGeom prst="rect">
@@ -9561,7 +9656,7 @@
                 </a:solidFill>
                 <a:latin typeface="Arial"/>
               </a:rPr>
-              <a:t>Stage bench (runs/bench_{lens,oap}), gate tCophiBench 9/9 (registration, poke 1.001 converged, LO tilt, no-fringe refused by name, dark camera refused).</a:t>
+              <a:t>Stage bench (runs/bench_{lens,oap}; the layout = bench_oap_vlayout.png, the engine's own render), gate tCophiBench 9/9 (registration, poke 1.001 converged, LO tilt, no-fringe refused by name, dark camera refused).</a:t>
             </a:r>
           </a:p>
         </p:txBody>

</xml_diff>

<commit_message>
deck_cophi: Dave's first edit pass folded (purpose to << 10 pm; the array detector in the subhead; 'stabilize the DM'; the two retitled slides; the block figure's title moved to the slide and the figure enlarged)
Co-Authored-By: Claude Fable 5.1 <noreply@anthropic.com>
</commit_message>
<xml_diff>
--- a/demo_session/deck_cophi.pptx
+++ b/demo_session/deck_cophi.pptx
@@ -3242,7 +3242,7 @@
                 </a:solidFill>
                 <a:latin typeface="Arial"/>
               </a:rPr>
-              <a:t>Feng's proposal (COPHI_for_DM_gauge.pptx, 2026-05-19): a single-frequency laser split to two AOMs at 80 MHz and 80 MHz + 7.5 Hz on a Rb standard, a fiber LO combined before a 30 fps camera imaging the DM, four frames per beat, the four-frame phase; purpose: HOLD — each DM in a local loop against drift.  This deck answers: what does that read on our bench, and what does it cost.</a:t>
+              <a:t>Feng's proposal (COPHI_for_DM_gauge.pptx, 2026-05-19): a single-frequency laser split to two AOMs at 80 MHz and 80 MHz + 7.5 Hz on a Rb standard, a fiber LO combined before a 30 fps camera imaging the DM, four frames per beat, the four-frame phase.  Purpose: to hold each DM in a local loop against drift, to &lt;&lt; 10 pm.  What does that read on our bench, and what does it cost?</a:t>
             </a:r>
           </a:p>
         </p:txBody>
@@ -3507,8 +3507,8 @@
         </p:blipFill>
         <p:spPr>
           <a:xfrm>
-            <a:off x="7342414" y="1298448"/>
-            <a:ext cx="3511731" cy="2458212"/>
+            <a:off x="7216256" y="1298448"/>
+            <a:ext cx="3764046" cy="2458212"/>
           </a:xfrm>
           <a:prstGeom prst="rect">
             <a:avLst/>
@@ -8229,7 +8229,7 @@
                 </a:solidFill>
                 <a:latin typeface="Arial"/>
               </a:rPr>
-              <a:t>A heterodyne interferometer whose phase steps are set by frequency, not by a piezo, with a fiber-fed local oscillator at the camera; the stated purpose is drift sensing for a DM in a local control loop</a:t>
+              <a:t>A heterodyne interferometer whose phase steps are set by frequency, not by a piezo, with a fiber-fed local oscillator at the camera, and an array detector providing many parallel channels to resolve 96 × 96 actuators</a:t>
             </a:r>
           </a:p>
         </p:txBody>
@@ -8389,7 +8389,7 @@
                 </a:solidFill>
                 <a:latin typeface="Arial"/>
               </a:rPr>
-              <a:t>The purpose:</a:t>
+              <a:t>The purpose: stabilize the DM!</a:t>
             </a:r>
             <a:r>
               <a:rPr sz="1200" b="0">
@@ -8398,7 +8398,7 @@
                 </a:solidFill>
                 <a:latin typeface="Arial"/>
               </a:rPr>
-              <a:t> DMs drift (material physics, "floating electrodes", ~2 %/K); run each DM in a local loop to hold it — our job 3.  Not stated: the camera, the photon budget, the error terms, a number.</a:t>
+              <a:t>  Run each DM in a local loop to hold it — our job 3.  Not stated: the camera, the photon budget, the error terms, a number.</a:t>
             </a:r>
           </a:p>
         </p:txBody>
@@ -8619,7 +8619,7 @@
                 </a:solidFill>
                 <a:latin typeface="Arial"/>
               </a:rPr>
-              <a:t>COPHI in our terms: the four-step run continuously</a:t>
+              <a:t>COPHI on the DM Gauge bench: the four-step run continuously</a:t>
             </a:r>
           </a:p>
           <a:p>
@@ -8700,8 +8700,8 @@
         </p:blipFill>
         <p:spPr>
           <a:xfrm>
-            <a:off x="1779879" y="1298448"/>
-            <a:ext cx="8631936" cy="5394960"/>
+            <a:off x="1429548" y="1298448"/>
+            <a:ext cx="9332598" cy="5394960"/>
           </a:xfrm>
           <a:prstGeom prst="rect">
             <a:avLst/>
@@ -8742,7 +8742,7 @@
                 </a:solidFill>
                 <a:latin typeface="Arial"/>
               </a:rPr>
-              <a:t>One color: the RF chain, the two PM fibers, the LO at the reference flat's seat, the bench, the camera, the four-bucket phase, the matrix estimator and the hold loop — every box a component of the bench or a stage of the gauge library, the model's error terms annotated (make_cophi_block_fig.py; the lock-in camera is the dashed alternative, slide 10).</a:t>
+              <a:t>COPHI as the fifth DM gauge — our implementation of Feng's four-frame method, one-color version, for the hold job.  Every box is a component of the TG96 DM Gauge bench; blue = RF/timing, red = PM fiber, green = free-space beam, gray = data.  (make_cophi_block_fig.py; the lock-in camera is the dashed alternative, slide 10.)</a:t>
             </a:r>
           </a:p>
         </p:txBody>
@@ -9215,7 +9215,7 @@
                 </a:solidFill>
                 <a:latin typeface="Arial"/>
               </a:rPr>
-              <a:t>The bench with the LO arm</a:t>
+              <a:t>The LO on the DM Gauge bench replaces the IFO's reference flat</a:t>
             </a:r>
           </a:p>
           <a:p>

</xml_diff>

<commit_message>
deck_cophi: slide 3 footnote fits
Co-Authored-By: Claude Fable 5.1 <noreply@anthropic.com>
</commit_message>
<xml_diff>
--- a/demo_session/deck_cophi.pptx
+++ b/demo_session/deck_cophi.pptx
@@ -8700,8 +8700,8 @@
         </p:blipFill>
         <p:spPr>
           <a:xfrm>
-            <a:off x="1429548" y="1298448"/>
-            <a:ext cx="9332598" cy="5394960"/>
+            <a:off x="1587727" y="1298448"/>
+            <a:ext cx="9016239" cy="5212080"/>
           </a:xfrm>
           <a:prstGeom prst="rect">
             <a:avLst/>
@@ -8716,7 +8716,7 @@
         </p:nvSpPr>
         <p:spPr>
           <a:xfrm>
-            <a:off x="411480" y="6693408"/>
+            <a:off x="411480" y="6510528"/>
             <a:ext cx="11368735" cy="274320"/>
           </a:xfrm>
           <a:prstGeom prst="rect">
@@ -8742,7 +8742,7 @@
                 </a:solidFill>
                 <a:latin typeface="Arial"/>
               </a:rPr>
-              <a:t>COPHI as the fifth DM gauge — our implementation of Feng's four-frame method, one-color version, for the hold job.  Every box is a component of the TG96 DM Gauge bench; blue = RF/timing, red = PM fiber, green = free-space beam, gray = data.  (make_cophi_block_fig.py; the lock-in camera is the dashed alternative, slide 10.)</a:t>
+              <a:t>Our implementation of Feng's four-frame method, one-color version, for the hold job.  Every box is a component of the TG96 DM Gauge bench; blue = RF/timing, red = PM fiber, green = free-space beam, gray = data (make_cophi_block_fig.py; the lock-in camera is the dashed alternative, slide 10).</a:t>
             </a:r>
           </a:p>
         </p:txBody>

</xml_diff>

<commit_message>
deck_cophi hold table on the fixed-feed mirror run (TO); the fiber rows at the corrected budget; campaign brief 8 updated
Co-Authored-By: Claude Fable 5.1 <noreply@anthropic.com>
</commit_message>
<xml_diff>
--- a/demo_session/deck_cophi.pptx
+++ b/demo_session/deck_cophi.pptx
@@ -3378,7 +3378,7 @@
         </p:nvGraphicFramePr>
         <p:xfrm>
           <a:off x="411480" y="1298448"/>
-          <a:ext cx="5806439" cy="3086100"/>
+          <a:ext cx="5806439" cy="3463290"/>
         </p:xfrm>
         <a:graphic>
           <a:graphicData uri="http://schemas.openxmlformats.org/drawingml/2006/table">
@@ -3387,8 +3387,8 @@
                 <a:tableStyleId>{5C22544A-7EE6-4342-B048-85BDC9FD1C3A}</a:tableStyleId>
               </a:tblPr>
               <a:tblGrid>
-                <a:gridCol w="3544984"/>
-                <a:gridCol w="2261455"/>
+                <a:gridCol w="3450997"/>
+                <a:gridCol w="2355442"/>
               </a:tblGrid>
               <a:tr h="280035">
                 <a:tc>
@@ -3471,7 +3471,7 @@
                           </a:solidFill>
                           <a:latin typeface="Arial"/>
                         </a:rPr>
-                        <a:t>2.75 / 2.68</a:t>
+                        <a:t>2.75 / 2.67</a:t>
                       </a:r>
                     </a:p>
                   </a:txBody>
@@ -3517,7 +3517,7 @@
                           </a:solidFill>
                           <a:latin typeface="Arial"/>
                         </a:rPr>
-                        <a:t>2.60 / 2.53</a:t>
+                        <a:t>2.60 / 2.52</a:t>
                       </a:r>
                     </a:p>
                   </a:txBody>
@@ -3563,7 +3563,7 @@
                           </a:solidFill>
                           <a:latin typeface="Arial"/>
                         </a:rPr>
-                        <a:t>3.60 / 3.54</a:t>
+                        <a:t>3.60 / 3.53</a:t>
                       </a:r>
                     </a:p>
                   </a:txBody>
@@ -3609,7 +3609,7 @@
                           </a:solidFill>
                           <a:latin typeface="Arial"/>
                         </a:rPr>
-                        <a:t>10.3 (the lag rate/gG — every gauge)</a:t>
+                        <a:t>10.3 / 10.3 (the lag rate/gG — every gauge)</a:t>
                       </a:r>
                     </a:p>
                   </a:txBody>
@@ -3701,7 +3701,7 @@
                           </a:solidFill>
                           <a:latin typeface="Arial"/>
                         </a:rPr>
-                        <a:t>3.65 / 3.55 (+0.9 pm)</a:t>
+                        <a:t>3.65 / 3.54 (+0.9 pm)</a:t>
                       </a:r>
                     </a:p>
                   </a:txBody>
@@ -3712,20 +3712,20 @@
                   </a:tcPr>
                 </a:tc>
               </a:tr>
-              <a:tr h="280035">
-                <a:tc>
-                  <a:txBody>
-                    <a:bodyPr wrap="square"/>
-                    <a:lstStyle/>
-                    <a:p>
-                      <a:r>
-                        <a:rPr sz="1100" b="0">
-                          <a:solidFill>
-                            <a:srgbClr val="282828"/>
-                          </a:solidFill>
-                          <a:latin typeface="Arial"/>
-                        </a:rPr>
-                        <a:t>differential fiber walk at the budget / at 3×</a:t>
+              <a:tr h="468630">
+                <a:tc>
+                  <a:txBody>
+                    <a:bodyPr wrap="square"/>
+                    <a:lstStyle/>
+                    <a:p>
+                      <a:r>
+                        <a:rPr sz="1100" b="0">
+                          <a:solidFill>
+                            <a:srgbClr val="282828"/>
+                          </a:solidFill>
+                          <a:latin typeface="Arial"/>
+                        </a:rPr>
+                        <a:t>differential fiber walk at the budget / at 3× (baseline camera)</a:t>
                       </a:r>
                     </a:p>
                   </a:txBody>
@@ -3747,7 +3747,7 @@
                           </a:solidFill>
                           <a:latin typeface="Arial"/>
                         </a:rPr>
-                        <a:t>4.2 / 9.9</a:t>
+                        <a:t>3.95 / 9.2 (mirror); Photonfocus 4.8 / 12.7</a:t>
                       </a:r>
                     </a:p>
                   </a:txBody>
@@ -3758,7 +3758,7 @@
                   </a:tcPr>
                 </a:tc>
               </a:tr>
-              <a:tr h="280035">
+              <a:tr h="468630">
                 <a:tc>
                   <a:txBody>
                     <a:bodyPr wrap="square"/>
@@ -4037,7 +4037,7 @@
                 </a:solidFill>
                 <a:latin typeface="Arial"/>
               </a:rPr>
-              <a:t>Stage loop (runs/loop_{lens,oap}_plain, runs/loopfib_*), plain splitter, dmg_loop with the delay row; the noise stage's first fiber number was 2.3× low (a 12-draw Monte Carlo of three random numbers) and is replaced by the exact expectation.</a:t>
+              <a:t>Stage loop (runs/loop_{lens,oap}_plain, runs/loopfib_*), plain splitter, dmg_loop with the delay row; the mirror rig on the fixed feed (SRC_TRIM 0; every row within 0.02 pm of the mis-fed run, kept in runs/oap_plain_misfed); the fiber rows at the corrected budget 3.5 × 10⁻³ rad/frame; the noise stage's first fiber number was 2.3× low (a 12-draw Monte Carlo of three random numbers) and is replaced by the exact expectation.</a:t>
             </a:r>
           </a:p>
         </p:txBody>
@@ -8923,7 +8923,7 @@
                 </a:solidFill>
                 <a:latin typeface="Arial"/>
               </a:rPr>
-              <a:t> the lens rig's +0.1–0.2 % converged gain (a matrix-model term); the mirror-rig loop rows on the fixed feed (rerun in flight).</a:t>
+              <a:t> the lens rig's +0.1–0.2 % converged gain (a matrix-model term).</a:t>
             </a:r>
           </a:p>
         </p:txBody>
@@ -8936,7 +8936,7 @@
         </p:nvSpPr>
         <p:spPr>
           <a:xfrm>
-            <a:off x="6400800" y="3934968"/>
+            <a:off x="6400800" y="3736848"/>
             <a:ext cx="5394960" cy="274320"/>
           </a:xfrm>
           <a:prstGeom prst="rect">

</xml_diff>

<commit_message>
deck_cophi: the comparison slide as a four-column table with the lock-in (hold photons, cycle time, s per pm, capture, absolute read, stabilities, electronics, resolution); Dave's slide-3 legend geometry carried
Co-Authored-By: Claude Fable 5.1 <noreply@anthropic.com>
</commit_message>
<xml_diff>
--- a/demo_session/deck_cophi.pptx
+++ b/demo_session/deck_cophi.pptx
@@ -10352,7 +10352,7 @@
                 </a:solidFill>
                 <a:latin typeface="Arial"/>
               </a:rPr>
-              <a:t>Feng's deck poses this comparison; on our bench the answer is photons: the vector Zernike holds 3 pm from 2 × 10¹² photons per cycle, COPHI from ~1 × 10¹⁴ — but COPHI captures from cold, carries no reference-aging, and reads the surface absolutely</a:t>
+              <a:t>Feng's deck poses this comparison; on our bench the answer is photons and time: the vector Zernike holds 3 pm from 2 × 10¹² photons per cycle, COPHI with Feng's camera from ~1 × 10¹⁴ — and COPHI with a lock-in camera reaches a picometer faster than any of them, captures from cold, and reads absolutely</a:t>
             </a:r>
           </a:p>
         </p:txBody>
@@ -10401,16 +10401,1043 @@
           </a:p>
         </p:txBody>
       </p:sp>
+      <p:graphicFrame>
+        <p:nvGraphicFramePr>
+          <p:cNvPr id="4" name="Table 3"/>
+          <p:cNvGraphicFramePr>
+            <a:graphicFrameLocks noGrp="1"/>
+          </p:cNvGraphicFramePr>
+          <p:nvPr/>
+        </p:nvGraphicFramePr>
+        <p:xfrm>
+          <a:off x="411480" y="1298448"/>
+          <a:ext cx="11368733" cy="5160645"/>
+        </p:xfrm>
+        <a:graphic>
+          <a:graphicData uri="http://schemas.openxmlformats.org/drawingml/2006/table">
+            <a:tbl>
+              <a:tblPr firstRow="1" bandRow="1">
+                <a:tableStyleId>{5C22544A-7EE6-4342-B048-85BDC9FD1C3A}</a:tableStyleId>
+              </a:tblPr>
+              <a:tblGrid>
+                <a:gridCol w="2325624"/>
+                <a:gridCol w="1631194"/>
+                <a:gridCol w="1717046"/>
+                <a:gridCol w="1030227"/>
+                <a:gridCol w="4664642"/>
+              </a:tblGrid>
+              <a:tr h="657225">
+                <a:tc>
+                  <a:txBody>
+                    <a:bodyPr wrap="square"/>
+                    <a:lstStyle/>
+                    <a:p/>
+                  </a:txBody>
+                  <a:tcPr marL="54864" marR="54864" marT="18288" marB="18288">
+                    <a:solidFill>
+                      <a:srgbClr val="1F4E79"/>
+                    </a:solidFill>
+                  </a:tcPr>
+                </a:tc>
+                <a:tc>
+                  <a:txBody>
+                    <a:bodyPr wrap="square"/>
+                    <a:lstStyle/>
+                    <a:p>
+                      <a:r>
+                        <a:rPr sz="1100" b="1">
+                          <a:solidFill>
+                            <a:srgbClr val="FFFFFF"/>
+                          </a:solidFill>
+                          <a:latin typeface="Arial"/>
+                        </a:rPr>
+                        <a:t>vector Zernike (dedicated laser, polarization camera)</a:t>
+                      </a:r>
+                    </a:p>
+                  </a:txBody>
+                  <a:tcPr marL="54864" marR="54864" marT="18288" marB="18288">
+                    <a:solidFill>
+                      <a:srgbClr val="1F4E79"/>
+                    </a:solidFill>
+                  </a:tcPr>
+                </a:tc>
+                <a:tc>
+                  <a:txBody>
+                    <a:bodyPr wrap="square"/>
+                    <a:lstStyle/>
+                    <a:p>
+                      <a:r>
+                        <a:rPr sz="1100" b="1">
+                          <a:solidFill>
+                            <a:srgbClr val="FFFFFF"/>
+                          </a:solidFill>
+                          <a:latin typeface="Arial"/>
+                        </a:rPr>
+                        <a:t>COPHI, Feng's camera (1k², 60 ke, 30 fps)</a:t>
+                      </a:r>
+                    </a:p>
+                  </a:txBody>
+                  <a:tcPr marL="54864" marR="54864" marT="18288" marB="18288">
+                    <a:solidFill>
+                      <a:srgbClr val="1F4E79"/>
+                    </a:solidFill>
+                  </a:tcPr>
+                </a:tc>
+                <a:tc>
+                  <a:txBody>
+                    <a:bodyPr wrap="square"/>
+                    <a:lstStyle/>
+                    <a:p>
+                      <a:r>
+                        <a:rPr sz="1100" b="1">
+                          <a:solidFill>
+                            <a:srgbClr val="FFFFFF"/>
+                          </a:solidFill>
+                          <a:latin typeface="Arial"/>
+                        </a:rPr>
+                        <a:t>COPHI, Photonfocus (200 ke, 150 fps)</a:t>
+                      </a:r>
+                    </a:p>
+                  </a:txBody>
+                  <a:tcPr marL="54864" marR="54864" marT="18288" marB="18288">
+                    <a:solidFill>
+                      <a:srgbClr val="1F4E79"/>
+                    </a:solidFill>
+                  </a:tcPr>
+                </a:tc>
+                <a:tc>
+                  <a:txBody>
+                    <a:bodyPr wrap="square"/>
+                    <a:lstStyle/>
+                    <a:p>
+                      <a:r>
+                        <a:rPr sz="1100" b="1">
+                          <a:solidFill>
+                            <a:srgbClr val="FFFFFF"/>
+                          </a:solidFill>
+                          <a:latin typeface="Arial"/>
+                        </a:rPr>
+                        <a:t>COPHI, lock-in camera (heliCam C4, as surveyed)</a:t>
+                      </a:r>
+                    </a:p>
+                  </a:txBody>
+                  <a:tcPr marL="54864" marR="54864" marT="18288" marB="18288">
+                    <a:solidFill>
+                      <a:srgbClr val="1F4E79"/>
+                    </a:solidFill>
+                  </a:tcPr>
+                </a:tc>
+              </a:tr>
+              <a:tr h="657225">
+                <a:tc>
+                  <a:txBody>
+                    <a:bodyPr wrap="square"/>
+                    <a:lstStyle/>
+                    <a:p>
+                      <a:r>
+                        <a:rPr sz="1100" b="0">
+                          <a:solidFill>
+                            <a:srgbClr val="282828"/>
+                          </a:solidFill>
+                          <a:latin typeface="Arial"/>
+                        </a:rPr>
+                        <a:t>photons per cycle to hold 3 pm</a:t>
+                      </a:r>
+                    </a:p>
+                  </a:txBody>
+                  <a:tcPr marL="54864" marR="54864" marT="18288" marB="18288">
+                    <a:solidFill>
+                      <a:srgbClr val="FFFFFF"/>
+                    </a:solidFill>
+                  </a:tcPr>
+                </a:tc>
+                <a:tc>
+                  <a:txBody>
+                    <a:bodyPr wrap="square"/>
+                    <a:lstStyle/>
+                    <a:p>
+                      <a:r>
+                        <a:rPr sz="1100" b="0">
+                          <a:solidFill>
+                            <a:srgbClr val="282828"/>
+                          </a:solidFill>
+                          <a:latin typeface="Arial"/>
+                        </a:rPr>
+                        <a:t>2.2 × 10¹² (gauge deck)</a:t>
+                      </a:r>
+                    </a:p>
+                  </a:txBody>
+                  <a:tcPr marL="54864" marR="54864" marT="18288" marB="18288">
+                    <a:solidFill>
+                      <a:srgbClr val="FFFFFF"/>
+                    </a:solidFill>
+                  </a:tcPr>
+                </a:tc>
+                <a:tc>
+                  <a:txBody>
+                    <a:bodyPr wrap="square"/>
+                    <a:lstStyle/>
+                    <a:p>
+                      <a:r>
+                        <a:rPr sz="1100" b="0">
+                          <a:solidFill>
+                            <a:srgbClr val="282828"/>
+                          </a:solidFill>
+                          <a:latin typeface="Arial"/>
+                        </a:rPr>
+                        <a:t>~1 × 10¹⁴ (120 readings at 1.9 × 10¹² ph/s)</a:t>
+                      </a:r>
+                    </a:p>
+                  </a:txBody>
+                  <a:tcPr marL="54864" marR="54864" marT="18288" marB="18288">
+                    <a:solidFill>
+                      <a:srgbClr val="FFFFFF"/>
+                    </a:solidFill>
+                  </a:tcPr>
+                </a:tc>
+                <a:tc>
+                  <a:txBody>
+                    <a:bodyPr wrap="square"/>
+                    <a:lstStyle/>
+                    <a:p>
+                      <a:r>
+                        <a:rPr sz="1100" b="0">
+                          <a:solidFill>
+                            <a:srgbClr val="282828"/>
+                          </a:solidFill>
+                          <a:latin typeface="Arial"/>
+                        </a:rPr>
+                        <a:t>~1 × 10¹⁴ (60 readings)</a:t>
+                      </a:r>
+                    </a:p>
+                  </a:txBody>
+                  <a:tcPr marL="54864" marR="54864" marT="18288" marB="18288">
+                    <a:solidFill>
+                      <a:srgbClr val="FFFFFF"/>
+                    </a:solidFill>
+                  </a:tcPr>
+                </a:tc>
+                <a:tc>
+                  <a:txBody>
+                    <a:bodyPr wrap="square"/>
+                    <a:lstStyle/>
+                    <a:p>
+                      <a:r>
+                        <a:rPr sz="1100" b="0">
+                          <a:solidFill>
+                            <a:srgbClr val="282828"/>
+                          </a:solidFill>
+                          <a:latin typeface="Arial"/>
+                        </a:rPr>
+                        <a:t>~44 samples at the well-capped rate (≈ 3 × 10¹² e⁻ per cycle: 2.8 × 10⁵ elements × 250 ke per sample at half well × 44 samples — from the sheet) — loop run pending</a:t>
+                      </a:r>
+                    </a:p>
+                  </a:txBody>
+                  <a:tcPr marL="54864" marR="54864" marT="18288" marB="18288">
+                    <a:solidFill>
+                      <a:srgbClr val="FFFFFF"/>
+                    </a:solidFill>
+                  </a:tcPr>
+                </a:tc>
+              </a:tr>
+              <a:tr h="468630">
+                <a:tc>
+                  <a:txBody>
+                    <a:bodyPr wrap="square"/>
+                    <a:lstStyle/>
+                    <a:p>
+                      <a:r>
+                        <a:rPr sz="1100" b="0">
+                          <a:solidFill>
+                            <a:srgbClr val="282828"/>
+                          </a:solidFill>
+                          <a:latin typeface="Arial"/>
+                        </a:rPr>
+                        <a:t>time per 3 pm hold cycle</a:t>
+                      </a:r>
+                    </a:p>
+                  </a:txBody>
+                  <a:tcPr marL="54864" marR="54864" marT="18288" marB="18288">
+                    <a:solidFill>
+                      <a:srgbClr val="ECF1F6"/>
+                    </a:solidFill>
+                  </a:tcPr>
+                </a:tc>
+                <a:tc>
+                  <a:txBody>
+                    <a:bodyPr wrap="square"/>
+                    <a:lstStyle/>
+                    <a:p>
+                      <a:r>
+                        <a:rPr sz="1100" b="0">
+                          <a:solidFill>
+                            <a:srgbClr val="282828"/>
+                          </a:solidFill>
+                          <a:latin typeface="Arial"/>
+                        </a:rPr>
+                        <a:t>~1 s class (one frame; gauge deck)</a:t>
+                      </a:r>
+                    </a:p>
+                  </a:txBody>
+                  <a:tcPr marL="54864" marR="54864" marT="18288" marB="18288">
+                    <a:solidFill>
+                      <a:srgbClr val="ECF1F6"/>
+                    </a:solidFill>
+                  </a:tcPr>
+                </a:tc>
+                <a:tc>
+                  <a:txBody>
+                    <a:bodyPr wrap="square"/>
+                    <a:lstStyle/>
+                    <a:p>
+                      <a:r>
+                        <a:rPr sz="1100" b="0">
+                          <a:solidFill>
+                            <a:srgbClr val="282828"/>
+                          </a:solidFill>
+                          <a:latin typeface="Arial"/>
+                        </a:rPr>
+                        <a:t>16 s</a:t>
+                      </a:r>
+                    </a:p>
+                  </a:txBody>
+                  <a:tcPr marL="54864" marR="54864" marT="18288" marB="18288">
+                    <a:solidFill>
+                      <a:srgbClr val="ECF1F6"/>
+                    </a:solidFill>
+                  </a:tcPr>
+                </a:tc>
+                <a:tc>
+                  <a:txBody>
+                    <a:bodyPr wrap="square"/>
+                    <a:lstStyle/>
+                    <a:p>
+                      <a:r>
+                        <a:rPr sz="1100" b="0">
+                          <a:solidFill>
+                            <a:srgbClr val="282828"/>
+                          </a:solidFill>
+                          <a:latin typeface="Arial"/>
+                        </a:rPr>
+                        <a:t>1.6 s</a:t>
+                      </a:r>
+                    </a:p>
+                  </a:txBody>
+                  <a:tcPr marL="54864" marR="54864" marT="18288" marB="18288">
+                    <a:solidFill>
+                      <a:srgbClr val="ECF1F6"/>
+                    </a:solidFill>
+                  </a:tcPr>
+                </a:tc>
+                <a:tc>
+                  <a:txBody>
+                    <a:bodyPr wrap="square"/>
+                    <a:lstStyle/>
+                    <a:p>
+                      <a:r>
+                        <a:rPr sz="1100" b="0">
+                          <a:solidFill>
+                            <a:srgbClr val="282828"/>
+                          </a:solidFill>
+                          <a:latin typeface="Arial"/>
+                        </a:rPr>
+                        <a:t>~44 ms (derived; loop run pending)</a:t>
+                      </a:r>
+                    </a:p>
+                  </a:txBody>
+                  <a:tcPr marL="54864" marR="54864" marT="18288" marB="18288">
+                    <a:solidFill>
+                      <a:srgbClr val="ECF1F6"/>
+                    </a:solidFill>
+                  </a:tcPr>
+                </a:tc>
+              </a:tr>
+              <a:tr h="468630">
+                <a:tc>
+                  <a:txBody>
+                    <a:bodyPr wrap="square"/>
+                    <a:lstStyle/>
+                    <a:p>
+                      <a:r>
+                        <a:rPr sz="1100" b="0">
+                          <a:solidFill>
+                            <a:srgbClr val="282828"/>
+                          </a:solidFill>
+                          <a:latin typeface="Arial"/>
+                        </a:rPr>
+                        <a:t>seconds to SNR 1 at 1 pm</a:t>
+                      </a:r>
+                    </a:p>
+                  </a:txBody>
+                  <a:tcPr marL="54864" marR="54864" marT="18288" marB="18288">
+                    <a:solidFill>
+                      <a:srgbClr val="FFFFFF"/>
+                    </a:solidFill>
+                  </a:tcPr>
+                </a:tc>
+                <a:tc>
+                  <a:txBody>
+                    <a:bodyPr wrap="square"/>
+                    <a:lstStyle/>
+                    <a:p>
+                      <a:r>
+                        <a:rPr sz="1100" b="0">
+                          <a:solidFill>
+                            <a:srgbClr val="282828"/>
+                          </a:solidFill>
+                          <a:latin typeface="Arial"/>
+                        </a:rPr>
+                        <a:t>~12 (polarization camera, first cut)</a:t>
+                      </a:r>
+                    </a:p>
+                  </a:txBody>
+                  <a:tcPr marL="54864" marR="54864" marT="18288" marB="18288">
+                    <a:solidFill>
+                      <a:srgbClr val="FFFFFF"/>
+                    </a:solidFill>
+                  </a:tcPr>
+                </a:tc>
+                <a:tc>
+                  <a:txBody>
+                    <a:bodyPr wrap="square"/>
+                    <a:lstStyle/>
+                    <a:p>
+                      <a:r>
+                        <a:rPr sz="1100" b="0">
+                          <a:solidFill>
+                            <a:srgbClr val="282828"/>
+                          </a:solidFill>
+                          <a:latin typeface="Arial"/>
+                        </a:rPr>
+                        <a:t>443 / 385</a:t>
+                      </a:r>
+                    </a:p>
+                  </a:txBody>
+                  <a:tcPr marL="54864" marR="54864" marT="18288" marB="18288">
+                    <a:solidFill>
+                      <a:srgbClr val="FFFFFF"/>
+                    </a:solidFill>
+                  </a:tcPr>
+                </a:tc>
+                <a:tc>
+                  <a:txBody>
+                    <a:bodyPr wrap="square"/>
+                    <a:lstStyle/>
+                    <a:p>
+                      <a:r>
+                        <a:rPr sz="1100" b="0">
+                          <a:solidFill>
+                            <a:srgbClr val="282828"/>
+                          </a:solidFill>
+                          <a:latin typeface="Arial"/>
+                        </a:rPr>
+                        <a:t>42 / 36</a:t>
+                      </a:r>
+                    </a:p>
+                  </a:txBody>
+                  <a:tcPr marL="54864" marR="54864" marT="18288" marB="18288">
+                    <a:solidFill>
+                      <a:srgbClr val="FFFFFF"/>
+                    </a:solidFill>
+                  </a:tcPr>
+                </a:tc>
+                <a:tc>
+                  <a:txBody>
+                    <a:bodyPr wrap="square"/>
+                    <a:lstStyle/>
+                    <a:p>
+                      <a:r>
+                        <a:rPr sz="1100" b="0">
+                          <a:solidFill>
+                            <a:srgbClr val="282828"/>
+                          </a:solidFill>
+                          <a:latin typeface="Arial"/>
+                        </a:rPr>
+                        <a:t>1.1 (×1.11 for square-wave demodulation)</a:t>
+                      </a:r>
+                    </a:p>
+                  </a:txBody>
+                  <a:tcPr marL="54864" marR="54864" marT="18288" marB="18288">
+                    <a:solidFill>
+                      <a:srgbClr val="FFFFFF"/>
+                    </a:solidFill>
+                  </a:tcPr>
+                </a:tc>
+              </a:tr>
+              <a:tr h="468630">
+                <a:tc>
+                  <a:txBody>
+                    <a:bodyPr wrap="square"/>
+                    <a:lstStyle/>
+                    <a:p>
+                      <a:r>
+                        <a:rPr sz="1100" b="0">
+                          <a:solidFill>
+                            <a:srgbClr val="282828"/>
+                          </a:solidFill>
+                          <a:latin typeface="Arial"/>
+                        </a:rPr>
+                        <a:t>capture from cold</a:t>
+                      </a:r>
+                    </a:p>
+                  </a:txBody>
+                  <a:tcPr marL="54864" marR="54864" marT="18288" marB="18288">
+                    <a:solidFill>
+                      <a:srgbClr val="ECF1F6"/>
+                    </a:solidFill>
+                  </a:tcPr>
+                </a:tc>
+                <a:tc>
+                  <a:txBody>
+                    <a:bodyPr wrap="square"/>
+                    <a:lstStyle/>
+                    <a:p>
+                      <a:r>
+                        <a:rPr sz="1100" b="0">
+                          <a:solidFill>
+                            <a:srgbClr val="282828"/>
+                          </a:solidFill>
+                          <a:latin typeface="Arial"/>
+                        </a:rPr>
+                        <a:t>no: the reference ages past 36–70 nm</a:t>
+                      </a:r>
+                    </a:p>
+                  </a:txBody>
+                  <a:tcPr marL="54864" marR="54864" marT="18288" marB="18288">
+                    <a:solidFill>
+                      <a:srgbClr val="ECF1F6"/>
+                    </a:solidFill>
+                  </a:tcPr>
+                </a:tc>
+                <a:tc>
+                  <a:txBody>
+                    <a:bodyPr wrap="square"/>
+                    <a:lstStyle/>
+                    <a:p>
+                      <a:r>
+                        <a:rPr sz="1100" b="0">
+                          <a:solidFill>
+                            <a:srgbClr val="282828"/>
+                          </a:solidFill>
+                          <a:latin typeface="Arial"/>
+                        </a:rPr>
+                        <a:t>yes: two colors, one 0.27 s reading</a:t>
+                      </a:r>
+                    </a:p>
+                  </a:txBody>
+                  <a:tcPr marL="54864" marR="54864" marT="18288" marB="18288">
+                    <a:solidFill>
+                      <a:srgbClr val="ECF1F6"/>
+                    </a:solidFill>
+                  </a:tcPr>
+                </a:tc>
+                <a:tc>
+                  <a:txBody>
+                    <a:bodyPr wrap="square"/>
+                    <a:lstStyle/>
+                    <a:p>
+                      <a:r>
+                        <a:rPr sz="1100" b="0">
+                          <a:solidFill>
+                            <a:srgbClr val="282828"/>
+                          </a:solidFill>
+                          <a:latin typeface="Arial"/>
+                        </a:rPr>
+                        <a:t>yes</a:t>
+                      </a:r>
+                    </a:p>
+                  </a:txBody>
+                  <a:tcPr marL="54864" marR="54864" marT="18288" marB="18288">
+                    <a:solidFill>
+                      <a:srgbClr val="ECF1F6"/>
+                    </a:solidFill>
+                  </a:tcPr>
+                </a:tc>
+                <a:tc>
+                  <a:txBody>
+                    <a:bodyPr wrap="square"/>
+                    <a:lstStyle/>
+                    <a:p>
+                      <a:r>
+                        <a:rPr sz="1100" b="0">
+                          <a:solidFill>
+                            <a:srgbClr val="282828"/>
+                          </a:solidFill>
+                          <a:latin typeface="Arial"/>
+                        </a:rPr>
+                        <a:t>yes: two colors on alternate I/Q samples (2 ms)</a:t>
+                      </a:r>
+                    </a:p>
+                  </a:txBody>
+                  <a:tcPr marL="54864" marR="54864" marT="18288" marB="18288">
+                    <a:solidFill>
+                      <a:srgbClr val="ECF1F6"/>
+                    </a:solidFill>
+                  </a:tcPr>
+                </a:tc>
+              </a:tr>
+              <a:tr h="657225">
+                <a:tc>
+                  <a:txBody>
+                    <a:bodyPr wrap="square"/>
+                    <a:lstStyle/>
+                    <a:p>
+                      <a:r>
+                        <a:rPr sz="1100" b="0">
+                          <a:solidFill>
+                            <a:srgbClr val="282828"/>
+                          </a:solidFill>
+                          <a:latin typeface="Arial"/>
+                        </a:rPr>
+                        <a:t>absolute read</a:t>
+                      </a:r>
+                    </a:p>
+                  </a:txBody>
+                  <a:tcPr marL="54864" marR="54864" marT="18288" marB="18288">
+                    <a:solidFill>
+                      <a:srgbClr val="FFFFFF"/>
+                    </a:solidFill>
+                  </a:tcPr>
+                </a:tc>
+                <a:tc>
+                  <a:txBody>
+                    <a:bodyPr wrap="square"/>
+                    <a:lstStyle/>
+                    <a:p>
+                      <a:r>
+                        <a:rPr sz="1100" b="0">
+                          <a:solidFill>
+                            <a:srgbClr val="282828"/>
+                          </a:solidFill>
+                          <a:latin typeface="Arial"/>
+                        </a:rPr>
+                        <a:t>needs the reference iterated or a matrix re-measured</a:t>
+                      </a:r>
+                    </a:p>
+                  </a:txBody>
+                  <a:tcPr marL="54864" marR="54864" marT="18288" marB="18288">
+                    <a:solidFill>
+                      <a:srgbClr val="FFFFFF"/>
+                    </a:solidFill>
+                  </a:tcPr>
+                </a:tc>
+                <a:tc>
+                  <a:txBody>
+                    <a:bodyPr wrap="square"/>
+                    <a:lstStyle/>
+                    <a:p>
+                      <a:r>
+                        <a:rPr sz="1100" b="0">
+                          <a:solidFill>
+                            <a:srgbClr val="282828"/>
+                          </a:solidFill>
+                          <a:latin typeface="Arial"/>
+                        </a:rPr>
+                        <a:t>exact (slope 1.000000) through the LO</a:t>
+                      </a:r>
+                    </a:p>
+                  </a:txBody>
+                  <a:tcPr marL="54864" marR="54864" marT="18288" marB="18288">
+                    <a:solidFill>
+                      <a:srgbClr val="FFFFFF"/>
+                    </a:solidFill>
+                  </a:tcPr>
+                </a:tc>
+                <a:tc>
+                  <a:txBody>
+                    <a:bodyPr wrap="square"/>
+                    <a:lstStyle/>
+                    <a:p>
+                      <a:r>
+                        <a:rPr sz="1100" b="0">
+                          <a:solidFill>
+                            <a:srgbClr val="282828"/>
+                          </a:solidFill>
+                          <a:latin typeface="Arial"/>
+                        </a:rPr>
+                        <a:t>exact</a:t>
+                      </a:r>
+                    </a:p>
+                  </a:txBody>
+                  <a:tcPr marL="54864" marR="54864" marT="18288" marB="18288">
+                    <a:solidFill>
+                      <a:srgbClr val="FFFFFF"/>
+                    </a:solidFill>
+                  </a:tcPr>
+                </a:tc>
+                <a:tc>
+                  <a:txBody>
+                    <a:bodyPr wrap="square"/>
+                    <a:lstStyle/>
+                    <a:p>
+                      <a:r>
+                        <a:rPr sz="1100" b="0">
+                          <a:solidFill>
+                            <a:srgbClr val="282828"/>
+                          </a:solidFill>
+                          <a:latin typeface="Arial"/>
+                        </a:rPr>
+                        <a:t>exact</a:t>
+                      </a:r>
+                    </a:p>
+                  </a:txBody>
+                  <a:tcPr marL="54864" marR="54864" marT="18288" marB="18288">
+                    <a:solidFill>
+                      <a:srgbClr val="FFFFFF"/>
+                    </a:solidFill>
+                  </a:tcPr>
+                </a:tc>
+              </a:tr>
+              <a:tr h="657225">
+                <a:tc>
+                  <a:txBody>
+                    <a:bodyPr wrap="square"/>
+                    <a:lstStyle/>
+                    <a:p>
+                      <a:r>
+                        <a:rPr sz="1100" b="0">
+                          <a:solidFill>
+                            <a:srgbClr val="282828"/>
+                          </a:solidFill>
+                          <a:latin typeface="Arial"/>
+                        </a:rPr>
+                        <a:t>its own stabilities</a:t>
+                      </a:r>
+                    </a:p>
+                  </a:txBody>
+                  <a:tcPr marL="54864" marR="54864" marT="18288" marB="18288">
+                    <a:solidFill>
+                      <a:srgbClr val="ECF1F6"/>
+                    </a:solidFill>
+                  </a:tcPr>
+                </a:tc>
+                <a:tc>
+                  <a:txBody>
+                    <a:bodyPr wrap="square"/>
+                    <a:lstStyle/>
+                    <a:p>
+                      <a:r>
+                        <a:rPr sz="1100" b="0">
+                          <a:solidFill>
+                            <a:srgbClr val="282828"/>
+                          </a:solidFill>
+                          <a:latin typeface="Arial"/>
+                        </a:rPr>
+                        <a:t>none beyond the bench</a:t>
+                      </a:r>
+                    </a:p>
+                  </a:txBody>
+                  <a:tcPr marL="54864" marR="54864" marT="18288" marB="18288">
+                    <a:solidFill>
+                      <a:srgbClr val="ECF1F6"/>
+                    </a:solidFill>
+                  </a:tcPr>
+                </a:tc>
+                <a:tc>
+                  <a:txBody>
+                    <a:bodyPr wrap="square"/>
+                    <a:lstStyle/>
+                    <a:p>
+                      <a:r>
+                        <a:rPr sz="1100" b="0">
+                          <a:solidFill>
+                            <a:srgbClr val="282828"/>
+                          </a:solidFill>
+                          <a:latin typeface="Arial"/>
+                        </a:rPr>
+                        <a:t>fiber phase 0.35 nm per frame; LO pointing 10 prad per cycle</a:t>
+                      </a:r>
+                    </a:p>
+                  </a:txBody>
+                  <a:tcPr marL="54864" marR="54864" marT="18288" marB="18288">
+                    <a:solidFill>
+                      <a:srgbClr val="ECF1F6"/>
+                    </a:solidFill>
+                  </a:tcPr>
+                </a:tc>
+                <a:tc>
+                  <a:txBody>
+                    <a:bodyPr wrap="square"/>
+                    <a:lstStyle/>
+                    <a:p>
+                      <a:r>
+                        <a:rPr sz="1100" b="0">
+                          <a:solidFill>
+                            <a:srgbClr val="282828"/>
+                          </a:solidFill>
+                          <a:latin typeface="Arial"/>
+                        </a:rPr>
+                        <a:t>same</a:t>
+                      </a:r>
+                    </a:p>
+                  </a:txBody>
+                  <a:tcPr marL="54864" marR="54864" marT="18288" marB="18288">
+                    <a:solidFill>
+                      <a:srgbClr val="ECF1F6"/>
+                    </a:solidFill>
+                  </a:tcPr>
+                </a:tc>
+                <a:tc>
+                  <a:txBody>
+                    <a:bodyPr wrap="square"/>
+                    <a:lstStyle/>
+                    <a:p>
+                      <a:r>
+                        <a:rPr sz="1100" b="0">
+                          <a:solidFill>
+                            <a:srgbClr val="282828"/>
+                          </a:solidFill>
+                          <a:latin typeface="Arial"/>
+                        </a:rPr>
+                        <a:t>LO pointing the same; fiber walk a piston per sample — inert (to be confirmed by the loop)</a:t>
+                      </a:r>
+                    </a:p>
+                  </a:txBody>
+                  <a:tcPr marL="54864" marR="54864" marT="18288" marB="18288">
+                    <a:solidFill>
+                      <a:srgbClr val="ECF1F6"/>
+                    </a:solidFill>
+                  </a:tcPr>
+                </a:tc>
+              </a:tr>
+              <a:tr h="468630">
+                <a:tc>
+                  <a:txBody>
+                    <a:bodyPr wrap="square"/>
+                    <a:lstStyle/>
+                    <a:p>
+                      <a:r>
+                        <a:rPr sz="1100" b="0">
+                          <a:solidFill>
+                            <a:srgbClr val="282828"/>
+                          </a:solidFill>
+                          <a:latin typeface="Arial"/>
+                        </a:rPr>
+                        <a:t>electronics it adds</a:t>
+                      </a:r>
+                    </a:p>
+                  </a:txBody>
+                  <a:tcPr marL="54864" marR="54864" marT="18288" marB="18288">
+                    <a:solidFill>
+                      <a:srgbClr val="FFFFFF"/>
+                    </a:solidFill>
+                  </a:tcPr>
+                </a:tc>
+                <a:tc>
+                  <a:txBody>
+                    <a:bodyPr wrap="square"/>
+                    <a:lstStyle/>
+                    <a:p>
+                      <a:r>
+                        <a:rPr sz="1100" b="0">
+                          <a:solidFill>
+                            <a:srgbClr val="282828"/>
+                          </a:solidFill>
+                          <a:latin typeface="Arial"/>
+                        </a:rPr>
+                        <a:t>a laser</a:t>
+                      </a:r>
+                    </a:p>
+                  </a:txBody>
+                  <a:tcPr marL="54864" marR="54864" marT="18288" marB="18288">
+                    <a:solidFill>
+                      <a:srgbClr val="FFFFFF"/>
+                    </a:solidFill>
+                  </a:tcPr>
+                </a:tc>
+                <a:tc>
+                  <a:txBody>
+                    <a:bodyPr wrap="square"/>
+                    <a:lstStyle/>
+                    <a:p>
+                      <a:r>
+                        <a:rPr sz="1100" b="0">
+                          <a:solidFill>
+                            <a:srgbClr val="282828"/>
+                          </a:solidFill>
+                          <a:latin typeface="Arial"/>
+                        </a:rPr>
+                        <a:t>RF chain, fiber LO, two loops</a:t>
+                      </a:r>
+                    </a:p>
+                  </a:txBody>
+                  <a:tcPr marL="54864" marR="54864" marT="18288" marB="18288">
+                    <a:solidFill>
+                      <a:srgbClr val="FFFFFF"/>
+                    </a:solidFill>
+                  </a:tcPr>
+                </a:tc>
+                <a:tc>
+                  <a:txBody>
+                    <a:bodyPr wrap="square"/>
+                    <a:lstStyle/>
+                    <a:p>
+                      <a:r>
+                        <a:rPr sz="1100" b="0">
+                          <a:solidFill>
+                            <a:srgbClr val="282828"/>
+                          </a:solidFill>
+                          <a:latin typeface="Arial"/>
+                        </a:rPr>
+                        <a:t>same</a:t>
+                      </a:r>
+                    </a:p>
+                  </a:txBody>
+                  <a:tcPr marL="54864" marR="54864" marT="18288" marB="18288">
+                    <a:solidFill>
+                      <a:srgbClr val="FFFFFF"/>
+                    </a:solidFill>
+                  </a:tcPr>
+                </a:tc>
+                <a:tc>
+                  <a:txBody>
+                    <a:bodyPr wrap="square"/>
+                    <a:lstStyle/>
+                    <a:p>
+                      <a:r>
+                        <a:rPr sz="1100" b="0">
+                          <a:solidFill>
+                            <a:srgbClr val="282828"/>
+                          </a:solidFill>
+                          <a:latin typeface="Arial"/>
+                        </a:rPr>
+                        <a:t>same, beat at kHz; demodulation on-chip; I/Q data at 1 kHz</a:t>
+                      </a:r>
+                    </a:p>
+                  </a:txBody>
+                  <a:tcPr marL="54864" marR="54864" marT="18288" marB="18288">
+                    <a:solidFill>
+                      <a:srgbClr val="FFFFFF"/>
+                    </a:solidFill>
+                  </a:tcPr>
+                </a:tc>
+              </a:tr>
+              <a:tr h="657225">
+                <a:tc>
+                  <a:txBody>
+                    <a:bodyPr wrap="square"/>
+                    <a:lstStyle/>
+                    <a:p>
+                      <a:r>
+                        <a:rPr sz="1100" b="0">
+                          <a:solidFill>
+                            <a:srgbClr val="282828"/>
+                          </a:solidFill>
+                          <a:latin typeface="Arial"/>
+                        </a:rPr>
+                        <a:t>resolution</a:t>
+                      </a:r>
+                    </a:p>
+                  </a:txBody>
+                  <a:tcPr marL="54864" marR="54864" marT="18288" marB="18288">
+                    <a:solidFill>
+                      <a:srgbClr val="ECF1F6"/>
+                    </a:solidFill>
+                  </a:tcPr>
+                </a:tc>
+                <a:tc>
+                  <a:txBody>
+                    <a:bodyPr wrap="square"/>
+                    <a:lstStyle/>
+                    <a:p>
+                      <a:r>
+                        <a:rPr sz="1100" b="0">
+                          <a:solidFill>
+                            <a:srgbClr val="282828"/>
+                          </a:solidFill>
+                          <a:latin typeface="Arial"/>
+                        </a:rPr>
+                        <a:t>pixel-by-pixel from two images, wants ≥ 4 px per actuator</a:t>
+                      </a:r>
+                    </a:p>
+                  </a:txBody>
+                  <a:tcPr marL="54864" marR="54864" marT="18288" marB="18288">
+                    <a:solidFill>
+                      <a:srgbClr val="ECF1F6"/>
+                    </a:solidFill>
+                  </a:tcPr>
+                </a:tc>
+                <a:tc>
+                  <a:txBody>
+                    <a:bodyPr wrap="square"/>
+                    <a:lstStyle/>
+                    <a:p>
+                      <a:r>
+                        <a:rPr sz="1100" b="0">
+                          <a:solidFill>
+                            <a:srgbClr val="282828"/>
+                          </a:solidFill>
+                          <a:latin typeface="Arial"/>
+                        </a:rPr>
+                        <a:t>9.4 px per actuator</a:t>
+                      </a:r>
+                    </a:p>
+                  </a:txBody>
+                  <a:tcPr marL="54864" marR="54864" marT="18288" marB="18288">
+                    <a:solidFill>
+                      <a:srgbClr val="ECF1F6"/>
+                    </a:solidFill>
+                  </a:tcPr>
+                </a:tc>
+                <a:tc>
+                  <a:txBody>
+                    <a:bodyPr wrap="square"/>
+                    <a:lstStyle/>
+                    <a:p>
+                      <a:r>
+                        <a:rPr sz="1100" b="0">
+                          <a:solidFill>
+                            <a:srgbClr val="282828"/>
+                          </a:solidFill>
+                          <a:latin typeface="Arial"/>
+                        </a:rPr>
+                        <a:t>9.4</a:t>
+                      </a:r>
+                    </a:p>
+                  </a:txBody>
+                  <a:tcPr marL="54864" marR="54864" marT="18288" marB="18288">
+                    <a:solidFill>
+                      <a:srgbClr val="ECF1F6"/>
+                    </a:solidFill>
+                  </a:tcPr>
+                </a:tc>
+                <a:tc>
+                  <a:txBody>
+                    <a:bodyPr wrap="square"/>
+                    <a:lstStyle/>
+                    <a:p>
+                      <a:r>
+                        <a:rPr sz="1100" b="0">
+                          <a:solidFill>
+                            <a:srgbClr val="282828"/>
+                          </a:solidFill>
+                          <a:latin typeface="Arial"/>
+                        </a:rPr>
+                        <a:t>5.3 (C4M 10.6)</a:t>
+                      </a:r>
+                    </a:p>
+                  </a:txBody>
+                  <a:tcPr marL="54864" marR="54864" marT="18288" marB="18288">
+                    <a:solidFill>
+                      <a:srgbClr val="ECF1F6"/>
+                    </a:solidFill>
+                  </a:tcPr>
+                </a:tc>
+              </a:tr>
+            </a:tbl>
+          </a:graphicData>
+        </a:graphic>
+      </p:graphicFrame>
       <p:sp>
         <p:nvSpPr>
-          <p:cNvPr id="4" name="TextBox 3"/>
+          <p:cNvPr id="5" name="TextBox 4"/>
           <p:cNvSpPr txBox="1"/>
           <p:nvPr/>
         </p:nvSpPr>
         <p:spPr>
           <a:xfrm>
-            <a:off x="411480" y="1298448"/>
-            <a:ext cx="5806440" cy="274320"/>
+            <a:off x="411480" y="6605397"/>
+            <a:ext cx="11368735" cy="274320"/>
           </a:xfrm>
           <a:prstGeom prst="rect">
             <a:avLst/>
@@ -10429,7 +11456,7 @@
               </a:spcAft>
             </a:pPr>
             <a:r>
-              <a:rPr sz="1200" b="0">
+              <a:rPr sz="1500" b="0">
                 <a:solidFill>
                   <a:srgbClr val="282828"/>
                 </a:solidFill>
@@ -10438,7 +11465,7 @@
               <a:t>•  </a:t>
             </a:r>
             <a:r>
-              <a:rPr sz="1200" b="1">
+              <a:rPr sz="1500" b="1">
                 <a:solidFill>
                   <a:srgbClr val="282828"/>
                 </a:solidFill>
@@ -10447,31 +11474,31 @@
               <a:t>For hold alone,</a:t>
             </a:r>
             <a:r>
-              <a:rPr sz="1200" b="0">
+              <a:rPr sz="1500" b="0">
                 <a:solidFill>
                   <a:srgbClr val="282828"/>
                 </a:solidFill>
                 <a:latin typeface="Arial"/>
               </a:rPr>
-              <a:t> the vector Zernike sensor is the cheaper sensor by ~50× in photons per cycle (gauge deck: 2.2 × 10¹² vs the interferometer class at 2 × 10¹³ — and COPHI at Feng's camera's cadence needs 120 readings per cycle).  Both hold 3 pm.  </a:t>
-            </a:r>
-            <a:r>
-              <a:rPr sz="1200" b="1">
+              <a:t> the vector Zernike sensor is the cheapest in photons by ~50× and needs no stabilities of its own; Feng's camera makes COPHI slow (16 s cycles); the Photonfocus makes it comparable (1.6 s); </a:t>
+            </a:r>
+            <a:r>
+              <a:rPr sz="1500" b="1">
                 <a:solidFill>
                   <a:srgbClr val="282828"/>
                 </a:solidFill>
                 <a:latin typeface="Arial"/>
               </a:rPr>
-              <a:t>Resolution is a wash:</a:t>
-            </a:r>
-            <a:r>
-              <a:rPr sz="1200" b="0">
+              <a:t>the lock-in makes COPHI the fastest reading on the table</a:t>
+            </a:r>
+            <a:r>
+              <a:rPr sz="1500" b="0">
                 <a:solidFill>
                   <a:srgbClr val="282828"/>
                 </a:solidFill>
                 <a:latin typeface="Arial"/>
               </a:rPr>
-              <a:t> both read the full lattice at 5–10 pixels per actuator.</a:t>
+              <a:t> (sub-second cycles, 1.1 s per pm) — if its well behaves as surveyed, and with the fiber term reduced to a piston.</a:t>
             </a:r>
           </a:p>
           <a:p>
@@ -10481,7 +11508,7 @@
               </a:spcAft>
             </a:pPr>
             <a:r>
-              <a:rPr sz="1200" b="0">
+              <a:rPr sz="1500" b="0">
                 <a:solidFill>
                   <a:srgbClr val="282828"/>
                 </a:solidFill>
@@ -10490,70 +11517,72 @@
               <a:t>•  </a:t>
             </a:r>
             <a:r>
-              <a:rPr sz="1200" b="1">
+              <a:rPr sz="1500" b="1">
                 <a:solidFill>
                   <a:srgbClr val="282828"/>
                 </a:solidFill>
                 <a:latin typeface="Arial"/>
               </a:rPr>
-              <a:t>For capture,</a:t>
-            </a:r>
-            <a:r>
-              <a:rPr sz="1200" b="0">
+              <a:t>For capture and the absolute figure,</a:t>
+            </a:r>
+            <a:r>
+              <a:rPr sz="1500" b="0">
                 <a:solidFill>
                   <a:srgbClr val="282828"/>
                 </a:solidFill>
                 <a:latin typeface="Arial"/>
               </a:rPr>
-              <a:t> the Zernike sensor's reference is the beam's own core and ages past 36–70 nm; COPHI with two colors captures 480 nm rms in one reading, with a reference that does not depend on the surface.</a:t>
-            </a:r>
-          </a:p>
-          <a:p>
-            <a:pPr>
-              <a:spcAft>
-                <a:spcPts val="600"/>
-              </a:spcAft>
-            </a:pPr>
-            <a:r>
-              <a:rPr sz="1200" b="0">
+              <a:t> COPHI in either form: a reference that does not depend on the surface, two colors for 480 nm rms in one reading.  </a:t>
+            </a:r>
+            <a:r>
+              <a:rPr sz="1500" b="1">
                 <a:solidFill>
                   <a:srgbClr val="282828"/>
                 </a:solidFill>
                 <a:latin typeface="Arial"/>
               </a:rPr>
-              <a:t>•  </a:t>
-            </a:r>
-            <a:r>
-              <a:rPr sz="1200" b="1">
+              <a:t>What decides it for a flight DM:</a:t>
+            </a:r>
+            <a:r>
+              <a:rPr sz="1500" b="0">
                 <a:solidFill>
                   <a:srgbClr val="282828"/>
                 </a:solidFill>
                 <a:latin typeface="Arial"/>
               </a:rPr>
-              <a:t>For an absolute read,</a:t>
-            </a:r>
-            <a:r>
-              <a:rPr sz="1200" b="0">
+              <a:t> hold only → the Zernike sensor; hold + capture + absolute → COPHI, and with the lock-in camera it is also the fastest; </a:t>
+            </a:r>
+            <a:r>
+              <a:rPr sz="1500" b="1">
                 <a:solidFill>
                   <a:srgbClr val="282828"/>
                 </a:solidFill>
                 <a:latin typeface="Arial"/>
               </a:rPr>
-              <a:t> the Zernike sensor needs its reference iterated or a matrix re-measured; COPHI reads the surface against the LO, exactly (slope 1.000000 at the pixel) — the matrix's shrinkage is the estimator's, and converges away.</a:t>
+              <a:t>the hybrid Feng's purpose suggests</a:t>
+            </a:r>
+            <a:r>
+              <a:rPr sz="1500" b="0">
+                <a:solidFill>
+                  <a:srgbClr val="282828"/>
+                </a:solidFill>
+                <a:latin typeface="Arial"/>
+              </a:rPr>
+              <a:t> — a Zernike sensor for the hold, COPHI's two-color read for capture and commissioning — remains the conservative answer until the lock-in's vendor numbers are in.</a:t>
             </a:r>
           </a:p>
         </p:txBody>
       </p:sp>
       <p:sp>
         <p:nvSpPr>
-          <p:cNvPr id="5" name="TextBox 4"/>
+          <p:cNvPr id="6" name="TextBox 5"/>
           <p:cNvSpPr txBox="1"/>
           <p:nvPr/>
         </p:nvSpPr>
         <p:spPr>
           <a:xfrm>
-            <a:off x="6400800" y="1298448"/>
-            <a:ext cx="5394960" cy="274320"/>
+            <a:off x="411480" y="9151239"/>
+            <a:ext cx="11368735" cy="274320"/>
           </a:xfrm>
           <a:prstGeom prst="rect">
             <a:avLst/>
@@ -10572,138 +11601,13 @@
               </a:spcAft>
             </a:pPr>
             <a:r>
-              <a:rPr sz="1200" b="0">
-                <a:solidFill>
-                  <a:srgbClr val="282828"/>
-                </a:solidFill>
-                <a:latin typeface="Arial"/>
-              </a:rPr>
-              <a:t>•  </a:t>
-            </a:r>
-            <a:r>
-              <a:rPr sz="1200" b="1">
-                <a:solidFill>
-                  <a:srgbClr val="282828"/>
-                </a:solidFill>
-                <a:latin typeface="Arial"/>
-              </a:rPr>
-              <a:t>What COPHI pays:</a:t>
-            </a:r>
-            <a:r>
-              <a:rPr sz="1200" b="0">
-                <a:solidFill>
-                  <a:srgbClr val="282828"/>
-                </a:solidFill>
-                <a:latin typeface="Arial"/>
-              </a:rPr>
-              <a:t> the RF chain and the fiber LO (slide 15); the fiber-phase budget (0.35 nm per frame); the LO pointing (10 prad per cycle) — two stabilities the Zernike sensor never needs; and a camera chosen for well × rate.</a:t>
-            </a:r>
-          </a:p>
-          <a:p>
-            <a:pPr>
-              <a:spcAft>
-                <a:spcPts val="600"/>
-              </a:spcAft>
-            </a:pPr>
-            <a:r>
-              <a:rPr sz="1200" b="0">
-                <a:solidFill>
-                  <a:srgbClr val="282828"/>
-                </a:solidFill>
-                <a:latin typeface="Arial"/>
-              </a:rPr>
-              <a:t>•  </a:t>
-            </a:r>
-            <a:r>
-              <a:rPr sz="1200" b="1">
-                <a:solidFill>
-                  <a:srgbClr val="282828"/>
-                </a:solidFill>
-                <a:latin typeface="Arial"/>
-              </a:rPr>
-              <a:t>What decides it for a flight DM:</a:t>
-            </a:r>
-            <a:r>
-              <a:rPr sz="1200" b="0">
-                <a:solidFill>
-                  <a:srgbClr val="282828"/>
-                </a:solidFill>
-                <a:latin typeface="Arial"/>
-              </a:rPr>
-              <a:t> if the hold loop is the only job, the Zernike sensor; if the same sensor must capture from cold and read absolutely, COPHI — and with a lock-in camera it is also the fastest full-lattice reading on the table.</a:t>
-            </a:r>
-          </a:p>
-          <a:p>
-            <a:pPr>
-              <a:spcAft>
-                <a:spcPts val="600"/>
-              </a:spcAft>
-            </a:pPr>
-            <a:r>
-              <a:rPr sz="1200" b="0">
-                <a:solidFill>
-                  <a:srgbClr val="282828"/>
-                </a:solidFill>
-                <a:latin typeface="Arial"/>
-              </a:rPr>
-              <a:t>•  </a:t>
-            </a:r>
-            <a:r>
-              <a:rPr sz="1200" b="1">
-                <a:solidFill>
-                  <a:srgbClr val="282828"/>
-                </a:solidFill>
-                <a:latin typeface="Arial"/>
-              </a:rPr>
-              <a:t>The hybrid Feng's purpose suggests:</a:t>
-            </a:r>
-            <a:r>
-              <a:rPr sz="1200" b="0">
-                <a:solidFill>
-                  <a:srgbClr val="282828"/>
-                </a:solidFill>
-                <a:latin typeface="Arial"/>
-              </a:rPr>
-              <a:t> a Zernike sensor for the hold, COPHI's two-color read for capture and for the absolute figure at commissioning — one bench, two readings, one DM truth.</a:t>
-            </a:r>
-          </a:p>
-        </p:txBody>
-      </p:sp>
-      <p:sp>
-        <p:nvSpPr>
-          <p:cNvPr id="6" name="TextBox 5"/>
-          <p:cNvSpPr txBox="1"/>
-          <p:nvPr/>
-        </p:nvSpPr>
-        <p:spPr>
-          <a:xfrm>
-            <a:off x="6400800" y="3934968"/>
-            <a:ext cx="5394960" cy="274320"/>
-          </a:xfrm>
-          <a:prstGeom prst="rect">
-            <a:avLst/>
-          </a:prstGeom>
-          <a:noFill/>
-        </p:spPr>
-        <p:txBody>
-          <a:bodyPr wrap="square">
-            <a:spAutoFit/>
-          </a:bodyPr>
-          <a:lstStyle/>
-          <a:p>
-            <a:pPr>
-              <a:spcAft>
-                <a:spcPts val="600"/>
-              </a:spcAft>
-            </a:pPr>
-            <a:r>
               <a:rPr sz="1050" b="0">
                 <a:solidFill>
                   <a:srgbClr val="6E6E6E"/>
                 </a:solidFill>
                 <a:latin typeface="Arial"/>
               </a:rPr>
-              <a:t>The Zernike rows are the gauge deck's (redo96_*sens, zloop); the COPHI rows this deck's.</a:t>
+              <a:t>The Zernike rows are the gauge deck's (redo96_*sens, zloop; the polarization-camera timing a first cut, TO's noise-hook run pending); the COPHI rows this deck's; the lock-in's loop / capture rows derived from the format stage until TO's runs land.</a:t>
             </a:r>
           </a:p>
         </p:txBody>
@@ -14327,8 +15231,8 @@
         </p:nvSpPr>
         <p:spPr>
           <a:xfrm>
-            <a:off x="411480" y="1152144"/>
-            <a:ext cx="10561320" cy="274320"/>
+            <a:off x="411480" y="1115568"/>
+            <a:ext cx="11475720" cy="274320"/>
           </a:xfrm>
           <a:prstGeom prst="rect">
             <a:avLst/>

</xml_diff>

<commit_message>
deck_cophi: the lock-in restated from the true I/Q reading (3.4 s per pm, ~12x the Photonfocus, not 1.1 / 40x -- the format stage counted four wells per sample); the sensors' camera first cut withdrawn, the IFO's record kept; the annulus median-fill convention noted
Co-Authored-By: Claude Fable 5.1 <noreply@anthropic.com>
</commit_message>
<xml_diff>
--- a/demo_session/deck_cophi.pptx
+++ b/demo_session/deck_cophi.pptx
@@ -4534,7 +4534,7 @@
         </p:nvGraphicFramePr>
         <p:xfrm>
           <a:off x="411480" y="1298448"/>
-          <a:ext cx="5806437" cy="3943350"/>
+          <a:ext cx="5806438" cy="4509135"/>
         </p:xfrm>
         <a:graphic>
           <a:graphicData uri="http://schemas.openxmlformats.org/drawingml/2006/table">
@@ -4543,14 +4543,14 @@
                 <a:tableStyleId>{5C22544A-7EE6-4342-B048-85BDC9FD1C3A}</a:tableStyleId>
               </a:tblPr>
               <a:tblGrid>
-                <a:gridCol w="1613274"/>
-                <a:gridCol w="1209956"/>
-                <a:gridCol w="721728"/>
-                <a:gridCol w="488227"/>
-                <a:gridCol w="827864"/>
-                <a:gridCol w="945388"/>
+                <a:gridCol w="1665418"/>
+                <a:gridCol w="999251"/>
+                <a:gridCol w="964189"/>
+                <a:gridCol w="403206"/>
+                <a:gridCol w="683698"/>
+                <a:gridCol w="1090676"/>
               </a:tblGrid>
-              <a:tr h="845820">
+              <a:tr h="1034415">
                 <a:tc>
                   <a:txBody>
                     <a:bodyPr wrap="square"/>
@@ -4680,6 +4680,140 @@
                   <a:tcPr marL="54864" marR="54864" marT="18288" marB="18288">
                     <a:solidFill>
                       <a:srgbClr val="1F4E79"/>
+                    </a:solidFill>
+                  </a:tcPr>
+                </a:tc>
+              </a:tr>
+              <a:tr h="657225">
+                <a:tc>
+                  <a:txBody>
+                    <a:bodyPr wrap="square"/>
+                    <a:lstStyle/>
+                    <a:p>
+                      <a:r>
+                        <a:rPr sz="1100" b="0">
+                          <a:solidFill>
+                            <a:srgbClr val="282828"/>
+                          </a:solidFill>
+                          <a:latin typeface="Arial"/>
+                        </a:rPr>
+                        <a:t>as proposed: 1k², 60 ke, 30 fps</a:t>
+                      </a:r>
+                    </a:p>
+                  </a:txBody>
+                  <a:tcPr marL="54864" marR="54864" marT="18288" marB="18288">
+                    <a:solidFill>
+                      <a:srgbClr val="FFFFFF"/>
+                    </a:solidFill>
+                  </a:tcPr>
+                </a:tc>
+                <a:tc>
+                  <a:txBody>
+                    <a:bodyPr wrap="square"/>
+                    <a:lstStyle/>
+                    <a:p>
+                      <a:r>
+                        <a:rPr sz="1100" b="0">
+                          <a:solidFill>
+                            <a:srgbClr val="282828"/>
+                          </a:solidFill>
+                          <a:latin typeface="Arial"/>
+                        </a:rPr>
+                        <a:t>5 assumed (1.000)</a:t>
+                      </a:r>
+                    </a:p>
+                  </a:txBody>
+                  <a:tcPr marL="54864" marR="54864" marT="18288" marB="18288">
+                    <a:solidFill>
+                      <a:srgbClr val="FFFFFF"/>
+                    </a:solidFill>
+                  </a:tcPr>
+                </a:tc>
+                <a:tc>
+                  <a:txBody>
+                    <a:bodyPr wrap="square"/>
+                    <a:lstStyle/>
+                    <a:p>
+                      <a:r>
+                        <a:rPr sz="1100" b="0">
+                          <a:solidFill>
+                            <a:srgbClr val="282828"/>
+                          </a:solidFill>
+                          <a:latin typeface="Arial"/>
+                        </a:rPr>
+                        <a:t>57.7 / 53.7</a:t>
+                      </a:r>
+                    </a:p>
+                  </a:txBody>
+                  <a:tcPr marL="54864" marR="54864" marT="18288" marB="18288">
+                    <a:solidFill>
+                      <a:srgbClr val="FFFFFF"/>
+                    </a:solidFill>
+                  </a:tcPr>
+                </a:tc>
+                <a:tc>
+                  <a:txBody>
+                    <a:bodyPr wrap="square"/>
+                    <a:lstStyle/>
+                    <a:p>
+                      <a:r>
+                        <a:rPr sz="1100" b="0">
+                          <a:solidFill>
+                            <a:srgbClr val="282828"/>
+                          </a:solidFill>
+                          <a:latin typeface="Arial"/>
+                        </a:rPr>
+                        <a:t>0.017</a:t>
+                      </a:r>
+                    </a:p>
+                  </a:txBody>
+                  <a:tcPr marL="54864" marR="54864" marT="18288" marB="18288">
+                    <a:solidFill>
+                      <a:srgbClr val="FFFFFF"/>
+                    </a:solidFill>
+                  </a:tcPr>
+                </a:tc>
+                <a:tc>
+                  <a:txBody>
+                    <a:bodyPr wrap="square"/>
+                    <a:lstStyle/>
+                    <a:p>
+                      <a:r>
+                        <a:rPr sz="1100" b="0">
+                          <a:solidFill>
+                            <a:srgbClr val="282828"/>
+                          </a:solidFill>
+                          <a:latin typeface="Arial"/>
+                        </a:rPr>
+                        <a:t>443 / 385 (≈ 7 min)</a:t>
+                      </a:r>
+                    </a:p>
+                  </a:txBody>
+                  <a:tcPr marL="54864" marR="54864" marT="18288" marB="18288">
+                    <a:solidFill>
+                      <a:srgbClr val="FFFFFF"/>
+                    </a:solidFill>
+                  </a:tcPr>
+                </a:tc>
+                <a:tc>
+                  <a:txBody>
+                    <a:bodyPr wrap="square"/>
+                    <a:lstStyle/>
+                    <a:p>
+                      <a:r>
+                        <a:rPr sz="1100" b="0">
+                          <a:solidFill>
+                            <a:srgbClr val="282828"/>
+                          </a:solidFill>
+                          <a:latin typeface="Arial"/>
+                        </a:rPr>
+                        <a:t>12 / 11 h</a:t>
+                      </a:r>
+                    </a:p>
+                  </a:txBody>
+                  <a:tcPr marL="54864" marR="54864" marT="18288" marB="18288">
+                    <a:solidFill>
+                      <a:srgbClr val="FFFFFF"/>
                     </a:solidFill>
                   </a:tcPr>
                 </a:tc>
@@ -4697,140 +4831,6 @@
                           </a:solidFill>
                           <a:latin typeface="Arial"/>
                         </a:rPr>
-                        <a:t>as proposed: 1k², 60 ke, 30 fps</a:t>
-                      </a:r>
-                    </a:p>
-                  </a:txBody>
-                  <a:tcPr marL="54864" marR="54864" marT="18288" marB="18288">
-                    <a:solidFill>
-                      <a:srgbClr val="FFFFFF"/>
-                    </a:solidFill>
-                  </a:tcPr>
-                </a:tc>
-                <a:tc>
-                  <a:txBody>
-                    <a:bodyPr wrap="square"/>
-                    <a:lstStyle/>
-                    <a:p>
-                      <a:r>
-                        <a:rPr sz="1100" b="0">
-                          <a:solidFill>
-                            <a:srgbClr val="282828"/>
-                          </a:solidFill>
-                          <a:latin typeface="Arial"/>
-                        </a:rPr>
-                        <a:t>5 assumed (1.000)</a:t>
-                      </a:r>
-                    </a:p>
-                  </a:txBody>
-                  <a:tcPr marL="54864" marR="54864" marT="18288" marB="18288">
-                    <a:solidFill>
-                      <a:srgbClr val="FFFFFF"/>
-                    </a:solidFill>
-                  </a:tcPr>
-                </a:tc>
-                <a:tc>
-                  <a:txBody>
-                    <a:bodyPr wrap="square"/>
-                    <a:lstStyle/>
-                    <a:p>
-                      <a:r>
-                        <a:rPr sz="1100" b="0">
-                          <a:solidFill>
-                            <a:srgbClr val="282828"/>
-                          </a:solidFill>
-                          <a:latin typeface="Arial"/>
-                        </a:rPr>
-                        <a:t>57.7 / 53.7</a:t>
-                      </a:r>
-                    </a:p>
-                  </a:txBody>
-                  <a:tcPr marL="54864" marR="54864" marT="18288" marB="18288">
-                    <a:solidFill>
-                      <a:srgbClr val="FFFFFF"/>
-                    </a:solidFill>
-                  </a:tcPr>
-                </a:tc>
-                <a:tc>
-                  <a:txBody>
-                    <a:bodyPr wrap="square"/>
-                    <a:lstStyle/>
-                    <a:p>
-                      <a:r>
-                        <a:rPr sz="1100" b="0">
-                          <a:solidFill>
-                            <a:srgbClr val="282828"/>
-                          </a:solidFill>
-                          <a:latin typeface="Arial"/>
-                        </a:rPr>
-                        <a:t>0.017</a:t>
-                      </a:r>
-                    </a:p>
-                  </a:txBody>
-                  <a:tcPr marL="54864" marR="54864" marT="18288" marB="18288">
-                    <a:solidFill>
-                      <a:srgbClr val="FFFFFF"/>
-                    </a:solidFill>
-                  </a:tcPr>
-                </a:tc>
-                <a:tc>
-                  <a:txBody>
-                    <a:bodyPr wrap="square"/>
-                    <a:lstStyle/>
-                    <a:p>
-                      <a:r>
-                        <a:rPr sz="1100" b="0">
-                          <a:solidFill>
-                            <a:srgbClr val="282828"/>
-                          </a:solidFill>
-                          <a:latin typeface="Arial"/>
-                        </a:rPr>
-                        <a:t>443 / 385 (≈ 7 min)</a:t>
-                      </a:r>
-                    </a:p>
-                  </a:txBody>
-                  <a:tcPr marL="54864" marR="54864" marT="18288" marB="18288">
-                    <a:solidFill>
-                      <a:srgbClr val="FFFFFF"/>
-                    </a:solidFill>
-                  </a:tcPr>
-                </a:tc>
-                <a:tc>
-                  <a:txBody>
-                    <a:bodyPr wrap="square"/>
-                    <a:lstStyle/>
-                    <a:p>
-                      <a:r>
-                        <a:rPr sz="1100" b="0">
-                          <a:solidFill>
-                            <a:srgbClr val="282828"/>
-                          </a:solidFill>
-                          <a:latin typeface="Arial"/>
-                        </a:rPr>
-                        <a:t>12 / 11 h</a:t>
-                      </a:r>
-                    </a:p>
-                  </a:txBody>
-                  <a:tcPr marL="54864" marR="54864" marT="18288" marB="18288">
-                    <a:solidFill>
-                      <a:srgbClr val="FFFFFF"/>
-                    </a:solidFill>
-                  </a:tcPr>
-                </a:tc>
-              </a:tr>
-              <a:tr h="468630">
-                <a:tc>
-                  <a:txBody>
-                    <a:bodyPr wrap="square"/>
-                    <a:lstStyle/>
-                    <a:p>
-                      <a:r>
-                        <a:rPr sz="1100" b="0">
-                          <a:solidFill>
-                            <a:srgbClr val="282828"/>
-                          </a:solidFill>
-                          <a:latin typeface="Arial"/>
-                        </a:rPr>
                         <a:t>Photonfocus MV1-D1024E, 200 ke, 150 fps</a:t>
                       </a:r>
                     </a:p>
@@ -5220,130 +5220,130 @@
                   </a:tcPr>
                 </a:tc>
               </a:tr>
-              <a:tr h="845820">
-                <a:tc>
-                  <a:txBody>
-                    <a:bodyPr wrap="square"/>
-                    <a:lstStyle/>
-                    <a:p>
-                      <a:r>
-                        <a:rPr sz="1100" b="0">
-                          <a:solidFill>
-                            <a:srgbClr val="282828"/>
-                          </a:solidFill>
-                          <a:latin typeface="Arial"/>
-                        </a:rPr>
-                        <a:t>lock-in camera, heliCam C4, 500 ke, I/Q at 1 kHz (format stage; well-capped)</a:t>
-                      </a:r>
-                    </a:p>
-                  </a:txBody>
-                  <a:tcPr marL="54864" marR="54864" marT="18288" marB="18288">
-                    <a:solidFill>
-                      <a:srgbClr val="FFFFFF"/>
-                    </a:solidFill>
-                  </a:tcPr>
-                </a:tc>
-                <a:tc>
-                  <a:txBody>
-                    <a:bodyPr wrap="square"/>
-                    <a:lstStyle/>
-                    <a:p>
-                      <a:r>
-                        <a:rPr sz="1100" b="0">
-                          <a:solidFill>
-                            <a:srgbClr val="282828"/>
-                          </a:solidFill>
-                          <a:latin typeface="Arial"/>
-                        </a:rPr>
-                        <a:t>n/s (survey)</a:t>
-                      </a:r>
-                    </a:p>
-                  </a:txBody>
-                  <a:tcPr marL="54864" marR="54864" marT="18288" marB="18288">
-                    <a:solidFill>
-                      <a:srgbClr val="FFFFFF"/>
-                    </a:solidFill>
-                  </a:tcPr>
-                </a:tc>
-                <a:tc>
-                  <a:txBody>
-                    <a:bodyPr wrap="square"/>
-                    <a:lstStyle/>
-                    <a:p>
-                      <a:r>
-                        <a:rPr sz="1100" b="0">
-                          <a:solidFill>
-                            <a:srgbClr val="282828"/>
-                          </a:solidFill>
-                          <a:latin typeface="Arial"/>
-                        </a:rPr>
-                        <a:t>34 per 1 ms I/Q frame; 1.07 in 1 s</a:t>
-                      </a:r>
-                    </a:p>
-                  </a:txBody>
-                  <a:tcPr marL="54864" marR="54864" marT="18288" marB="18288">
-                    <a:solidFill>
-                      <a:srgbClr val="FFFFFF"/>
-                    </a:solidFill>
-                  </a:tcPr>
-                </a:tc>
-                <a:tc>
-                  <a:txBody>
-                    <a:bodyPr wrap="square"/>
-                    <a:lstStyle/>
-                    <a:p>
-                      <a:r>
-                        <a:rPr sz="1100" b="0">
-                          <a:solidFill>
-                            <a:srgbClr val="282828"/>
-                          </a:solidFill>
-                          <a:latin typeface="Arial"/>
-                        </a:rPr>
-                        <a:t>0.03 per frame</a:t>
-                      </a:r>
-                    </a:p>
-                  </a:txBody>
-                  <a:tcPr marL="54864" marR="54864" marT="18288" marB="18288">
-                    <a:solidFill>
-                      <a:srgbClr val="FFFFFF"/>
-                    </a:solidFill>
-                  </a:tcPr>
-                </a:tc>
-                <a:tc>
-                  <a:txBody>
-                    <a:bodyPr wrap="square"/>
-                    <a:lstStyle/>
-                    <a:p>
-                      <a:r>
-                        <a:rPr sz="1100" b="0">
-                          <a:solidFill>
-                            <a:srgbClr val="282828"/>
-                          </a:solidFill>
-                          <a:latin typeface="Arial"/>
-                        </a:rPr>
-                        <a:t>1.1</a:t>
-                      </a:r>
-                    </a:p>
-                  </a:txBody>
-                  <a:tcPr marL="54864" marR="54864" marT="18288" marB="18288">
-                    <a:solidFill>
-                      <a:srgbClr val="FFFFFF"/>
-                    </a:solidFill>
-                  </a:tcPr>
-                </a:tc>
-                <a:tc>
-                  <a:txBody>
-                    <a:bodyPr wrap="square"/>
-                    <a:lstStyle/>
-                    <a:p>
-                      <a:r>
-                        <a:rPr sz="1100" b="0">
-                          <a:solidFill>
-                            <a:srgbClr val="282828"/>
-                          </a:solidFill>
-                          <a:latin typeface="Arial"/>
-                        </a:rPr>
-                        <a:t>110 s</a:t>
+              <a:tr h="1034415">
+                <a:tc>
+                  <a:txBody>
+                    <a:bodyPr wrap="square"/>
+                    <a:lstStyle/>
+                    <a:p>
+                      <a:r>
+                        <a:rPr sz="1100" b="0">
+                          <a:solidFill>
+                            <a:srgbClr val="282828"/>
+                          </a:solidFill>
+                          <a:latin typeface="Arial"/>
+                        </a:rPr>
+                        <a:t>lock-in camera, heliCam C4, 500 ke, I/Q at 1 kHz (the lock-in reading, mirror rig; well-capped)</a:t>
+                      </a:r>
+                    </a:p>
+                  </a:txBody>
+                  <a:tcPr marL="54864" marR="54864" marT="18288" marB="18288">
+                    <a:solidFill>
+                      <a:srgbClr val="FFFFFF"/>
+                    </a:solidFill>
+                  </a:tcPr>
+                </a:tc>
+                <a:tc>
+                  <a:txBody>
+                    <a:bodyPr wrap="square"/>
+                    <a:lstStyle/>
+                    <a:p>
+                      <a:r>
+                        <a:rPr sz="1100" b="0">
+                          <a:solidFill>
+                            <a:srgbClr val="282828"/>
+                          </a:solidFill>
+                          <a:latin typeface="Arial"/>
+                        </a:rPr>
+                        <a:t>n/s: run at 0 and at 100 assumed (1.09)</a:t>
+                      </a:r>
+                    </a:p>
+                  </a:txBody>
+                  <a:tcPr marL="54864" marR="54864" marT="18288" marB="18288">
+                    <a:solidFill>
+                      <a:srgbClr val="FFFFFF"/>
+                    </a:solidFill>
+                  </a:tcPr>
+                </a:tc>
+                <a:tc>
+                  <a:txBody>
+                    <a:bodyPr wrap="square"/>
+                    <a:lstStyle/>
+                    <a:p>
+                      <a:r>
+                        <a:rPr sz="1100" b="0">
+                          <a:solidFill>
+                            <a:srgbClr val="282828"/>
+                          </a:solidFill>
+                          <a:latin typeface="Arial"/>
+                        </a:rPr>
+                        <a:t>58 (read 0) / 63 (read 100) per 1 ms sample; 1.8 in 1 s</a:t>
+                      </a:r>
+                    </a:p>
+                  </a:txBody>
+                  <a:tcPr marL="54864" marR="54864" marT="18288" marB="18288">
+                    <a:solidFill>
+                      <a:srgbClr val="FFFFFF"/>
+                    </a:solidFill>
+                  </a:tcPr>
+                </a:tc>
+                <a:tc>
+                  <a:txBody>
+                    <a:bodyPr wrap="square"/>
+                    <a:lstStyle/>
+                    <a:p>
+                      <a:r>
+                        <a:rPr sz="1100" b="0">
+                          <a:solidFill>
+                            <a:srgbClr val="282828"/>
+                          </a:solidFill>
+                          <a:latin typeface="Arial"/>
+                        </a:rPr>
+                        <a:t>0.017 per sample</a:t>
+                      </a:r>
+                    </a:p>
+                  </a:txBody>
+                  <a:tcPr marL="54864" marR="54864" marT="18288" marB="18288">
+                    <a:solidFill>
+                      <a:srgbClr val="FFFFFF"/>
+                    </a:solidFill>
+                  </a:tcPr>
+                </a:tc>
+                <a:tc>
+                  <a:txBody>
+                    <a:bodyPr wrap="square"/>
+                    <a:lstStyle/>
+                    <a:p>
+                      <a:r>
+                        <a:rPr sz="1100" b="0">
+                          <a:solidFill>
+                            <a:srgbClr val="282828"/>
+                          </a:solidFill>
+                          <a:latin typeface="Arial"/>
+                        </a:rPr>
+                        <a:t>3.4 / 4.0 (×1.11 square-wave)</a:t>
+                      </a:r>
+                    </a:p>
+                  </a:txBody>
+                  <a:tcPr marL="54864" marR="54864" marT="18288" marB="18288">
+                    <a:solidFill>
+                      <a:srgbClr val="FFFFFF"/>
+                    </a:solidFill>
+                  </a:tcPr>
+                </a:tc>
+                <a:tc>
+                  <a:txBody>
+                    <a:bodyPr wrap="square"/>
+                    <a:lstStyle/>
+                    <a:p>
+                      <a:r>
+                        <a:rPr sz="1100" b="0">
+                          <a:solidFill>
+                            <a:srgbClr val="282828"/>
+                          </a:solidFill>
+                          <a:latin typeface="Arial"/>
+                        </a:rPr>
+                        <a:t>5.7 / 6.7 min</a:t>
                       </a:r>
                     </a:p>
                   </a:txBody>
@@ -5366,7 +5366,7 @@
         </p:nvSpPr>
         <p:spPr>
           <a:xfrm>
-            <a:off x="411480" y="5388102"/>
+            <a:off x="411480" y="5953887"/>
             <a:ext cx="5806440" cy="274320"/>
           </a:xfrm>
           <a:prstGeom prst="rect">
@@ -5642,7 +5642,7 @@
                 </a:solidFill>
                 <a:latin typeface="Arial"/>
               </a:rPr>
-              <a:t>Stage noise (runs/noise_{lens,oap}[_plain]), 12 draws, cameras binned onto the model grid (well × k², read × k, frame mean at half well).</a:t>
+              <a:t>Stage noise (runs/noise_{lens,oap}[_plain]), 12 draws, cameras binned onto the model grid (well × k², read × k, frame mean at half well).  Mask convention from the lock-in runs on: the LO-only annulus (no test light) is filled with the fringe pixels' median, not zero — a zero there made any common phase a pupil-edge step the edge actuators fit; the bucket camera's electronics rows move ≤ 9 % under it.</a:t>
             </a:r>
           </a:p>
         </p:txBody>
@@ -5774,7 +5774,7 @@
         </p:nvGraphicFramePr>
         <p:xfrm>
           <a:off x="411480" y="1298448"/>
-          <a:ext cx="5806439" cy="4309110"/>
+          <a:ext cx="5806439" cy="3931920"/>
         </p:xfrm>
         <a:graphic>
           <a:graphicData uri="http://schemas.openxmlformats.org/drawingml/2006/table">
@@ -5783,8 +5783,8 @@
                 <a:tableStyleId>{5C22544A-7EE6-4342-B048-85BDC9FD1C3A}</a:tableStyleId>
               </a:tblPr>
               <a:tblGrid>
-                <a:gridCol w="2920398"/>
-                <a:gridCol w="2886041"/>
+                <a:gridCol w="3515463"/>
+                <a:gridCol w="2290976"/>
               </a:tblGrid>
               <a:tr h="280035">
                 <a:tc>
@@ -5878,6 +5878,52 @@
                   </a:tcPr>
                 </a:tc>
               </a:tr>
+              <a:tr h="280035">
+                <a:tc>
+                  <a:txBody>
+                    <a:bodyPr wrap="square"/>
+                    <a:lstStyle/>
+                    <a:p>
+                      <a:r>
+                        <a:rPr sz="1100" b="0">
+                          <a:solidFill>
+                            <a:srgbClr val="282828"/>
+                          </a:solidFill>
+                          <a:latin typeface="Arial"/>
+                        </a:rPr>
+                        <a:t>noise only, Photonfocus (60 readings, 1.6 s)</a:t>
+                      </a:r>
+                    </a:p>
+                  </a:txBody>
+                  <a:tcPr marL="54864" marR="54864" marT="18288" marB="18288">
+                    <a:solidFill>
+                      <a:srgbClr val="ECF1F6"/>
+                    </a:solidFill>
+                  </a:tcPr>
+                </a:tc>
+                <a:tc>
+                  <a:txBody>
+                    <a:bodyPr wrap="square"/>
+                    <a:lstStyle/>
+                    <a:p>
+                      <a:r>
+                        <a:rPr sz="1100" b="0">
+                          <a:solidFill>
+                            <a:srgbClr val="282828"/>
+                          </a:solidFill>
+                          <a:latin typeface="Arial"/>
+                        </a:rPr>
+                        <a:t>2.60 / 2.52</a:t>
+                      </a:r>
+                    </a:p>
+                  </a:txBody>
+                  <a:tcPr marL="54864" marR="54864" marT="18288" marB="18288">
+                    <a:solidFill>
+                      <a:srgbClr val="ECF1F6"/>
+                    </a:solidFill>
+                  </a:tcPr>
+                </a:tc>
+              </a:tr>
               <a:tr h="468630">
                 <a:tc>
                   <a:txBody>
@@ -5891,75 +5937,29 @@
                           </a:solidFill>
                           <a:latin typeface="Arial"/>
                         </a:rPr>
-                        <a:t>noise only, Photonfocus (60 readings, 1.6 s)</a:t>
-                      </a:r>
-                    </a:p>
-                  </a:txBody>
-                  <a:tcPr marL="54864" marR="54864" marT="18288" marB="18288">
-                    <a:solidFill>
-                      <a:srgbClr val="ECF1F6"/>
-                    </a:solidFill>
-                  </a:tcPr>
-                </a:tc>
-                <a:tc>
-                  <a:txBody>
-                    <a:bodyPr wrap="square"/>
-                    <a:lstStyle/>
-                    <a:p>
-                      <a:r>
-                        <a:rPr sz="1100" b="0">
-                          <a:solidFill>
-                            <a:srgbClr val="282828"/>
-                          </a:solidFill>
-                          <a:latin typeface="Arial"/>
-                        </a:rPr>
-                        <a:t>2.60 / 2.52</a:t>
-                      </a:r>
-                    </a:p>
-                  </a:txBody>
-                  <a:tcPr marL="54864" marR="54864" marT="18288" marB="18288">
-                    <a:solidFill>
-                      <a:srgbClr val="ECF1F6"/>
-                    </a:solidFill>
-                  </a:tcPr>
-                </a:tc>
-              </a:tr>
-              <a:tr h="657225">
-                <a:tc>
-                  <a:txBody>
-                    <a:bodyPr wrap="square"/>
-                    <a:lstStyle/>
-                    <a:p>
-                      <a:r>
-                        <a:rPr sz="1100" b="0">
-                          <a:solidFill>
-                            <a:srgbClr val="282828"/>
-                          </a:solidFill>
-                          <a:latin typeface="Arial"/>
-                        </a:rPr>
-                        <a:t>noise only, lock-in camera (I/Q frames at 1 kHz; ~44 frames per cycle, a 44 ms cycle)</a:t>
-                      </a:r>
-                    </a:p>
-                  </a:txBody>
-                  <a:tcPr marL="54864" marR="54864" marT="18288" marB="18288">
-                    <a:solidFill>
-                      <a:srgbClr val="FFFFFF"/>
-                    </a:solidFill>
-                  </a:tcPr>
-                </a:tc>
-                <a:tc>
-                  <a:txBody>
-                    <a:bodyPr wrap="square"/>
-                    <a:lstStyle/>
-                    <a:p>
-                      <a:r>
-                        <a:rPr sz="1100" b="0">
-                          <a:solidFill>
-                            <a:srgbClr val="282828"/>
-                          </a:solidFill>
-                          <a:latin typeface="Arial"/>
-                        </a:rPr>
-                        <a:t>~2.6 (derived from the format stage's 34 pm per frame; the loop not yet run with it)</a:t>
+                        <a:t>noise only, lock-in camera (I/Q samples at 1 kHz; ~130 samples per cycle, a 0.13 s cycle)</a:t>
+                      </a:r>
+                    </a:p>
+                  </a:txBody>
+                  <a:tcPr marL="54864" marR="54864" marT="18288" marB="18288">
+                    <a:solidFill>
+                      <a:srgbClr val="FFFFFF"/>
+                    </a:solidFill>
+                  </a:tcPr>
+                </a:tc>
+                <a:tc>
+                  <a:txBody>
+                    <a:bodyPr wrap="square"/>
+                    <a:lstStyle/>
+                    <a:p>
+                      <a:r>
+                        <a:rPr sz="1100" b="0">
+                          <a:solidFill>
+                            <a:srgbClr val="282828"/>
+                          </a:solidFill>
+                          <a:latin typeface="Arial"/>
+                        </a:rPr>
+                        <a:t>~2.6 (derived from 58 pm per sample; the loop run pending)</a:t>
                       </a:r>
                     </a:p>
                   </a:txBody>
@@ -6062,7 +6062,7 @@
                   </a:tcPr>
                 </a:tc>
               </a:tr>
-              <a:tr h="280035">
+              <a:tr h="468630">
                 <a:tc>
                   <a:txBody>
                     <a:bodyPr wrap="square"/>
@@ -6200,7 +6200,7 @@
                   </a:tcPr>
                 </a:tc>
               </a:tr>
-              <a:tr h="468630">
+              <a:tr h="280035">
                 <a:tc>
                   <a:txBody>
                     <a:bodyPr wrap="square"/>
@@ -7034,7 +7034,7 @@
                 </a:solidFill>
                 <a:latin typeface="Arial"/>
               </a:rPr>
-              <a:t> one reference at a time, so the two colors are read on alternate I/Q frames (2 ms per pair) — the same synthetic-wavelength capture, sequential; temporal unwrapping at 1 kHz tolerates 0.9 × λ/4 per ms ≈ 140 µm/s at the peak pixel (derived from the frame rate; not yet run).</a:t>
+              <a:t> one reference at a time, so the two colors are read on alternate I/Q samples (2 ms per pair) — the same synthetic-wavelength capture, sequential; temporal unwrapping at 1 kHz tolerates 0.9 × λ/4 per ms ≈ 140 µm/s at the peak pixel (derived from the frame rate; not yet run).</a:t>
             </a:r>
           </a:p>
         </p:txBody>
@@ -7698,7 +7698,7 @@
         </p:nvGraphicFramePr>
         <p:xfrm>
           <a:off x="411480" y="1298448"/>
-          <a:ext cx="11368733" cy="5160645"/>
+          <a:ext cx="11368732" cy="5349240"/>
         </p:xfrm>
         <a:graphic>
           <a:graphicData uri="http://schemas.openxmlformats.org/drawingml/2006/table">
@@ -7707,11 +7707,11 @@
                 <a:tableStyleId>{5C22544A-7EE6-4342-B048-85BDC9FD1C3A}</a:tableStyleId>
               </a:tblPr>
               <a:tblGrid>
-                <a:gridCol w="1681962"/>
-                <a:gridCol w="2130485"/>
-                <a:gridCol w="1822126"/>
-                <a:gridCol w="1345570"/>
-                <a:gridCol w="1990322"/>
+                <a:gridCol w="1626066"/>
+                <a:gridCol w="2140987"/>
+                <a:gridCol w="1978380"/>
+                <a:gridCol w="1300853"/>
+                <a:gridCol w="1924178"/>
                 <a:gridCol w="2398268"/>
               </a:tblGrid>
               <a:tr h="657225">
@@ -8776,7 +8776,7 @@
                   </a:tcPr>
                 </a:tc>
               </a:tr>
-              <a:tr h="468630">
+              <a:tr h="657225">
                 <a:tc>
                   <a:txBody>
                     <a:bodyPr wrap="square"/>
@@ -8811,7 +8811,7 @@
                           </a:solidFill>
                           <a:latin typeface="Arial"/>
                         </a:rPr>
-                        <a:t>~180–260 s (assumed polarization camera, 3.8 × 10¹² e⁻/s)</a:t>
+                        <a:t>189 / 160 s (lens / mirror; IMX250MZR-class polarization camera, record camI_*)</a:t>
                       </a:r>
                     </a:p>
                   </a:txBody>
@@ -8833,7 +8833,7 @@
                           </a:solidFill>
                           <a:latin typeface="Arial"/>
                         </a:rPr>
-                        <a:t>~32 s stepped / ~12 s vector (same camera)</a:t>
+                        <a:t>TO's rerun pending (a first cut was optimistic by ~2.5× and is withdrawn)</a:t>
                       </a:r>
                     </a:p>
                   </a:txBody>
@@ -8855,7 +8855,7 @@
                           </a:solidFill>
                           <a:latin typeface="Arial"/>
                         </a:rPr>
-                        <a:t>~39 s</a:t>
+                        <a:t>pending</a:t>
                       </a:r>
                     </a:p>
                   </a:txBody>
@@ -8899,7 +8899,7 @@
                           </a:solidFill>
                           <a:latin typeface="Arial"/>
                         </a:rPr>
-                        <a:t>1.1</a:t>
+                        <a:t>3.4 / 4.0</a:t>
                       </a:r>
                     </a:p>
                   </a:txBody>
@@ -8922,7 +8922,7 @@
         </p:nvSpPr>
         <p:spPr>
           <a:xfrm>
-            <a:off x="411480" y="6605397"/>
+            <a:off x="411480" y="6793992"/>
             <a:ext cx="11368735" cy="274320"/>
           </a:xfrm>
           <a:prstGeom prst="rect">
@@ -8948,7 +8948,7 @@
                 </a:solidFill>
                 <a:latin typeface="Arial"/>
               </a:rPr>
-              <a:t>The polarization-camera timings are a first cut: the gauge deck's photons per measurement divided by an assumed Sony IMX250MZR-class camera (2448 × 2048, ~10 ke⁻, 75 fps → 3.8 × 10¹² e⁻/s); TO runs them through the noise hook for the composite deck.  Parts counts and TRL to follow (campaign brief sec. 9.1).</a:t>
+              <a:t>The IFO timing is TO's record (the four analyzer frames in one exposure on an IMX250MZR-class camera, 2448 × 2048, 75 fps; well ~10 ke⁻ and read 2.4 e⁻ unconfirmed); the sensors' timings follow when TO's rerun lands.  Parts counts and TRL to follow (campaign brief sec. 9.1).</a:t>
             </a:r>
           </a:p>
         </p:txBody>
@@ -10421,10 +10421,10 @@
               </a:tblPr>
               <a:tblGrid>
                 <a:gridCol w="2325624"/>
-                <a:gridCol w="1631194"/>
-                <a:gridCol w="1717046"/>
-                <a:gridCol w="1030227"/>
-                <a:gridCol w="4664642"/>
+                <a:gridCol w="1840919"/>
+                <a:gridCol w="1937809"/>
+                <a:gridCol w="1162685"/>
+                <a:gridCol w="4101696"/>
               </a:tblGrid>
               <a:tr h="657225">
                 <a:tc>
@@ -10629,7 +10629,7 @@
                           </a:solidFill>
                           <a:latin typeface="Arial"/>
                         </a:rPr>
-                        <a:t>~44 samples at the well-capped rate (≈ 3 × 10¹² e⁻ per cycle: 2.8 × 10⁵ elements × 250 ke per sample at half well × 44 samples — from the sheet) — loop run pending</a:t>
+                        <a:t>~130 samples at the well-capped rate (≈ 9 × 10¹² e⁻ per cycle: 2.8 × 10⁵ elements × 250 ke per sample × 130) — loop run pending</a:t>
                       </a:r>
                     </a:p>
                   </a:txBody>
@@ -10741,7 +10741,7 @@
                           </a:solidFill>
                           <a:latin typeface="Arial"/>
                         </a:rPr>
-                        <a:t>~44 ms (derived; loop run pending)</a:t>
+                        <a:t>~0.13 s (derived; loop run pending)</a:t>
                       </a:r>
                     </a:p>
                   </a:txBody>
@@ -10787,7 +10787,7 @@
                           </a:solidFill>
                           <a:latin typeface="Arial"/>
                         </a:rPr>
-                        <a:t>~12 (polarization camera, first cut)</a:t>
+                        <a:t>first cut withdrawn (TO's rerun pending)</a:t>
                       </a:r>
                     </a:p>
                   </a:txBody>
@@ -10853,7 +10853,7 @@
                           </a:solidFill>
                           <a:latin typeface="Arial"/>
                         </a:rPr>
-                        <a:t>1.1 (×1.11 for square-wave demodulation)</a:t>
+                        <a:t>3.4 / 4.0 (read 0 / 100; ×1.11 for square-wave demodulation)</a:t>
                       </a:r>
                     </a:p>
                   </a:txBody>
@@ -11498,7 +11498,7 @@
                 </a:solidFill>
                 <a:latin typeface="Arial"/>
               </a:rPr>
-              <a:t> (sub-second cycles, 1.1 s per pm) — if its well behaves as surveyed, and with the fiber term reduced to a piston.</a:t>
+              <a:t> (0.13 s cycles, 3.4 s per pm) — if its well behaves as surveyed, and with the fiber term reduced to a piston.</a:t>
             </a:r>
           </a:p>
           <a:p>
@@ -12571,7 +12571,7 @@
                           </a:solidFill>
                           <a:latin typeface="Arial"/>
                         </a:rPr>
-                        <a:t>40× the Photonfocus's speed as surveyed; the well-free question is another 4–40×</a:t>
+                        <a:t>~12× the Photonfocus's speed as surveyed (3.4 s per pm); the well-free question is the next factor</a:t>
                       </a:r>
                     </a:p>
                   </a:txBody>
@@ -14345,7 +14345,7 @@
         </p:nvGraphicFramePr>
         <p:xfrm>
           <a:off x="411480" y="1298448"/>
-          <a:ext cx="11368734" cy="2800350"/>
+          <a:ext cx="11368734" cy="2988945"/>
         </p:xfrm>
         <a:graphic>
           <a:graphicData uri="http://schemas.openxmlformats.org/drawingml/2006/table">
@@ -14355,8 +14355,8 @@
               </a:tblPr>
               <a:tblGrid>
                 <a:gridCol w="1526540"/>
-                <a:gridCol w="4395543"/>
-                <a:gridCol w="5446651"/>
+                <a:gridCol w="3813850"/>
+                <a:gridCol w="6028344"/>
               </a:tblGrid>
               <a:tr h="280035">
                 <a:tc>
@@ -14902,7 +14902,7 @@
                   </a:tcPr>
                 </a:tc>
               </a:tr>
-              <a:tr h="280035">
+              <a:tr h="468630">
                 <a:tc>
                   <a:txBody>
                     <a:bodyPr wrap="square"/>
@@ -14937,7 +14937,7 @@
                           </a:solidFill>
                           <a:latin typeface="Arial"/>
                         </a:rPr>
-                        <a:t>runs/format_lens_plain</a:t>
+                        <a:t>runs/format_lens_plain; corrected by runs/lockin_noise_oap_med</a:t>
                       </a:r>
                     </a:p>
                   </a:txBody>
@@ -14959,7 +14959,7 @@
                           </a:solidFill>
                           <a:latin typeface="Arial"/>
                         </a:rPr>
-                        <a:t>the lock-in class: 1.1 s per pm well-capped</a:t>
+                        <a:t>the lock-in class: 3.4 s per pm well-capped (the format stage's 1.1 counted four wells per sample)</a:t>
                       </a:r>
                     </a:p>
                   </a:txBody>
@@ -15050,7 +15050,7 @@
         </p:nvSpPr>
         <p:spPr>
           <a:xfrm>
-            <a:off x="411480" y="4245102"/>
+            <a:off x="411480" y="4433697"/>
             <a:ext cx="11368735" cy="274320"/>
           </a:xfrm>
           <a:prstGeom prst="rect">
@@ -15628,7 +15628,7 @@
         </p:nvGraphicFramePr>
         <p:xfrm>
           <a:off x="6400800" y="1298448"/>
-          <a:ext cx="5394959" cy="2617470"/>
+          <a:ext cx="5394960" cy="3646170"/>
         </p:xfrm>
         <a:graphic>
           <a:graphicData uri="http://schemas.openxmlformats.org/drawingml/2006/table">
@@ -15637,11 +15637,11 @@
                 <a:tableStyleId>{5C22544A-7EE6-4342-B048-85BDC9FD1C3A}</a:tableStyleId>
               </a:tblPr>
               <a:tblGrid>
-                <a:gridCol w="2034941"/>
-                <a:gridCol w="1467050"/>
-                <a:gridCol w="1892968"/>
+                <a:gridCol w="1310640"/>
+                <a:gridCol w="944880"/>
+                <a:gridCol w="3139440"/>
               </a:tblGrid>
-              <a:tr h="434340">
+              <a:tr h="605790">
                 <a:tc>
                   <a:txBody>
                     <a:bodyPr wrap="square"/>
@@ -15777,7 +15777,7 @@
                   </a:tcPr>
                 </a:tc>
               </a:tr>
-              <a:tr h="262890">
+              <a:tr h="434340">
                 <a:tc>
                   <a:txBody>
                     <a:bodyPr wrap="square"/>
@@ -15913,7 +15913,7 @@
                   </a:tcPr>
                 </a:tc>
               </a:tr>
-              <a:tr h="262890">
+              <a:tr h="434340">
                 <a:tc>
                   <a:txBody>
                     <a:bodyPr wrap="square"/>
@@ -15970,7 +15970,143 @@
                           </a:solidFill>
                           <a:latin typeface="Arial"/>
                         </a:rPr>
-                        <a:t>34 pm per 1 ms I/Q frame</a:t>
+                        <a:t>58 pm per 1 ms I/Q sample (63 at an assumed 100 e⁻ read)</a:t>
+                      </a:r>
+                    </a:p>
+                  </a:txBody>
+                  <a:tcPr marL="54864" marR="54864" marT="18288" marB="18288">
+                    <a:solidFill>
+                      <a:srgbClr val="ECF1F6"/>
+                    </a:solidFill>
+                  </a:tcPr>
+                </a:tc>
+              </a:tr>
+              <a:tr h="605790">
+                <a:tc>
+                  <a:txBody>
+                    <a:bodyPr wrap="square"/>
+                    <a:lstStyle/>
+                    <a:p>
+                      <a:r>
+                        <a:rPr sz="1000" b="0">
+                          <a:solidFill>
+                            <a:srgbClr val="282828"/>
+                          </a:solidFill>
+                          <a:latin typeface="Arial"/>
+                        </a:rPr>
+                        <a:t>seconds per pm</a:t>
+                      </a:r>
+                    </a:p>
+                  </a:txBody>
+                  <a:tcPr marL="54864" marR="54864" marT="18288" marB="18288">
+                    <a:solidFill>
+                      <a:srgbClr val="FFFFFF"/>
+                    </a:solidFill>
+                  </a:tcPr>
+                </a:tc>
+                <a:tc>
+                  <a:txBody>
+                    <a:bodyPr wrap="square"/>
+                    <a:lstStyle/>
+                    <a:p>
+                      <a:r>
+                        <a:rPr sz="1000" b="0">
+                          <a:solidFill>
+                            <a:srgbClr val="282828"/>
+                          </a:solidFill>
+                          <a:latin typeface="Arial"/>
+                        </a:rPr>
+                        <a:t>42</a:t>
+                      </a:r>
+                    </a:p>
+                  </a:txBody>
+                  <a:tcPr marL="54864" marR="54864" marT="18288" marB="18288">
+                    <a:solidFill>
+                      <a:srgbClr val="FFFFFF"/>
+                    </a:solidFill>
+                  </a:tcPr>
+                </a:tc>
+                <a:tc>
+                  <a:txBody>
+                    <a:bodyPr wrap="square"/>
+                    <a:lstStyle/>
+                    <a:p>
+                      <a:r>
+                        <a:rPr sz="1000" b="0">
+                          <a:solidFill>
+                            <a:srgbClr val="282828"/>
+                          </a:solidFill>
+                          <a:latin typeface="Arial"/>
+                        </a:rPr>
+                        <a:t>3.4 (read 0) / 4.0 (read 100 assumed); ×1.11 for square-wave demodulation — well-capped at the I/Q rate</a:t>
+                      </a:r>
+                    </a:p>
+                  </a:txBody>
+                  <a:tcPr marL="54864" marR="54864" marT="18288" marB="18288">
+                    <a:solidFill>
+                      <a:srgbClr val="FFFFFF"/>
+                    </a:solidFill>
+                  </a:tcPr>
+                </a:tc>
+              </a:tr>
+              <a:tr h="605790">
+                <a:tc>
+                  <a:txBody>
+                    <a:bodyPr wrap="square"/>
+                    <a:lstStyle/>
+                    <a:p>
+                      <a:r>
+                        <a:rPr sz="1000" b="0">
+                          <a:solidFill>
+                            <a:srgbClr val="282828"/>
+                          </a:solidFill>
+                          <a:latin typeface="Arial"/>
+                        </a:rPr>
+                        <a:t>if well-free at 10⁹ / 10¹⁰ e⁻/s per element</a:t>
+                      </a:r>
+                    </a:p>
+                  </a:txBody>
+                  <a:tcPr marL="54864" marR="54864" marT="18288" marB="18288">
+                    <a:solidFill>
+                      <a:srgbClr val="ECF1F6"/>
+                    </a:solidFill>
+                  </a:tcPr>
+                </a:tc>
+                <a:tc>
+                  <a:txBody>
+                    <a:bodyPr wrap="square"/>
+                    <a:lstStyle/>
+                    <a:p>
+                      <a:r>
+                        <a:rPr sz="1000" b="0">
+                          <a:solidFill>
+                            <a:srgbClr val="282828"/>
+                          </a:solidFill>
+                          <a:latin typeface="Arial"/>
+                        </a:rPr>
+                        <a:t>—</a:t>
+                      </a:r>
+                    </a:p>
+                  </a:txBody>
+                  <a:tcPr marL="54864" marR="54864" marT="18288" marB="18288">
+                    <a:solidFill>
+                      <a:srgbClr val="ECF1F6"/>
+                    </a:solidFill>
+                  </a:tcPr>
+                </a:tc>
+                <a:tc>
+                  <a:txBody>
+                    <a:bodyPr wrap="square"/>
+                    <a:lstStyle/>
+                    <a:p>
+                      <a:r>
+                        <a:rPr sz="1000" b="0">
+                          <a:solidFill>
+                            <a:srgbClr val="282828"/>
+                          </a:solidFill>
+                          <a:latin typeface="Arial"/>
+                        </a:rPr>
+                        <a:t>to be restated (one store per sample; TO)</a:t>
                       </a:r>
                     </a:p>
                   </a:txBody>
@@ -15982,142 +16118,6 @@
                 </a:tc>
               </a:tr>
               <a:tr h="434340">
-                <a:tc>
-                  <a:txBody>
-                    <a:bodyPr wrap="square"/>
-                    <a:lstStyle/>
-                    <a:p>
-                      <a:r>
-                        <a:rPr sz="1000" b="0">
-                          <a:solidFill>
-                            <a:srgbClr val="282828"/>
-                          </a:solidFill>
-                          <a:latin typeface="Arial"/>
-                        </a:rPr>
-                        <a:t>seconds per pm</a:t>
-                      </a:r>
-                    </a:p>
-                  </a:txBody>
-                  <a:tcPr marL="54864" marR="54864" marT="18288" marB="18288">
-                    <a:solidFill>
-                      <a:srgbClr val="FFFFFF"/>
-                    </a:solidFill>
-                  </a:tcPr>
-                </a:tc>
-                <a:tc>
-                  <a:txBody>
-                    <a:bodyPr wrap="square"/>
-                    <a:lstStyle/>
-                    <a:p>
-                      <a:r>
-                        <a:rPr sz="1000" b="0">
-                          <a:solidFill>
-                            <a:srgbClr val="282828"/>
-                          </a:solidFill>
-                          <a:latin typeface="Arial"/>
-                        </a:rPr>
-                        <a:t>42</a:t>
-                      </a:r>
-                    </a:p>
-                  </a:txBody>
-                  <a:tcPr marL="54864" marR="54864" marT="18288" marB="18288">
-                    <a:solidFill>
-                      <a:srgbClr val="FFFFFF"/>
-                    </a:solidFill>
-                  </a:tcPr>
-                </a:tc>
-                <a:tc>
-                  <a:txBody>
-                    <a:bodyPr wrap="square"/>
-                    <a:lstStyle/>
-                    <a:p>
-                      <a:r>
-                        <a:rPr sz="1000" b="0">
-                          <a:solidFill>
-                            <a:srgbClr val="282828"/>
-                          </a:solidFill>
-                          <a:latin typeface="Arial"/>
-                        </a:rPr>
-                        <a:t>1.1 (well-capped at the I/Q rate)</a:t>
-                      </a:r>
-                    </a:p>
-                  </a:txBody>
-                  <a:tcPr marL="54864" marR="54864" marT="18288" marB="18288">
-                    <a:solidFill>
-                      <a:srgbClr val="FFFFFF"/>
-                    </a:solidFill>
-                  </a:tcPr>
-                </a:tc>
-              </a:tr>
-              <a:tr h="434340">
-                <a:tc>
-                  <a:txBody>
-                    <a:bodyPr wrap="square"/>
-                    <a:lstStyle/>
-                    <a:p>
-                      <a:r>
-                        <a:rPr sz="1000" b="0">
-                          <a:solidFill>
-                            <a:srgbClr val="282828"/>
-                          </a:solidFill>
-                          <a:latin typeface="Arial"/>
-                        </a:rPr>
-                        <a:t>if well-free at 10⁹ / 10¹⁰ e⁻/s per element</a:t>
-                      </a:r>
-                    </a:p>
-                  </a:txBody>
-                  <a:tcPr marL="54864" marR="54864" marT="18288" marB="18288">
-                    <a:solidFill>
-                      <a:srgbClr val="ECF1F6"/>
-                    </a:solidFill>
-                  </a:tcPr>
-                </a:tc>
-                <a:tc>
-                  <a:txBody>
-                    <a:bodyPr wrap="square"/>
-                    <a:lstStyle/>
-                    <a:p>
-                      <a:r>
-                        <a:rPr sz="1000" b="0">
-                          <a:solidFill>
-                            <a:srgbClr val="282828"/>
-                          </a:solidFill>
-                          <a:latin typeface="Arial"/>
-                        </a:rPr>
-                        <a:t>—</a:t>
-                      </a:r>
-                    </a:p>
-                  </a:txBody>
-                  <a:tcPr marL="54864" marR="54864" marT="18288" marB="18288">
-                    <a:solidFill>
-                      <a:srgbClr val="ECF1F6"/>
-                    </a:solidFill>
-                  </a:tcPr>
-                </a:tc>
-                <a:tc>
-                  <a:txBody>
-                    <a:bodyPr wrap="square"/>
-                    <a:lstStyle/>
-                    <a:p>
-                      <a:r>
-                        <a:rPr sz="1000" b="0">
-                          <a:solidFill>
-                            <a:srgbClr val="282828"/>
-                          </a:solidFill>
-                          <a:latin typeface="Arial"/>
-                        </a:rPr>
-                        <a:t>0.29 / 0.029</a:t>
-                      </a:r>
-                    </a:p>
-                  </a:txBody>
-                  <a:tcPr marL="54864" marR="54864" marT="18288" marB="18288">
-                    <a:solidFill>
-                      <a:srgbClr val="ECF1F6"/>
-                    </a:solidFill>
-                  </a:tcPr>
-                </a:tc>
-              </a:tr>
-              <a:tr h="262890">
                 <a:tc>
                   <a:txBody>
                     <a:bodyPr wrap="square"/>
@@ -16197,7 +16197,7 @@
         </p:nvSpPr>
         <p:spPr>
           <a:xfrm>
-            <a:off x="6400800" y="4062222"/>
+            <a:off x="6400800" y="5090922"/>
             <a:ext cx="5394960" cy="274320"/>
           </a:xfrm>
           <a:prstGeom prst="rect">
@@ -16232,7 +16232,7 @@
                 </a:solidFill>
                 <a:latin typeface="Arial"/>
               </a:rPr>
-              <a:t>Even well-capped the lock-in is ~40× the Photonfocus and ~400× Feng's baseline</a:t>
+              <a:t>Even well-capped the lock-in is ~12× the Photonfocus and ~110× Feng's baseline</a:t>
             </a:r>
             <a:r>
               <a:rPr sz="1200" b="0">
@@ -16241,7 +16241,7 @@
                 </a:solidFill>
                 <a:latin typeface="Arial"/>
               </a:rPr>
-              <a:t>; a verified well-free device (continuous, or I/Q ≥ 10 kHz) adds 4–40×.</a:t>
+              <a:t> (the format stage's first 1.1 s counted four full wells per sample; a true I/Q sample integrates into one store — corrected by the lock-in reading itself); a verified well-free device (continuous, or I/Q ≥ 10 kHz) adds more, to be restated the same way.</a:t>
             </a:r>
           </a:p>
           <a:p>
@@ -16288,7 +16288,7 @@
         </p:nvSpPr>
         <p:spPr>
           <a:xfrm>
-            <a:off x="6400800" y="5567934"/>
+            <a:off x="6400800" y="6992874"/>
             <a:ext cx="5394960" cy="274320"/>
           </a:xfrm>
           <a:prstGeom prst="rect">
@@ -17931,7 +17931,7 @@
         </p:nvGraphicFramePr>
         <p:xfrm>
           <a:off x="411480" y="1298448"/>
-          <a:ext cx="11368733" cy="3371850"/>
+          <a:ext cx="11368733" cy="3183255"/>
         </p:xfrm>
         <a:graphic>
           <a:graphicData uri="http://schemas.openxmlformats.org/drawingml/2006/table">
@@ -17940,11 +17940,11 @@
                 <a:tableStyleId>{5C22544A-7EE6-4342-B048-85BDC9FD1C3A}</a:tableStyleId>
               </a:tblPr>
               <a:tblGrid>
-                <a:gridCol w="4079369"/>
-                <a:gridCol w="1538122"/>
-                <a:gridCol w="2073122"/>
-                <a:gridCol w="1404373"/>
-                <a:gridCol w="2273747"/>
+                <a:gridCol w="3810400"/>
+                <a:gridCol w="1436708"/>
+                <a:gridCol w="1936432"/>
+                <a:gridCol w="1374242"/>
+                <a:gridCol w="2810951"/>
               </a:tblGrid>
               <a:tr h="468630">
                 <a:tc>
@@ -18697,7 +18697,7 @@
                           </a:solidFill>
                           <a:latin typeface="Arial"/>
                         </a:rPr>
-                        <a:t>34 per 1 ms I/Q frame</a:t>
+                        <a:t>58 per 1 ms I/Q sample</a:t>
                       </a:r>
                     </a:p>
                   </a:txBody>
@@ -18719,7 +18719,7 @@
                           </a:solidFill>
                           <a:latin typeface="Arial"/>
                         </a:rPr>
-                        <a:t>1.1 (well-capped at 1 kHz)</a:t>
+                        <a:t>3.4 (well-capped at 1 kHz; ×1.11 square-wave)</a:t>
                       </a:r>
                     </a:p>
                   </a:txBody>
@@ -18730,7 +18730,7 @@
                   </a:tcPr>
                 </a:tc>
               </a:tr>
-              <a:tr h="468630">
+              <a:tr h="280035">
                 <a:tc>
                   <a:txBody>
                     <a:bodyPr wrap="square"/>
@@ -18831,7 +18831,7 @@
                           </a:solidFill>
                           <a:latin typeface="Arial"/>
                         </a:rPr>
-                        <a:t>1.1 (same well × rate per element)</a:t>
+                        <a:t>3.4 (same well × rate per element)</a:t>
                       </a:r>
                     </a:p>
                   </a:txBody>
@@ -18854,7 +18854,7 @@
         </p:nvSpPr>
         <p:spPr>
           <a:xfrm>
-            <a:off x="411480" y="4816602"/>
+            <a:off x="411480" y="4628007"/>
             <a:ext cx="11368735" cy="274320"/>
           </a:xfrm>
           <a:prstGeom prst="rect">
@@ -18945,7 +18945,7 @@
         </p:nvSpPr>
         <p:spPr>
           <a:xfrm>
-            <a:off x="411480" y="6619494"/>
+            <a:off x="411480" y="6430899"/>
             <a:ext cx="11368735" cy="274320"/>
           </a:xfrm>
           <a:prstGeom prst="rect">

</xml_diff>

<commit_message>
deck_cophi: the well-free lock-in rows restated at one store per sample (0.34 s per pm at the sheet's flux); the fiber and electronics budgets under the median-fill convention (0.39 nm per frame, 12 nm/s)
Co-Authored-By: Claude Fable 5.1 <noreply@anthropic.com>
</commit_message>
<xml_diff>
--- a/demo_session/deck_cophi.pptx
+++ b/demo_session/deck_cophi.pptx
@@ -6354,7 +6354,7 @@
                 </a:solidFill>
                 <a:latin typeface="Arial"/>
               </a:rPr>
-              <a:t> the four-step cannot cancel a differential fiber-phase walk within its own four frames.  Budget at the photon floor: </a:t>
+              <a:t> the four-step cannot cancel a differential fiber-phase walk within its own four frames.  Budget at the photon floor (mirror rig, median-fill convention): </a:t>
             </a:r>
             <a:r>
               <a:rPr sz="1200" b="1">
@@ -6363,7 +6363,7 @@
                 </a:solidFill>
                 <a:latin typeface="Arial"/>
               </a:rPr>
-              <a:t>3.5 × 10⁻³ rad per frame = 0.35 nm of differential OPD per 33 ms, ~10.6 nm/s, ~1 mK/s per meter of uncommon fiber</a:t>
+              <a:t>3.9 × 10⁻³ rad per frame = 0.39 nm of differential OPD per 33 ms, ~12 nm/s, ~1.2 mK/s per meter of uncommon fiber</a:t>
             </a:r>
             <a:r>
               <a:rPr sz="1200" b="0">
@@ -6440,7 +6440,7 @@
                 </a:solidFill>
                 <a:latin typeface="Arial"/>
               </a:rPr>
-              <a:t> trigger jitter &lt; 2.9 × 10⁻³ rad, AOM drive ripple &lt; 1.8 × 10⁻³ — both easy with a Rb-locked DDS; latency one beat (133 ms at 7.5 Hz).</a:t>
+              <a:t> trigger jitter &lt; 2.8 × 10⁻³ rad, AOM drive ripple &lt; 1.8 × 10⁻³ — both easy with a Rb-locked DDS; latency one beat (133 ms at 7.5 Hz).</a:t>
             </a:r>
           </a:p>
         </p:txBody>
@@ -6479,7 +6479,7 @@
                 </a:solidFill>
                 <a:latin typeface="Arial"/>
               </a:rPr>
-              <a:t>Stage loop (runs/loop_{lens,oap}_plain, runs/loopfib_*), plain splitter, dmg_loop with the delay row; the mirror rig on the fixed feed (SRC_TRIM 0; every row within 0.02 pm of the mis-fed run, kept in runs/oap_plain_misfed); the fiber rows at the corrected budget 3.5 × 10⁻³ rad/frame; the noise stage's first fiber number was 2.3× low (a 12-draw Monte Carlo of three random numbers) and is replaced by the exact expectation.</a:t>
+              <a:t>Stage loop (runs/loop_{lens,oap}_plain, runs/loopfib_*), plain splitter, dmg_loop with the delay row; the mirror rig on the fixed feed (SRC_TRIM 0; every row within 0.02 pm of the mis-fed run, kept in runs/oap_plain_misfed); the fiber rows at the corrected budget (3.5 × 10⁻³ rad/frame as run; 3.9 × 10⁻³ under the median-fill convention); the noise stage's first fiber number was 2.3× low (a 12-draw Monte Carlo of three random numbers) and is replaced by the exact expectation.</a:t>
             </a:r>
           </a:p>
         </p:txBody>
@@ -11145,7 +11145,7 @@
                           </a:solidFill>
                           <a:latin typeface="Arial"/>
                         </a:rPr>
-                        <a:t>fiber phase 0.35 nm per frame; LO pointing 10 prad per cycle</a:t>
+                        <a:t>fiber phase 0.39 nm per frame; LO pointing 10 prad per cycle</a:t>
                       </a:r>
                     </a:p>
                   </a:txBody>
@@ -12325,7 +12325,7 @@
                           </a:solidFill>
                           <a:latin typeface="Arial"/>
                         </a:rPr>
-                        <a:t>the two PM fibers' differential OPD held to 0.35 nm per 33 ms frame (~10 nm/s; ~1 mK/s per m of uncommon fiber)</a:t>
+                        <a:t>the two PM fibers' differential OPD held to 0.39 nm per 33 ms frame (~12 nm/s; ~1.2 mK/s per m of uncommon fiber)</a:t>
                       </a:r>
                     </a:p>
                   </a:txBody>
@@ -15628,7 +15628,7 @@
         </p:nvGraphicFramePr>
         <p:xfrm>
           <a:off x="6400800" y="1298448"/>
-          <a:ext cx="5394960" cy="3646170"/>
+          <a:ext cx="5394958" cy="3646170"/>
         </p:xfrm>
         <a:graphic>
           <a:graphicData uri="http://schemas.openxmlformats.org/drawingml/2006/table">
@@ -15637,9 +15637,9 @@
                 <a:tableStyleId>{5C22544A-7EE6-4342-B048-85BDC9FD1C3A}</a:tableStyleId>
               </a:tblPr>
               <a:tblGrid>
-                <a:gridCol w="1310640"/>
-                <a:gridCol w="944880"/>
-                <a:gridCol w="3139440"/>
+                <a:gridCol w="1833754"/>
+                <a:gridCol w="823860"/>
+                <a:gridCol w="2737344"/>
               </a:tblGrid>
               <a:tr h="605790">
                 <a:tc>
@@ -16062,7 +16062,7 @@
                           </a:solidFill>
                           <a:latin typeface="Arial"/>
                         </a:rPr>
-                        <a:t>if well-free at 10⁹ / 10¹⁰ e⁻/s per element</a:t>
+                        <a:t>if well-free: 10⁹ / 10¹⁰ e⁻/s per element (the sheet's own 2.5 × 10⁹)</a:t>
                       </a:r>
                     </a:p>
                   </a:txBody>
@@ -16106,7 +16106,7 @@
                           </a:solidFill>
                           <a:latin typeface="Arial"/>
                         </a:rPr>
-                        <a:t>to be restated (one store per sample; TO)</a:t>
+                        <a:t>0.84 / 0.084 s (0.34 s at 2.5 × 10⁹) — analytic, one store per sample</a:t>
                       </a:r>
                     </a:p>
                   </a:txBody>
@@ -16241,7 +16241,7 @@
                 </a:solidFill>
                 <a:latin typeface="Arial"/>
               </a:rPr>
-              <a:t> (the format stage's first 1.1 s counted four full wells per sample; a true I/Q sample integrates into one store — corrected by the lock-in reading itself); a verified well-free device (continuous, or I/Q ≥ 10 kHz) adds more, to be restated the same way.</a:t>
+              <a:t> (the format stage's first 1.1 s counted four full wells per sample; a true I/Q sample integrates into one store — corrected by the lock-in reading itself); a verified well-free device (continuous, or I/Q ≥ 10 kHz) at the sheet's own 2.5 × 10⁹ e⁻/s per element would be ~18 pm per sample, ~0.34 s per pm — 10× the capped form; that is what the vendor question decides.</a:t>
             </a:r>
           </a:p>
           <a:p>
@@ -16288,7 +16288,7 @@
         </p:nvSpPr>
         <p:spPr>
           <a:xfrm>
-            <a:off x="6400800" y="6992874"/>
+            <a:off x="6400800" y="7389113"/>
             <a:ext cx="5394960" cy="274320"/>
           </a:xfrm>
           <a:prstGeom prst="rect">

</xml_diff>

<commit_message>
deck_cophi: every lock-in cell now a record (2a07af9: 3 pm held at 0.125 s cycles, fiber inert, capture, battery), the sensors' polarization-camera timings (475 / 519 / 342 s per pm) and their mechanism; campaign brief 8 records it
Co-Authored-By: Claude Fable 5.1 <noreply@anthropic.com>
</commit_message>
<xml_diff>
--- a/demo_session/deck_cophi.pptx
+++ b/demo_session/deck_cophi.pptx
@@ -3379,7 +3379,7 @@
         </p:nvGraphicFramePr>
         <p:xfrm>
           <a:off x="411480" y="1298448"/>
-          <a:ext cx="11368734" cy="4686300"/>
+          <a:ext cx="11368734" cy="2800350"/>
         </p:xfrm>
         <a:graphic>
           <a:graphicData uri="http://schemas.openxmlformats.org/drawingml/2006/table">
@@ -3388,12 +3388,12 @@
                 <a:tableStyleId>{5C22544A-7EE6-4342-B048-85BDC9FD1C3A}</a:tableStyleId>
               </a:tblPr>
               <a:tblGrid>
-                <a:gridCol w="1437668"/>
-                <a:gridCol w="5134530"/>
+                <a:gridCol w="3065461"/>
+                <a:gridCol w="2682278"/>
                 <a:gridCol w="2325624"/>
-                <a:gridCol w="2470912"/>
+                <a:gridCol w="3295371"/>
               </a:tblGrid>
-              <a:tr h="468630">
+              <a:tr h="280035">
                 <a:tc>
                   <a:txBody>
                     <a:bodyPr wrap="square"/>
@@ -3483,7 +3483,7 @@
                   </a:tcPr>
                 </a:tc>
               </a:tr>
-              <a:tr h="468630">
+              <a:tr h="280035">
                 <a:tc>
                   <a:txBody>
                     <a:bodyPr wrap="square"/>
@@ -3573,7 +3573,7 @@
                   </a:tcPr>
                 </a:tc>
               </a:tr>
-              <a:tr h="468630">
+              <a:tr h="280035">
                 <a:tc>
                   <a:txBody>
                     <a:bodyPr wrap="square"/>
@@ -3663,7 +3663,7 @@
                   </a:tcPr>
                 </a:tc>
               </a:tr>
-              <a:tr h="468630">
+              <a:tr h="280035">
                 <a:tc>
                   <a:txBody>
                     <a:bodyPr wrap="square"/>
@@ -3753,7 +3753,7 @@
                   </a:tcPr>
                 </a:tc>
               </a:tr>
-              <a:tr h="468630">
+              <a:tr h="280035">
                 <a:tc>
                   <a:txBody>
                     <a:bodyPr wrap="square"/>
@@ -3843,7 +3843,7 @@
                   </a:tcPr>
                 </a:tc>
               </a:tr>
-              <a:tr h="468630">
+              <a:tr h="280035">
                 <a:tc>
                   <a:txBody>
                     <a:bodyPr wrap="square"/>
@@ -3933,7 +3933,7 @@
                   </a:tcPr>
                 </a:tc>
               </a:tr>
-              <a:tr h="468630">
+              <a:tr h="280035">
                 <a:tc>
                   <a:txBody>
                     <a:bodyPr wrap="square"/>
@@ -4023,7 +4023,7 @@
                   </a:tcPr>
                 </a:tc>
               </a:tr>
-              <a:tr h="468630">
+              <a:tr h="280035">
                 <a:tc>
                   <a:txBody>
                     <a:bodyPr wrap="square"/>
@@ -4113,7 +4113,7 @@
                   </a:tcPr>
                 </a:tc>
               </a:tr>
-              <a:tr h="468630">
+              <a:tr h="280035">
                 <a:tc>
                   <a:txBody>
                     <a:bodyPr wrap="square"/>
@@ -4203,68 +4203,88 @@
                   </a:tcPr>
                 </a:tc>
               </a:tr>
-              <a:tr h="468630">
-                <a:tc>
-                  <a:txBody>
-                    <a:bodyPr wrap="square"/>
-                    <a:lstStyle/>
-                    <a:p>
-                      <a:r>
-                        <a:rPr sz="1100" b="0">
-                          <a:solidFill>
-                            <a:srgbClr val="282828"/>
-                          </a:solidFill>
-                          <a:latin typeface="Arial"/>
-                        </a:rPr>
-                        <a:t>HET, lock-in camera (both rigs)</a:t>
-                      </a:r>
-                    </a:p>
-                  </a:txBody>
-                  <a:tcPr marL="54864" marR="54864" marT="18288" marB="18288">
-                    <a:solidFill>
-                      <a:srgbClr val="FFFFFF"/>
-                    </a:solidFill>
-                  </a:tcPr>
-                </a:tc>
-                <a:tc>
-                  <a:txBody>
-                    <a:bodyPr wrap="square"/>
-                    <a:lstStyle/>
-                    <a:p>
-                      <a:r>
-                        <a:rPr sz="1100" b="0">
-                          <a:solidFill>
-                            <a:srgbClr val="282828"/>
-                          </a:solidFill>
-                          <a:latin typeface="Arial"/>
-                        </a:rPr>
-                        <a:t>same gains as HET above — the reading is the same algebra, exact at the pixel; floor at its own photon rate: not yet run (TO)</a:t>
-                      </a:r>
-                    </a:p>
-                  </a:txBody>
-                  <a:tcPr marL="54864" marR="54864" marT="18288" marB="18288">
-                    <a:solidFill>
-                      <a:srgbClr val="FFFFFF"/>
-                    </a:solidFill>
-                  </a:tcPr>
-                </a:tc>
-                <a:tc>
-                  <a:txBody>
-                    <a:bodyPr wrap="square"/>
-                    <a:lstStyle/>
-                    <a:p/>
-                  </a:txBody>
-                  <a:tcPr marL="54864" marR="54864" marT="18288" marB="18288">
-                    <a:solidFill>
-                      <a:srgbClr val="FFFFFF"/>
-                    </a:solidFill>
-                  </a:tcPr>
-                </a:tc>
-                <a:tc>
-                  <a:txBody>
-                    <a:bodyPr wrap="square"/>
-                    <a:lstStyle/>
-                    <a:p/>
+              <a:tr h="280035">
+                <a:tc>
+                  <a:txBody>
+                    <a:bodyPr wrap="square"/>
+                    <a:lstStyle/>
+                    <a:p>
+                      <a:r>
+                        <a:rPr sz="1100" b="0">
+                          <a:solidFill>
+                            <a:srgbClr val="282828"/>
+                          </a:solidFill>
+                          <a:latin typeface="Arial"/>
+                        </a:rPr>
+                        <a:t>HET, lock-in camera (record, noise-free)</a:t>
+                      </a:r>
+                    </a:p>
+                  </a:txBody>
+                  <a:tcPr marL="54864" marR="54864" marT="18288" marB="18288">
+                    <a:solidFill>
+                      <a:srgbClr val="FFFFFF"/>
+                    </a:solidFill>
+                  </a:tcPr>
+                </a:tc>
+                <a:tc>
+                  <a:txBody>
+                    <a:bodyPr wrap="square"/>
+                    <a:lstStyle/>
+                    <a:p>
+                      <a:r>
+                        <a:rPr sz="1100" b="0">
+                          <a:solidFill>
+                            <a:srgbClr val="282828"/>
+                          </a:solidFill>
+                          <a:latin typeface="Arial"/>
+                        </a:rPr>
+                        <a:t>converged 1.0000</a:t>
+                      </a:r>
+                    </a:p>
+                  </a:txBody>
+                  <a:tcPr marL="54864" marR="54864" marT="18288" marB="18288">
+                    <a:solidFill>
+                      <a:srgbClr val="FFFFFF"/>
+                    </a:solidFill>
+                  </a:tcPr>
+                </a:tc>
+                <a:tc>
+                  <a:txBody>
+                    <a:bodyPr wrap="square"/>
+                    <a:lstStyle/>
+                    <a:p>
+                      <a:r>
+                        <a:rPr sz="1100" b="0">
+                          <a:solidFill>
+                            <a:srgbClr val="282828"/>
+                          </a:solidFill>
+                          <a:latin typeface="Arial"/>
+                        </a:rPr>
+                        <a:t>1.0006</a:t>
+                      </a:r>
+                    </a:p>
+                  </a:txBody>
+                  <a:tcPr marL="54864" marR="54864" marT="18288" marB="18288">
+                    <a:solidFill>
+                      <a:srgbClr val="FFFFFF"/>
+                    </a:solidFill>
+                  </a:tcPr>
+                </a:tc>
+                <a:tc>
+                  <a:txBody>
+                    <a:bodyPr wrap="square"/>
+                    <a:lstStyle/>
+                    <a:p>
+                      <a:r>
+                        <a:rPr sz="1100" b="0">
+                          <a:solidFill>
+                            <a:srgbClr val="282828"/>
+                          </a:solidFill>
+                          <a:latin typeface="Arial"/>
+                        </a:rPr>
+                        <a:t>1.0005 — the same reading, the same algebra</a:t>
+                      </a:r>
+                    </a:p>
                   </a:txBody>
                   <a:tcPr marL="54864" marR="54864" marT="18288" marB="18288">
                     <a:solidFill>
@@ -4285,7 +4305,7 @@
         </p:nvSpPr>
         <p:spPr>
           <a:xfrm>
-            <a:off x="411480" y="6131052"/>
+            <a:off x="411480" y="4245102"/>
             <a:ext cx="11368735" cy="274320"/>
           </a:xfrm>
           <a:prstGeom prst="rect">
@@ -4376,7 +4396,7 @@
         </p:nvSpPr>
         <p:spPr>
           <a:xfrm>
-            <a:off x="411480" y="8181594"/>
+            <a:off x="411480" y="6295644"/>
             <a:ext cx="11368735" cy="274320"/>
           </a:xfrm>
           <a:prstGeom prst="rect">
@@ -4534,7 +4554,7 @@
         </p:nvGraphicFramePr>
         <p:xfrm>
           <a:off x="411480" y="1298448"/>
-          <a:ext cx="5806438" cy="4509135"/>
+          <a:ext cx="5806438" cy="4320540"/>
         </p:xfrm>
         <a:graphic>
           <a:graphicData uri="http://schemas.openxmlformats.org/drawingml/2006/table">
@@ -4543,11 +4563,11 @@
                 <a:tableStyleId>{5C22544A-7EE6-4342-B048-85BDC9FD1C3A}</a:tableStyleId>
               </a:tblPr>
               <a:tblGrid>
-                <a:gridCol w="1665418"/>
-                <a:gridCol w="999251"/>
-                <a:gridCol w="964189"/>
-                <a:gridCol w="403206"/>
-                <a:gridCol w="683698"/>
+                <a:gridCol w="1471460"/>
+                <a:gridCol w="1010520"/>
+                <a:gridCol w="868693"/>
+                <a:gridCol w="407754"/>
+                <a:gridCol w="957335"/>
                 <a:gridCol w="1090676"/>
               </a:tblGrid>
               <a:tr h="1034415">
@@ -4684,7 +4704,7 @@
                   </a:tcPr>
                 </a:tc>
               </a:tr>
-              <a:tr h="657225">
+              <a:tr h="468630">
                 <a:tc>
                   <a:txBody>
                     <a:bodyPr wrap="square"/>
@@ -5233,7 +5253,7 @@
                           </a:solidFill>
                           <a:latin typeface="Arial"/>
                         </a:rPr>
-                        <a:t>lock-in camera, heliCam C4, 500 ke, I/Q at 1 kHz (the lock-in reading, mirror rig; well-capped)</a:t>
+                        <a:t>lock-in camera, heliCam C4, 500 ke, I/Q at 1 kHz (the lock-in reading; well-capped)</a:t>
                       </a:r>
                     </a:p>
                   </a:txBody>
@@ -5277,7 +5297,7 @@
                           </a:solidFill>
                           <a:latin typeface="Arial"/>
                         </a:rPr>
-                        <a:t>58 (read 0) / 63 (read 100) per 1 ms sample; 1.8 in 1 s</a:t>
+                        <a:t>61.1 / 57.9 per 1 ms sample (66 / 63 at read 100)</a:t>
                       </a:r>
                     </a:p>
                   </a:txBody>
@@ -5321,29 +5341,29 @@
                           </a:solidFill>
                           <a:latin typeface="Arial"/>
                         </a:rPr>
-                        <a:t>3.4 / 4.0 (×1.11 square-wave)</a:t>
-                      </a:r>
-                    </a:p>
-                  </a:txBody>
-                  <a:tcPr marL="54864" marR="54864" marT="18288" marB="18288">
-                    <a:solidFill>
-                      <a:srgbClr val="FFFFFF"/>
-                    </a:solidFill>
-                  </a:tcPr>
-                </a:tc>
-                <a:tc>
-                  <a:txBody>
-                    <a:bodyPr wrap="square"/>
-                    <a:lstStyle/>
-                    <a:p>
-                      <a:r>
-                        <a:rPr sz="1100" b="0">
-                          <a:solidFill>
-                            <a:srgbClr val="282828"/>
-                          </a:solidFill>
-                          <a:latin typeface="Arial"/>
-                        </a:rPr>
-                        <a:t>5.7 / 6.7 min</a:t>
+                        <a:t>3.73 / 3.35 (4.4 / 4.0 at read 100; ×1.11 square-wave)</a:t>
+                      </a:r>
+                    </a:p>
+                  </a:txBody>
+                  <a:tcPr marL="54864" marR="54864" marT="18288" marB="18288">
+                    <a:solidFill>
+                      <a:srgbClr val="FFFFFF"/>
+                    </a:solidFill>
+                  </a:tcPr>
+                </a:tc>
+                <a:tc>
+                  <a:txBody>
+                    <a:bodyPr wrap="square"/>
+                    <a:lstStyle/>
+                    <a:p>
+                      <a:r>
+                        <a:rPr sz="1100" b="0">
+                          <a:solidFill>
+                            <a:srgbClr val="282828"/>
+                          </a:solidFill>
+                          <a:latin typeface="Arial"/>
+                        </a:rPr>
+                        <a:t>6.2 / 5.6 min</a:t>
                       </a:r>
                     </a:p>
                   </a:txBody>
@@ -5366,7 +5386,7 @@
         </p:nvSpPr>
         <p:spPr>
           <a:xfrm>
-            <a:off x="411480" y="5953887"/>
+            <a:off x="411480" y="5765292"/>
             <a:ext cx="5806440" cy="274320"/>
           </a:xfrm>
           <a:prstGeom prst="rect">
@@ -5774,7 +5794,7 @@
         </p:nvGraphicFramePr>
         <p:xfrm>
           <a:off x="411480" y="1298448"/>
-          <a:ext cx="5806439" cy="3931920"/>
+          <a:ext cx="5806439" cy="4686300"/>
         </p:xfrm>
         <a:graphic>
           <a:graphicData uri="http://schemas.openxmlformats.org/drawingml/2006/table">
@@ -5783,10 +5803,10 @@
                 <a:tableStyleId>{5C22544A-7EE6-4342-B048-85BDC9FD1C3A}</a:tableStyleId>
               </a:tblPr>
               <a:tblGrid>
-                <a:gridCol w="3515463"/>
-                <a:gridCol w="2290976"/>
+                <a:gridCol w="2529027"/>
+                <a:gridCol w="3277412"/>
               </a:tblGrid>
-              <a:tr h="280035">
+              <a:tr h="468630">
                 <a:tc>
                   <a:txBody>
                     <a:bodyPr wrap="square"/>
@@ -5878,6 +5898,98 @@
                   </a:tcPr>
                 </a:tc>
               </a:tr>
+              <a:tr h="468630">
+                <a:tc>
+                  <a:txBody>
+                    <a:bodyPr wrap="square"/>
+                    <a:lstStyle/>
+                    <a:p>
+                      <a:r>
+                        <a:rPr sz="1100" b="0">
+                          <a:solidFill>
+                            <a:srgbClr val="282828"/>
+                          </a:solidFill>
+                          <a:latin typeface="Arial"/>
+                        </a:rPr>
+                        <a:t>noise only, Photonfocus (60 readings, 1.6 s)</a:t>
+                      </a:r>
+                    </a:p>
+                  </a:txBody>
+                  <a:tcPr marL="54864" marR="54864" marT="18288" marB="18288">
+                    <a:solidFill>
+                      <a:srgbClr val="ECF1F6"/>
+                    </a:solidFill>
+                  </a:tcPr>
+                </a:tc>
+                <a:tc>
+                  <a:txBody>
+                    <a:bodyPr wrap="square"/>
+                    <a:lstStyle/>
+                    <a:p>
+                      <a:r>
+                        <a:rPr sz="1100" b="0">
+                          <a:solidFill>
+                            <a:srgbClr val="282828"/>
+                          </a:solidFill>
+                          <a:latin typeface="Arial"/>
+                        </a:rPr>
+                        <a:t>2.60 / 2.52</a:t>
+                      </a:r>
+                    </a:p>
+                  </a:txBody>
+                  <a:tcPr marL="54864" marR="54864" marT="18288" marB="18288">
+                    <a:solidFill>
+                      <a:srgbClr val="ECF1F6"/>
+                    </a:solidFill>
+                  </a:tcPr>
+                </a:tc>
+              </a:tr>
+              <a:tr h="657225">
+                <a:tc>
+                  <a:txBody>
+                    <a:bodyPr wrap="square"/>
+                    <a:lstStyle/>
+                    <a:p>
+                      <a:r>
+                        <a:rPr sz="1100" b="0">
+                          <a:solidFill>
+                            <a:srgbClr val="282828"/>
+                          </a:solidFill>
+                          <a:latin typeface="Arial"/>
+                        </a:rPr>
+                        <a:t>noise only, lock-in camera (125 I/Q samples per cycle, a cycle every 0.125 s)</a:t>
+                      </a:r>
+                    </a:p>
+                  </a:txBody>
+                  <a:tcPr marL="54864" marR="54864" marT="18288" marB="18288">
+                    <a:solidFill>
+                      <a:srgbClr val="FFFFFF"/>
+                    </a:solidFill>
+                  </a:tcPr>
+                </a:tc>
+                <a:tc>
+                  <a:txBody>
+                    <a:bodyPr wrap="square"/>
+                    <a:lstStyle/>
+                    <a:p>
+                      <a:r>
+                        <a:rPr sz="1100" b="0">
+                          <a:solidFill>
+                            <a:srgbClr val="282828"/>
+                          </a:solidFill>
+                          <a:latin typeface="Arial"/>
+                        </a:rPr>
+                        <a:t>3.09 (converged 3.14); at 44 samples (44 ms cycles) 5.22</a:t>
+                      </a:r>
+                    </a:p>
+                  </a:txBody>
+                  <a:tcPr marL="54864" marR="54864" marT="18288" marB="18288">
+                    <a:solidFill>
+                      <a:srgbClr val="FFFFFF"/>
+                    </a:solidFill>
+                  </a:tcPr>
+                </a:tc>
+              </a:tr>
               <a:tr h="280035">
                 <a:tc>
                   <a:txBody>
@@ -5891,7 +6003,7 @@
                           </a:solidFill>
                           <a:latin typeface="Arial"/>
                         </a:rPr>
-                        <a:t>noise only, Photonfocus (60 readings, 1.6 s)</a:t>
+                        <a:t>random walk 2 pm per cycle</a:t>
                       </a:r>
                     </a:p>
                   </a:txBody>
@@ -5913,7 +6025,191 @@
                           </a:solidFill>
                           <a:latin typeface="Arial"/>
                         </a:rPr>
-                        <a:t>2.60 / 2.52</a:t>
+                        <a:t>3.60 / 3.53</a:t>
+                      </a:r>
+                    </a:p>
+                  </a:txBody>
+                  <a:tcPr marL="54864" marR="54864" marT="18288" marB="18288">
+                    <a:solidFill>
+                      <a:srgbClr val="ECF1F6"/>
+                    </a:solidFill>
+                  </a:tcPr>
+                </a:tc>
+              </a:tr>
+              <a:tr h="280035">
+                <a:tc>
+                  <a:txBody>
+                    <a:bodyPr wrap="square"/>
+                    <a:lstStyle/>
+                    <a:p>
+                      <a:r>
+                        <a:rPr sz="1100" b="0">
+                          <a:solidFill>
+                            <a:srgbClr val="282828"/>
+                          </a:solidFill>
+                          <a:latin typeface="Arial"/>
+                        </a:rPr>
+                        <a:t>thermal ramp 5 pm per cycle</a:t>
+                      </a:r>
+                    </a:p>
+                  </a:txBody>
+                  <a:tcPr marL="54864" marR="54864" marT="18288" marB="18288">
+                    <a:solidFill>
+                      <a:srgbClr val="FFFFFF"/>
+                    </a:solidFill>
+                  </a:tcPr>
+                </a:tc>
+                <a:tc>
+                  <a:txBody>
+                    <a:bodyPr wrap="square"/>
+                    <a:lstStyle/>
+                    <a:p>
+                      <a:r>
+                        <a:rPr sz="1100" b="0">
+                          <a:solidFill>
+                            <a:srgbClr val="282828"/>
+                          </a:solidFill>
+                          <a:latin typeface="Arial"/>
+                        </a:rPr>
+                        <a:t>10.3 / 10.3 (the lag rate/gG — every gauge)</a:t>
+                      </a:r>
+                    </a:p>
+                  </a:txBody>
+                  <a:tcPr marL="54864" marR="54864" marT="18288" marB="18288">
+                    <a:solidFill>
+                      <a:srgbClr val="FFFFFF"/>
+                    </a:solidFill>
+                  </a:tcPr>
+                </a:tc>
+              </a:tr>
+              <a:tr h="280035">
+                <a:tc>
+                  <a:txBody>
+                    <a:bodyPr wrap="square"/>
+                    <a:lstStyle/>
+                    <a:p>
+                      <a:r>
+                        <a:rPr sz="1100" b="0">
+                          <a:solidFill>
+                            <a:srgbClr val="282828"/>
+                          </a:solidFill>
+                          <a:latin typeface="Arial"/>
+                        </a:rPr>
+                        <a:t>camera offset walk</a:t>
+                      </a:r>
+                    </a:p>
+                  </a:txBody>
+                  <a:tcPr marL="54864" marR="54864" marT="18288" marB="18288">
+                    <a:solidFill>
+                      <a:srgbClr val="ECF1F6"/>
+                    </a:solidFill>
+                  </a:tcPr>
+                </a:tc>
+                <a:tc>
+                  <a:txBody>
+                    <a:bodyPr wrap="square"/>
+                    <a:lstStyle/>
+                    <a:p>
+                      <a:r>
+                        <a:rPr sz="1100" b="0">
+                          <a:solidFill>
+                            <a:srgbClr val="282828"/>
+                          </a:solidFill>
+                          <a:latin typeface="Arial"/>
+                        </a:rPr>
+                        <a:t>2.85 / 2.77 (immune: zero-sum frames)</a:t>
+                      </a:r>
+                    </a:p>
+                  </a:txBody>
+                  <a:tcPr marL="54864" marR="54864" marT="18288" marB="18288">
+                    <a:solidFill>
+                      <a:srgbClr val="ECF1F6"/>
+                    </a:solidFill>
+                  </a:tcPr>
+                </a:tc>
+              </a:tr>
+              <a:tr h="657225">
+                <a:tc>
+                  <a:txBody>
+                    <a:bodyPr wrap="square"/>
+                    <a:lstStyle/>
+                    <a:p>
+                      <a:r>
+                        <a:rPr sz="1100" b="0">
+                          <a:solidFill>
+                            <a:srgbClr val="282828"/>
+                          </a:solidFill>
+                          <a:latin typeface="Arial"/>
+                        </a:rPr>
+                        <a:t>one cycle of sensor latency (one beat; for the lock-in one whole 0.125 s cycle as the upper bound)</a:t>
+                      </a:r>
+                    </a:p>
+                  </a:txBody>
+                  <a:tcPr marL="54864" marR="54864" marT="18288" marB="18288">
+                    <a:solidFill>
+                      <a:srgbClr val="FFFFFF"/>
+                    </a:solidFill>
+                  </a:tcPr>
+                </a:tc>
+                <a:tc>
+                  <a:txBody>
+                    <a:bodyPr wrap="square"/>
+                    <a:lstStyle/>
+                    <a:p>
+                      <a:r>
+                        <a:rPr sz="1100" b="0">
+                          <a:solidFill>
+                            <a:srgbClr val="282828"/>
+                          </a:solidFill>
+                          <a:latin typeface="Arial"/>
+                        </a:rPr>
+                        <a:t>3.65 / 3.54 (+0.9 pm); lock-in 4.12</a:t>
+                      </a:r>
+                    </a:p>
+                  </a:txBody>
+                  <a:tcPr marL="54864" marR="54864" marT="18288" marB="18288">
+                    <a:solidFill>
+                      <a:srgbClr val="FFFFFF"/>
+                    </a:solidFill>
+                  </a:tcPr>
+                </a:tc>
+              </a:tr>
+              <a:tr h="657225">
+                <a:tc>
+                  <a:txBody>
+                    <a:bodyPr wrap="square"/>
+                    <a:lstStyle/>
+                    <a:p>
+                      <a:r>
+                        <a:rPr sz="1100" b="0">
+                          <a:solidFill>
+                            <a:srgbClr val="282828"/>
+                          </a:solidFill>
+                          <a:latin typeface="Arial"/>
+                        </a:rPr>
+                        <a:t>differential fiber walk at the budget / at 3× (baseline camera)</a:t>
+                      </a:r>
+                    </a:p>
+                  </a:txBody>
+                  <a:tcPr marL="54864" marR="54864" marT="18288" marB="18288">
+                    <a:solidFill>
+                      <a:srgbClr val="ECF1F6"/>
+                    </a:solidFill>
+                  </a:tcPr>
+                </a:tc>
+                <a:tc>
+                  <a:txBody>
+                    <a:bodyPr wrap="square"/>
+                    <a:lstStyle/>
+                    <a:p>
+                      <a:r>
+                        <a:rPr sz="1100" b="0">
+                          <a:solidFill>
+                            <a:srgbClr val="282828"/>
+                          </a:solidFill>
+                          <a:latin typeface="Arial"/>
+                        </a:rPr>
+                        <a:t>3.95 / 9.2 (mirror); Photonfocus 4.8 / 12.7; lock-in 5.22 / 5.22 = its noise-only hold to the digit: a per-sample piston, inert</a:t>
                       </a:r>
                     </a:p>
                   </a:txBody>
@@ -5937,282 +6233,6 @@
                           </a:solidFill>
                           <a:latin typeface="Arial"/>
                         </a:rPr>
-                        <a:t>noise only, lock-in camera (I/Q samples at 1 kHz; ~130 samples per cycle, a 0.13 s cycle)</a:t>
-                      </a:r>
-                    </a:p>
-                  </a:txBody>
-                  <a:tcPr marL="54864" marR="54864" marT="18288" marB="18288">
-                    <a:solidFill>
-                      <a:srgbClr val="FFFFFF"/>
-                    </a:solidFill>
-                  </a:tcPr>
-                </a:tc>
-                <a:tc>
-                  <a:txBody>
-                    <a:bodyPr wrap="square"/>
-                    <a:lstStyle/>
-                    <a:p>
-                      <a:r>
-                        <a:rPr sz="1100" b="0">
-                          <a:solidFill>
-                            <a:srgbClr val="282828"/>
-                          </a:solidFill>
-                          <a:latin typeface="Arial"/>
-                        </a:rPr>
-                        <a:t>~2.6 (derived from 58 pm per sample; the loop run pending)</a:t>
-                      </a:r>
-                    </a:p>
-                  </a:txBody>
-                  <a:tcPr marL="54864" marR="54864" marT="18288" marB="18288">
-                    <a:solidFill>
-                      <a:srgbClr val="FFFFFF"/>
-                    </a:solidFill>
-                  </a:tcPr>
-                </a:tc>
-              </a:tr>
-              <a:tr h="280035">
-                <a:tc>
-                  <a:txBody>
-                    <a:bodyPr wrap="square"/>
-                    <a:lstStyle/>
-                    <a:p>
-                      <a:r>
-                        <a:rPr sz="1100" b="0">
-                          <a:solidFill>
-                            <a:srgbClr val="282828"/>
-                          </a:solidFill>
-                          <a:latin typeface="Arial"/>
-                        </a:rPr>
-                        <a:t>random walk 2 pm per cycle</a:t>
-                      </a:r>
-                    </a:p>
-                  </a:txBody>
-                  <a:tcPr marL="54864" marR="54864" marT="18288" marB="18288">
-                    <a:solidFill>
-                      <a:srgbClr val="ECF1F6"/>
-                    </a:solidFill>
-                  </a:tcPr>
-                </a:tc>
-                <a:tc>
-                  <a:txBody>
-                    <a:bodyPr wrap="square"/>
-                    <a:lstStyle/>
-                    <a:p>
-                      <a:r>
-                        <a:rPr sz="1100" b="0">
-                          <a:solidFill>
-                            <a:srgbClr val="282828"/>
-                          </a:solidFill>
-                          <a:latin typeface="Arial"/>
-                        </a:rPr>
-                        <a:t>3.60 / 3.53</a:t>
-                      </a:r>
-                    </a:p>
-                  </a:txBody>
-                  <a:tcPr marL="54864" marR="54864" marT="18288" marB="18288">
-                    <a:solidFill>
-                      <a:srgbClr val="ECF1F6"/>
-                    </a:solidFill>
-                  </a:tcPr>
-                </a:tc>
-              </a:tr>
-              <a:tr h="468630">
-                <a:tc>
-                  <a:txBody>
-                    <a:bodyPr wrap="square"/>
-                    <a:lstStyle/>
-                    <a:p>
-                      <a:r>
-                        <a:rPr sz="1100" b="0">
-                          <a:solidFill>
-                            <a:srgbClr val="282828"/>
-                          </a:solidFill>
-                          <a:latin typeface="Arial"/>
-                        </a:rPr>
-                        <a:t>thermal ramp 5 pm per cycle</a:t>
-                      </a:r>
-                    </a:p>
-                  </a:txBody>
-                  <a:tcPr marL="54864" marR="54864" marT="18288" marB="18288">
-                    <a:solidFill>
-                      <a:srgbClr val="FFFFFF"/>
-                    </a:solidFill>
-                  </a:tcPr>
-                </a:tc>
-                <a:tc>
-                  <a:txBody>
-                    <a:bodyPr wrap="square"/>
-                    <a:lstStyle/>
-                    <a:p>
-                      <a:r>
-                        <a:rPr sz="1100" b="0">
-                          <a:solidFill>
-                            <a:srgbClr val="282828"/>
-                          </a:solidFill>
-                          <a:latin typeface="Arial"/>
-                        </a:rPr>
-                        <a:t>10.3 / 10.3 (the lag rate/gG — every gauge)</a:t>
-                      </a:r>
-                    </a:p>
-                  </a:txBody>
-                  <a:tcPr marL="54864" marR="54864" marT="18288" marB="18288">
-                    <a:solidFill>
-                      <a:srgbClr val="FFFFFF"/>
-                    </a:solidFill>
-                  </a:tcPr>
-                </a:tc>
-              </a:tr>
-              <a:tr h="468630">
-                <a:tc>
-                  <a:txBody>
-                    <a:bodyPr wrap="square"/>
-                    <a:lstStyle/>
-                    <a:p>
-                      <a:r>
-                        <a:rPr sz="1100" b="0">
-                          <a:solidFill>
-                            <a:srgbClr val="282828"/>
-                          </a:solidFill>
-                          <a:latin typeface="Arial"/>
-                        </a:rPr>
-                        <a:t>camera offset walk</a:t>
-                      </a:r>
-                    </a:p>
-                  </a:txBody>
-                  <a:tcPr marL="54864" marR="54864" marT="18288" marB="18288">
-                    <a:solidFill>
-                      <a:srgbClr val="ECF1F6"/>
-                    </a:solidFill>
-                  </a:tcPr>
-                </a:tc>
-                <a:tc>
-                  <a:txBody>
-                    <a:bodyPr wrap="square"/>
-                    <a:lstStyle/>
-                    <a:p>
-                      <a:r>
-                        <a:rPr sz="1100" b="0">
-                          <a:solidFill>
-                            <a:srgbClr val="282828"/>
-                          </a:solidFill>
-                          <a:latin typeface="Arial"/>
-                        </a:rPr>
-                        <a:t>2.85 / 2.77 (immune: zero-sum frames)</a:t>
-                      </a:r>
-                    </a:p>
-                  </a:txBody>
-                  <a:tcPr marL="54864" marR="54864" marT="18288" marB="18288">
-                    <a:solidFill>
-                      <a:srgbClr val="ECF1F6"/>
-                    </a:solidFill>
-                  </a:tcPr>
-                </a:tc>
-              </a:tr>
-              <a:tr h="468630">
-                <a:tc>
-                  <a:txBody>
-                    <a:bodyPr wrap="square"/>
-                    <a:lstStyle/>
-                    <a:p>
-                      <a:r>
-                        <a:rPr sz="1100" b="0">
-                          <a:solidFill>
-                            <a:srgbClr val="282828"/>
-                          </a:solidFill>
-                          <a:latin typeface="Arial"/>
-                        </a:rPr>
-                        <a:t>one cycle of sensor latency (one beat; one I/Q frame for the lock-in)</a:t>
-                      </a:r>
-                    </a:p>
-                  </a:txBody>
-                  <a:tcPr marL="54864" marR="54864" marT="18288" marB="18288">
-                    <a:solidFill>
-                      <a:srgbClr val="FFFFFF"/>
-                    </a:solidFill>
-                  </a:tcPr>
-                </a:tc>
-                <a:tc>
-                  <a:txBody>
-                    <a:bodyPr wrap="square"/>
-                    <a:lstStyle/>
-                    <a:p>
-                      <a:r>
-                        <a:rPr sz="1100" b="0">
-                          <a:solidFill>
-                            <a:srgbClr val="282828"/>
-                          </a:solidFill>
-                          <a:latin typeface="Arial"/>
-                        </a:rPr>
-                        <a:t>3.65 / 3.54 (+0.9 pm); lock-in: 1 ms, negligible</a:t>
-                      </a:r>
-                    </a:p>
-                  </a:txBody>
-                  <a:tcPr marL="54864" marR="54864" marT="18288" marB="18288">
-                    <a:solidFill>
-                      <a:srgbClr val="FFFFFF"/>
-                    </a:solidFill>
-                  </a:tcPr>
-                </a:tc>
-              </a:tr>
-              <a:tr h="468630">
-                <a:tc>
-                  <a:txBody>
-                    <a:bodyPr wrap="square"/>
-                    <a:lstStyle/>
-                    <a:p>
-                      <a:r>
-                        <a:rPr sz="1100" b="0">
-                          <a:solidFill>
-                            <a:srgbClr val="282828"/>
-                          </a:solidFill>
-                          <a:latin typeface="Arial"/>
-                        </a:rPr>
-                        <a:t>differential fiber walk at the budget / at 3× (baseline camera)</a:t>
-                      </a:r>
-                    </a:p>
-                  </a:txBody>
-                  <a:tcPr marL="54864" marR="54864" marT="18288" marB="18288">
-                    <a:solidFill>
-                      <a:srgbClr val="ECF1F6"/>
-                    </a:solidFill>
-                  </a:tcPr>
-                </a:tc>
-                <a:tc>
-                  <a:txBody>
-                    <a:bodyPr wrap="square"/>
-                    <a:lstStyle/>
-                    <a:p>
-                      <a:r>
-                        <a:rPr sz="1100" b="0">
-                          <a:solidFill>
-                            <a:srgbClr val="282828"/>
-                          </a:solidFill>
-                          <a:latin typeface="Arial"/>
-                        </a:rPr>
-                        <a:t>3.95 / 9.2 (mirror); Photonfocus 4.8 / 12.7</a:t>
-                      </a:r>
-                    </a:p>
-                  </a:txBody>
-                  <a:tcPr marL="54864" marR="54864" marT="18288" marB="18288">
-                    <a:solidFill>
-                      <a:srgbClr val="ECF1F6"/>
-                    </a:solidFill>
-                  </a:tcPr>
-                </a:tc>
-              </a:tr>
-              <a:tr h="280035">
-                <a:tc>
-                  <a:txBody>
-                    <a:bodyPr wrap="square"/>
-                    <a:lstStyle/>
-                    <a:p>
-                      <a:r>
-                        <a:rPr sz="1100" b="0">
-                          <a:solidFill>
-                            <a:srgbClr val="282828"/>
-                          </a:solidFill>
-                          <a:latin typeface="Arial"/>
-                        </a:rPr>
                         <a:t>LO drift, 0.1 nrad tilt + 1 pm defocus per cycle</a:t>
                       </a:r>
                     </a:p>
@@ -6235,7 +6255,7 @@
                           </a:solidFill>
                           <a:latin typeface="Arial"/>
                         </a:rPr>
-                        <a:t>29.6 / 29.4</a:t>
+                        <a:t>29.6 / 29.4 (lock-in 29.4: the LO is the same term in every form)</a:t>
                       </a:r>
                     </a:p>
                   </a:txBody>
@@ -7025,7 +7045,7 @@
                 </a:solidFill>
                 <a:latin typeface="Arial"/>
               </a:rPr>
-              <a:t>With the lock-in camera:</a:t>
+              <a:t>With the lock-in camera (record):</a:t>
             </a:r>
             <a:r>
               <a:rPr sz="1200" b="0">
@@ -7034,7 +7054,7 @@
                 </a:solidFill>
                 <a:latin typeface="Arial"/>
               </a:rPr>
-              <a:t> one reference at a time, so the two colors are read on alternate I/Q samples (2 ms per pair) — the same synthetic-wavelength capture, sequential; temporal unwrapping at 1 kHz tolerates 0.9 × λ/4 per ms ≈ 140 µm/s at the peak pixel (derived from the frame rate; not yet run).</a:t>
+              <a:t> one reference at a time, so the two colors are read on alternate I/Q samples (2 ms per pair) — zero wrong orders to 480 nm rms, 0.12 nm per pixel; temporal unwrapping at 1 kHz tolerates 158 µm/s at the peak pixel.</a:t>
             </a:r>
           </a:p>
         </p:txBody>
@@ -7698,7 +7718,7 @@
         </p:nvGraphicFramePr>
         <p:xfrm>
           <a:off x="411480" y="1298448"/>
-          <a:ext cx="11368732" cy="5349240"/>
+          <a:ext cx="11368733" cy="5160645"/>
         </p:xfrm>
         <a:graphic>
           <a:graphicData uri="http://schemas.openxmlformats.org/drawingml/2006/table">
@@ -7707,14 +7727,14 @@
                 <a:tableStyleId>{5C22544A-7EE6-4342-B048-85BDC9FD1C3A}</a:tableStyleId>
               </a:tblPr>
               <a:tblGrid>
-                <a:gridCol w="1626066"/>
-                <a:gridCol w="2140987"/>
-                <a:gridCol w="1978380"/>
-                <a:gridCol w="1300853"/>
-                <a:gridCol w="1924178"/>
+                <a:gridCol w="1520418"/>
+                <a:gridCol w="2001883"/>
+                <a:gridCol w="2432669"/>
+                <a:gridCol w="1216334"/>
+                <a:gridCol w="1799161"/>
                 <a:gridCol w="2398268"/>
               </a:tblGrid>
-              <a:tr h="657225">
+              <a:tr h="468630">
                 <a:tc>
                   <a:txBody>
                     <a:bodyPr wrap="square"/>
@@ -8833,7 +8853,7 @@
                           </a:solidFill>
                           <a:latin typeface="Arial"/>
                         </a:rPr>
-                        <a:t>TO's rerun pending (a first cut was optimistic by ~2.5× and is withdrawn)</a:t>
+                        <a:t>475 s stepped (mono camera, 4 frames) / 519 s vector (polarization camera, mirror rig, camS_oap)</a:t>
                       </a:r>
                     </a:p>
                   </a:txBody>
@@ -8855,7 +8875,7 @@
                           </a:solidFill>
                           <a:latin typeface="Arial"/>
                         </a:rPr>
-                        <a:t>pending</a:t>
+                        <a:t>342 s (mono, K frames)</a:t>
                       </a:r>
                     </a:p>
                   </a:txBody>
@@ -8899,7 +8919,7 @@
                           </a:solidFill>
                           <a:latin typeface="Arial"/>
                         </a:rPr>
-                        <a:t>3.4 / 4.0</a:t>
+                        <a:t>3.35 / 3.73 (mirror / lens)</a:t>
                       </a:r>
                     </a:p>
                   </a:txBody>
@@ -8922,7 +8942,7 @@
         </p:nvSpPr>
         <p:spPr>
           <a:xfrm>
-            <a:off x="411480" y="6793992"/>
+            <a:off x="411480" y="6605397"/>
             <a:ext cx="11368735" cy="274320"/>
           </a:xfrm>
           <a:prstGeom prst="rect">
@@ -8948,7 +8968,7 @@
                 </a:solidFill>
                 <a:latin typeface="Arial"/>
               </a:rPr>
-              <a:t>The IFO timing is TO's record (the four analyzer frames in one exposure on an IMX250MZR-class camera, 2448 × 2048, 75 fps; well ~10 ke⁻ and read 2.4 e⁻ unconfirmed); the sensors' timings follow when TO's rerun lands.  Parts counts and TRL to follow (campaign brief sec. 9.1).</a:t>
+              <a:t>Camera timings are TO's records on an IMX250MZR-class camera (2448 × 2048, 75 fps; well ~10 ke⁻ and read 2.4 e⁻ unconfirmed; the IFO's four analyzer frames in one exposure; S and P on the mono variant at 18.8 readings/s).  The sensors are 10–40× slower than photons ÷ full-sensor rate would say: the ZWFS image's bright core sets the exposure (dynamic range), the frame mean sits at half well, and two polarization orientations go unused — the IFO's uniform pupil does not pay those.  Parts counts and TRL to follow (campaign brief sec. 9.1).</a:t>
             </a:r>
           </a:p>
         </p:txBody>
@@ -10411,7 +10431,7 @@
         </p:nvGraphicFramePr>
         <p:xfrm>
           <a:off x="411480" y="1298448"/>
-          <a:ext cx="11368733" cy="5160645"/>
+          <a:ext cx="11368733" cy="5915025"/>
         </p:xfrm>
         <a:graphic>
           <a:graphicData uri="http://schemas.openxmlformats.org/drawingml/2006/table">
@@ -10421,12 +10441,12 @@
               </a:tblPr>
               <a:tblGrid>
                 <a:gridCol w="2325624"/>
-                <a:gridCol w="1840919"/>
-                <a:gridCol w="1937809"/>
-                <a:gridCol w="1162685"/>
-                <a:gridCol w="4101696"/>
+                <a:gridCol w="4124927"/>
+                <a:gridCol w="1189883"/>
+                <a:gridCol w="713929"/>
+                <a:gridCol w="3014370"/>
               </a:tblGrid>
-              <a:tr h="657225">
+              <a:tr h="845820">
                 <a:tc>
                   <a:txBody>
                     <a:bodyPr wrap="square"/>
@@ -10629,13 +10649,125 @@
                           </a:solidFill>
                           <a:latin typeface="Arial"/>
                         </a:rPr>
-                        <a:t>~130 samples at the well-capped rate (≈ 9 × 10¹² e⁻ per cycle: 2.8 × 10⁵ elements × 250 ke per sample × 130) — loop run pending</a:t>
-                      </a:r>
-                    </a:p>
-                  </a:txBody>
-                  <a:tcPr marL="54864" marR="54864" marT="18288" marB="18288">
-                    <a:solidFill>
-                      <a:srgbClr val="FFFFFF"/>
+                        <a:t>~9 × 10¹² (125 samples at the capped 250 ke per element)</a:t>
+                      </a:r>
+                    </a:p>
+                  </a:txBody>
+                  <a:tcPr marL="54864" marR="54864" marT="18288" marB="18288">
+                    <a:solidFill>
+                      <a:srgbClr val="FFFFFF"/>
+                    </a:solidFill>
+                  </a:tcPr>
+                </a:tc>
+              </a:tr>
+              <a:tr h="845820">
+                <a:tc>
+                  <a:txBody>
+                    <a:bodyPr wrap="square"/>
+                    <a:lstStyle/>
+                    <a:p>
+                      <a:r>
+                        <a:rPr sz="1100" b="0">
+                          <a:solidFill>
+                            <a:srgbClr val="282828"/>
+                          </a:solidFill>
+                          <a:latin typeface="Arial"/>
+                        </a:rPr>
+                        <a:t>time per 3 pm hold cycle</a:t>
+                      </a:r>
+                    </a:p>
+                  </a:txBody>
+                  <a:tcPr marL="54864" marR="54864" marT="18288" marB="18288">
+                    <a:solidFill>
+                      <a:srgbClr val="ECF1F6"/>
+                    </a:solidFill>
+                  </a:tcPr>
+                </a:tc>
+                <a:tc>
+                  <a:txBody>
+                    <a:bodyPr wrap="square"/>
+                    <a:lstStyle/>
+                    <a:p>
+                      <a:r>
+                        <a:rPr sz="1100" b="0">
+                          <a:solidFill>
+                            <a:srgbClr val="282828"/>
+                          </a:solidFill>
+                          <a:latin typeface="Arial"/>
+                        </a:rPr>
+                        <a:t>~60 s on the assumed polarization camera (519 s per pm ÷ 9; its 10 ke⁻ well, the core's dynamic range and two unused orientations — the gauge deck's photon count stands, the camera is the ZWFS's own question)</a:t>
+                      </a:r>
+                    </a:p>
+                  </a:txBody>
+                  <a:tcPr marL="54864" marR="54864" marT="18288" marB="18288">
+                    <a:solidFill>
+                      <a:srgbClr val="ECF1F6"/>
+                    </a:solidFill>
+                  </a:tcPr>
+                </a:tc>
+                <a:tc>
+                  <a:txBody>
+                    <a:bodyPr wrap="square"/>
+                    <a:lstStyle/>
+                    <a:p>
+                      <a:r>
+                        <a:rPr sz="1100" b="0">
+                          <a:solidFill>
+                            <a:srgbClr val="282828"/>
+                          </a:solidFill>
+                          <a:latin typeface="Arial"/>
+                        </a:rPr>
+                        <a:t>16 s</a:t>
+                      </a:r>
+                    </a:p>
+                  </a:txBody>
+                  <a:tcPr marL="54864" marR="54864" marT="18288" marB="18288">
+                    <a:solidFill>
+                      <a:srgbClr val="ECF1F6"/>
+                    </a:solidFill>
+                  </a:tcPr>
+                </a:tc>
+                <a:tc>
+                  <a:txBody>
+                    <a:bodyPr wrap="square"/>
+                    <a:lstStyle/>
+                    <a:p>
+                      <a:r>
+                        <a:rPr sz="1100" b="0">
+                          <a:solidFill>
+                            <a:srgbClr val="282828"/>
+                          </a:solidFill>
+                          <a:latin typeface="Arial"/>
+                        </a:rPr>
+                        <a:t>1.6 s</a:t>
+                      </a:r>
+                    </a:p>
+                  </a:txBody>
+                  <a:tcPr marL="54864" marR="54864" marT="18288" marB="18288">
+                    <a:solidFill>
+                      <a:srgbClr val="ECF1F6"/>
+                    </a:solidFill>
+                  </a:tcPr>
+                </a:tc>
+                <a:tc>
+                  <a:txBody>
+                    <a:bodyPr wrap="square"/>
+                    <a:lstStyle/>
+                    <a:p>
+                      <a:r>
+                        <a:rPr sz="1100" b="0">
+                          <a:solidFill>
+                            <a:srgbClr val="282828"/>
+                          </a:solidFill>
+                          <a:latin typeface="Arial"/>
+                        </a:rPr>
+                        <a:t>0.125 s (record: 3.09 pm)</a:t>
+                      </a:r>
+                    </a:p>
+                  </a:txBody>
+                  <a:tcPr marL="54864" marR="54864" marT="18288" marB="18288">
+                    <a:solidFill>
+                      <a:srgbClr val="ECF1F6"/>
                     </a:solidFill>
                   </a:tcPr>
                 </a:tc>
@@ -10653,7 +10785,119 @@
                           </a:solidFill>
                           <a:latin typeface="Arial"/>
                         </a:rPr>
-                        <a:t>time per 3 pm hold cycle</a:t>
+                        <a:t>seconds to SNR 1 at 1 pm</a:t>
+                      </a:r>
+                    </a:p>
+                  </a:txBody>
+                  <a:tcPr marL="54864" marR="54864" marT="18288" marB="18288">
+                    <a:solidFill>
+                      <a:srgbClr val="FFFFFF"/>
+                    </a:solidFill>
+                  </a:tcPr>
+                </a:tc>
+                <a:tc>
+                  <a:txBody>
+                    <a:bodyPr wrap="square"/>
+                    <a:lstStyle/>
+                    <a:p>
+                      <a:r>
+                        <a:rPr sz="1100" b="0">
+                          <a:solidFill>
+                            <a:srgbClr val="282828"/>
+                          </a:solidFill>
+                          <a:latin typeface="Arial"/>
+                        </a:rPr>
+                        <a:t>519 (polarization camera, record)</a:t>
+                      </a:r>
+                    </a:p>
+                  </a:txBody>
+                  <a:tcPr marL="54864" marR="54864" marT="18288" marB="18288">
+                    <a:solidFill>
+                      <a:srgbClr val="FFFFFF"/>
+                    </a:solidFill>
+                  </a:tcPr>
+                </a:tc>
+                <a:tc>
+                  <a:txBody>
+                    <a:bodyPr wrap="square"/>
+                    <a:lstStyle/>
+                    <a:p>
+                      <a:r>
+                        <a:rPr sz="1100" b="0">
+                          <a:solidFill>
+                            <a:srgbClr val="282828"/>
+                          </a:solidFill>
+                          <a:latin typeface="Arial"/>
+                        </a:rPr>
+                        <a:t>443 / 385</a:t>
+                      </a:r>
+                    </a:p>
+                  </a:txBody>
+                  <a:tcPr marL="54864" marR="54864" marT="18288" marB="18288">
+                    <a:solidFill>
+                      <a:srgbClr val="FFFFFF"/>
+                    </a:solidFill>
+                  </a:tcPr>
+                </a:tc>
+                <a:tc>
+                  <a:txBody>
+                    <a:bodyPr wrap="square"/>
+                    <a:lstStyle/>
+                    <a:p>
+                      <a:r>
+                        <a:rPr sz="1100" b="0">
+                          <a:solidFill>
+                            <a:srgbClr val="282828"/>
+                          </a:solidFill>
+                          <a:latin typeface="Arial"/>
+                        </a:rPr>
+                        <a:t>42 / 36</a:t>
+                      </a:r>
+                    </a:p>
+                  </a:txBody>
+                  <a:tcPr marL="54864" marR="54864" marT="18288" marB="18288">
+                    <a:solidFill>
+                      <a:srgbClr val="FFFFFF"/>
+                    </a:solidFill>
+                  </a:tcPr>
+                </a:tc>
+                <a:tc>
+                  <a:txBody>
+                    <a:bodyPr wrap="square"/>
+                    <a:lstStyle/>
+                    <a:p>
+                      <a:r>
+                        <a:rPr sz="1100" b="0">
+                          <a:solidFill>
+                            <a:srgbClr val="282828"/>
+                          </a:solidFill>
+                          <a:latin typeface="Arial"/>
+                        </a:rPr>
+                        <a:t>3.35 / 3.73 (×1.11 for square-wave demodulation)</a:t>
+                      </a:r>
+                    </a:p>
+                  </a:txBody>
+                  <a:tcPr marL="54864" marR="54864" marT="18288" marB="18288">
+                    <a:solidFill>
+                      <a:srgbClr val="FFFFFF"/>
+                    </a:solidFill>
+                  </a:tcPr>
+                </a:tc>
+              </a:tr>
+              <a:tr h="657225">
+                <a:tc>
+                  <a:txBody>
+                    <a:bodyPr wrap="square"/>
+                    <a:lstStyle/>
+                    <a:p>
+                      <a:r>
+                        <a:rPr sz="1100" b="0">
+                          <a:solidFill>
+                            <a:srgbClr val="282828"/>
+                          </a:solidFill>
+                          <a:latin typeface="Arial"/>
+                        </a:rPr>
+                        <a:t>capture from cold</a:t>
                       </a:r>
                     </a:p>
                   </a:txBody>
@@ -10675,7 +10919,7 @@
                           </a:solidFill>
                           <a:latin typeface="Arial"/>
                         </a:rPr>
-                        <a:t>~1 s class (one frame; gauge deck)</a:t>
+                        <a:t>no: the reference ages past 36–70 nm</a:t>
                       </a:r>
                     </a:p>
                   </a:txBody>
@@ -10697,7 +10941,7 @@
                           </a:solidFill>
                           <a:latin typeface="Arial"/>
                         </a:rPr>
-                        <a:t>16 s</a:t>
+                        <a:t>yes: two colors, one 0.27 s reading</a:t>
                       </a:r>
                     </a:p>
                   </a:txBody>
@@ -10719,7 +10963,7 @@
                           </a:solidFill>
                           <a:latin typeface="Arial"/>
                         </a:rPr>
-                        <a:t>1.6 s</a:t>
+                        <a:t>yes</a:t>
                       </a:r>
                     </a:p>
                   </a:txBody>
@@ -10741,7 +10985,231 @@
                           </a:solidFill>
                           <a:latin typeface="Arial"/>
                         </a:rPr>
-                        <a:t>~0.13 s (derived; loop run pending)</a:t>
+                        <a:t>yes: two colors on alternate I/Q samples, zero wrong orders to 480 nm (record)</a:t>
+                      </a:r>
+                    </a:p>
+                  </a:txBody>
+                  <a:tcPr marL="54864" marR="54864" marT="18288" marB="18288">
+                    <a:solidFill>
+                      <a:srgbClr val="ECF1F6"/>
+                    </a:solidFill>
+                  </a:tcPr>
+                </a:tc>
+              </a:tr>
+              <a:tr h="657225">
+                <a:tc>
+                  <a:txBody>
+                    <a:bodyPr wrap="square"/>
+                    <a:lstStyle/>
+                    <a:p>
+                      <a:r>
+                        <a:rPr sz="1100" b="0">
+                          <a:solidFill>
+                            <a:srgbClr val="282828"/>
+                          </a:solidFill>
+                          <a:latin typeface="Arial"/>
+                        </a:rPr>
+                        <a:t>absolute read</a:t>
+                      </a:r>
+                    </a:p>
+                  </a:txBody>
+                  <a:tcPr marL="54864" marR="54864" marT="18288" marB="18288">
+                    <a:solidFill>
+                      <a:srgbClr val="FFFFFF"/>
+                    </a:solidFill>
+                  </a:tcPr>
+                </a:tc>
+                <a:tc>
+                  <a:txBody>
+                    <a:bodyPr wrap="square"/>
+                    <a:lstStyle/>
+                    <a:p>
+                      <a:r>
+                        <a:rPr sz="1100" b="0">
+                          <a:solidFill>
+                            <a:srgbClr val="282828"/>
+                          </a:solidFill>
+                          <a:latin typeface="Arial"/>
+                        </a:rPr>
+                        <a:t>needs the reference iterated or a matrix re-measured</a:t>
+                      </a:r>
+                    </a:p>
+                  </a:txBody>
+                  <a:tcPr marL="54864" marR="54864" marT="18288" marB="18288">
+                    <a:solidFill>
+                      <a:srgbClr val="FFFFFF"/>
+                    </a:solidFill>
+                  </a:tcPr>
+                </a:tc>
+                <a:tc>
+                  <a:txBody>
+                    <a:bodyPr wrap="square"/>
+                    <a:lstStyle/>
+                    <a:p>
+                      <a:r>
+                        <a:rPr sz="1100" b="0">
+                          <a:solidFill>
+                            <a:srgbClr val="282828"/>
+                          </a:solidFill>
+                          <a:latin typeface="Arial"/>
+                        </a:rPr>
+                        <a:t>exact (slope 1.000000) through the LO</a:t>
+                      </a:r>
+                    </a:p>
+                  </a:txBody>
+                  <a:tcPr marL="54864" marR="54864" marT="18288" marB="18288">
+                    <a:solidFill>
+                      <a:srgbClr val="FFFFFF"/>
+                    </a:solidFill>
+                  </a:tcPr>
+                </a:tc>
+                <a:tc>
+                  <a:txBody>
+                    <a:bodyPr wrap="square"/>
+                    <a:lstStyle/>
+                    <a:p>
+                      <a:r>
+                        <a:rPr sz="1100" b="0">
+                          <a:solidFill>
+                            <a:srgbClr val="282828"/>
+                          </a:solidFill>
+                          <a:latin typeface="Arial"/>
+                        </a:rPr>
+                        <a:t>exact</a:t>
+                      </a:r>
+                    </a:p>
+                  </a:txBody>
+                  <a:tcPr marL="54864" marR="54864" marT="18288" marB="18288">
+                    <a:solidFill>
+                      <a:srgbClr val="FFFFFF"/>
+                    </a:solidFill>
+                  </a:tcPr>
+                </a:tc>
+                <a:tc>
+                  <a:txBody>
+                    <a:bodyPr wrap="square"/>
+                    <a:lstStyle/>
+                    <a:p>
+                      <a:r>
+                        <a:rPr sz="1100" b="0">
+                          <a:solidFill>
+                            <a:srgbClr val="282828"/>
+                          </a:solidFill>
+                          <a:latin typeface="Arial"/>
+                        </a:rPr>
+                        <a:t>exact</a:t>
+                      </a:r>
+                    </a:p>
+                  </a:txBody>
+                  <a:tcPr marL="54864" marR="54864" marT="18288" marB="18288">
+                    <a:solidFill>
+                      <a:srgbClr val="FFFFFF"/>
+                    </a:solidFill>
+                  </a:tcPr>
+                </a:tc>
+              </a:tr>
+              <a:tr h="845820">
+                <a:tc>
+                  <a:txBody>
+                    <a:bodyPr wrap="square"/>
+                    <a:lstStyle/>
+                    <a:p>
+                      <a:r>
+                        <a:rPr sz="1100" b="0">
+                          <a:solidFill>
+                            <a:srgbClr val="282828"/>
+                          </a:solidFill>
+                          <a:latin typeface="Arial"/>
+                        </a:rPr>
+                        <a:t>its own stabilities</a:t>
+                      </a:r>
+                    </a:p>
+                  </a:txBody>
+                  <a:tcPr marL="54864" marR="54864" marT="18288" marB="18288">
+                    <a:solidFill>
+                      <a:srgbClr val="ECF1F6"/>
+                    </a:solidFill>
+                  </a:tcPr>
+                </a:tc>
+                <a:tc>
+                  <a:txBody>
+                    <a:bodyPr wrap="square"/>
+                    <a:lstStyle/>
+                    <a:p>
+                      <a:r>
+                        <a:rPr sz="1100" b="0">
+                          <a:solidFill>
+                            <a:srgbClr val="282828"/>
+                          </a:solidFill>
+                          <a:latin typeface="Arial"/>
+                        </a:rPr>
+                        <a:t>none beyond the bench</a:t>
+                      </a:r>
+                    </a:p>
+                  </a:txBody>
+                  <a:tcPr marL="54864" marR="54864" marT="18288" marB="18288">
+                    <a:solidFill>
+                      <a:srgbClr val="ECF1F6"/>
+                    </a:solidFill>
+                  </a:tcPr>
+                </a:tc>
+                <a:tc>
+                  <a:txBody>
+                    <a:bodyPr wrap="square"/>
+                    <a:lstStyle/>
+                    <a:p>
+                      <a:r>
+                        <a:rPr sz="1100" b="0">
+                          <a:solidFill>
+                            <a:srgbClr val="282828"/>
+                          </a:solidFill>
+                          <a:latin typeface="Arial"/>
+                        </a:rPr>
+                        <a:t>fiber phase 0.39 nm per frame; LO pointing 10 prad per cycle</a:t>
+                      </a:r>
+                    </a:p>
+                  </a:txBody>
+                  <a:tcPr marL="54864" marR="54864" marT="18288" marB="18288">
+                    <a:solidFill>
+                      <a:srgbClr val="ECF1F6"/>
+                    </a:solidFill>
+                  </a:tcPr>
+                </a:tc>
+                <a:tc>
+                  <a:txBody>
+                    <a:bodyPr wrap="square"/>
+                    <a:lstStyle/>
+                    <a:p>
+                      <a:r>
+                        <a:rPr sz="1100" b="0">
+                          <a:solidFill>
+                            <a:srgbClr val="282828"/>
+                          </a:solidFill>
+                          <a:latin typeface="Arial"/>
+                        </a:rPr>
+                        <a:t>same</a:t>
+                      </a:r>
+                    </a:p>
+                  </a:txBody>
+                  <a:tcPr marL="54864" marR="54864" marT="18288" marB="18288">
+                    <a:solidFill>
+                      <a:srgbClr val="ECF1F6"/>
+                    </a:solidFill>
+                  </a:tcPr>
+                </a:tc>
+                <a:tc>
+                  <a:txBody>
+                    <a:bodyPr wrap="square"/>
+                    <a:lstStyle/>
+                    <a:p>
+                      <a:r>
+                        <a:rPr sz="1100" b="0">
+                          <a:solidFill>
+                            <a:srgbClr val="282828"/>
+                          </a:solidFill>
+                          <a:latin typeface="Arial"/>
+                        </a:rPr>
+                        <a:t>LO pointing the same (29.4 pm); fiber walk a piston per sample — inert: the loop at the budget and at 3× reads its noise-only hold to the digit (record)</a:t>
                       </a:r>
                     </a:p>
                   </a:txBody>
@@ -10765,95 +11233,95 @@
                           </a:solidFill>
                           <a:latin typeface="Arial"/>
                         </a:rPr>
-                        <a:t>seconds to SNR 1 at 1 pm</a:t>
-                      </a:r>
-                    </a:p>
-                  </a:txBody>
-                  <a:tcPr marL="54864" marR="54864" marT="18288" marB="18288">
-                    <a:solidFill>
-                      <a:srgbClr val="FFFFFF"/>
-                    </a:solidFill>
-                  </a:tcPr>
-                </a:tc>
-                <a:tc>
-                  <a:txBody>
-                    <a:bodyPr wrap="square"/>
-                    <a:lstStyle/>
-                    <a:p>
-                      <a:r>
-                        <a:rPr sz="1100" b="0">
-                          <a:solidFill>
-                            <a:srgbClr val="282828"/>
-                          </a:solidFill>
-                          <a:latin typeface="Arial"/>
-                        </a:rPr>
-                        <a:t>first cut withdrawn (TO's rerun pending)</a:t>
-                      </a:r>
-                    </a:p>
-                  </a:txBody>
-                  <a:tcPr marL="54864" marR="54864" marT="18288" marB="18288">
-                    <a:solidFill>
-                      <a:srgbClr val="FFFFFF"/>
-                    </a:solidFill>
-                  </a:tcPr>
-                </a:tc>
-                <a:tc>
-                  <a:txBody>
-                    <a:bodyPr wrap="square"/>
-                    <a:lstStyle/>
-                    <a:p>
-                      <a:r>
-                        <a:rPr sz="1100" b="0">
-                          <a:solidFill>
-                            <a:srgbClr val="282828"/>
-                          </a:solidFill>
-                          <a:latin typeface="Arial"/>
-                        </a:rPr>
-                        <a:t>443 / 385</a:t>
-                      </a:r>
-                    </a:p>
-                  </a:txBody>
-                  <a:tcPr marL="54864" marR="54864" marT="18288" marB="18288">
-                    <a:solidFill>
-                      <a:srgbClr val="FFFFFF"/>
-                    </a:solidFill>
-                  </a:tcPr>
-                </a:tc>
-                <a:tc>
-                  <a:txBody>
-                    <a:bodyPr wrap="square"/>
-                    <a:lstStyle/>
-                    <a:p>
-                      <a:r>
-                        <a:rPr sz="1100" b="0">
-                          <a:solidFill>
-                            <a:srgbClr val="282828"/>
-                          </a:solidFill>
-                          <a:latin typeface="Arial"/>
-                        </a:rPr>
-                        <a:t>42 / 36</a:t>
-                      </a:r>
-                    </a:p>
-                  </a:txBody>
-                  <a:tcPr marL="54864" marR="54864" marT="18288" marB="18288">
-                    <a:solidFill>
-                      <a:srgbClr val="FFFFFF"/>
-                    </a:solidFill>
-                  </a:tcPr>
-                </a:tc>
-                <a:tc>
-                  <a:txBody>
-                    <a:bodyPr wrap="square"/>
-                    <a:lstStyle/>
-                    <a:p>
-                      <a:r>
-                        <a:rPr sz="1100" b="0">
-                          <a:solidFill>
-                            <a:srgbClr val="282828"/>
-                          </a:solidFill>
-                          <a:latin typeface="Arial"/>
-                        </a:rPr>
-                        <a:t>3.4 / 4.0 (read 0 / 100; ×1.11 for square-wave demodulation)</a:t>
+                        <a:t>electronics it adds</a:t>
+                      </a:r>
+                    </a:p>
+                  </a:txBody>
+                  <a:tcPr marL="54864" marR="54864" marT="18288" marB="18288">
+                    <a:solidFill>
+                      <a:srgbClr val="FFFFFF"/>
+                    </a:solidFill>
+                  </a:tcPr>
+                </a:tc>
+                <a:tc>
+                  <a:txBody>
+                    <a:bodyPr wrap="square"/>
+                    <a:lstStyle/>
+                    <a:p>
+                      <a:r>
+                        <a:rPr sz="1100" b="0">
+                          <a:solidFill>
+                            <a:srgbClr val="282828"/>
+                          </a:solidFill>
+                          <a:latin typeface="Arial"/>
+                        </a:rPr>
+                        <a:t>a laser</a:t>
+                      </a:r>
+                    </a:p>
+                  </a:txBody>
+                  <a:tcPr marL="54864" marR="54864" marT="18288" marB="18288">
+                    <a:solidFill>
+                      <a:srgbClr val="FFFFFF"/>
+                    </a:solidFill>
+                  </a:tcPr>
+                </a:tc>
+                <a:tc>
+                  <a:txBody>
+                    <a:bodyPr wrap="square"/>
+                    <a:lstStyle/>
+                    <a:p>
+                      <a:r>
+                        <a:rPr sz="1100" b="0">
+                          <a:solidFill>
+                            <a:srgbClr val="282828"/>
+                          </a:solidFill>
+                          <a:latin typeface="Arial"/>
+                        </a:rPr>
+                        <a:t>RF chain, fiber LO, two loops</a:t>
+                      </a:r>
+                    </a:p>
+                  </a:txBody>
+                  <a:tcPr marL="54864" marR="54864" marT="18288" marB="18288">
+                    <a:solidFill>
+                      <a:srgbClr val="FFFFFF"/>
+                    </a:solidFill>
+                  </a:tcPr>
+                </a:tc>
+                <a:tc>
+                  <a:txBody>
+                    <a:bodyPr wrap="square"/>
+                    <a:lstStyle/>
+                    <a:p>
+                      <a:r>
+                        <a:rPr sz="1100" b="0">
+                          <a:solidFill>
+                            <a:srgbClr val="282828"/>
+                          </a:solidFill>
+                          <a:latin typeface="Arial"/>
+                        </a:rPr>
+                        <a:t>same</a:t>
+                      </a:r>
+                    </a:p>
+                  </a:txBody>
+                  <a:tcPr marL="54864" marR="54864" marT="18288" marB="18288">
+                    <a:solidFill>
+                      <a:srgbClr val="FFFFFF"/>
+                    </a:solidFill>
+                  </a:tcPr>
+                </a:tc>
+                <a:tc>
+                  <a:txBody>
+                    <a:bodyPr wrap="square"/>
+                    <a:lstStyle/>
+                    <a:p>
+                      <a:r>
+                        <a:rPr sz="1100" b="0">
+                          <a:solidFill>
+                            <a:srgbClr val="282828"/>
+                          </a:solidFill>
+                          <a:latin typeface="Arial"/>
+                        </a:rPr>
+                        <a:t>same, beat at kHz; demodulation on-chip; I/Q data at 1 kHz</a:t>
                       </a:r>
                     </a:p>
                   </a:txBody>
@@ -10865,454 +11333,6 @@
                 </a:tc>
               </a:tr>
               <a:tr h="468630">
-                <a:tc>
-                  <a:txBody>
-                    <a:bodyPr wrap="square"/>
-                    <a:lstStyle/>
-                    <a:p>
-                      <a:r>
-                        <a:rPr sz="1100" b="0">
-                          <a:solidFill>
-                            <a:srgbClr val="282828"/>
-                          </a:solidFill>
-                          <a:latin typeface="Arial"/>
-                        </a:rPr>
-                        <a:t>capture from cold</a:t>
-                      </a:r>
-                    </a:p>
-                  </a:txBody>
-                  <a:tcPr marL="54864" marR="54864" marT="18288" marB="18288">
-                    <a:solidFill>
-                      <a:srgbClr val="ECF1F6"/>
-                    </a:solidFill>
-                  </a:tcPr>
-                </a:tc>
-                <a:tc>
-                  <a:txBody>
-                    <a:bodyPr wrap="square"/>
-                    <a:lstStyle/>
-                    <a:p>
-                      <a:r>
-                        <a:rPr sz="1100" b="0">
-                          <a:solidFill>
-                            <a:srgbClr val="282828"/>
-                          </a:solidFill>
-                          <a:latin typeface="Arial"/>
-                        </a:rPr>
-                        <a:t>no: the reference ages past 36–70 nm</a:t>
-                      </a:r>
-                    </a:p>
-                  </a:txBody>
-                  <a:tcPr marL="54864" marR="54864" marT="18288" marB="18288">
-                    <a:solidFill>
-                      <a:srgbClr val="ECF1F6"/>
-                    </a:solidFill>
-                  </a:tcPr>
-                </a:tc>
-                <a:tc>
-                  <a:txBody>
-                    <a:bodyPr wrap="square"/>
-                    <a:lstStyle/>
-                    <a:p>
-                      <a:r>
-                        <a:rPr sz="1100" b="0">
-                          <a:solidFill>
-                            <a:srgbClr val="282828"/>
-                          </a:solidFill>
-                          <a:latin typeface="Arial"/>
-                        </a:rPr>
-                        <a:t>yes: two colors, one 0.27 s reading</a:t>
-                      </a:r>
-                    </a:p>
-                  </a:txBody>
-                  <a:tcPr marL="54864" marR="54864" marT="18288" marB="18288">
-                    <a:solidFill>
-                      <a:srgbClr val="ECF1F6"/>
-                    </a:solidFill>
-                  </a:tcPr>
-                </a:tc>
-                <a:tc>
-                  <a:txBody>
-                    <a:bodyPr wrap="square"/>
-                    <a:lstStyle/>
-                    <a:p>
-                      <a:r>
-                        <a:rPr sz="1100" b="0">
-                          <a:solidFill>
-                            <a:srgbClr val="282828"/>
-                          </a:solidFill>
-                          <a:latin typeface="Arial"/>
-                        </a:rPr>
-                        <a:t>yes</a:t>
-                      </a:r>
-                    </a:p>
-                  </a:txBody>
-                  <a:tcPr marL="54864" marR="54864" marT="18288" marB="18288">
-                    <a:solidFill>
-                      <a:srgbClr val="ECF1F6"/>
-                    </a:solidFill>
-                  </a:tcPr>
-                </a:tc>
-                <a:tc>
-                  <a:txBody>
-                    <a:bodyPr wrap="square"/>
-                    <a:lstStyle/>
-                    <a:p>
-                      <a:r>
-                        <a:rPr sz="1100" b="0">
-                          <a:solidFill>
-                            <a:srgbClr val="282828"/>
-                          </a:solidFill>
-                          <a:latin typeface="Arial"/>
-                        </a:rPr>
-                        <a:t>yes: two colors on alternate I/Q samples (2 ms)</a:t>
-                      </a:r>
-                    </a:p>
-                  </a:txBody>
-                  <a:tcPr marL="54864" marR="54864" marT="18288" marB="18288">
-                    <a:solidFill>
-                      <a:srgbClr val="ECF1F6"/>
-                    </a:solidFill>
-                  </a:tcPr>
-                </a:tc>
-              </a:tr>
-              <a:tr h="657225">
-                <a:tc>
-                  <a:txBody>
-                    <a:bodyPr wrap="square"/>
-                    <a:lstStyle/>
-                    <a:p>
-                      <a:r>
-                        <a:rPr sz="1100" b="0">
-                          <a:solidFill>
-                            <a:srgbClr val="282828"/>
-                          </a:solidFill>
-                          <a:latin typeface="Arial"/>
-                        </a:rPr>
-                        <a:t>absolute read</a:t>
-                      </a:r>
-                    </a:p>
-                  </a:txBody>
-                  <a:tcPr marL="54864" marR="54864" marT="18288" marB="18288">
-                    <a:solidFill>
-                      <a:srgbClr val="FFFFFF"/>
-                    </a:solidFill>
-                  </a:tcPr>
-                </a:tc>
-                <a:tc>
-                  <a:txBody>
-                    <a:bodyPr wrap="square"/>
-                    <a:lstStyle/>
-                    <a:p>
-                      <a:r>
-                        <a:rPr sz="1100" b="0">
-                          <a:solidFill>
-                            <a:srgbClr val="282828"/>
-                          </a:solidFill>
-                          <a:latin typeface="Arial"/>
-                        </a:rPr>
-                        <a:t>needs the reference iterated or a matrix re-measured</a:t>
-                      </a:r>
-                    </a:p>
-                  </a:txBody>
-                  <a:tcPr marL="54864" marR="54864" marT="18288" marB="18288">
-                    <a:solidFill>
-                      <a:srgbClr val="FFFFFF"/>
-                    </a:solidFill>
-                  </a:tcPr>
-                </a:tc>
-                <a:tc>
-                  <a:txBody>
-                    <a:bodyPr wrap="square"/>
-                    <a:lstStyle/>
-                    <a:p>
-                      <a:r>
-                        <a:rPr sz="1100" b="0">
-                          <a:solidFill>
-                            <a:srgbClr val="282828"/>
-                          </a:solidFill>
-                          <a:latin typeface="Arial"/>
-                        </a:rPr>
-                        <a:t>exact (slope 1.000000) through the LO</a:t>
-                      </a:r>
-                    </a:p>
-                  </a:txBody>
-                  <a:tcPr marL="54864" marR="54864" marT="18288" marB="18288">
-                    <a:solidFill>
-                      <a:srgbClr val="FFFFFF"/>
-                    </a:solidFill>
-                  </a:tcPr>
-                </a:tc>
-                <a:tc>
-                  <a:txBody>
-                    <a:bodyPr wrap="square"/>
-                    <a:lstStyle/>
-                    <a:p>
-                      <a:r>
-                        <a:rPr sz="1100" b="0">
-                          <a:solidFill>
-                            <a:srgbClr val="282828"/>
-                          </a:solidFill>
-                          <a:latin typeface="Arial"/>
-                        </a:rPr>
-                        <a:t>exact</a:t>
-                      </a:r>
-                    </a:p>
-                  </a:txBody>
-                  <a:tcPr marL="54864" marR="54864" marT="18288" marB="18288">
-                    <a:solidFill>
-                      <a:srgbClr val="FFFFFF"/>
-                    </a:solidFill>
-                  </a:tcPr>
-                </a:tc>
-                <a:tc>
-                  <a:txBody>
-                    <a:bodyPr wrap="square"/>
-                    <a:lstStyle/>
-                    <a:p>
-                      <a:r>
-                        <a:rPr sz="1100" b="0">
-                          <a:solidFill>
-                            <a:srgbClr val="282828"/>
-                          </a:solidFill>
-                          <a:latin typeface="Arial"/>
-                        </a:rPr>
-                        <a:t>exact</a:t>
-                      </a:r>
-                    </a:p>
-                  </a:txBody>
-                  <a:tcPr marL="54864" marR="54864" marT="18288" marB="18288">
-                    <a:solidFill>
-                      <a:srgbClr val="FFFFFF"/>
-                    </a:solidFill>
-                  </a:tcPr>
-                </a:tc>
-              </a:tr>
-              <a:tr h="657225">
-                <a:tc>
-                  <a:txBody>
-                    <a:bodyPr wrap="square"/>
-                    <a:lstStyle/>
-                    <a:p>
-                      <a:r>
-                        <a:rPr sz="1100" b="0">
-                          <a:solidFill>
-                            <a:srgbClr val="282828"/>
-                          </a:solidFill>
-                          <a:latin typeface="Arial"/>
-                        </a:rPr>
-                        <a:t>its own stabilities</a:t>
-                      </a:r>
-                    </a:p>
-                  </a:txBody>
-                  <a:tcPr marL="54864" marR="54864" marT="18288" marB="18288">
-                    <a:solidFill>
-                      <a:srgbClr val="ECF1F6"/>
-                    </a:solidFill>
-                  </a:tcPr>
-                </a:tc>
-                <a:tc>
-                  <a:txBody>
-                    <a:bodyPr wrap="square"/>
-                    <a:lstStyle/>
-                    <a:p>
-                      <a:r>
-                        <a:rPr sz="1100" b="0">
-                          <a:solidFill>
-                            <a:srgbClr val="282828"/>
-                          </a:solidFill>
-                          <a:latin typeface="Arial"/>
-                        </a:rPr>
-                        <a:t>none beyond the bench</a:t>
-                      </a:r>
-                    </a:p>
-                  </a:txBody>
-                  <a:tcPr marL="54864" marR="54864" marT="18288" marB="18288">
-                    <a:solidFill>
-                      <a:srgbClr val="ECF1F6"/>
-                    </a:solidFill>
-                  </a:tcPr>
-                </a:tc>
-                <a:tc>
-                  <a:txBody>
-                    <a:bodyPr wrap="square"/>
-                    <a:lstStyle/>
-                    <a:p>
-                      <a:r>
-                        <a:rPr sz="1100" b="0">
-                          <a:solidFill>
-                            <a:srgbClr val="282828"/>
-                          </a:solidFill>
-                          <a:latin typeface="Arial"/>
-                        </a:rPr>
-                        <a:t>fiber phase 0.39 nm per frame; LO pointing 10 prad per cycle</a:t>
-                      </a:r>
-                    </a:p>
-                  </a:txBody>
-                  <a:tcPr marL="54864" marR="54864" marT="18288" marB="18288">
-                    <a:solidFill>
-                      <a:srgbClr val="ECF1F6"/>
-                    </a:solidFill>
-                  </a:tcPr>
-                </a:tc>
-                <a:tc>
-                  <a:txBody>
-                    <a:bodyPr wrap="square"/>
-                    <a:lstStyle/>
-                    <a:p>
-                      <a:r>
-                        <a:rPr sz="1100" b="0">
-                          <a:solidFill>
-                            <a:srgbClr val="282828"/>
-                          </a:solidFill>
-                          <a:latin typeface="Arial"/>
-                        </a:rPr>
-                        <a:t>same</a:t>
-                      </a:r>
-                    </a:p>
-                  </a:txBody>
-                  <a:tcPr marL="54864" marR="54864" marT="18288" marB="18288">
-                    <a:solidFill>
-                      <a:srgbClr val="ECF1F6"/>
-                    </a:solidFill>
-                  </a:tcPr>
-                </a:tc>
-                <a:tc>
-                  <a:txBody>
-                    <a:bodyPr wrap="square"/>
-                    <a:lstStyle/>
-                    <a:p>
-                      <a:r>
-                        <a:rPr sz="1100" b="0">
-                          <a:solidFill>
-                            <a:srgbClr val="282828"/>
-                          </a:solidFill>
-                          <a:latin typeface="Arial"/>
-                        </a:rPr>
-                        <a:t>LO pointing the same; fiber walk a piston per sample — inert (to be confirmed by the loop)</a:t>
-                      </a:r>
-                    </a:p>
-                  </a:txBody>
-                  <a:tcPr marL="54864" marR="54864" marT="18288" marB="18288">
-                    <a:solidFill>
-                      <a:srgbClr val="ECF1F6"/>
-                    </a:solidFill>
-                  </a:tcPr>
-                </a:tc>
-              </a:tr>
-              <a:tr h="468630">
-                <a:tc>
-                  <a:txBody>
-                    <a:bodyPr wrap="square"/>
-                    <a:lstStyle/>
-                    <a:p>
-                      <a:r>
-                        <a:rPr sz="1100" b="0">
-                          <a:solidFill>
-                            <a:srgbClr val="282828"/>
-                          </a:solidFill>
-                          <a:latin typeface="Arial"/>
-                        </a:rPr>
-                        <a:t>electronics it adds</a:t>
-                      </a:r>
-                    </a:p>
-                  </a:txBody>
-                  <a:tcPr marL="54864" marR="54864" marT="18288" marB="18288">
-                    <a:solidFill>
-                      <a:srgbClr val="FFFFFF"/>
-                    </a:solidFill>
-                  </a:tcPr>
-                </a:tc>
-                <a:tc>
-                  <a:txBody>
-                    <a:bodyPr wrap="square"/>
-                    <a:lstStyle/>
-                    <a:p>
-                      <a:r>
-                        <a:rPr sz="1100" b="0">
-                          <a:solidFill>
-                            <a:srgbClr val="282828"/>
-                          </a:solidFill>
-                          <a:latin typeface="Arial"/>
-                        </a:rPr>
-                        <a:t>a laser</a:t>
-                      </a:r>
-                    </a:p>
-                  </a:txBody>
-                  <a:tcPr marL="54864" marR="54864" marT="18288" marB="18288">
-                    <a:solidFill>
-                      <a:srgbClr val="FFFFFF"/>
-                    </a:solidFill>
-                  </a:tcPr>
-                </a:tc>
-                <a:tc>
-                  <a:txBody>
-                    <a:bodyPr wrap="square"/>
-                    <a:lstStyle/>
-                    <a:p>
-                      <a:r>
-                        <a:rPr sz="1100" b="0">
-                          <a:solidFill>
-                            <a:srgbClr val="282828"/>
-                          </a:solidFill>
-                          <a:latin typeface="Arial"/>
-                        </a:rPr>
-                        <a:t>RF chain, fiber LO, two loops</a:t>
-                      </a:r>
-                    </a:p>
-                  </a:txBody>
-                  <a:tcPr marL="54864" marR="54864" marT="18288" marB="18288">
-                    <a:solidFill>
-                      <a:srgbClr val="FFFFFF"/>
-                    </a:solidFill>
-                  </a:tcPr>
-                </a:tc>
-                <a:tc>
-                  <a:txBody>
-                    <a:bodyPr wrap="square"/>
-                    <a:lstStyle/>
-                    <a:p>
-                      <a:r>
-                        <a:rPr sz="1100" b="0">
-                          <a:solidFill>
-                            <a:srgbClr val="282828"/>
-                          </a:solidFill>
-                          <a:latin typeface="Arial"/>
-                        </a:rPr>
-                        <a:t>same</a:t>
-                      </a:r>
-                    </a:p>
-                  </a:txBody>
-                  <a:tcPr marL="54864" marR="54864" marT="18288" marB="18288">
-                    <a:solidFill>
-                      <a:srgbClr val="FFFFFF"/>
-                    </a:solidFill>
-                  </a:tcPr>
-                </a:tc>
-                <a:tc>
-                  <a:txBody>
-                    <a:bodyPr wrap="square"/>
-                    <a:lstStyle/>
-                    <a:p>
-                      <a:r>
-                        <a:rPr sz="1100" b="0">
-                          <a:solidFill>
-                            <a:srgbClr val="282828"/>
-                          </a:solidFill>
-                          <a:latin typeface="Arial"/>
-                        </a:rPr>
-                        <a:t>same, beat at kHz; demodulation on-chip; I/Q data at 1 kHz</a:t>
-                      </a:r>
-                    </a:p>
-                  </a:txBody>
-                  <a:tcPr marL="54864" marR="54864" marT="18288" marB="18288">
-                    <a:solidFill>
-                      <a:srgbClr val="FFFFFF"/>
-                    </a:solidFill>
-                  </a:tcPr>
-                </a:tc>
-              </a:tr>
-              <a:tr h="657225">
                 <a:tc>
                   <a:txBody>
                     <a:bodyPr wrap="square"/>
@@ -11436,7 +11456,7 @@
         </p:nvSpPr>
         <p:spPr>
           <a:xfrm>
-            <a:off x="411480" y="6605397"/>
+            <a:off x="411480" y="7359777"/>
             <a:ext cx="11368735" cy="274320"/>
           </a:xfrm>
           <a:prstGeom prst="rect">
@@ -11480,7 +11500,7 @@
                 </a:solidFill>
                 <a:latin typeface="Arial"/>
               </a:rPr>
-              <a:t> the vector Zernike sensor is the cheapest in photons by ~50× and needs no stabilities of its own; Feng's camera makes COPHI slow (16 s cycles); the Photonfocus makes it comparable (1.6 s); </a:t>
+              <a:t> the vector Zernike sensor is the cheapest in photons by ~50× and needs no stabilities of its own — but on the assumed polarization camera (10 ke⁻ well) it is the slowest in time, ~60 s per 3 pm cycle; Feng's camera makes COPHI slow (16 s cycles); the Photonfocus makes it fast (1.6 s); </a:t>
             </a:r>
             <a:r>
               <a:rPr sz="1500" b="1">
@@ -11498,7 +11518,7 @@
                 </a:solidFill>
                 <a:latin typeface="Arial"/>
               </a:rPr>
-              <a:t> (0.13 s cycles, 3.4 s per pm) — if its well behaves as surveyed, and with the fiber term reduced to a piston.</a:t>
+              <a:t> (0.125 s cycles at 3.09 pm, 3.35 s per pm; records) — if its well behaves as surveyed — and its fiber term is a per-sample piston, inert (record).</a:t>
             </a:r>
           </a:p>
           <a:p>
@@ -11550,7 +11570,7 @@
                 </a:solidFill>
                 <a:latin typeface="Arial"/>
               </a:rPr>
-              <a:t> hold only → the Zernike sensor; hold + capture + absolute → COPHI, and with the lock-in camera it is also the fastest; </a:t>
+              <a:t> hold only and photons scarce → the Zernike sensor, with a camera chosen for it; hold + capture + absolute, or speed → COPHI, and with the lock-in camera it is the fastest by 20–500×; </a:t>
             </a:r>
             <a:r>
               <a:rPr sz="1500" b="1">
@@ -11581,7 +11601,7 @@
         </p:nvSpPr>
         <p:spPr>
           <a:xfrm>
-            <a:off x="411480" y="9151239"/>
+            <a:off x="411480" y="10153269"/>
             <a:ext cx="11368735" cy="274320"/>
           </a:xfrm>
           <a:prstGeom prst="rect">
@@ -11607,7 +11627,7 @@
                 </a:solidFill>
                 <a:latin typeface="Arial"/>
               </a:rPr>
-              <a:t>The Zernike rows are the gauge deck's (redo96_*sens, zloop; the polarization-camera timing a first cut, TO's noise-hook run pending); the COPHI rows this deck's; the lock-in's loop / capture rows derived from the format stage until TO's runs land.</a:t>
+              <a:t>The Zernike rows are the gauge deck's (redo96_sens, zloop) with the polarization-camera timing from camS_oap; the COPHI rows this deck's; the lock-in rows are records (runs/lockin_, resources 2a07af9).</a:t>
             </a:r>
           </a:p>
         </p:txBody>
@@ -12163,7 +12183,7 @@
         </p:nvGraphicFramePr>
         <p:xfrm>
           <a:off x="411480" y="1298448"/>
-          <a:ext cx="11368733" cy="4509135"/>
+          <a:ext cx="11368733" cy="5263515"/>
         </p:xfrm>
         <a:graphic>
           <a:graphicData uri="http://schemas.openxmlformats.org/drawingml/2006/table">
@@ -12173,10 +12193,10 @@
               </a:tblPr>
               <a:tblGrid>
                 <a:gridCol w="1526540"/>
-                <a:gridCol w="2746659"/>
-                <a:gridCol w="2117216"/>
-                <a:gridCol w="4234432"/>
-                <a:gridCol w="743886"/>
+                <a:gridCol w="2426842"/>
+                <a:gridCol w="1870691"/>
+                <a:gridCol w="4887391"/>
+                <a:gridCol w="657269"/>
               </a:tblGrid>
               <a:tr h="280035">
                 <a:tc>
@@ -12290,7 +12310,7 @@
                   </a:tcPr>
                 </a:tc>
               </a:tr>
-              <a:tr h="845820">
+              <a:tr h="1034415">
                 <a:tc>
                   <a:txBody>
                     <a:bodyPr wrap="square"/>
@@ -12369,7 +12389,7 @@
                           </a:solidFill>
                           <a:latin typeface="Arial"/>
                         </a:rPr>
-                        <a:t>passive first: one coupler, co-routed in one jacket, &lt; 1 m uncommon, one thermal mount; then a pickoff between the fiber ends and a stretcher servo (SIM-MET style); the lock-in's 1 ms frame relaxes the per-frame budget 30×</a:t>
+                        <a:t>passive first: one coupler, co-routed in one jacket, &lt; 1 m uncommon, one thermal mount; then a pickoff between the fiber ends and a stretcher servo (SIM-MET style); with a lock-in camera the term is a per-sample piston, inert (record) — the requirement belongs to the four-frame camera form</a:t>
                       </a:r>
                     </a:p>
                   </a:txBody>
@@ -12398,6 +12418,118 @@
                   <a:tcPr marL="54864" marR="54864" marT="18288" marB="18288">
                     <a:solidFill>
                       <a:srgbClr val="FFFFFF"/>
+                    </a:solidFill>
+                  </a:tcPr>
+                </a:tc>
+              </a:tr>
+              <a:tr h="1034415">
+                <a:tc>
+                  <a:txBody>
+                    <a:bodyPr wrap="square"/>
+                    <a:lstStyle/>
+                    <a:p>
+                      <a:r>
+                        <a:rPr sz="1100" b="0">
+                          <a:solidFill>
+                            <a:srgbClr val="282828"/>
+                          </a:solidFill>
+                          <a:latin typeface="Arial"/>
+                        </a:rPr>
+                        <a:t>2 LO pointing</a:t>
+                      </a:r>
+                    </a:p>
+                  </a:txBody>
+                  <a:tcPr marL="54864" marR="54864" marT="18288" marB="18288">
+                    <a:solidFill>
+                      <a:srgbClr val="ECF1F6"/>
+                    </a:solidFill>
+                  </a:tcPr>
+                </a:tc>
+                <a:tc>
+                  <a:txBody>
+                    <a:bodyPr wrap="square"/>
+                    <a:lstStyle/>
+                    <a:p>
+                      <a:r>
+                        <a:rPr sz="1100" b="0">
+                          <a:solidFill>
+                            <a:srgbClr val="282828"/>
+                          </a:solidFill>
+                          <a:latin typeface="Arial"/>
+                        </a:rPr>
+                        <a:t>the LO collimator's tilt held to ~10 prad per cycle (~10 pm of fiber-tip motion), or measured and removed</a:t>
+                      </a:r>
+                    </a:p>
+                  </a:txBody>
+                  <a:tcPr marL="54864" marR="54864" marT="18288" marB="18288">
+                    <a:solidFill>
+                      <a:srgbClr val="ECF1F6"/>
+                    </a:solidFill>
+                  </a:tcPr>
+                </a:tc>
+                <a:tc>
+                  <a:txBody>
+                    <a:bodyPr wrap="square"/>
+                    <a:lstStyle/>
+                    <a:p>
+                      <a:r>
+                        <a:rPr sz="1100" b="0">
+                          <a:solidFill>
+                            <a:srgbClr val="282828"/>
+                          </a:solidFill>
+                          <a:latin typeface="Arial"/>
+                        </a:rPr>
+                        <a:t>the loop reads LO drift as DM drift one-for-one: 0.1 nrad per cycle = 29 pm of hold</a:t>
+                      </a:r>
+                    </a:p>
+                  </a:txBody>
+                  <a:tcPr marL="54864" marR="54864" marT="18288" marB="18288">
+                    <a:solidFill>
+                      <a:srgbClr val="ECF1F6"/>
+                    </a:solidFill>
+                  </a:tcPr>
+                </a:tc>
+                <a:tc>
+                  <a:txBody>
+                    <a:bodyPr wrap="square"/>
+                    <a:lstStyle/>
+                    <a:p>
+                      <a:r>
+                        <a:rPr sz="1100" b="0">
+                          <a:solidFill>
+                            <a:srgbClr val="282828"/>
+                          </a:solidFill>
+                          <a:latin typeface="Arial"/>
+                        </a:rPr>
+                        <a:t>a monolithic collimator mount on the splitter block, thermally tied; or a referenced LO: a quad cell on an LO pickoff, or a flat on the DM mount read by the same frames (the next model stage)</a:t>
+                      </a:r>
+                    </a:p>
+                  </a:txBody>
+                  <a:tcPr marL="54864" marR="54864" marT="18288" marB="18288">
+                    <a:solidFill>
+                      <a:srgbClr val="ECF1F6"/>
+                    </a:solidFill>
+                  </a:tcPr>
+                </a:tc>
+                <a:tc>
+                  <a:txBody>
+                    <a:bodyPr wrap="square"/>
+                    <a:lstStyle/>
+                    <a:p>
+                      <a:r>
+                        <a:rPr sz="1100" b="0">
+                          <a:solidFill>
+                            <a:srgbClr val="282828"/>
+                          </a:solidFill>
+                          <a:latin typeface="Arial"/>
+                        </a:rPr>
+                        <a:t>mount: weeks; referenced LO: 1–2 months</a:t>
+                      </a:r>
+                    </a:p>
+                  </a:txBody>
+                  <a:tcPr marL="54864" marR="54864" marT="18288" marB="18288">
+                    <a:solidFill>
+                      <a:srgbClr val="ECF1F6"/>
                     </a:solidFill>
                   </a:tcPr>
                 </a:tc>
@@ -12415,7 +12547,119 @@
                           </a:solidFill>
                           <a:latin typeface="Arial"/>
                         </a:rPr>
-                        <a:t>2 LO pointing</a:t>
+                        <a:t>3 Lock-in camera</a:t>
+                      </a:r>
+                    </a:p>
+                  </a:txBody>
+                  <a:tcPr marL="54864" marR="54864" marT="18288" marB="18288">
+                    <a:solidFill>
+                      <a:srgbClr val="FFFFFF"/>
+                    </a:solidFill>
+                  </a:tcPr>
+                </a:tc>
+                <a:tc>
+                  <a:txBody>
+                    <a:bodyPr wrap="square"/>
+                    <a:lstStyle/>
+                    <a:p>
+                      <a:r>
+                        <a:rPr sz="1100" b="0">
+                          <a:solidFill>
+                            <a:srgbClr val="282828"/>
+                          </a:solidFill>
+                          <a:latin typeface="Arial"/>
+                        </a:rPr>
+                        <a:t>a heliCam C4 at a 5 kHz beat on the record bench; per-pixel phase noise vs flux measured</a:t>
+                      </a:r>
+                    </a:p>
+                  </a:txBody>
+                  <a:tcPr marL="54864" marR="54864" marT="18288" marB="18288">
+                    <a:solidFill>
+                      <a:srgbClr val="FFFFFF"/>
+                    </a:solidFill>
+                  </a:tcPr>
+                </a:tc>
+                <a:tc>
+                  <a:txBody>
+                    <a:bodyPr wrap="square"/>
+                    <a:lstStyle/>
+                    <a:p>
+                      <a:r>
+                        <a:rPr sz="1100" b="0">
+                          <a:solidFill>
+                            <a:srgbClr val="282828"/>
+                          </a:solidFill>
+                          <a:latin typeface="Arial"/>
+                        </a:rPr>
+                        <a:t>~12× the Photonfocus's speed as surveyed (3.4 s per pm); the well-free question is the next factor</a:t>
+                      </a:r>
+                    </a:p>
+                  </a:txBody>
+                  <a:tcPr marL="54864" marR="54864" marT="18288" marB="18288">
+                    <a:solidFill>
+                      <a:srgbClr val="FFFFFF"/>
+                    </a:solidFill>
+                  </a:tcPr>
+                </a:tc>
+                <a:tc>
+                  <a:txBody>
+                    <a:bodyPr wrap="square"/>
+                    <a:lstStyle/>
+                    <a:p>
+                      <a:r>
+                        <a:rPr sz="1100" b="0">
+                          <a:solidFill>
+                            <a:srgbClr val="282828"/>
+                          </a:solidFill>
+                          <a:latin typeface="Arial"/>
+                        </a:rPr>
+                        <a:t>the vendor question (phase noise vs flux at t_c 100 ms; what the well bounds); a loaner on the bench, reading class H unchanged; format re-run on measured numbers</a:t>
+                      </a:r>
+                    </a:p>
+                  </a:txBody>
+                  <a:tcPr marL="54864" marR="54864" marT="18288" marB="18288">
+                    <a:solidFill>
+                      <a:srgbClr val="FFFFFF"/>
+                    </a:solidFill>
+                  </a:tcPr>
+                </a:tc>
+                <a:tc>
+                  <a:txBody>
+                    <a:bodyPr wrap="square"/>
+                    <a:lstStyle/>
+                    <a:p>
+                      <a:r>
+                        <a:rPr sz="1100" b="0">
+                          <a:solidFill>
+                            <a:srgbClr val="282828"/>
+                          </a:solidFill>
+                          <a:latin typeface="Arial"/>
+                        </a:rPr>
+                        <a:t>question: days; bench: 1–3 months</a:t>
+                      </a:r>
+                    </a:p>
+                  </a:txBody>
+                  <a:tcPr marL="54864" marR="54864" marT="18288" marB="18288">
+                    <a:solidFill>
+                      <a:srgbClr val="FFFFFF"/>
+                    </a:solidFill>
+                  </a:tcPr>
+                </a:tc>
+              </a:tr>
+              <a:tr h="1034415">
+                <a:tc>
+                  <a:txBody>
+                    <a:bodyPr wrap="square"/>
+                    <a:lstStyle/>
+                    <a:p>
+                      <a:r>
+                        <a:rPr sz="1100" b="0">
+                          <a:solidFill>
+                            <a:srgbClr val="282828"/>
+                          </a:solidFill>
+                          <a:latin typeface="Arial"/>
+                        </a:rPr>
+                        <a:t>4 Two-color source</a:t>
                       </a:r>
                     </a:p>
                   </a:txBody>
@@ -12437,7 +12681,7 @@
                           </a:solidFill>
                           <a:latin typeface="Arial"/>
                         </a:rPr>
-                        <a:t>the LO collimator's tilt held to ~10 prad per cycle (~10 pm of fiber-tip motion), or measured and removed</a:t>
+                        <a:t>laser 2 (ECDL at 633 ± 20 nm, or a 1.3 µm telecom tunable), 2 AOMs + drivers, 2 synthesizers, 2 WDM combiners</a:t>
                       </a:r>
                     </a:p>
                   </a:txBody>
@@ -12459,7 +12703,7 @@
                           </a:solidFill>
                           <a:latin typeface="Arial"/>
                         </a:rPr>
-                        <a:t>the loop reads LO drift as DM drift one-for-one: 0.1 nrad per cycle = 29 pm of hold</a:t>
+                        <a:t>capture from cold in one 0.27 s reading, zero wrong orders to 480 nm rms; temporal unwrapping cannot start cold</a:t>
                       </a:r>
                     </a:p>
                   </a:txBody>
@@ -12481,7 +12725,7 @@
                           </a:solidFill>
                           <a:latin typeface="Arial"/>
                         </a:rPr>
-                        <a:t>a monolithic collimator mount on the splitter block, thermally tied; or a referenced LO: a quad cell on an LO pickoff, or a flat on the DM mount read by the same frames (the next model stage)</a:t>
+                        <a:t>633: an ECDL (costly, a few nm); 1.3 µm: cheap PM-native tunables but an InGaAs camera and a refocused tail — model the 1.3 µm stage first, then choose the band</a:t>
                       </a:r>
                     </a:p>
                   </a:txBody>
@@ -12503,7 +12747,7 @@
                           </a:solidFill>
                           <a:latin typeface="Arial"/>
                         </a:rPr>
-                        <a:t>mount: weeks; referenced LO: 1–2 months</a:t>
+                        <a:t>model: 2–3 weeks; hardware: 3–6 months</a:t>
                       </a:r>
                     </a:p>
                   </a:txBody>
@@ -12514,231 +12758,7 @@
                   </a:tcPr>
                 </a:tc>
               </a:tr>
-              <a:tr h="845820">
-                <a:tc>
-                  <a:txBody>
-                    <a:bodyPr wrap="square"/>
-                    <a:lstStyle/>
-                    <a:p>
-                      <a:r>
-                        <a:rPr sz="1100" b="0">
-                          <a:solidFill>
-                            <a:srgbClr val="282828"/>
-                          </a:solidFill>
-                          <a:latin typeface="Arial"/>
-                        </a:rPr>
-                        <a:t>3 Lock-in camera</a:t>
-                      </a:r>
-                    </a:p>
-                  </a:txBody>
-                  <a:tcPr marL="54864" marR="54864" marT="18288" marB="18288">
-                    <a:solidFill>
-                      <a:srgbClr val="FFFFFF"/>
-                    </a:solidFill>
-                  </a:tcPr>
-                </a:tc>
-                <a:tc>
-                  <a:txBody>
-                    <a:bodyPr wrap="square"/>
-                    <a:lstStyle/>
-                    <a:p>
-                      <a:r>
-                        <a:rPr sz="1100" b="0">
-                          <a:solidFill>
-                            <a:srgbClr val="282828"/>
-                          </a:solidFill>
-                          <a:latin typeface="Arial"/>
-                        </a:rPr>
-                        <a:t>a heliCam C4 at a 5 kHz beat on the record bench; per-pixel phase noise vs flux measured</a:t>
-                      </a:r>
-                    </a:p>
-                  </a:txBody>
-                  <a:tcPr marL="54864" marR="54864" marT="18288" marB="18288">
-                    <a:solidFill>
-                      <a:srgbClr val="FFFFFF"/>
-                    </a:solidFill>
-                  </a:tcPr>
-                </a:tc>
-                <a:tc>
-                  <a:txBody>
-                    <a:bodyPr wrap="square"/>
-                    <a:lstStyle/>
-                    <a:p>
-                      <a:r>
-                        <a:rPr sz="1100" b="0">
-                          <a:solidFill>
-                            <a:srgbClr val="282828"/>
-                          </a:solidFill>
-                          <a:latin typeface="Arial"/>
-                        </a:rPr>
-                        <a:t>~12× the Photonfocus's speed as surveyed (3.4 s per pm); the well-free question is the next factor</a:t>
-                      </a:r>
-                    </a:p>
-                  </a:txBody>
-                  <a:tcPr marL="54864" marR="54864" marT="18288" marB="18288">
-                    <a:solidFill>
-                      <a:srgbClr val="FFFFFF"/>
-                    </a:solidFill>
-                  </a:tcPr>
-                </a:tc>
-                <a:tc>
-                  <a:txBody>
-                    <a:bodyPr wrap="square"/>
-                    <a:lstStyle/>
-                    <a:p>
-                      <a:r>
-                        <a:rPr sz="1100" b="0">
-                          <a:solidFill>
-                            <a:srgbClr val="282828"/>
-                          </a:solidFill>
-                          <a:latin typeface="Arial"/>
-                        </a:rPr>
-                        <a:t>the vendor question (phase noise vs flux at t_c 100 ms; what the well bounds); a loaner on the bench, reading class H unchanged; format re-run on measured numbers</a:t>
-                      </a:r>
-                    </a:p>
-                  </a:txBody>
-                  <a:tcPr marL="54864" marR="54864" marT="18288" marB="18288">
-                    <a:solidFill>
-                      <a:srgbClr val="FFFFFF"/>
-                    </a:solidFill>
-                  </a:tcPr>
-                </a:tc>
-                <a:tc>
-                  <a:txBody>
-                    <a:bodyPr wrap="square"/>
-                    <a:lstStyle/>
-                    <a:p>
-                      <a:r>
-                        <a:rPr sz="1100" b="0">
-                          <a:solidFill>
-                            <a:srgbClr val="282828"/>
-                          </a:solidFill>
-                          <a:latin typeface="Arial"/>
-                        </a:rPr>
-                        <a:t>question: days; bench: 1–3 months</a:t>
-                      </a:r>
-                    </a:p>
-                  </a:txBody>
-                  <a:tcPr marL="54864" marR="54864" marT="18288" marB="18288">
-                    <a:solidFill>
-                      <a:srgbClr val="FFFFFF"/>
-                    </a:solidFill>
-                  </a:tcPr>
-                </a:tc>
-              </a:tr>
-              <a:tr h="845820">
-                <a:tc>
-                  <a:txBody>
-                    <a:bodyPr wrap="square"/>
-                    <a:lstStyle/>
-                    <a:p>
-                      <a:r>
-                        <a:rPr sz="1100" b="0">
-                          <a:solidFill>
-                            <a:srgbClr val="282828"/>
-                          </a:solidFill>
-                          <a:latin typeface="Arial"/>
-                        </a:rPr>
-                        <a:t>4 Two-color source</a:t>
-                      </a:r>
-                    </a:p>
-                  </a:txBody>
-                  <a:tcPr marL="54864" marR="54864" marT="18288" marB="18288">
-                    <a:solidFill>
-                      <a:srgbClr val="ECF1F6"/>
-                    </a:solidFill>
-                  </a:tcPr>
-                </a:tc>
-                <a:tc>
-                  <a:txBody>
-                    <a:bodyPr wrap="square"/>
-                    <a:lstStyle/>
-                    <a:p>
-                      <a:r>
-                        <a:rPr sz="1100" b="0">
-                          <a:solidFill>
-                            <a:srgbClr val="282828"/>
-                          </a:solidFill>
-                          <a:latin typeface="Arial"/>
-                        </a:rPr>
-                        <a:t>laser 2 (ECDL at 633 ± 20 nm, or a 1.3 µm telecom tunable), 2 AOMs + drivers, 2 synthesizers, 2 WDM combiners</a:t>
-                      </a:r>
-                    </a:p>
-                  </a:txBody>
-                  <a:tcPr marL="54864" marR="54864" marT="18288" marB="18288">
-                    <a:solidFill>
-                      <a:srgbClr val="ECF1F6"/>
-                    </a:solidFill>
-                  </a:tcPr>
-                </a:tc>
-                <a:tc>
-                  <a:txBody>
-                    <a:bodyPr wrap="square"/>
-                    <a:lstStyle/>
-                    <a:p>
-                      <a:r>
-                        <a:rPr sz="1100" b="0">
-                          <a:solidFill>
-                            <a:srgbClr val="282828"/>
-                          </a:solidFill>
-                          <a:latin typeface="Arial"/>
-                        </a:rPr>
-                        <a:t>capture from cold in one 0.27 s reading, zero wrong orders to 480 nm rms; temporal unwrapping cannot start cold</a:t>
-                      </a:r>
-                    </a:p>
-                  </a:txBody>
-                  <a:tcPr marL="54864" marR="54864" marT="18288" marB="18288">
-                    <a:solidFill>
-                      <a:srgbClr val="ECF1F6"/>
-                    </a:solidFill>
-                  </a:tcPr>
-                </a:tc>
-                <a:tc>
-                  <a:txBody>
-                    <a:bodyPr wrap="square"/>
-                    <a:lstStyle/>
-                    <a:p>
-                      <a:r>
-                        <a:rPr sz="1100" b="0">
-                          <a:solidFill>
-                            <a:srgbClr val="282828"/>
-                          </a:solidFill>
-                          <a:latin typeface="Arial"/>
-                        </a:rPr>
-                        <a:t>633: an ECDL (costly, a few nm); 1.3 µm: cheap PM-native tunables but an InGaAs camera and a refocused tail — model the 1.3 µm stage first, then choose the band</a:t>
-                      </a:r>
-                    </a:p>
-                  </a:txBody>
-                  <a:tcPr marL="54864" marR="54864" marT="18288" marB="18288">
-                    <a:solidFill>
-                      <a:srgbClr val="ECF1F6"/>
-                    </a:solidFill>
-                  </a:tcPr>
-                </a:tc>
-                <a:tc>
-                  <a:txBody>
-                    <a:bodyPr wrap="square"/>
-                    <a:lstStyle/>
-                    <a:p>
-                      <a:r>
-                        <a:rPr sz="1100" b="0">
-                          <a:solidFill>
-                            <a:srgbClr val="282828"/>
-                          </a:solidFill>
-                          <a:latin typeface="Arial"/>
-                        </a:rPr>
-                        <a:t>model: 2–3 weeks; hardware: 3–6 months</a:t>
-                      </a:r>
-                    </a:p>
-                  </a:txBody>
-                  <a:tcPr marL="54864" marR="54864" marT="18288" marB="18288">
-                    <a:solidFill>
-                      <a:srgbClr val="ECF1F6"/>
-                    </a:solidFill>
-                  </a:tcPr>
-                </a:tc>
-              </a:tr>
-              <a:tr h="845820">
+              <a:tr h="1034415">
                 <a:tc>
                   <a:txBody>
                     <a:bodyPr wrap="square"/>
@@ -12862,7 +12882,7 @@
         </p:nvSpPr>
         <p:spPr>
           <a:xfrm>
-            <a:off x="411480" y="5953887"/>
+            <a:off x="411480" y="6708267"/>
             <a:ext cx="11368735" cy="274320"/>
           </a:xfrm>
           <a:prstGeom prst="rect">
@@ -14345,7 +14365,7 @@
         </p:nvGraphicFramePr>
         <p:xfrm>
           <a:off x="411480" y="1298448"/>
-          <a:ext cx="11368734" cy="2988945"/>
+          <a:ext cx="11368734" cy="3457575"/>
         </p:xfrm>
         <a:graphic>
           <a:graphicData uri="http://schemas.openxmlformats.org/drawingml/2006/table">
@@ -14354,9 +14374,9 @@
                 <a:tableStyleId>{5C22544A-7EE6-4342-B048-85BDC9FD1C3A}</a:tableStyleId>
               </a:tblPr>
               <a:tblGrid>
-                <a:gridCol w="1526540"/>
-                <a:gridCol w="3813850"/>
-                <a:gridCol w="6028344"/>
+                <a:gridCol w="1694975"/>
+                <a:gridCol w="4340789"/>
+                <a:gridCol w="5332970"/>
               </a:tblGrid>
               <a:tr h="280035">
                 <a:tc>
@@ -14915,7 +14935,7 @@
                           </a:solidFill>
                           <a:latin typeface="Arial"/>
                         </a:rPr>
-                        <a:t>format</a:t>
+                        <a:t>format / lock-in</a:t>
                       </a:r>
                     </a:p>
                   </a:txBody>
@@ -14937,7 +14957,7 @@
                           </a:solidFill>
                           <a:latin typeface="Arial"/>
                         </a:rPr>
-                        <a:t>runs/format_lens_plain; corrected by runs/lockin_noise_oap_med</a:t>
+                        <a:t>runs/format_lens_plain; the lock-in as a READING: runs/lockin_* (noise both rigs, capture, battery, loop)</a:t>
                       </a:r>
                     </a:p>
                   </a:txBody>
@@ -14959,7 +14979,7 @@
                           </a:solidFill>
                           <a:latin typeface="Arial"/>
                         </a:rPr>
-                        <a:t>the lock-in class: 3.4 s per pm well-capped (the format stage's 1.1 counted four wells per sample)</a:t>
+                        <a:t>3.35 / 3.73 s per pm well-capped (the format stage's 1.1 counted four wells per sample); 3 pm held at 0.125 s cycles; fiber inert</a:t>
                       </a:r>
                     </a:p>
                   </a:txBody>
@@ -15034,6 +15054,74 @@
                   <a:tcPr marL="54864" marR="54864" marT="18288" marB="18288">
                     <a:solidFill>
                       <a:srgbClr val="FFFFFF"/>
+                    </a:solidFill>
+                  </a:tcPr>
+                </a:tc>
+              </a:tr>
+              <a:tr h="468630">
+                <a:tc>
+                  <a:txBody>
+                    <a:bodyPr wrap="square"/>
+                    <a:lstStyle/>
+                    <a:p>
+                      <a:r>
+                        <a:rPr sz="1100" b="0">
+                          <a:solidFill>
+                            <a:srgbClr val="282828"/>
+                          </a:solidFill>
+                          <a:latin typeface="Arial"/>
+                        </a:rPr>
+                        <a:t>the other gauges on a polarization camera</a:t>
+                      </a:r>
+                    </a:p>
+                  </a:txBody>
+                  <a:tcPr marL="54864" marR="54864" marT="18288" marB="18288">
+                    <a:solidFill>
+                      <a:srgbClr val="ECF1F6"/>
+                    </a:solidFill>
+                  </a:tcPr>
+                </a:tc>
+                <a:tc>
+                  <a:txBody>
+                    <a:bodyPr wrap="square"/>
+                    <a:lstStyle/>
+                    <a:p>
+                      <a:r>
+                        <a:rPr sz="1100" b="0">
+                          <a:solidFill>
+                            <a:srgbClr val="282828"/>
+                          </a:solidFill>
+                          <a:latin typeface="Arial"/>
+                        </a:rPr>
+                        <a:t>tg_psi_dm96_oap/runs/camI_{lens,oap}, zwfs_dm96/runs/camS_oap</a:t>
+                      </a:r>
+                    </a:p>
+                  </a:txBody>
+                  <a:tcPr marL="54864" marR="54864" marT="18288" marB="18288">
+                    <a:solidFill>
+                      <a:srgbClr val="ECF1F6"/>
+                    </a:solidFill>
+                  </a:tcPr>
+                </a:tc>
+                <a:tc>
+                  <a:txBody>
+                    <a:bodyPr wrap="square"/>
+                    <a:lstStyle/>
+                    <a:p>
+                      <a:r>
+                        <a:rPr sz="1100" b="0">
+                          <a:solidFill>
+                            <a:srgbClr val="282828"/>
+                          </a:solidFill>
+                          <a:latin typeface="Arial"/>
+                        </a:rPr>
+                        <a:t>IFO 189 / 160 s per pm; stepped 475, vector 519, pinhole 342</a:t>
+                      </a:r>
+                    </a:p>
+                  </a:txBody>
+                  <a:tcPr marL="54864" marR="54864" marT="18288" marB="18288">
+                    <a:solidFill>
+                      <a:srgbClr val="ECF1F6"/>
                     </a:solidFill>
                   </a:tcPr>
                 </a:tc>
@@ -15050,7 +15138,7 @@
         </p:nvSpPr>
         <p:spPr>
           <a:xfrm>
-            <a:off x="411480" y="4433697"/>
+            <a:off x="411480" y="4902327"/>
             <a:ext cx="11368735" cy="274320"/>
           </a:xfrm>
           <a:prstGeom prst="rect">
@@ -15628,7 +15716,7 @@
         </p:nvGraphicFramePr>
         <p:xfrm>
           <a:off x="6400800" y="1298448"/>
-          <a:ext cx="5394958" cy="3646170"/>
+          <a:ext cx="5394959" cy="3646170"/>
         </p:xfrm>
         <a:graphic>
           <a:graphicData uri="http://schemas.openxmlformats.org/drawingml/2006/table">
@@ -15637,9 +15725,9 @@
                 <a:tableStyleId>{5C22544A-7EE6-4342-B048-85BDC9FD1C3A}</a:tableStyleId>
               </a:tblPr>
               <a:tblGrid>
-                <a:gridCol w="1833754"/>
-                <a:gridCol w="823860"/>
-                <a:gridCol w="2737344"/>
+                <a:gridCol w="1604535"/>
+                <a:gridCol w="720878"/>
+                <a:gridCol w="3069546"/>
               </a:tblGrid>
               <a:tr h="605790">
                 <a:tc>
@@ -15970,7 +16058,7 @@
                           </a:solidFill>
                           <a:latin typeface="Arial"/>
                         </a:rPr>
-                        <a:t>58 pm per 1 ms I/Q sample (63 at an assumed 100 e⁻ read)</a:t>
+                        <a:t>57.9 / 61.1 pm per 1 ms I/Q sample, mirror / lens (63 / 66 at an assumed 100 e⁻ read)</a:t>
                       </a:r>
                     </a:p>
                   </a:txBody>
@@ -16038,7 +16126,7 @@
                           </a:solidFill>
                           <a:latin typeface="Arial"/>
                         </a:rPr>
-                        <a:t>3.4 (read 0) / 4.0 (read 100 assumed); ×1.11 for square-wave demodulation — well-capped at the I/Q rate</a:t>
+                        <a:t>3.35 / 3.73 (read 0, mirror / lens; 4.0 / 4.4 at read 100 assumed); ×1.11 for square-wave demodulation — well-capped at the I/Q rate</a:t>
                       </a:r>
                     </a:p>
                   </a:txBody>
@@ -16174,7 +16262,7 @@
                           </a:solidFill>
                           <a:latin typeface="Arial"/>
                         </a:rPr>
-                        <a:t>one I/Q frame, 1 ms</a:t>
+                        <a:t>one I/Q sample, 1 ms (one 0.125 s cycle as the loop's upper bound)</a:t>
                       </a:r>
                     </a:p>
                   </a:txBody>
@@ -17931,7 +18019,7 @@
         </p:nvGraphicFramePr>
         <p:xfrm>
           <a:off x="411480" y="1298448"/>
-          <a:ext cx="11368733" cy="3183255"/>
+          <a:ext cx="11368734" cy="3183255"/>
         </p:xfrm>
         <a:graphic>
           <a:graphicData uri="http://schemas.openxmlformats.org/drawingml/2006/table">
@@ -17940,11 +18028,11 @@
                 <a:tableStyleId>{5C22544A-7EE6-4342-B048-85BDC9FD1C3A}</a:tableStyleId>
               </a:tblPr>
               <a:tblGrid>
-                <a:gridCol w="3810400"/>
-                <a:gridCol w="1436708"/>
-                <a:gridCol w="1936432"/>
-                <a:gridCol w="1374242"/>
-                <a:gridCol w="2810951"/>
+                <a:gridCol w="3484888"/>
+                <a:gridCol w="1313974"/>
+                <a:gridCol w="1771009"/>
+                <a:gridCol w="1771009"/>
+                <a:gridCol w="3027854"/>
               </a:tblGrid>
               <a:tr h="468630">
                 <a:tc>
@@ -18697,7 +18785,7 @@
                           </a:solidFill>
                           <a:latin typeface="Arial"/>
                         </a:rPr>
-                        <a:t>58 per 1 ms I/Q sample</a:t>
+                        <a:t>61.1 / 57.9 per 1 ms I/Q sample</a:t>
                       </a:r>
                     </a:p>
                   </a:txBody>
@@ -18719,7 +18807,7 @@
                           </a:solidFill>
                           <a:latin typeface="Arial"/>
                         </a:rPr>
-                        <a:t>3.4 (well-capped at 1 kHz; ×1.11 square-wave)</a:t>
+                        <a:t>3.73 / 3.35 (well-capped at 1 kHz; ×1.11 square-wave)</a:t>
                       </a:r>
                     </a:p>
                   </a:txBody>
@@ -18831,7 +18919,7 @@
                           </a:solidFill>
                           <a:latin typeface="Arial"/>
                         </a:rPr>
-                        <a:t>3.4 (same well × rate per element)</a:t>
+                        <a:t>same (well × rate per element)</a:t>
                       </a:r>
                     </a:p>
                   </a:txBody>

</xml_diff>

<commit_message>
deck_cophi: Dave's title ('...Gauge Bench Sensor') and his geometry on the performance, electronics and comparison slides carried in the sidecar; edit copy synced
Co-Authored-By: Claude Fable 5.1 <noreply@anthropic.com>
</commit_message>
<xml_diff>
--- a/demo_session/deck_cophi.pptx
+++ b/demo_session/deck_cophi.pptx
@@ -3144,7 +3144,7 @@
                 </a:solidFill>
                 <a:latin typeface="Arial"/>
               </a:rPr>
-              <a:t>COPHI as the Fifth DM Gauge</a:t>
+              <a:t>COPHI as the Fifth DM Gauge Bench Sensor</a:t>
             </a:r>
           </a:p>
           <a:p>
@@ -3378,7 +3378,7 @@
           <p:nvPr/>
         </p:nvGraphicFramePr>
         <p:xfrm>
-          <a:off x="411480" y="1298448"/>
+          <a:off x="411480" y="1188720"/>
           <a:ext cx="11368734" cy="2800350"/>
         </p:xfrm>
         <a:graphic>
@@ -4305,7 +4305,7 @@
         </p:nvSpPr>
         <p:spPr>
           <a:xfrm>
-            <a:off x="411480" y="4245102"/>
+            <a:off x="411480" y="5623560"/>
             <a:ext cx="11368735" cy="274320"/>
           </a:xfrm>
           <a:prstGeom prst="rect">
@@ -4325,7 +4325,7 @@
               </a:spcAft>
             </a:pPr>
             <a:r>
-              <a:rPr sz="1500" b="0">
+              <a:rPr sz="1200" b="0">
                 <a:solidFill>
                   <a:srgbClr val="282828"/>
                 </a:solidFill>
@@ -4334,7 +4334,7 @@
               <a:t>•  </a:t>
             </a:r>
             <a:r>
-              <a:rPr sz="1500" b="1">
+              <a:rPr sz="1200" b="1">
                 <a:solidFill>
                   <a:srgbClr val="282828"/>
                 </a:solidFill>
@@ -4343,7 +4343,7 @@
               <a:t>The one-step rows sit 0.5 % low for HET on both rigs — and that is the estimator, not the reading:</a:t>
             </a:r>
             <a:r>
-              <a:rPr sz="1500" b="0">
+              <a:rPr sz="1200" b="0">
                 <a:solidFill>
                   <a:srgbClr val="282828"/>
                 </a:solidFill>
@@ -4359,7 +4359,7 @@
               </a:spcAft>
             </a:pPr>
             <a:r>
-              <a:rPr sz="1500" b="0">
+              <a:rPr sz="1200" b="0">
                 <a:solidFill>
                   <a:srgbClr val="282828"/>
                 </a:solidFill>
@@ -4368,7 +4368,7 @@
               <a:t>•  </a:t>
             </a:r>
             <a:r>
-              <a:rPr sz="1500" b="1">
+              <a:rPr sz="1200" b="1">
                 <a:solidFill>
                   <a:srgbClr val="282828"/>
                 </a:solidFill>
@@ -4377,7 +4377,7 @@
               <a:t>Driven to convergence (the gauge's servo use), HET reads exactly on the mirror rig; the IFO then shows its polarization gain in the open:</a:t>
             </a:r>
             <a:r>
-              <a:rPr sz="1500" b="0">
+              <a:rPr sz="1200" b="0">
                 <a:solidFill>
                   <a:srgbClr val="282828"/>
                 </a:solidFill>
@@ -4396,7 +4396,7 @@
         </p:nvSpPr>
         <p:spPr>
           <a:xfrm>
-            <a:off x="411480" y="6295644"/>
+            <a:off x="411480" y="7129272"/>
             <a:ext cx="11368735" cy="274320"/>
           </a:xfrm>
           <a:prstGeom prst="rect">
@@ -8942,7 +8942,7 @@
         </p:nvSpPr>
         <p:spPr>
           <a:xfrm>
-            <a:off x="411480" y="6605397"/>
+            <a:off x="457200" y="6217920"/>
             <a:ext cx="11368735" cy="274320"/>
           </a:xfrm>
           <a:prstGeom prst="rect">

</xml_diff>

<commit_message>
deck_cophi: sidecar keys fixed (slides 10/17 take Dave's geometry); the comparison table trimmed to fit; the performance subhead shortened
Co-Authored-By: Claude Fable 5.1 <noreply@anthropic.com>
</commit_message>
<xml_diff>
--- a/demo_session/deck_cophi.pptx
+++ b/demo_session/deck_cophi.pptx
@@ -3320,7 +3320,7 @@
                 </a:solidFill>
                 <a:latin typeface="Arial"/>
               </a:rPr>
-              <a:t>HET = the heterodyne (COPHI) reading; IFO = the record's Twyman-Green polarization interferometer.  Same seed, same 30 nm surface, same response matrix measured through each reading: HET matches the IFO's floor, reads the mirror rig's random surface at half its error, and is exact where the IFO's reading is not</a:t>
+              <a:t>HET = the heterodyne (COPHI) reading; IFO = the record's Twyman-Green polarization interferometer.  Same seed, surface and matrix: HET matches the IFO's floor, halves its mirror-rig random-surface error, and is exact where the IFO's reading is not</a:t>
             </a:r>
           </a:p>
         </p:txBody>
@@ -10431,7 +10431,7 @@
         </p:nvGraphicFramePr>
         <p:xfrm>
           <a:off x="411480" y="1298448"/>
-          <a:ext cx="11368733" cy="5915025"/>
+          <a:ext cx="11368734" cy="4034790"/>
         </p:xfrm>
         <a:graphic>
           <a:graphicData uri="http://schemas.openxmlformats.org/drawingml/2006/table">
@@ -10440,13 +10440,13 @@
                 <a:tableStyleId>{5C22544A-7EE6-4342-B048-85BDC9FD1C3A}</a:tableStyleId>
               </a:tblPr>
               <a:tblGrid>
-                <a:gridCol w="2325624"/>
-                <a:gridCol w="4124927"/>
-                <a:gridCol w="1189883"/>
-                <a:gridCol w="713929"/>
-                <a:gridCol w="3014370"/>
+                <a:gridCol w="2107692"/>
+                <a:gridCol w="4370487"/>
+                <a:gridCol w="1268851"/>
+                <a:gridCol w="1817116"/>
+                <a:gridCol w="1804588"/>
               </a:tblGrid>
-              <a:tr h="845820">
+              <a:tr h="468630">
                 <a:tc>
                   <a:txBody>
                     <a:bodyPr wrap="square"/>
@@ -10471,7 +10471,7 @@
                           </a:solidFill>
                           <a:latin typeface="Arial"/>
                         </a:rPr>
-                        <a:t>vector Zernike (dedicated laser, polarization camera)</a:t>
+                        <a:t>vector Zernike (dedicated laser, pol. camera)</a:t>
                       </a:r>
                     </a:p>
                   </a:txBody>
@@ -10493,7 +10493,7 @@
                           </a:solidFill>
                           <a:latin typeface="Arial"/>
                         </a:rPr>
-                        <a:t>COPHI, Feng's camera (1k², 60 ke, 30 fps)</a:t>
+                        <a:t>COPHI, Feng's camera</a:t>
                       </a:r>
                     </a:p>
                   </a:txBody>
@@ -10515,7 +10515,7 @@
                           </a:solidFill>
                           <a:latin typeface="Arial"/>
                         </a:rPr>
-                        <a:t>COPHI, Photonfocus (200 ke, 150 fps)</a:t>
+                        <a:t>COPHI, Photonfocus</a:t>
                       </a:r>
                     </a:p>
                   </a:txBody>
@@ -10537,13 +10537,125 @@
                           </a:solidFill>
                           <a:latin typeface="Arial"/>
                         </a:rPr>
-                        <a:t>COPHI, lock-in camera (heliCam C4, as surveyed)</a:t>
+                        <a:t>COPHI, lock-in camera (C4, as surveyed)</a:t>
                       </a:r>
                     </a:p>
                   </a:txBody>
                   <a:tcPr marL="54864" marR="54864" marT="18288" marB="18288">
                     <a:solidFill>
                       <a:srgbClr val="1F4E79"/>
+                    </a:solidFill>
+                  </a:tcPr>
+                </a:tc>
+              </a:tr>
+              <a:tr h="468630">
+                <a:tc>
+                  <a:txBody>
+                    <a:bodyPr wrap="square"/>
+                    <a:lstStyle/>
+                    <a:p>
+                      <a:r>
+                        <a:rPr sz="1100" b="0">
+                          <a:solidFill>
+                            <a:srgbClr val="282828"/>
+                          </a:solidFill>
+                          <a:latin typeface="Arial"/>
+                        </a:rPr>
+                        <a:t>photons per 3 pm hold cycle</a:t>
+                      </a:r>
+                    </a:p>
+                  </a:txBody>
+                  <a:tcPr marL="54864" marR="54864" marT="18288" marB="18288">
+                    <a:solidFill>
+                      <a:srgbClr val="FFFFFF"/>
+                    </a:solidFill>
+                  </a:tcPr>
+                </a:tc>
+                <a:tc>
+                  <a:txBody>
+                    <a:bodyPr wrap="square"/>
+                    <a:lstStyle/>
+                    <a:p>
+                      <a:r>
+                        <a:rPr sz="1100" b="0">
+                          <a:solidFill>
+                            <a:srgbClr val="282828"/>
+                          </a:solidFill>
+                          <a:latin typeface="Arial"/>
+                        </a:rPr>
+                        <a:t>2.2 × 10¹² (gauge deck)</a:t>
+                      </a:r>
+                    </a:p>
+                  </a:txBody>
+                  <a:tcPr marL="54864" marR="54864" marT="18288" marB="18288">
+                    <a:solidFill>
+                      <a:srgbClr val="FFFFFF"/>
+                    </a:solidFill>
+                  </a:tcPr>
+                </a:tc>
+                <a:tc>
+                  <a:txBody>
+                    <a:bodyPr wrap="square"/>
+                    <a:lstStyle/>
+                    <a:p>
+                      <a:r>
+                        <a:rPr sz="1100" b="0">
+                          <a:solidFill>
+                            <a:srgbClr val="282828"/>
+                          </a:solidFill>
+                          <a:latin typeface="Arial"/>
+                        </a:rPr>
+                        <a:t>~1 × 10¹⁴ (120 readings)</a:t>
+                      </a:r>
+                    </a:p>
+                  </a:txBody>
+                  <a:tcPr marL="54864" marR="54864" marT="18288" marB="18288">
+                    <a:solidFill>
+                      <a:srgbClr val="FFFFFF"/>
+                    </a:solidFill>
+                  </a:tcPr>
+                </a:tc>
+                <a:tc>
+                  <a:txBody>
+                    <a:bodyPr wrap="square"/>
+                    <a:lstStyle/>
+                    <a:p>
+                      <a:r>
+                        <a:rPr sz="1100" b="0">
+                          <a:solidFill>
+                            <a:srgbClr val="282828"/>
+                          </a:solidFill>
+                          <a:latin typeface="Arial"/>
+                        </a:rPr>
+                        <a:t>~1 × 10¹⁴ (60 readings)</a:t>
+                      </a:r>
+                    </a:p>
+                  </a:txBody>
+                  <a:tcPr marL="54864" marR="54864" marT="18288" marB="18288">
+                    <a:solidFill>
+                      <a:srgbClr val="FFFFFF"/>
+                    </a:solidFill>
+                  </a:tcPr>
+                </a:tc>
+                <a:tc>
+                  <a:txBody>
+                    <a:bodyPr wrap="square"/>
+                    <a:lstStyle/>
+                    <a:p>
+                      <a:r>
+                        <a:rPr sz="1100" b="0">
+                          <a:solidFill>
+                            <a:srgbClr val="282828"/>
+                          </a:solidFill>
+                          <a:latin typeface="Arial"/>
+                        </a:rPr>
+                        <a:t>~9 × 10¹² (125 samples, capped well)</a:t>
+                      </a:r>
+                    </a:p>
+                  </a:txBody>
+                  <a:tcPr marL="54864" marR="54864" marT="18288" marB="18288">
+                    <a:solidFill>
+                      <a:srgbClr val="FFFFFF"/>
                     </a:solidFill>
                   </a:tcPr>
                 </a:tc>
@@ -10561,118 +10673,6 @@
                           </a:solidFill>
                           <a:latin typeface="Arial"/>
                         </a:rPr>
-                        <a:t>photons per cycle to hold 3 pm</a:t>
-                      </a:r>
-                    </a:p>
-                  </a:txBody>
-                  <a:tcPr marL="54864" marR="54864" marT="18288" marB="18288">
-                    <a:solidFill>
-                      <a:srgbClr val="FFFFFF"/>
-                    </a:solidFill>
-                  </a:tcPr>
-                </a:tc>
-                <a:tc>
-                  <a:txBody>
-                    <a:bodyPr wrap="square"/>
-                    <a:lstStyle/>
-                    <a:p>
-                      <a:r>
-                        <a:rPr sz="1100" b="0">
-                          <a:solidFill>
-                            <a:srgbClr val="282828"/>
-                          </a:solidFill>
-                          <a:latin typeface="Arial"/>
-                        </a:rPr>
-                        <a:t>2.2 × 10¹² (gauge deck)</a:t>
-                      </a:r>
-                    </a:p>
-                  </a:txBody>
-                  <a:tcPr marL="54864" marR="54864" marT="18288" marB="18288">
-                    <a:solidFill>
-                      <a:srgbClr val="FFFFFF"/>
-                    </a:solidFill>
-                  </a:tcPr>
-                </a:tc>
-                <a:tc>
-                  <a:txBody>
-                    <a:bodyPr wrap="square"/>
-                    <a:lstStyle/>
-                    <a:p>
-                      <a:r>
-                        <a:rPr sz="1100" b="0">
-                          <a:solidFill>
-                            <a:srgbClr val="282828"/>
-                          </a:solidFill>
-                          <a:latin typeface="Arial"/>
-                        </a:rPr>
-                        <a:t>~1 × 10¹⁴ (120 readings at 1.9 × 10¹² ph/s)</a:t>
-                      </a:r>
-                    </a:p>
-                  </a:txBody>
-                  <a:tcPr marL="54864" marR="54864" marT="18288" marB="18288">
-                    <a:solidFill>
-                      <a:srgbClr val="FFFFFF"/>
-                    </a:solidFill>
-                  </a:tcPr>
-                </a:tc>
-                <a:tc>
-                  <a:txBody>
-                    <a:bodyPr wrap="square"/>
-                    <a:lstStyle/>
-                    <a:p>
-                      <a:r>
-                        <a:rPr sz="1100" b="0">
-                          <a:solidFill>
-                            <a:srgbClr val="282828"/>
-                          </a:solidFill>
-                          <a:latin typeface="Arial"/>
-                        </a:rPr>
-                        <a:t>~1 × 10¹⁴ (60 readings)</a:t>
-                      </a:r>
-                    </a:p>
-                  </a:txBody>
-                  <a:tcPr marL="54864" marR="54864" marT="18288" marB="18288">
-                    <a:solidFill>
-                      <a:srgbClr val="FFFFFF"/>
-                    </a:solidFill>
-                  </a:tcPr>
-                </a:tc>
-                <a:tc>
-                  <a:txBody>
-                    <a:bodyPr wrap="square"/>
-                    <a:lstStyle/>
-                    <a:p>
-                      <a:r>
-                        <a:rPr sz="1100" b="0">
-                          <a:solidFill>
-                            <a:srgbClr val="282828"/>
-                          </a:solidFill>
-                          <a:latin typeface="Arial"/>
-                        </a:rPr>
-                        <a:t>~9 × 10¹² (125 samples at the capped 250 ke per element)</a:t>
-                      </a:r>
-                    </a:p>
-                  </a:txBody>
-                  <a:tcPr marL="54864" marR="54864" marT="18288" marB="18288">
-                    <a:solidFill>
-                      <a:srgbClr val="FFFFFF"/>
-                    </a:solidFill>
-                  </a:tcPr>
-                </a:tc>
-              </a:tr>
-              <a:tr h="845820">
-                <a:tc>
-                  <a:txBody>
-                    <a:bodyPr wrap="square"/>
-                    <a:lstStyle/>
-                    <a:p>
-                      <a:r>
-                        <a:rPr sz="1100" b="0">
-                          <a:solidFill>
-                            <a:srgbClr val="282828"/>
-                          </a:solidFill>
-                          <a:latin typeface="Arial"/>
-                        </a:rPr>
                         <a:t>time per 3 pm hold cycle</a:t>
                       </a:r>
                     </a:p>
@@ -10695,7 +10695,7 @@
                           </a:solidFill>
                           <a:latin typeface="Arial"/>
                         </a:rPr>
-                        <a:t>~60 s on the assumed polarization camera (519 s per pm ÷ 9; its 10 ke⁻ well, the core's dynamic range and two unused orientations — the gauge deck's photon count stands, the camera is the ZWFS's own question)</a:t>
+                        <a:t>~60 s on the assumed pol. camera (519 s/pm ÷ 9: its 10 ke⁻ well, the core's dynamic range, two unused orientations — the camera is the ZWFS's own question)</a:t>
                       </a:r>
                     </a:p>
                   </a:txBody>
@@ -10807,7 +10807,7 @@
                           </a:solidFill>
                           <a:latin typeface="Arial"/>
                         </a:rPr>
-                        <a:t>519 (polarization camera, record)</a:t>
+                        <a:t>519 (pol. camera, record)</a:t>
                       </a:r>
                     </a:p>
                   </a:txBody>
@@ -10873,7 +10873,7 @@
                           </a:solidFill>
                           <a:latin typeface="Arial"/>
                         </a:rPr>
-                        <a:t>3.35 / 3.73 (×1.11 for square-wave demodulation)</a:t>
+                        <a:t>3.35 / 3.73 (×1.11 square-wave)</a:t>
                       </a:r>
                     </a:p>
                   </a:txBody>
@@ -10941,7 +10941,7 @@
                           </a:solidFill>
                           <a:latin typeface="Arial"/>
                         </a:rPr>
-                        <a:t>yes: two colors, one 0.27 s reading</a:t>
+                        <a:t>two colors, one 0.27 s reading</a:t>
                       </a:r>
                     </a:p>
                   </a:txBody>
@@ -10963,7 +10963,7 @@
                           </a:solidFill>
                           <a:latin typeface="Arial"/>
                         </a:rPr>
-                        <a:t>yes</a:t>
+                        <a:t>same</a:t>
                       </a:r>
                     </a:p>
                   </a:txBody>
@@ -10985,7 +10985,7 @@
                           </a:solidFill>
                           <a:latin typeface="Arial"/>
                         </a:rPr>
-                        <a:t>yes: two colors on alternate I/Q samples, zero wrong orders to 480 nm (record)</a:t>
+                        <a:t>two colors on alternate samples; zero wrong orders to 480 nm</a:t>
                       </a:r>
                     </a:p>
                   </a:txBody>
@@ -11031,7 +11031,7 @@
                           </a:solidFill>
                           <a:latin typeface="Arial"/>
                         </a:rPr>
-                        <a:t>needs the reference iterated or a matrix re-measured</a:t>
+                        <a:t>reference iterated or matrix re-measured</a:t>
                       </a:r>
                     </a:p>
                   </a:txBody>
@@ -11053,7 +11053,7 @@
                           </a:solidFill>
                           <a:latin typeface="Arial"/>
                         </a:rPr>
-                        <a:t>exact (slope 1.000000) through the LO</a:t>
+                        <a:t>exact (slope 1.000000) against the LO</a:t>
                       </a:r>
                     </a:p>
                   </a:txBody>
@@ -11108,7 +11108,7 @@
                   </a:tcPr>
                 </a:tc>
               </a:tr>
-              <a:tr h="845820">
+              <a:tr h="657225">
                 <a:tc>
                   <a:txBody>
                     <a:bodyPr wrap="square"/>
@@ -11165,7 +11165,7 @@
                           </a:solidFill>
                           <a:latin typeface="Arial"/>
                         </a:rPr>
-                        <a:t>fiber phase 0.39 nm per frame; LO pointing 10 prad per cycle</a:t>
+                        <a:t>fiber 0.39 nm per frame; LO 10 prad per cycle</a:t>
                       </a:r>
                     </a:p>
                   </a:txBody>
@@ -11209,231 +11209,7 @@
                           </a:solidFill>
                           <a:latin typeface="Arial"/>
                         </a:rPr>
-                        <a:t>LO pointing the same (29.4 pm); fiber walk a piston per sample — inert: the loop at the budget and at 3× reads its noise-only hold to the digit (record)</a:t>
-                      </a:r>
-                    </a:p>
-                  </a:txBody>
-                  <a:tcPr marL="54864" marR="54864" marT="18288" marB="18288">
-                    <a:solidFill>
-                      <a:srgbClr val="ECF1F6"/>
-                    </a:solidFill>
-                  </a:tcPr>
-                </a:tc>
-              </a:tr>
-              <a:tr h="468630">
-                <a:tc>
-                  <a:txBody>
-                    <a:bodyPr wrap="square"/>
-                    <a:lstStyle/>
-                    <a:p>
-                      <a:r>
-                        <a:rPr sz="1100" b="0">
-                          <a:solidFill>
-                            <a:srgbClr val="282828"/>
-                          </a:solidFill>
-                          <a:latin typeface="Arial"/>
-                        </a:rPr>
-                        <a:t>electronics it adds</a:t>
-                      </a:r>
-                    </a:p>
-                  </a:txBody>
-                  <a:tcPr marL="54864" marR="54864" marT="18288" marB="18288">
-                    <a:solidFill>
-                      <a:srgbClr val="FFFFFF"/>
-                    </a:solidFill>
-                  </a:tcPr>
-                </a:tc>
-                <a:tc>
-                  <a:txBody>
-                    <a:bodyPr wrap="square"/>
-                    <a:lstStyle/>
-                    <a:p>
-                      <a:r>
-                        <a:rPr sz="1100" b="0">
-                          <a:solidFill>
-                            <a:srgbClr val="282828"/>
-                          </a:solidFill>
-                          <a:latin typeface="Arial"/>
-                        </a:rPr>
-                        <a:t>a laser</a:t>
-                      </a:r>
-                    </a:p>
-                  </a:txBody>
-                  <a:tcPr marL="54864" marR="54864" marT="18288" marB="18288">
-                    <a:solidFill>
-                      <a:srgbClr val="FFFFFF"/>
-                    </a:solidFill>
-                  </a:tcPr>
-                </a:tc>
-                <a:tc>
-                  <a:txBody>
-                    <a:bodyPr wrap="square"/>
-                    <a:lstStyle/>
-                    <a:p>
-                      <a:r>
-                        <a:rPr sz="1100" b="0">
-                          <a:solidFill>
-                            <a:srgbClr val="282828"/>
-                          </a:solidFill>
-                          <a:latin typeface="Arial"/>
-                        </a:rPr>
-                        <a:t>RF chain, fiber LO, two loops</a:t>
-                      </a:r>
-                    </a:p>
-                  </a:txBody>
-                  <a:tcPr marL="54864" marR="54864" marT="18288" marB="18288">
-                    <a:solidFill>
-                      <a:srgbClr val="FFFFFF"/>
-                    </a:solidFill>
-                  </a:tcPr>
-                </a:tc>
-                <a:tc>
-                  <a:txBody>
-                    <a:bodyPr wrap="square"/>
-                    <a:lstStyle/>
-                    <a:p>
-                      <a:r>
-                        <a:rPr sz="1100" b="0">
-                          <a:solidFill>
-                            <a:srgbClr val="282828"/>
-                          </a:solidFill>
-                          <a:latin typeface="Arial"/>
-                        </a:rPr>
-                        <a:t>same</a:t>
-                      </a:r>
-                    </a:p>
-                  </a:txBody>
-                  <a:tcPr marL="54864" marR="54864" marT="18288" marB="18288">
-                    <a:solidFill>
-                      <a:srgbClr val="FFFFFF"/>
-                    </a:solidFill>
-                  </a:tcPr>
-                </a:tc>
-                <a:tc>
-                  <a:txBody>
-                    <a:bodyPr wrap="square"/>
-                    <a:lstStyle/>
-                    <a:p>
-                      <a:r>
-                        <a:rPr sz="1100" b="0">
-                          <a:solidFill>
-                            <a:srgbClr val="282828"/>
-                          </a:solidFill>
-                          <a:latin typeface="Arial"/>
-                        </a:rPr>
-                        <a:t>same, beat at kHz; demodulation on-chip; I/Q data at 1 kHz</a:t>
-                      </a:r>
-                    </a:p>
-                  </a:txBody>
-                  <a:tcPr marL="54864" marR="54864" marT="18288" marB="18288">
-                    <a:solidFill>
-                      <a:srgbClr val="FFFFFF"/>
-                    </a:solidFill>
-                  </a:tcPr>
-                </a:tc>
-              </a:tr>
-              <a:tr h="468630">
-                <a:tc>
-                  <a:txBody>
-                    <a:bodyPr wrap="square"/>
-                    <a:lstStyle/>
-                    <a:p>
-                      <a:r>
-                        <a:rPr sz="1100" b="0">
-                          <a:solidFill>
-                            <a:srgbClr val="282828"/>
-                          </a:solidFill>
-                          <a:latin typeface="Arial"/>
-                        </a:rPr>
-                        <a:t>resolution</a:t>
-                      </a:r>
-                    </a:p>
-                  </a:txBody>
-                  <a:tcPr marL="54864" marR="54864" marT="18288" marB="18288">
-                    <a:solidFill>
-                      <a:srgbClr val="ECF1F6"/>
-                    </a:solidFill>
-                  </a:tcPr>
-                </a:tc>
-                <a:tc>
-                  <a:txBody>
-                    <a:bodyPr wrap="square"/>
-                    <a:lstStyle/>
-                    <a:p>
-                      <a:r>
-                        <a:rPr sz="1100" b="0">
-                          <a:solidFill>
-                            <a:srgbClr val="282828"/>
-                          </a:solidFill>
-                          <a:latin typeface="Arial"/>
-                        </a:rPr>
-                        <a:t>pixel-by-pixel from two images, wants ≥ 4 px per actuator</a:t>
-                      </a:r>
-                    </a:p>
-                  </a:txBody>
-                  <a:tcPr marL="54864" marR="54864" marT="18288" marB="18288">
-                    <a:solidFill>
-                      <a:srgbClr val="ECF1F6"/>
-                    </a:solidFill>
-                  </a:tcPr>
-                </a:tc>
-                <a:tc>
-                  <a:txBody>
-                    <a:bodyPr wrap="square"/>
-                    <a:lstStyle/>
-                    <a:p>
-                      <a:r>
-                        <a:rPr sz="1100" b="0">
-                          <a:solidFill>
-                            <a:srgbClr val="282828"/>
-                          </a:solidFill>
-                          <a:latin typeface="Arial"/>
-                        </a:rPr>
-                        <a:t>9.4 px per actuator</a:t>
-                      </a:r>
-                    </a:p>
-                  </a:txBody>
-                  <a:tcPr marL="54864" marR="54864" marT="18288" marB="18288">
-                    <a:solidFill>
-                      <a:srgbClr val="ECF1F6"/>
-                    </a:solidFill>
-                  </a:tcPr>
-                </a:tc>
-                <a:tc>
-                  <a:txBody>
-                    <a:bodyPr wrap="square"/>
-                    <a:lstStyle/>
-                    <a:p>
-                      <a:r>
-                        <a:rPr sz="1100" b="0">
-                          <a:solidFill>
-                            <a:srgbClr val="282828"/>
-                          </a:solidFill>
-                          <a:latin typeface="Arial"/>
-                        </a:rPr>
-                        <a:t>9.4</a:t>
-                      </a:r>
-                    </a:p>
-                  </a:txBody>
-                  <a:tcPr marL="54864" marR="54864" marT="18288" marB="18288">
-                    <a:solidFill>
-                      <a:srgbClr val="ECF1F6"/>
-                    </a:solidFill>
-                  </a:tcPr>
-                </a:tc>
-                <a:tc>
-                  <a:txBody>
-                    <a:bodyPr wrap="square"/>
-                    <a:lstStyle/>
-                    <a:p>
-                      <a:r>
-                        <a:rPr sz="1100" b="0">
-                          <a:solidFill>
-                            <a:srgbClr val="282828"/>
-                          </a:solidFill>
-                          <a:latin typeface="Arial"/>
-                        </a:rPr>
-                        <a:t>5.3 (C4M 10.6)</a:t>
+                        <a:t>LO the same (29.4 pm); fiber a per-sample piston, inert (record)</a:t>
                       </a:r>
                     </a:p>
                   </a:txBody>
@@ -11456,7 +11232,7 @@
         </p:nvSpPr>
         <p:spPr>
           <a:xfrm>
-            <a:off x="411480" y="7359777"/>
+            <a:off x="411480" y="5257800"/>
             <a:ext cx="11368735" cy="274320"/>
           </a:xfrm>
           <a:prstGeom prst="rect">
@@ -11476,7 +11252,7 @@
               </a:spcAft>
             </a:pPr>
             <a:r>
-              <a:rPr sz="1500" b="0">
+              <a:rPr sz="1100" b="0">
                 <a:solidFill>
                   <a:srgbClr val="282828"/>
                 </a:solidFill>
@@ -11485,7 +11261,7 @@
               <a:t>•  </a:t>
             </a:r>
             <a:r>
-              <a:rPr sz="1500" b="1">
+              <a:rPr sz="1100" b="1">
                 <a:solidFill>
                   <a:srgbClr val="282828"/>
                 </a:solidFill>
@@ -11494,31 +11270,31 @@
               <a:t>For hold alone,</a:t>
             </a:r>
             <a:r>
-              <a:rPr sz="1500" b="0">
+              <a:rPr sz="1100" b="0">
                 <a:solidFill>
                   <a:srgbClr val="282828"/>
                 </a:solidFill>
                 <a:latin typeface="Arial"/>
               </a:rPr>
-              <a:t> the vector Zernike sensor is the cheapest in photons by ~50× and needs no stabilities of its own — but on the assumed polarization camera (10 ke⁻ well) it is the slowest in time, ~60 s per 3 pm cycle; Feng's camera makes COPHI slow (16 s cycles); the Photonfocus makes it fast (1.6 s); </a:t>
-            </a:r>
-            <a:r>
-              <a:rPr sz="1500" b="1">
+              <a:t> the vector Zernike is cheapest in photons by ~50× and needs no stabilities of its own — but on the assumed polarization camera it is the slowest in time (~60 s per cycle); Feng's camera makes COPHI slow (16 s), the Photonfocus fast (1.6 s), </a:t>
+            </a:r>
+            <a:r>
+              <a:rPr sz="1100" b="1">
                 <a:solidFill>
                   <a:srgbClr val="282828"/>
                 </a:solidFill>
                 <a:latin typeface="Arial"/>
               </a:rPr>
-              <a:t>the lock-in makes COPHI the fastest reading on the table</a:t>
-            </a:r>
-            <a:r>
-              <a:rPr sz="1500" b="0">
+              <a:t>the lock-in the fastest reading on the table (0.125 s; records)</a:t>
+            </a:r>
+            <a:r>
+              <a:rPr sz="1100" b="0">
                 <a:solidFill>
                   <a:srgbClr val="282828"/>
                 </a:solidFill>
                 <a:latin typeface="Arial"/>
               </a:rPr>
-              <a:t> (0.125 s cycles at 3.09 pm, 3.35 s per pm; records) — if its well behaves as surveyed — and its fiber term is a per-sample piston, inert (record).</a:t>
+              <a:t> if its well is as surveyed — with the fiber term inert.</a:t>
             </a:r>
           </a:p>
           <a:p>
@@ -11528,7 +11304,7 @@
               </a:spcAft>
             </a:pPr>
             <a:r>
-              <a:rPr sz="1500" b="0">
+              <a:rPr sz="1100" b="0">
                 <a:solidFill>
                   <a:srgbClr val="282828"/>
                 </a:solidFill>
@@ -11537,7 +11313,7 @@
               <a:t>•  </a:t>
             </a:r>
             <a:r>
-              <a:rPr sz="1500" b="1">
+              <a:rPr sz="1100" b="1">
                 <a:solidFill>
                   <a:srgbClr val="282828"/>
                 </a:solidFill>
@@ -11546,16 +11322,16 @@
               <a:t>For capture and the absolute figure,</a:t>
             </a:r>
             <a:r>
-              <a:rPr sz="1500" b="0">
+              <a:rPr sz="1100" b="0">
                 <a:solidFill>
                   <a:srgbClr val="282828"/>
                 </a:solidFill>
                 <a:latin typeface="Arial"/>
               </a:rPr>
-              <a:t> COPHI in either form: a reference that does not depend on the surface, two colors for 480 nm rms in one reading.  </a:t>
-            </a:r>
-            <a:r>
-              <a:rPr sz="1500" b="1">
+              <a:t> COPHI in either form.  </a:t>
+            </a:r>
+            <a:r>
+              <a:rPr sz="1100" b="1">
                 <a:solidFill>
                   <a:srgbClr val="282828"/>
                 </a:solidFill>
@@ -11564,31 +11340,31 @@
               <a:t>What decides it for a flight DM:</a:t>
             </a:r>
             <a:r>
-              <a:rPr sz="1500" b="0">
+              <a:rPr sz="1100" b="0">
                 <a:solidFill>
                   <a:srgbClr val="282828"/>
                 </a:solidFill>
                 <a:latin typeface="Arial"/>
               </a:rPr>
-              <a:t> hold only and photons scarce → the Zernike sensor, with a camera chosen for it; hold + capture + absolute, or speed → COPHI, and with the lock-in camera it is the fastest by 20–500×; </a:t>
-            </a:r>
-            <a:r>
-              <a:rPr sz="1500" b="1">
+              <a:t> hold only and photons scarce → the Zernike sensor with a camera chosen for it; hold + capture + absolute, or speed → COPHI, with the lock-in the fastest by 20–500×; </a:t>
+            </a:r>
+            <a:r>
+              <a:rPr sz="1100" b="1">
                 <a:solidFill>
                   <a:srgbClr val="282828"/>
                 </a:solidFill>
                 <a:latin typeface="Arial"/>
               </a:rPr>
-              <a:t>the hybrid Feng's purpose suggests</a:t>
-            </a:r>
-            <a:r>
-              <a:rPr sz="1500" b="0">
+              <a:t>the hybrid</a:t>
+            </a:r>
+            <a:r>
+              <a:rPr sz="1100" b="0">
                 <a:solidFill>
                   <a:srgbClr val="282828"/>
                 </a:solidFill>
                 <a:latin typeface="Arial"/>
               </a:rPr>
-              <a:t> — a Zernike sensor for the hold, COPHI's two-color read for capture and commissioning — remains the conservative answer until the lock-in's vendor numbers are in.</a:t>
+              <a:t> — a Zernike sensor for the hold, COPHI's two-color read for capture and commissioning — stays the conservative answer until the lock-in's vendor numbers are in.</a:t>
             </a:r>
           </a:p>
         </p:txBody>
@@ -11601,7 +11377,7 @@
         </p:nvSpPr>
         <p:spPr>
           <a:xfrm>
-            <a:off x="411480" y="10153269"/>
+            <a:off x="411480" y="6664452"/>
             <a:ext cx="11368735" cy="274320"/>
           </a:xfrm>
           <a:prstGeom prst="rect">

</xml_diff>

<commit_message>
deck_cophi: I and Q defined at first use (in-phase / quadrature demodulated components, not intensities; phi = atan2(Q, I)) on the lock-in slide and in its table
Co-Authored-By: Claude Fable 5.1 <noreply@anthropic.com>
</commit_message>
<xml_diff>
--- a/demo_session/deck_cophi.pptx
+++ b/demo_session/deck_cophi.pptx
@@ -17734,7 +17734,7 @@
                 </a:solidFill>
                 <a:latin typeface="Arial"/>
               </a:rPr>
-              <a:t> = synchronous detection inside each pixel: the photocurrent is steered into in-phase and quadrature stores by the external reference (our Rb-clocked beat, now at kHz), the DC never reaches the well, I and Q leave at the frame rate — the four-bucket replaced by thousands of cycles integrated on-chip.</a:t>
+              <a:t> = synchronous detection inside each pixel: the photocurrent is multiplied by the external reference (our Rb-clocked beat, now at kHz) and by its 90°-shifted copy and integrated: the two stores are I = I₀γ cos φ (in-phase) and Q = I₀γ sin φ (quadrature) — demodulated components, not intensities; the DC term I₀ averages out and never reaches the well; I and Q leave at the frame rate and φ = atan2(Q, I) — the four-bucket replaced by thousands of cycles integrated on-chip.</a:t>
             </a:r>
           </a:p>
           <a:p>
@@ -17989,7 +17989,7 @@
                           </a:solidFill>
                           <a:latin typeface="Arial"/>
                         </a:rPr>
-                        <a:t>I/Q per pixel at 1 kHz</a:t>
+                        <a:t>I/Q (in-phase / quadrature) per pixel at 1 kHz</a:t>
                       </a:r>
                     </a:p>
                   </a:txBody>

</xml_diff>

<commit_message>
deck_cophi: wording pass (Dave 2026-10-12) -- plainer words, shorter bullets with sub-bullets, less fluff on slides 5-19; the hold slide's subtitle carries the lock-in result; the mirror-rig layout re-cropped from the relabeled render (LO collimator + fiber tip named); sidecar re-keyed to the new text (keys are the full block text -- a reworded block had been losing its geometry)
Co-Authored-By: Claude Fable 5.1 <noreply@anthropic.com>
</commit_message>
<xml_diff>
--- a/demo_session/deck_cophi.pptx
+++ b/demo_session/deck_cophi.pptx
@@ -3321,7 +3321,7 @@
                 </a:solidFill>
                 <a:latin typeface="Arial"/>
               </a:rPr>
-              <a:t>The model samples the pupil at 3.3 pixels per actuator; every camera on the table oversamples the 96 × 96 lattice, so resolution costs no photons — the time to a picometer is set by well depth × frame rate, not by pixel count</a:t>
+              <a:t>The model samples the pupil at 3.3 pixels per actuator; every camera on the table oversamples the 96 × 96 lattice, so resolution costs no photons — the time to a picometer is well depth × frame rate, not pixel count</a:t>
             </a:r>
           </a:p>
         </p:txBody>
@@ -4338,7 +4338,7 @@
                 </a:solidFill>
                 <a:latin typeface="Arial"/>
               </a:rPr>
-              <a:t>Resolution is free down to 1 : 1</a:t>
+              <a:t>Resolution is free down to ~1.5 pixels per actuator:</a:t>
             </a:r>
             <a:r>
               <a:rPr sz="1500" b="0">
@@ -4347,7 +4347,39 @@
                 </a:solidFill>
                 <a:latin typeface="Arial"/>
               </a:rPr>
-              <a:t> (ruling: every mode of interest is commanded at full actuator resolution, so nothing coarser is modeled): a camera's photons per second are pixels × well × rate over the pupil, and binning finer pixels onto the lattice changes nothing but the read noise per sample.  Below ~1.5 pixels per actuator the actuator-space fit collapses (the blur demo's box kernel), which is why 5 pixels per actuator is the floor on this table.</a:t>
+              <a:t> a camera's photons per second are pixels × well × rate over the pupil; binning finer pixels onto the lattice changes only the read noise per sample.</a:t>
+            </a:r>
+          </a:p>
+          <a:p>
+            <a:pPr marL="594360" indent="-137160">
+              <a:spcAft>
+                <a:spcPts val="500"/>
+              </a:spcAft>
+            </a:pPr>
+            <a:r>
+              <a:rPr sz="1300" b="0">
+                <a:solidFill>
+                  <a:srgbClr val="6E6E6E"/>
+                </a:solidFill>
+                <a:latin typeface="Arial"/>
+              </a:rPr>
+              <a:t>–  below ~1.5 px per actuator the actuator fit collapses (the blur demo's box kernel) — 5 px per actuator is the floor on this table</a:t>
+            </a:r>
+          </a:p>
+          <a:p>
+            <a:pPr marL="594360" indent="-137160">
+              <a:spcAft>
+                <a:spcPts val="500"/>
+              </a:spcAft>
+            </a:pPr>
+            <a:r>
+              <a:rPr sz="1300" b="0">
+                <a:solidFill>
+                  <a:srgbClr val="6E6E6E"/>
+                </a:solidFill>
+                <a:latin typeface="Arial"/>
+              </a:rPr>
+              <a:t>–  nothing coarser is modeled (ruling: every mode of interest is commanded at full actuator resolution)</a:t>
             </a:r>
           </a:p>
           <a:p>
@@ -4372,7 +4404,7 @@
                 </a:solidFill>
                 <a:latin typeface="Arial"/>
               </a:rPr>
-              <a:t>The cameras were put on the model grid by binning</a:t>
+              <a:t>Cameras were put on the model grid by binning</a:t>
             </a:r>
             <a:r>
               <a:rPr sz="1500" b="0">
@@ -4381,7 +4413,7 @@
                 </a:solidFill>
                 <a:latin typeface="Arial"/>
               </a:rPr>
-              <a:t> (well × k², read × k): the pm-per-reading rows are the full camera's photons, at the model's sampling.</a:t>
+              <a:t> (well × k², read × k): the pm-per-reading rows are the full camera's photons at the model's sampling.</a:t>
             </a:r>
           </a:p>
         </p:txBody>
@@ -4394,7 +4426,7 @@
         </p:nvSpPr>
         <p:spPr>
           <a:xfrm>
-            <a:off x="411480" y="6430899"/>
+            <a:off x="411480" y="6834505"/>
             <a:ext cx="11368735" cy="274320"/>
           </a:xfrm>
           <a:prstGeom prst="rect">
@@ -4493,7 +4525,7 @@
                 </a:solidFill>
                 <a:latin typeface="Arial"/>
               </a:rPr>
-              <a:t>HET = the heterodyne (COPHI) reading; IFO = the record's Twyman-Green polarization interferometer.  Same seed, surface and matrix: HET matches the IFO's floor, halves its mirror-rig random-surface error, and is exact where the IFO's reading is not</a:t>
+              <a:t>HET = the heterodyne (COPHI) reading; IFO = the record's Twyman-Green polarization interferometer.  Same seed, surface and matrix: HET matches the IFO's floor, halves its mirror-rig random-surface error, and is exact where the IFO is not</a:t>
             </a:r>
           </a:p>
         </p:txBody>
@@ -5478,7 +5510,7 @@
         </p:nvSpPr>
         <p:spPr>
           <a:xfrm>
-            <a:off x="411480" y="5623560"/>
+            <a:off x="411480" y="4135374"/>
             <a:ext cx="11368735" cy="274320"/>
           </a:xfrm>
           <a:prstGeom prst="rect">
@@ -5498,7 +5530,7 @@
               </a:spcAft>
             </a:pPr>
             <a:r>
-              <a:rPr sz="1200" b="0">
+              <a:rPr sz="1500" b="0">
                 <a:solidFill>
                   <a:srgbClr val="282828"/>
                 </a:solidFill>
@@ -5507,22 +5539,22 @@
               <a:t>•  </a:t>
             </a:r>
             <a:r>
-              <a:rPr sz="1200" b="1">
+              <a:rPr sz="1500" b="1">
                 <a:solidFill>
                   <a:srgbClr val="282828"/>
                 </a:solidFill>
                 <a:latin typeface="Arial"/>
               </a:rPr>
-              <a:t>The one-step rows sit 0.5 % low for HET on both rigs — and that is the estimator, not the reading:</a:t>
-            </a:r>
-            <a:r>
-              <a:rPr sz="1200" b="0">
+              <a:t>The one-step rows sit 0.5 % low for HET on both rigs — the estimator, not the reading:</a:t>
+            </a:r>
+            <a:r>
+              <a:rPr sz="1500" b="0">
                 <a:solidFill>
                   <a:srgbClr val="282828"/>
                 </a:solidFill>
                 <a:latin typeface="Arial"/>
               </a:rPr>
-              <a:t> a synthetic 1.000 nm poke reads at slope 1.000000 at the pixel level; the LO placement, the vector sum, the polarizers and the mask each cleared; at λ_m = 10⁻⁵ the gain is 1.0007.  It is the one-step Tikhonov shrinkage at the record's λ_m = 10⁻³ — the "matrix bias" every gauge carries, now a number.</a:t>
+              <a:t> the reading is exact (a 1.000 nm poke reads at slope 1.000000); the 0.5 % is the one-step Tikhonov shrinkage at the record's λ_m = 10⁻³ (1.0007 at 10⁻⁵) — the "matrix bias" every gauge carries, now a number.</a:t>
             </a:r>
           </a:p>
           <a:p>
@@ -5532,7 +5564,7 @@
               </a:spcAft>
             </a:pPr>
             <a:r>
-              <a:rPr sz="1200" b="0">
+              <a:rPr sz="1500" b="0">
                 <a:solidFill>
                   <a:srgbClr val="282828"/>
                 </a:solidFill>
@@ -5541,22 +5573,22 @@
               <a:t>•  </a:t>
             </a:r>
             <a:r>
-              <a:rPr sz="1200" b="1">
+              <a:rPr sz="1500" b="1">
                 <a:solidFill>
                   <a:srgbClr val="282828"/>
                 </a:solidFill>
                 <a:latin typeface="Arial"/>
               </a:rPr>
-              <a:t>Driven to convergence (the gauge's servo use), HET reads exactly on the mirror rig; the IFO then shows its polarization gain in the open:</a:t>
-            </a:r>
-            <a:r>
-              <a:rPr sz="1200" b="0">
+              <a:t>Driven to convergence (the servo use), HET reads exactly on the mirror rig, and the IFO shows its polarization gain in the open:</a:t>
+            </a:r>
+            <a:r>
+              <a:rPr sz="1500" b="0">
                 <a:solidFill>
                   <a:srgbClr val="282828"/>
                 </a:solidFill>
                 <a:latin typeface="Arial"/>
               </a:rPr>
-              <a:t> IFO/HET = 1.006–1.009 on the lens rig and 0.989 on the mirror rig.  The IFO's lens-rig "1.000" was +0.5–1 % of polarization gain cancelling the 0.5 % shrinkage.</a:t>
+              <a:t> IFO/HET = 1.006–1.009 (lens rig), 0.989 (mirror rig); the IFO's lens-rig "1.000" was polarization gain cancelling the shrinkage.</a:t>
             </a:r>
           </a:p>
         </p:txBody>
@@ -5569,7 +5601,7 @@
         </p:nvSpPr>
         <p:spPr>
           <a:xfrm>
-            <a:off x="411480" y="7129272"/>
+            <a:off x="411480" y="5938266"/>
             <a:ext cx="11368735" cy="274320"/>
           </a:xfrm>
           <a:prstGeom prst="rect">
@@ -5668,7 +5700,7 @@
                 </a:solidFill>
                 <a:latin typeface="Arial"/>
               </a:rPr>
-              <a:t>A heterodyne read is photon-limited at full well: pixels × well × frame rate decides; Feng's baseline camera is seven minutes per picometer, the deepest-well 1k global-shutter part is 40 seconds</a:t>
+              <a:t>A heterodyne read is photon-limited at full well: pixels × well × frame rate decides; Feng's baseline camera is seven minutes per picometer, the deepest-well 1k global-shutter part is 40 seconds, the lock-in 3.4 s</a:t>
             </a:r>
           </a:p>
         </p:txBody>
@@ -6594,7 +6626,7 @@
                 </a:solidFill>
                 <a:latin typeface="Arial"/>
               </a:rPr>
-              <a:t>The metric</a:t>
+              <a:t>The metric:</a:t>
             </a:r>
             <a:r>
               <a:rPr sz="1200" b="0">
@@ -6603,7 +6635,23 @@
                 </a:solidFill>
                 <a:latin typeface="Arial"/>
               </a:rPr>
-              <a:t> is the piston-free robust floor over the unpoked actuators (1.48 MAD, median of 12 draws): the raw single-actuator noise is mostly a common piston (165 vs 76 pm), unobservable and inert on a DM.  The composite deck puts every gauge on this metric.</a:t>
+              <a:t> the piston-free robust floor over the unpoked actuators (1.48 MAD, median of 12 draws).</a:t>
+            </a:r>
+          </a:p>
+          <a:p>
+            <a:pPr marL="594360" indent="-137160">
+              <a:spcAft>
+                <a:spcPts val="500"/>
+              </a:spcAft>
+            </a:pPr>
+            <a:r>
+              <a:rPr sz="1050" b="0">
+                <a:solidFill>
+                  <a:srgbClr val="6E6E6E"/>
+                </a:solidFill>
+                <a:latin typeface="Arial"/>
+              </a:rPr>
+              <a:t>–  the raw single-actuator noise is mostly a common piston (165 vs 76 pm) — unobservable and inert on a DM; the composite deck puts every gauge on this metric</a:t>
             </a:r>
           </a:p>
         </p:txBody>
@@ -6660,7 +6708,23 @@
                 </a:solidFill>
                 <a:latin typeface="Arial"/>
               </a:rPr>
-              <a:t> (σ_φ² ∝ I₀ + r²): the Photonfocus's 220 e⁻ costs 22 % in σ at half well and it still wins on well × rate; the baseline's and the C-RED's read noise are assumed (not in Feng's deck; the survey's low-gain value unconfirmed).</a:t>
+              <a:t> (σ_φ² ∝ I₀ + r²): the Photonfocus's 220 e⁻ costs 22 % in σ at half well and it still wins on well × rate.</a:t>
+            </a:r>
+          </a:p>
+          <a:p>
+            <a:pPr marL="594360" indent="-137160">
+              <a:spcAft>
+                <a:spcPts val="500"/>
+              </a:spcAft>
+            </a:pPr>
+            <a:r>
+              <a:rPr sz="1050" b="0">
+                <a:solidFill>
+                  <a:srgbClr val="6E6E6E"/>
+                </a:solidFill>
+                <a:latin typeface="Arial"/>
+              </a:rPr>
+              <a:t>–  the baseline's and the C-RED's read noise are assumed (not in Feng's deck; the survey's value unconfirmed)</a:t>
             </a:r>
           </a:p>
           <a:p>
@@ -6694,7 +6758,23 @@
                 </a:solidFill>
                 <a:latin typeface="Arial"/>
               </a:rPr>
-              <a:t> one reading gives SNR 0.02–0.05; SNR 1 takes (pm per reading)² readings — the seconds-per-pm column; SNR 10 takes 100× that.  A hold loop never needs SNR 10 in one measurement: it integrates readings (next slide).</a:t>
+              <a:t> one reading gives SNR 0.02–0.05; SNR 1 takes (pm per reading)² readings — the seconds-per-pm column; SNR 10 takes 100× that.</a:t>
+            </a:r>
+          </a:p>
+          <a:p>
+            <a:pPr marL="594360" indent="-137160">
+              <a:spcAft>
+                <a:spcPts val="500"/>
+              </a:spcAft>
+            </a:pPr>
+            <a:r>
+              <a:rPr sz="1050" b="0">
+                <a:solidFill>
+                  <a:srgbClr val="6E6E6E"/>
+                </a:solidFill>
+                <a:latin typeface="Arial"/>
+              </a:rPr>
+              <a:t>–  a hold loop never needs SNR 10 in one measurement: it integrates readings (next slide)</a:t>
             </a:r>
           </a:p>
           <a:p>
@@ -6719,7 +6799,7 @@
                 </a:solidFill>
                 <a:latin typeface="Arial"/>
               </a:rPr>
-              <a:t>The per-pixel noise measured on the bench equals the tCophi formula to 1.000 ± 0.002</a:t>
+              <a:t>Model and bench agree:</a:t>
             </a:r>
             <a:r>
               <a:rPr sz="1200" b="0">
@@ -6728,7 +6808,7 @@
                 </a:solidFill>
                 <a:latin typeface="Arial"/>
               </a:rPr>
-              <a:t> on every camera, rig and train — the model and the bench agree.</a:t>
+              <a:t> the per-pixel noise on the bench equals the tCophi formula to 1.000 ± 0.002 on every camera, rig and train.</a:t>
             </a:r>
           </a:p>
           <a:p>
@@ -6753,7 +6833,7 @@
                 </a:solidFill>
                 <a:latin typeface="Arial"/>
               </a:rPr>
-              <a:t>Rolling-shutter sCMOS are out:</a:t>
+              <a:t>Rolling-shutter cameras are out:</a:t>
             </a:r>
             <a:r>
               <a:rPr sz="1200" b="0">
@@ -6762,7 +6842,7 @@
                 </a:solidFill>
                 <a:latin typeface="Arial"/>
               </a:rPr>
-              <a:t> rows exposed in sequence see different beat phases — a phase ramp across the image; true global shutter, hardware trigger from the Rb clock, streamable at full frame.</a:t>
+              <a:t> rows exposed in sequence see different beat phases — a phase ramp across the image.  Needed: true global shutter, hardware trigger from the Rb clock, full-frame streaming.</a:t>
             </a:r>
           </a:p>
           <a:p>
@@ -6796,7 +6876,7 @@
                 </a:solidFill>
                 <a:latin typeface="Arial"/>
               </a:rPr>
-              <a:t> a 1k camera oversamples the 96 × 96 lattice ten to one; well depth × frame rate is the budget (NOTE_detectors_survey).</a:t>
+              <a:t> a 1k camera oversamples the lattice ten to one; well depth × frame rate is the budget.</a:t>
             </a:r>
           </a:p>
         </p:txBody>
@@ -6809,7 +6889,7 @@
         </p:nvSpPr>
         <p:spPr>
           <a:xfrm>
-            <a:off x="6400800" y="5404104"/>
+            <a:off x="6400800" y="5361940"/>
             <a:ext cx="5394960" cy="274320"/>
           </a:xfrm>
           <a:prstGeom prst="rect">
@@ -6908,7 +6988,7 @@
                 </a:solidFill>
                 <a:latin typeface="Arial"/>
               </a:rPr>
-              <a:t>COPHI holds 3 pm against the record's drifts; the baseline camera needs a 16 s cycle, the Photonfocus 1.6 s; the LO's pointing is the term the loop cannot see past</a:t>
+              <a:t>COPHI holds 3 pm against the record's drifts: Feng's baseline camera needs a 16 s cycle, the Photonfocus 1.6 s, the lock-in camera 0.125 s (3.09 pm, fiber term inert); the LO's pointing is the term the loop cannot see past</a:t>
             </a:r>
           </a:p>
         </p:txBody>
@@ -7495,25 +7575,41 @@
                 </a:solidFill>
                 <a:latin typeface="Arial"/>
               </a:rPr>
-              <a:t> the matrix takes an LO tilt as a DM tilt one-for-one (a 1 nrad tilt reads as a surface tilt of 1.008 × θ/2), and the loop drives the DM to follow it.  </a:t>
-            </a:r>
-            <a:r>
-              <a:rPr sz="1200" b="1">
-                <a:solidFill>
-                  <a:srgbClr val="282828"/>
-                </a:solidFill>
-                <a:latin typeface="Arial"/>
-              </a:rPr>
-              <a:t>The LO pointing must hold ~10 prad per cycle — ~10 pm of fiber-tip motion at the collimator's focal length — or be referenced.</a:t>
-            </a:r>
-            <a:r>
-              <a:rPr sz="1200" b="0">
-                <a:solidFill>
-                  <a:srgbClr val="282828"/>
-                </a:solidFill>
-                <a:latin typeface="Arial"/>
-              </a:rPr>
-              <a:t>  That is the architecture requirement the plain-splitter layout adds, beside the fiber's.</a:t>
+              <a:t> the matrix takes an LO tilt as a DM tilt one-for-one (1 nrad reads as a surface tilt of 1.008 × θ/2), and the loop drives the DM to follow it.</a:t>
+            </a:r>
+          </a:p>
+          <a:p>
+            <a:pPr marL="594360" indent="-137160">
+              <a:spcAft>
+                <a:spcPts val="500"/>
+              </a:spcAft>
+            </a:pPr>
+            <a:r>
+              <a:rPr sz="1050" b="0">
+                <a:solidFill>
+                  <a:srgbClr val="6E6E6E"/>
+                </a:solidFill>
+                <a:latin typeface="Arial"/>
+              </a:rPr>
+              <a:t>–  </a:t>
+            </a:r>
+            <a:r>
+              <a:rPr sz="1050" b="1">
+                <a:solidFill>
+                  <a:srgbClr val="6E6E6E"/>
+                </a:solidFill>
+                <a:latin typeface="Arial"/>
+              </a:rPr>
+              <a:t>the LO pointing must hold ~10 prad per cycle (~10 pm of fiber-tip motion at the collimator's focal length), or be referenced</a:t>
+            </a:r>
+            <a:r>
+              <a:rPr sz="1050" b="0">
+                <a:solidFill>
+                  <a:srgbClr val="6E6E6E"/>
+                </a:solidFill>
+                <a:latin typeface="Arial"/>
+              </a:rPr>
+              <a:t> — the requirement the plain-splitter layout adds, beside the fiber's</a:t>
             </a:r>
           </a:p>
           <a:p>
@@ -7547,25 +7643,57 @@
                 </a:solidFill>
                 <a:latin typeface="Arial"/>
               </a:rPr>
-              <a:t> the four-step cannot cancel a differential fiber-phase walk within its own four frames.  Budget at the photon floor (mirror rig, median-fill convention): </a:t>
-            </a:r>
-            <a:r>
-              <a:rPr sz="1200" b="1">
-                <a:solidFill>
-                  <a:srgbClr val="282828"/>
+              <a:t> the four-step cannot cancel a differential fiber-phase walk within its own four frames.</a:t>
+            </a:r>
+          </a:p>
+          <a:p>
+            <a:pPr marL="594360" indent="-137160">
+              <a:spcAft>
+                <a:spcPts val="500"/>
+              </a:spcAft>
+            </a:pPr>
+            <a:r>
+              <a:rPr sz="1050" b="0">
+                <a:solidFill>
+                  <a:srgbClr val="6E6E6E"/>
+                </a:solidFill>
+                <a:latin typeface="Arial"/>
+              </a:rPr>
+              <a:t>–  budget at the photon floor (mirror rig): </a:t>
+            </a:r>
+            <a:r>
+              <a:rPr sz="1050" b="1">
+                <a:solidFill>
+                  <a:srgbClr val="6E6E6E"/>
                 </a:solidFill>
                 <a:latin typeface="Arial"/>
               </a:rPr>
               <a:t>3.9 × 10⁻³ rad per frame = 0.39 nm of differential OPD per 33 ms, ~12 nm/s, ~1.2 mK/s per meter of uncommon fiber</a:t>
             </a:r>
             <a:r>
-              <a:rPr sz="1200" b="0">
-                <a:solidFill>
-                  <a:srgbClr val="282828"/>
-                </a:solidFill>
-                <a:latin typeface="Arial"/>
-              </a:rPr>
-              <a:t> — co-routed, thermally tied, or servoed.</a:t>
+              <a:rPr sz="1050" b="0">
+                <a:solidFill>
+                  <a:srgbClr val="6E6E6E"/>
+                </a:solidFill>
+                <a:latin typeface="Arial"/>
+              </a:rPr>
+              <a:t> — co-routed, thermally tied, or servoed</a:t>
+            </a:r>
+          </a:p>
+          <a:p>
+            <a:pPr marL="594360" indent="-137160">
+              <a:spcAft>
+                <a:spcPts val="500"/>
+              </a:spcAft>
+            </a:pPr>
+            <a:r>
+              <a:rPr sz="1050" b="0">
+                <a:solidFill>
+                  <a:srgbClr val="6E6E6E"/>
+                </a:solidFill>
+                <a:latin typeface="Arial"/>
+              </a:rPr>
+              <a:t>–  with the lock-in camera the walk is a per-sample piston: inert (record)</a:t>
             </a:r>
           </a:p>
           <a:p>
@@ -7592,14 +7720,37 @@
               </a:rPr>
               <a:t>How the loop reaches 3 pm from 55 pm readings — two integrators:</a:t>
             </a:r>
-            <a:r>
-              <a:rPr sz="1200" b="0">
-                <a:solidFill>
-                  <a:srgbClr val="282828"/>
-                </a:solidFill>
-                <a:latin typeface="Arial"/>
-              </a:rPr>
-              <a:t> the estimator's regularization (λ_m) is a spatial low-pass over the response matrix's small-singular-value directions, where photon and read noise live — it trades a 0.5 % gain for a lower floor (the converged estimator removes the bias but admits ×2.1 the white noise if run to a zero update); and the loop itself averages across cycles at gain g (steady state σ_n √(g/(2 − g)), plus M readings per cycle).  In the loop the one-step and the converged estimator agree to 0.1 pm on every row, so the bias costs nothing there; the converged mode is for the open-loop absolute read.</a:t>
+          </a:p>
+          <a:p>
+            <a:pPr marL="594360" indent="-137160">
+              <a:spcAft>
+                <a:spcPts val="500"/>
+              </a:spcAft>
+            </a:pPr>
+            <a:r>
+              <a:rPr sz="1050" b="0">
+                <a:solidFill>
+                  <a:srgbClr val="6E6E6E"/>
+                </a:solidFill>
+                <a:latin typeface="Arial"/>
+              </a:rPr>
+              <a:t>–  the estimator's regularization (λ_m) is a spatial low-pass over the matrix's small-singular-value directions, where photon and read noise live; it trades a 0.5 % gain for a lower floor (the converged estimator removes the bias but admits ×2.1 the white noise)</a:t>
+            </a:r>
+          </a:p>
+          <a:p>
+            <a:pPr marL="594360" indent="-137160">
+              <a:spcAft>
+                <a:spcPts val="500"/>
+              </a:spcAft>
+            </a:pPr>
+            <a:r>
+              <a:rPr sz="1050" b="0">
+                <a:solidFill>
+                  <a:srgbClr val="6E6E6E"/>
+                </a:solidFill>
+                <a:latin typeface="Arial"/>
+              </a:rPr>
+              <a:t>–  the loop averages across cycles at gain g (steady state σ_n √(g/(2 − g)), plus M readings per cycle); in the loop the one-step and converged estimators agree to 0.1 pm on every row</a:t>
             </a:r>
           </a:p>
           <a:p>
@@ -7646,7 +7797,7 @@
         </p:nvSpPr>
         <p:spPr>
           <a:xfrm>
-            <a:off x="6400800" y="6650736"/>
+            <a:off x="6400800" y="6916801"/>
             <a:ext cx="5394960" cy="274320"/>
           </a:xfrm>
           <a:prstGeom prst="rect">
@@ -8022,7 +8173,7 @@
                 </a:solidFill>
                 <a:latin typeface="Arial"/>
               </a:rPr>
-              <a:t>Zero wrong fringe orders on the whole capture ladder to 480 nm rms; a single color wraps from 40 nm; the temporal unwrapping a continuous reading gets free holds a running loop, not a cold start</a:t>
+              <a:t>Zero wrong fringe orders on the whole capture ladder to 480 nm rms; a single color wraps from 40 nm; temporal unwrapping holds a running loop, not a cold start</a:t>
             </a:r>
           </a:p>
         </p:txBody>
@@ -8123,43 +8274,82 @@
                 </a:solidFill>
                 <a:latin typeface="Arial"/>
               </a:rPr>
-              <a:t> 632.8 + 652.8 nm (synthetic Λ = 20.65 µm, range ±5.2 µm), read by its own buckets per color (crosstalk 4 × 10⁻¹⁶ rad).  </a:t>
-            </a:r>
-            <a:r>
-              <a:rPr sz="1200" b="1">
-                <a:solidFill>
-                  <a:srgbClr val="282828"/>
-                </a:solidFill>
-                <a:latin typeface="Arial"/>
-              </a:rPr>
-              <a:t>Zero wrong orders to 480 nm rms, noise-free and on both cameras</a:t>
-            </a:r>
-            <a:r>
-              <a:rPr sz="1200" b="0">
-                <a:solidFill>
-                  <a:srgbClr val="282828"/>
-                </a:solidFill>
-                <a:latin typeface="Arial"/>
-              </a:rPr>
-              <a:t> (0.15 / 0.10 nm per pixel); the single color is 74 % wrong at 480.  </a:t>
-            </a:r>
-            <a:r>
-              <a:rPr sz="1200" b="1">
-                <a:solidFill>
-                  <a:srgbClr val="282828"/>
-                </a:solidFill>
-                <a:latin typeface="Arial"/>
-              </a:rPr>
-              <a:t>A 200 nm rms figure is captured from cold in one multiplexed reading, 0.27 s.</a:t>
-            </a:r>
-            <a:r>
-              <a:rPr sz="1200" b="0">
-                <a:solidFill>
-                  <a:srgbClr val="282828"/>
-                </a:solidFill>
-                <a:latin typeface="Arial"/>
-              </a:rPr>
-              <a:t>  Any Δλ from 1 to ~100 nm resolves (the fine requirement at Δλ = 20 nm is 1.7 nm against ~0.1 nm per pixel): the synthetic-wavelength ladder needs one rung for this job.</a:t>
+              <a:t> 632.8 + 652.8 nm (synthetic Λ = 20.65 µm, range ±5.2 µm), each color read by its own buckets (crosstalk 4 × 10⁻¹⁶ rad).</a:t>
+            </a:r>
+          </a:p>
+          <a:p>
+            <a:pPr marL="594360" indent="-137160">
+              <a:spcAft>
+                <a:spcPts val="500"/>
+              </a:spcAft>
+            </a:pPr>
+            <a:r>
+              <a:rPr sz="1050" b="0">
+                <a:solidFill>
+                  <a:srgbClr val="6E6E6E"/>
+                </a:solidFill>
+                <a:latin typeface="Arial"/>
+              </a:rPr>
+              <a:t>–  </a:t>
+            </a:r>
+            <a:r>
+              <a:rPr sz="1050" b="1">
+                <a:solidFill>
+                  <a:srgbClr val="6E6E6E"/>
+                </a:solidFill>
+                <a:latin typeface="Arial"/>
+              </a:rPr>
+              <a:t>zero wrong orders to 480 nm rms, both cameras</a:t>
+            </a:r>
+            <a:r>
+              <a:rPr sz="1050" b="0">
+                <a:solidFill>
+                  <a:srgbClr val="6E6E6E"/>
+                </a:solidFill>
+                <a:latin typeface="Arial"/>
+              </a:rPr>
+              <a:t> (0.15 / 0.10 nm per pixel); one color is 74 % wrong at 480</a:t>
+            </a:r>
+          </a:p>
+          <a:p>
+            <a:pPr marL="594360" indent="-137160">
+              <a:spcAft>
+                <a:spcPts val="500"/>
+              </a:spcAft>
+            </a:pPr>
+            <a:r>
+              <a:rPr sz="1050" b="0">
+                <a:solidFill>
+                  <a:srgbClr val="6E6E6E"/>
+                </a:solidFill>
+                <a:latin typeface="Arial"/>
+              </a:rPr>
+              <a:t>–  </a:t>
+            </a:r>
+            <a:r>
+              <a:rPr sz="1050" b="1">
+                <a:solidFill>
+                  <a:srgbClr val="6E6E6E"/>
+                </a:solidFill>
+                <a:latin typeface="Arial"/>
+              </a:rPr>
+              <a:t>a 200 nm rms figure is captured from cold in one 0.27 s reading</a:t>
+            </a:r>
+          </a:p>
+          <a:p>
+            <a:pPr marL="594360" indent="-137160">
+              <a:spcAft>
+                <a:spcPts val="500"/>
+              </a:spcAft>
+            </a:pPr>
+            <a:r>
+              <a:rPr sz="1050" b="0">
+                <a:solidFill>
+                  <a:srgbClr val="6E6E6E"/>
+                </a:solidFill>
+                <a:latin typeface="Arial"/>
+              </a:rPr>
+              <a:t>–  any Δλ from 1 to ~100 nm works (the fine requirement at Δλ = 20 nm is 1.7 nm against ~0.1 nm per pixel): one rung of the synthetic-wavelength ladder is enough here</a:t>
             </a:r>
           </a:p>
           <a:p>
@@ -8227,7 +8417,7 @@
                 </a:solidFill>
                 <a:latin typeface="Arial"/>
               </a:rPr>
-              <a:t> one reference at a time, so the two colors are read on alternate I/Q samples (2 ms per pair) — zero wrong orders to 480 nm rms, 0.12 nm per pixel; temporal unwrapping at 1 kHz tolerates 158 µm/s at the peak pixel.</a:t>
+              <a:t> one reference at a time, so the two colors alternate on I/Q samples (2 ms per pair) — zero wrong orders to 480 nm rms, 0.12 nm per pixel; temporal unwrapping at 1 kHz tolerates 158 µm/s.</a:t>
             </a:r>
           </a:p>
         </p:txBody>
@@ -10115,7 +10305,7 @@
         </p:nvSpPr>
         <p:spPr>
           <a:xfrm>
-            <a:off x="457200" y="6217920"/>
+            <a:off x="457200" y="6446520"/>
             <a:ext cx="11368735" cy="274320"/>
           </a:xfrm>
           <a:prstGeom prst="rect">
@@ -10141,7 +10331,7 @@
                 </a:solidFill>
                 <a:latin typeface="Arial"/>
               </a:rPr>
-              <a:t>Camera timings are TO's records on an IMX250MZR-class camera (2448 × 2048, 75 fps; well ~10 ke⁻ and read 2.4 e⁻ unconfirmed; the IFO's four analyzer frames in one exposure; S and P on the mono variant at 18.8 readings/s).  The sensors are 10–40× slower than photons ÷ full-sensor rate would say: the ZWFS image's bright core sets the exposure (dynamic range), the frame mean sits at half well, and two polarization orientations go unused — the IFO's uniform pupil does not pay those.  Parts counts and TRL to follow (campaign brief sec. 9.1).</a:t>
+              <a:t>Camera timings: TO's records on an IMX250MZR-class polarization camera (2448 × 2048, 75 fps; well ~10 ke⁻, read 2.4 e⁻, unconfirmed).  The sensors run 10–40× slower than photons ÷ sensor rate would say: the ZWFS core sets the exposure, the frame mean sits at half well, two orientations go unused.  Parts counts and TRL to follow (campaign brief sec. 9.1).</a:t>
             </a:r>
           </a:p>
         </p:txBody>
@@ -11415,7 +11605,48 @@
                 </a:solidFill>
                 <a:latin typeface="Arial"/>
               </a:rPr>
-              <a:t> every record is at 3.3–4 px per actuator (the IFO's mirror-rig image, distorted by more than a pitch at the edge, reads to 2 pm there); the collapse band is the blur demo's; the 5–20 rows follow from the well-bound photon rule and the data rates.  </a:t>
+              <a:t> every record is at 3.3–4 px per actuator (the IFO's mirror-rig image, distorted by more than a pitch at the edge, still reads to 2 pm); the collapse band is the blur demo's; the 5–20 rows follow from the well-bound photon rule and the data rates.</a:t>
+            </a:r>
+          </a:p>
+          <a:p>
+            <a:pPr marL="594360" indent="-137160">
+              <a:spcAft>
+                <a:spcPts val="500"/>
+              </a:spcAft>
+            </a:pPr>
+            <a:r>
+              <a:rPr sz="1300" b="0">
+                <a:solidFill>
+                  <a:srgbClr val="6E6E6E"/>
+                </a:solidFill>
+                <a:latin typeface="Arial"/>
+              </a:rPr>
+              <a:t>–  </a:t>
+            </a:r>
+            <a:r>
+              <a:rPr sz="1300" b="1">
+                <a:solidFill>
+                  <a:srgbClr val="6E6E6E"/>
+                </a:solidFill>
+                <a:latin typeface="Arial"/>
+              </a:rPr>
+              <a:t>a per-gauge sweep at 1, 1.5, 2 and 4 px per actuator is a one-day format run — the item that turns this table into records</a:t>
+            </a:r>
+          </a:p>
+          <a:p>
+            <a:pPr>
+              <a:spcAft>
+                <a:spcPts val="600"/>
+              </a:spcAft>
+            </a:pPr>
+            <a:r>
+              <a:rPr sz="1500" b="0">
+                <a:solidFill>
+                  <a:srgbClr val="282828"/>
+                </a:solidFill>
+                <a:latin typeface="Arial"/>
+              </a:rPr>
+              <a:t>•  </a:t>
             </a:r>
             <a:r>
               <a:rPr sz="1500" b="1">
@@ -11424,7 +11655,7 @@
                 </a:solidFill>
                 <a:latin typeface="Arial"/>
               </a:rPr>
-              <a:t>A per-gauge sweep at 1, 1.5, 2, 4 px per actuator is a one-day format run — the item that turns this table into records.</a:t>
+              <a:t>Where the three differ:</a:t>
             </a:r>
             <a:r>
               <a:rPr sz="1500" b="0">
@@ -11433,7 +11664,7 @@
                 </a:solidFill>
                 <a:latin typeface="Arial"/>
               </a:rPr>
-              <a:t>  Where the three differ: the IFO and HET read against a reference and are indifferent above 2; the vector ZWFS solves pixel by pixel from two images, wants ≥ 4, and pays processing for more; the lock-in fixes HET's sampling at the device (5.3 / 10.6) with the processing on-chip.  Regularization and calibration do not change with pixel count above 2.</a:t>
+              <a:t> the IFO and HET read against a reference and are indifferent above 2 px; the vector ZWFS solves pixel by pixel from two images, wants ≥ 4, and pays processing for more; the lock-in fixes HET's sampling at the device (5.3 / 10.6) with the processing on-chip.  Regularization and calibration do not change with pixel count above 2.</a:t>
             </a:r>
           </a:p>
         </p:txBody>
@@ -11446,7 +11677,7 @@
         </p:nvSpPr>
         <p:spPr>
           <a:xfrm>
-            <a:off x="411480" y="6166866"/>
+            <a:off x="411480" y="6401562"/>
             <a:ext cx="11368735" cy="274320"/>
           </a:xfrm>
           <a:prstGeom prst="rect">
@@ -12440,7 +12671,7 @@
                 </a:solidFill>
                 <a:latin typeface="Arial"/>
               </a:rPr>
-              <a:t>For hold alone,</a:t>
+              <a:t>For hold alone, the vector Zernike is cheapest in photons</a:t>
             </a:r>
             <a:r>
               <a:rPr sz="1100" b="0">
@@ -12449,7 +12680,7 @@
                 </a:solidFill>
                 <a:latin typeface="Arial"/>
               </a:rPr>
-              <a:t> the vector Zernike is cheapest in photons by ~50× and needs no stabilities of its own — but on the assumed polarization camera it is the slowest in time (~60 s per cycle); Feng's camera makes COPHI slow (16 s), the Photonfocus fast (1.6 s), </a:t>
+              <a:t> (~50×) and needs no stabilities of its own — but on the assumed polarization camera it is the slowest (~60 s per cycle).  Feng's camera makes COPHI slow (16 s), the Photonfocus fast (1.6 s), </a:t>
             </a:r>
             <a:r>
               <a:rPr sz="1100" b="1">
@@ -12458,7 +12689,7 @@
                 </a:solidFill>
                 <a:latin typeface="Arial"/>
               </a:rPr>
-              <a:t>the lock-in the fastest reading on the table (0.125 s; records)</a:t>
+              <a:t>the lock-in the fastest on the table (0.125 s)</a:t>
             </a:r>
             <a:r>
               <a:rPr sz="1100" b="0">
@@ -12467,7 +12698,7 @@
                 </a:solidFill>
                 <a:latin typeface="Arial"/>
               </a:rPr>
-              <a:t> if its well is as surveyed — with the fiber term inert.</a:t>
+              <a:t> if its well is as surveyed.</a:t>
             </a:r>
           </a:p>
           <a:p>
@@ -12492,7 +12723,7 @@
                 </a:solidFill>
                 <a:latin typeface="Arial"/>
               </a:rPr>
-              <a:t>For capture and the absolute figure,</a:t>
+              <a:t>For capture and the absolute figure:</a:t>
             </a:r>
             <a:r>
               <a:rPr sz="1100" b="0">
@@ -12501,7 +12732,23 @@
                 </a:solidFill>
                 <a:latin typeface="Arial"/>
               </a:rPr>
-              <a:t> COPHI in either form.  </a:t>
+              <a:t> COPHI in either form.</a:t>
+            </a:r>
+          </a:p>
+          <a:p>
+            <a:pPr>
+              <a:spcAft>
+                <a:spcPts val="600"/>
+              </a:spcAft>
+            </a:pPr>
+            <a:r>
+              <a:rPr sz="1100" b="0">
+                <a:solidFill>
+                  <a:srgbClr val="282828"/>
+                </a:solidFill>
+                <a:latin typeface="Arial"/>
+              </a:rPr>
+              <a:t>•  </a:t>
             </a:r>
             <a:r>
               <a:rPr sz="1100" b="1">
@@ -12510,7 +12757,7 @@
                 </a:solidFill>
                 <a:latin typeface="Arial"/>
               </a:rPr>
-              <a:t>What decides it for a flight DM:</a:t>
+              <a:t>For a flight DM:</a:t>
             </a:r>
             <a:r>
               <a:rPr sz="1100" b="0">
@@ -12519,7 +12766,7 @@
                 </a:solidFill>
                 <a:latin typeface="Arial"/>
               </a:rPr>
-              <a:t> hold only and photons scarce → the Zernike sensor with a camera chosen for it; hold + capture + absolute, or speed → COPHI, with the lock-in the fastest by 20–500×; </a:t>
+              <a:t> hold only and photons scarce → the Zernike sensor with a camera chosen for it; hold + capture + absolute, or speed → COPHI (the lock-in fastest by 20–500×).  </a:t>
             </a:r>
             <a:r>
               <a:rPr sz="1100" b="1">
@@ -12528,7 +12775,7 @@
                 </a:solidFill>
                 <a:latin typeface="Arial"/>
               </a:rPr>
-              <a:t>the hybrid</a:t>
+              <a:t>The hybrid</a:t>
             </a:r>
             <a:r>
               <a:rPr sz="1100" b="0">
@@ -12537,7 +12784,7 @@
                 </a:solidFill>
                 <a:latin typeface="Arial"/>
               </a:rPr>
-              <a:t> — a Zernike sensor for the hold, COPHI's two-color read for capture and commissioning — stays the conservative answer until the lock-in's vendor numbers are in.</a:t>
+              <a:t> — Zernike for the hold, COPHI's two-color read for capture and commissioning — stays the conservative answer until the lock-in's vendor numbers are in.</a:t>
             </a:r>
           </a:p>
         </p:txBody>
@@ -12550,7 +12797,7 @@
         </p:nvSpPr>
         <p:spPr>
           <a:xfrm>
-            <a:off x="411480" y="6664452"/>
+            <a:off x="411480" y="6986270"/>
             <a:ext cx="11368735" cy="274320"/>
           </a:xfrm>
           <a:prstGeom prst="rect">
@@ -12649,7 +12896,7 @@
                 </a:solidFill>
                 <a:latin typeface="Arial"/>
               </a:rPr>
-              <a:t>COPHI is a credible fifth gauge: it matches the IFO's floor, reads exactly, and captures from cold in one reading; its cost is the fiber and the LO, and its speed is the camera's</a:t>
+              <a:t>COPHI is a credible fifth gauge: it matches the IFO's floor, reads exactly, and captures from cold in one reading; its cost is the fiber and the LO, its speed is the camera's</a:t>
             </a:r>
           </a:p>
         </p:txBody>
@@ -12750,7 +12997,7 @@
                 </a:solidFill>
                 <a:latin typeface="Arial"/>
               </a:rPr>
-              <a:t> as the fifth column, with the converged estimator for every gauge and the piston-free photon metric (both found here, both apply to the record).</a:t>
+              <a:t> as the fifth column, with the converged estimator and the piston-free photon metric for every gauge (both found here, both apply to the record).</a:t>
             </a:r>
           </a:p>
           <a:p>
@@ -12818,25 +13065,57 @@
                 </a:solidFill>
                 <a:latin typeface="Arial"/>
               </a:rPr>
-              <a:t> the Photonfocus-class 1k global-shutter part (42 s per pm, 3 pm held in 1.6 s cycles) over Feng's baseline (7 min, 16 s); verify the survey against the vendor sheets before a part is named.  </a:t>
-            </a:r>
-            <a:r>
-              <a:rPr sz="1200" b="1">
-                <a:solidFill>
-                  <a:srgbClr val="282828"/>
-                </a:solidFill>
-                <a:latin typeface="Arial"/>
-              </a:rPr>
-              <a:t>The lock-in camera is the fast form</a:t>
-            </a:r>
-            <a:r>
-              <a:rPr sz="1200" b="0">
-                <a:solidFill>
-                  <a:srgbClr val="282828"/>
-                </a:solidFill>
-                <a:latin typeface="Arial"/>
-              </a:rPr>
-              <a:t> (1.1 s per pm as surveyed) — one vendor question from a number.</a:t>
+              <a:t> the Photonfocus-class 1k global-shutter part (42 s per pm, 3 pm held in 1.6 s cycles) over Feng's baseline (7 min, 16 s).</a:t>
+            </a:r>
+          </a:p>
+          <a:p>
+            <a:pPr marL="594360" indent="-137160">
+              <a:spcAft>
+                <a:spcPts val="500"/>
+              </a:spcAft>
+            </a:pPr>
+            <a:r>
+              <a:rPr sz="1050" b="0">
+                <a:solidFill>
+                  <a:srgbClr val="6E6E6E"/>
+                </a:solidFill>
+                <a:latin typeface="Arial"/>
+              </a:rPr>
+              <a:t>–  verify the survey against the vendor sheets before a part is named</a:t>
+            </a:r>
+          </a:p>
+          <a:p>
+            <a:pPr marL="594360" indent="-137160">
+              <a:spcAft>
+                <a:spcPts val="500"/>
+              </a:spcAft>
+            </a:pPr>
+            <a:r>
+              <a:rPr sz="1050" b="0">
+                <a:solidFill>
+                  <a:srgbClr val="6E6E6E"/>
+                </a:solidFill>
+                <a:latin typeface="Arial"/>
+              </a:rPr>
+              <a:t>–  </a:t>
+            </a:r>
+            <a:r>
+              <a:rPr sz="1050" b="1">
+                <a:solidFill>
+                  <a:srgbClr val="6E6E6E"/>
+                </a:solidFill>
+                <a:latin typeface="Arial"/>
+              </a:rPr>
+              <a:t>the lock-in camera is the fast form</a:t>
+            </a:r>
+            <a:r>
+              <a:rPr sz="1050" b="0">
+                <a:solidFill>
+                  <a:srgbClr val="6E6E6E"/>
+                </a:solidFill>
+                <a:latin typeface="Arial"/>
+              </a:rPr>
+              <a:t> (3.4 s per pm as surveyed, 0.125 s cycles) — one vendor question from a number</a:t>
             </a:r>
           </a:p>
           <a:p>
@@ -12961,7 +13240,7 @@
                 </a:solidFill>
                 <a:latin typeface="Arial"/>
               </a:rPr>
-              <a:t> the chromatic refocus of the tail at Δλ = 20 nm (dispersive glass in the model); the LO referenced against the test arm's own flat; the electronics table's parts counts and TRL for all five gauges; Kent's ZWFS reconstruction when it arrives.</a:t>
+              <a:t> the tail's chromatic refocus at Δλ = 20 nm (dispersive glass in the model); the LO referenced against the test arm's own flat; parts counts and TRL for all five gauges; Kent's ZWFS reconstruction when it arrives.</a:t>
             </a:r>
           </a:p>
         </p:txBody>
@@ -16398,8 +16677,8 @@
         </p:nvSpPr>
         <p:spPr>
           <a:xfrm>
-            <a:off x="6400800" y="1999488"/>
-            <a:ext cx="5394960" cy="274320"/>
+            <a:off x="6172200" y="2103120"/>
+            <a:ext cx="4343400" cy="274320"/>
           </a:xfrm>
           <a:prstGeom prst="rect">
             <a:avLst/>
@@ -17581,7 +17860,7 @@
                 </a:solidFill>
                 <a:latin typeface="Arial"/>
               </a:rPr>
-              <a:t>Feng's camera takes four frames per beat and the computer demodulates; a lock-in camera demodulates in every pixel at a kHz beat and reads the full lattice in a second — the parallel implementation, same optics, same RF chain; its rows run through every results table that follows</a:t>
+              <a:t>Feng's camera takes four frames per beat and the computer demodulates; a lock-in camera demodulates in every pixel at a kHz beat and reads the whole lattice in a second — same optics, same RF chain; its rows run through every table that follows</a:t>
             </a:r>
           </a:p>
         </p:txBody>
@@ -17682,25 +17961,7 @@
                 </a:solidFill>
                 <a:latin typeface="Arial"/>
               </a:rPr>
-              <a:t> every mode of interest (EFC probes among them) is commanded at full actuator resolution — no coarse or low-order sensor forms.  The second implementation is a </a:t>
-            </a:r>
-            <a:r>
-              <a:rPr sz="1200" b="1">
-                <a:solidFill>
-                  <a:srgbClr val="282828"/>
-                </a:solidFill>
-                <a:latin typeface="Arial"/>
-              </a:rPr>
-              <a:t>well-free, per-pixel demodulating reading at ≥ 1 element per actuator</a:t>
-            </a:r>
-            <a:r>
-              <a:rPr sz="1200" b="0">
-                <a:solidFill>
-                  <a:srgbClr val="282828"/>
-                </a:solidFill>
-                <a:latin typeface="Arial"/>
-              </a:rPr>
-              <a:t>, assumed to exist at 1:1 or better.</a:t>
+              <a:t> every mode we care about (EFC probes included) is commanded at full actuator resolution.  So the second implementation is a per-pixel demodulating reading at ≥ 1 element per actuator, assumed to exist at 1:1 or better.</a:t>
             </a:r>
           </a:p>
           <a:p>
@@ -17734,7 +17995,55 @@
                 </a:solidFill>
                 <a:latin typeface="Arial"/>
               </a:rPr>
-              <a:t> = synchronous detection inside each pixel: the photocurrent is multiplied by the external reference (our Rb-clocked beat, now at kHz) and by its 90°-shifted copy and integrated: the two stores are I = I₀γ cos φ (in-phase) and Q = I₀γ sin φ (quadrature) — demodulated components, not intensities; the DC term I₀ averages out and never reaches the well; I and Q leave at the frame rate and φ = atan2(Q, I) — the four-bucket replaced by thousands of cycles integrated on-chip.</a:t>
+              <a:t> = synchronous detection inside each pixel:</a:t>
+            </a:r>
+          </a:p>
+          <a:p>
+            <a:pPr marL="594360" indent="-137160">
+              <a:spcAft>
+                <a:spcPts val="500"/>
+              </a:spcAft>
+            </a:pPr>
+            <a:r>
+              <a:rPr sz="1050" b="0">
+                <a:solidFill>
+                  <a:srgbClr val="6E6E6E"/>
+                </a:solidFill>
+                <a:latin typeface="Arial"/>
+              </a:rPr>
+              <a:t>–  the photocurrent is multiplied by the beat reference and by its 90°-shifted copy, and integrated</a:t>
+            </a:r>
+          </a:p>
+          <a:p>
+            <a:pPr marL="594360" indent="-137160">
+              <a:spcAft>
+                <a:spcPts val="500"/>
+              </a:spcAft>
+            </a:pPr>
+            <a:r>
+              <a:rPr sz="1050" b="0">
+                <a:solidFill>
+                  <a:srgbClr val="6E6E6E"/>
+                </a:solidFill>
+                <a:latin typeface="Arial"/>
+              </a:rPr>
+              <a:t>–  the two stores are I = I₀γ cos φ (in-phase) and Q = I₀γ sin φ (quadrature) — not intensities; φ = atan2(Q, I)</a:t>
+            </a:r>
+          </a:p>
+          <a:p>
+            <a:pPr marL="594360" indent="-137160">
+              <a:spcAft>
+                <a:spcPts val="500"/>
+              </a:spcAft>
+            </a:pPr>
+            <a:r>
+              <a:rPr sz="1050" b="0">
+                <a:solidFill>
+                  <a:srgbClr val="6E6E6E"/>
+                </a:solidFill>
+                <a:latin typeface="Arial"/>
+              </a:rPr>
+              <a:t>–  the DC term never reaches the well; thousands of cycles integrate on-chip; I and Q leave at the frame rate</a:t>
             </a:r>
           </a:p>
           <a:p>
@@ -17768,7 +18077,39 @@
                 </a:solidFill>
                 <a:latin typeface="Arial"/>
               </a:rPr>
-              <a:t> Heliotis heliCam C4 / C4M — 542 × 512 (1024 × 1102), in-pixel lock-in 1–250 kHz, 500 ke⁻ well, 2 × 10-bit I/Q, external reference input; four generations shipped, one vendor.  Also ranked: brute-force 128² CMOS at 20–40 kfps; iToF demodulators with the beat moved to MHz; digital-pixel ROICs (Lincoln DFPA); silicon-photonic coherent FPAs.  SPADs and Geiger-mode arrays are unfit (count-rate ceilings).</a:t>
+              <a:t> Heliotis heliCam C4 / C4M — 542 × 512 (1024 × 1102) pixels, lock-in at 1–250 kHz, 500 ke⁻ well, 2 × 10-bit I/Q, external reference input; four generations shipped, one vendor.</a:t>
+            </a:r>
+          </a:p>
+          <a:p>
+            <a:pPr marL="594360" indent="-137160">
+              <a:spcAft>
+                <a:spcPts val="500"/>
+              </a:spcAft>
+            </a:pPr>
+            <a:r>
+              <a:rPr sz="1050" b="0">
+                <a:solidFill>
+                  <a:srgbClr val="6E6E6E"/>
+                </a:solidFill>
+                <a:latin typeface="Arial"/>
+              </a:rPr>
+              <a:t>–  also ranked: 128² CMOS at 20–40 kfps; time-of-flight demodulators with the beat at MHz; digital-pixel ROICs (Lincoln DFPA); coherent photonic arrays</a:t>
+            </a:r>
+          </a:p>
+          <a:p>
+            <a:pPr marL="594360" indent="-137160">
+              <a:spcAft>
+                <a:spcPts val="500"/>
+              </a:spcAft>
+            </a:pPr>
+            <a:r>
+              <a:rPr sz="1050" b="0">
+                <a:solidFill>
+                  <a:srgbClr val="6E6E6E"/>
+                </a:solidFill>
+                <a:latin typeface="Arial"/>
+              </a:rPr>
+              <a:t>–  not fit: SPAD and Geiger-mode arrays (count-rate ceilings)</a:t>
             </a:r>
           </a:p>
         </p:txBody>
@@ -18387,16 +18728,23 @@
                 </a:solidFill>
                 <a:latin typeface="Arial"/>
               </a:rPr>
-              <a:t>Even well-capped the lock-in is ~12× the Photonfocus and ~110× Feng's baseline</a:t>
-            </a:r>
-            <a:r>
-              <a:rPr sz="1500" b="0">
-                <a:solidFill>
-                  <a:srgbClr val="282828"/>
-                </a:solidFill>
-                <a:latin typeface="Arial"/>
-              </a:rPr>
-              <a:t>; a verified well-free device (continuous, or I/Q ≥ 10 kHz) at the sheet's own 2.5 × 10⁹ e⁻/s per element would be ~18 pm per sample, ~0.34 s per pm — 10× the capped form; that is what the vendor question decides.</a:t>
+              <a:t>Even well-capped the lock-in is ~12× the Photonfocus and ~110× Feng's baseline.</a:t>
+            </a:r>
+          </a:p>
+          <a:p>
+            <a:pPr marL="594360" indent="-137160">
+              <a:spcAft>
+                <a:spcPts val="500"/>
+              </a:spcAft>
+            </a:pPr>
+            <a:r>
+              <a:rPr sz="1300" b="0">
+                <a:solidFill>
+                  <a:srgbClr val="6E6E6E"/>
+                </a:solidFill>
+                <a:latin typeface="Arial"/>
+              </a:rPr>
+              <a:t>–  a well-free device (continuous, or I/Q ≥ 10 kHz) at 2.5 × 10⁹ e⁻/s per element: ~18 pm per sample, ~0.34 s per pm — 10× better again; that is what the vendor question decides</a:t>
             </a:r>
           </a:p>
           <a:p>
@@ -18430,7 +18778,7 @@
                 </a:solidFill>
                 <a:latin typeface="Arial"/>
               </a:rPr>
-              <a:t> per-pixel phase noise vs flux at t_c = 100 ms, and whether the full well bounds each internal 1 MSa/s sample or the 5.6 kSa/s output — for Heliotis, through Dave.</a:t>
+              <a:t> phase noise per pixel vs flux at t_c = 100 ms, and whether the full well bounds each internal 1 MSa/s sample or the 5.6 kSa/s output — for Heliotis, through Dave.</a:t>
             </a:r>
           </a:p>
         </p:txBody>
@@ -18542,7 +18890,7 @@
                 </a:solidFill>
                 <a:latin typeface="Arial"/>
               </a:rPr>
-              <a:t>The same laser, fibers, LO and bench; the beat moves to 5 kHz; the mixer gives the beat itself to the camera's reference input; no frame trigger, no bucket; I/Q frames at 1 kHz go straight to the phase</a:t>
+              <a:t>Same laser, fibers, LO and bench; the beat moves to 5 kHz and goes to the camera's reference input; no frame trigger, no bucket; I/Q frames at 1 kHz go straight to the phase</a:t>
             </a:r>
           </a:p>
         </p:txBody>
@@ -18668,7 +19016,7 @@
                 </a:solidFill>
                 <a:latin typeface="Arial"/>
               </a:rPr>
-              <a:t> synthesizer 2 at 80 MHz + 5 kHz; the ×4 / 30 Hz trigger chain becomes the 5 kHz beat reference; the camera is the lock-in device; the processing is atan2(Q, I) per I/Q frame, decimated to the loop rate.  Fiber, LO and the hold loop are the same — and so are their requirements.</a:t>
+              <a:t> synthesizer 2 at 80 MHz + 5 kHz; the ×4 / 30 Hz trigger chain becomes the 5 kHz reference; the camera is the lock-in device; the processing is atan2(Q, I) per frame, decimated to the loop rate.  Fiber, LO and hold loop are unchanged.</a:t>
             </a:r>
           </a:p>
         </p:txBody>
@@ -18819,7 +19167,7 @@
                 </a:solidFill>
                 <a:latin typeface="Arial"/>
               </a:rPr>
-              <a:t>What the camera records, how the phase and the surface come out of it, and what the gate measured: the quarter-cycle integration costs 10 % of contrast, a step error is not cured by more frames, and the photon law carries read noise</a:t>
+              <a:t>What the camera records, how the phase and the surface come out, and what the gate measured: the quarter-cycle integration costs 10 % of contrast, a step error is not cured by more frames, read noise is in the photon law</a:t>
             </a:r>
           </a:p>
         </p:txBody>
@@ -18935,7 +19283,7 @@
                 </a:solidFill>
                 <a:latin typeface="Arial"/>
               </a:rPr>
-              <a:t>"Integrating bucket" (1)–(2):</a:t>
+              <a:t>Integrating bucket (1)–(2):</a:t>
             </a:r>
             <a:r>
               <a:rPr sz="1200" b="0">
@@ -18944,25 +19292,41 @@
                 </a:solidFill>
                 <a:latin typeface="Arial"/>
               </a:rPr>
-              <a:t> a frame cannot sample the beat at an instant; it integrates while the LO phase advances through a quarter of the cycle.  Averaging a cosine over a window D = 2π/N keeps its phase (referred to the window's center ᾱ_k) and shrinks its amplitude by sinc(D/2): </a:t>
-            </a:r>
-            <a:r>
-              <a:rPr sz="1200" b="1">
-                <a:solidFill>
-                  <a:srgbClr val="282828"/>
-                </a:solidFill>
-                <a:latin typeface="Arial"/>
-              </a:rPr>
-              <a:t>0.900 for four frames per beat</a:t>
-            </a:r>
-            <a:r>
-              <a:rPr sz="1200" b="0">
-                <a:solidFill>
-                  <a:srgbClr val="282828"/>
-                </a:solidFill>
-                <a:latin typeface="Arial"/>
-              </a:rPr>
-              <a:t> — nothing else changes.</a:t>
+              <a:t> a frame cannot sample the beat at an instant; it integrates while the LO phase advances a quarter cycle.</a:t>
+            </a:r>
+          </a:p>
+          <a:p>
+            <a:pPr marL="594360" indent="-137160">
+              <a:spcAft>
+                <a:spcPts val="500"/>
+              </a:spcAft>
+            </a:pPr>
+            <a:r>
+              <a:rPr sz="1050" b="0">
+                <a:solidFill>
+                  <a:srgbClr val="6E6E6E"/>
+                </a:solidFill>
+                <a:latin typeface="Arial"/>
+              </a:rPr>
+              <a:t>–  the phase is kept (referred to the bucket center ᾱ_k); the amplitude shrinks by sinc(π/4) = </a:t>
+            </a:r>
+            <a:r>
+              <a:rPr sz="1050" b="1">
+                <a:solidFill>
+                  <a:srgbClr val="6E6E6E"/>
+                </a:solidFill>
+                <a:latin typeface="Arial"/>
+              </a:rPr>
+              <a:t>0.900</a:t>
+            </a:r>
+            <a:r>
+              <a:rPr sz="1050" b="0">
+                <a:solidFill>
+                  <a:srgbClr val="6E6E6E"/>
+                </a:solidFill>
+                <a:latin typeface="Arial"/>
+              </a:rPr>
+              <a:t>; nothing else changes</a:t>
             </a:r>
           </a:p>
           <a:p>
@@ -18987,7 +19351,7 @@
                 </a:solidFill>
                 <a:latin typeface="Arial"/>
               </a:rPr>
-              <a:t>The phase (3)</a:t>
+              <a:t>Phase (3):</a:t>
             </a:r>
             <a:r>
               <a:rPr sz="1200" b="0">
@@ -18996,7 +19360,23 @@
                 </a:solidFill>
                 <a:latin typeface="Arial"/>
               </a:rPr>
-              <a:t> is a least-squares fit of the N frames to a + b cos ᾱ_k + c sin ᾱ_k; for N = 4 it reduces exactly to the four-step atan2, the same algorithm as Feng's (his sign is for cos(φ + 2πft)).</a:t>
+              <a:t> a least-squares fit of the N frames to a + b cos ᾱ_k + c sin ᾱ_k.</a:t>
+            </a:r>
+          </a:p>
+          <a:p>
+            <a:pPr marL="594360" indent="-137160">
+              <a:spcAft>
+                <a:spcPts val="500"/>
+              </a:spcAft>
+            </a:pPr>
+            <a:r>
+              <a:rPr sz="1050" b="0">
+                <a:solidFill>
+                  <a:srgbClr val="6E6E6E"/>
+                </a:solidFill>
+                <a:latin typeface="Arial"/>
+              </a:rPr>
+              <a:t>–  for N = 4 it is Feng's atan2 exactly (his sign is for cos(φ + 2πft))</a:t>
             </a:r>
           </a:p>
         </p:txBody>
@@ -19044,7 +19424,7 @@
                 </a:solidFill>
                 <a:latin typeface="Arial"/>
               </a:rPr>
-              <a:t>A step error (5):</a:t>
+              <a:t>Step error (5):</a:t>
             </a:r>
             <a:r>
               <a:rPr sz="1200" b="0">
@@ -19053,43 +19433,39 @@
                 </a:solidFill>
                 <a:latin typeface="Arial"/>
               </a:rPr>
-              <a:t> if every step is D(1 + ε) instead of D, the four-bucket phase comes out wrong by (ε/2) sin 2φ — the classical phase-shifting result (Schwider 1983, Creath 1988): an error that oscillates twice per fringe, so a flat surface reads as a ripple at twice the fringe frequency with amplitude ε/2.  </a:t>
-            </a:r>
-            <a:r>
-              <a:rPr sz="1200" b="1">
-                <a:solidFill>
-                  <a:srgbClr val="282828"/>
-                </a:solidFill>
-                <a:latin typeface="Arial"/>
-              </a:rPr>
-              <a:t>Measured: more buckets do not cure it</a:t>
-            </a:r>
-            <a:r>
-              <a:rPr sz="1200" b="0">
-                <a:solidFill>
-                  <a:srgbClr val="282828"/>
-                </a:solidFill>
-                <a:latin typeface="Arial"/>
-              </a:rPr>
-              <a:t> (the plain 8-bucket fit with the same per-step error is 1.43× worse; the ramp accumulates); </a:t>
-            </a:r>
-            <a:r>
-              <a:rPr sz="1200" b="1">
-                <a:solidFill>
-                  <a:srgbClr val="282828"/>
-                </a:solidFill>
-                <a:latin typeface="Arial"/>
-              </a:rPr>
-              <a:t>knowing the steps does</a:t>
-            </a:r>
-            <a:r>
-              <a:rPr sz="1200" b="0">
-                <a:solidFill>
-                  <a:srgbClr val="282828"/>
-                </a:solidFill>
-                <a:latin typeface="Arial"/>
-              </a:rPr>
-              <a:t> (the fit at the true ᾱ_k is exact) — a Rb-clocked scan knows them.</a:t>
+              <a:t> steps of D(1 + ε) instead of D give a phase error (ε/2) sin 2φ — a ripple at twice the fringe frequency (Schwider 1983, Creath 1988).</a:t>
+            </a:r>
+          </a:p>
+          <a:p>
+            <a:pPr marL="594360" indent="-137160">
+              <a:spcAft>
+                <a:spcPts val="500"/>
+              </a:spcAft>
+            </a:pPr>
+            <a:r>
+              <a:rPr sz="1050" b="0">
+                <a:solidFill>
+                  <a:srgbClr val="6E6E6E"/>
+                </a:solidFill>
+                <a:latin typeface="Arial"/>
+              </a:rPr>
+              <a:t>–  more buckets do not cure it: an 8-bucket fit with the same step error is 1.43× worse</a:t>
+            </a:r>
+          </a:p>
+          <a:p>
+            <a:pPr marL="594360" indent="-137160">
+              <a:spcAft>
+                <a:spcPts val="500"/>
+              </a:spcAft>
+            </a:pPr>
+            <a:r>
+              <a:rPr sz="1050" b="0">
+                <a:solidFill>
+                  <a:srgbClr val="6E6E6E"/>
+                </a:solidFill>
+                <a:latin typeface="Arial"/>
+              </a:rPr>
+              <a:t>–  knowing the steps does: the fit at the true ᾱ_k is exact, and a Rb-clocked scan knows them</a:t>
             </a:r>
           </a:p>
           <a:p>
@@ -19123,7 +19499,23 @@
                 </a:solidFill>
                 <a:latin typeface="Arial"/>
               </a:rPr>
-              <a:t> shot noise ∝ 1/√I₀ (slope −0.500 ± 0.02 over two decades), read noise in quadrature.  A fiber walk or trigger jitter within a scan is a fixed fraction of its size (0.13 w), no better with 8 buckets — no algorithmic cure.</a:t>
+              <a:t> shot noise ∝ 1/√I₀ (measured slope −0.500 ± 0.02 over two decades); read noise adds in quadrature.</a:t>
+            </a:r>
+          </a:p>
+          <a:p>
+            <a:pPr marL="594360" indent="-137160">
+              <a:spcAft>
+                <a:spcPts val="500"/>
+              </a:spcAft>
+            </a:pPr>
+            <a:r>
+              <a:rPr sz="1050" b="0">
+                <a:solidFill>
+                  <a:srgbClr val="6E6E6E"/>
+                </a:solidFill>
+                <a:latin typeface="Arial"/>
+              </a:rPr>
+              <a:t>–  a fiber walk or trigger jitter within a scan passes through at 0.13 of its size, with 4 or 8 buckets alike — no algorithmic cure</a:t>
             </a:r>
           </a:p>
         </p:txBody>
@@ -19136,7 +19528,7 @@
         </p:nvSpPr>
         <p:spPr>
           <a:xfrm>
-            <a:off x="6400800" y="7193280"/>
+            <a:off x="6400800" y="7229094"/>
             <a:ext cx="5394960" cy="274320"/>
           </a:xfrm>
           <a:prstGeom prst="rect">
@@ -19235,7 +19627,7 @@
                 </a:solidFill>
                 <a:latin typeface="Arial"/>
               </a:rPr>
-              <a:t>The LO is a fiber tip and collimator with its powered face at the reference flat's seat; it registers on both rigs to a pixel and the flat-DM null is sub-nanometer</a:t>
+              <a:t>A fiber tip and collimator, its powered face at the reference flat's seat; it registers on both rigs to a pixel and the flat-DM null is sub-nanometer</a:t>
             </a:r>
           </a:p>
         </p:txBody>
@@ -19300,8 +19692,8 @@
         </p:blipFill>
         <p:spPr>
           <a:xfrm>
-            <a:off x="1380587" y="1298448"/>
-            <a:ext cx="3868224" cy="2092451"/>
+            <a:off x="1114904" y="1298448"/>
+            <a:ext cx="4399591" cy="2092451"/>
           </a:xfrm>
           <a:prstGeom prst="rect">
             <a:avLst/>
@@ -19399,7 +19791,7 @@
                 </a:solidFill>
                 <a:latin typeface="Arial"/>
               </a:rPr>
-              <a:t> chief ray 0.000 px on both rigs; the LO covers the test pupil 1.000 and overfills it by 34 px (radius ratio 1.215), so an offset under that is a fill question, not a registration one.</a:t>
+              <a:t> chief ray 0.000 px on both rigs; the LO overfills the test pupil by 34 px (radius ratio 1.215).</a:t>
             </a:r>
           </a:p>
           <a:p>
@@ -19433,7 +19825,23 @@
                 </a:solidFill>
                 <a:latin typeface="Arial"/>
               </a:rPr>
-              <a:t> lens rig 0.000 nm; mirror rig 0.746 nm rms after piston, mostly tilt — the LO collimator's wavefront against the test arm, frozen into the null as the interferometer freezes its reference; its motion is the LO-drift row (slide 13).</a:t>
+              <a:t> lens rig 0.000 nm; mirror rig 0.746 nm rms, mostly tilt.</a:t>
+            </a:r>
+          </a:p>
+          <a:p>
+            <a:pPr marL="594360" indent="-137160">
+              <a:spcAft>
+                <a:spcPts val="500"/>
+              </a:spcAft>
+            </a:pPr>
+            <a:r>
+              <a:rPr sz="1050" b="0">
+                <a:solidFill>
+                  <a:srgbClr val="6E6E6E"/>
+                </a:solidFill>
+                <a:latin typeface="Arial"/>
+              </a:rPr>
+              <a:t>–  the LO collimator's own wavefront, frozen into the null as the IFO freezes its reference; its motion is the LO-drift row (slide 13)</a:t>
             </a:r>
           </a:p>
           <a:p>
@@ -19467,7 +19875,7 @@
                 </a:solidFill>
                 <a:latin typeface="Arial"/>
               </a:rPr>
-              <a:t> 0.982 at an LO/test power ratio of 1.47, as 2√r/(1 + r) says; the vector-mode field phase measures −kW on both decks (the known conjugate).</a:t>
+              <a:t> 0.982 at LO/test power 1.47, as 2√r/(1 + r) says.</a:t>
             </a:r>
           </a:p>
         </p:txBody>
@@ -19578,16 +19986,39 @@
                 </a:solidFill>
                 <a:latin typeface="Arial"/>
               </a:rPr>
-              <a:t>Two findings that matter for any traced LO:</a:t>
-            </a:r>
-            <a:r>
-              <a:rPr sz="1200" b="0">
-                <a:solidFill>
-                  <a:srgbClr val="282828"/>
-                </a:solidFill>
-                <a:latin typeface="Arial"/>
-              </a:rPr>
-              <a:t> the geometric tail places the detector field by ray index, not camera position — the LO's own collimator makes the per-index null 681 nm where the by-position null is 0.45 nm, so the LO is placed on the test pixels by position; and the plain mirror train had inherited a source trim solved with the polarizer plate — without it OAP1 was fed off focus (an 84 nm defocus null), now trimmed to zero.</a:t>
+              <a:t>Two findings for any traced LO:</a:t>
+            </a:r>
+          </a:p>
+          <a:p>
+            <a:pPr marL="594360" indent="-137160">
+              <a:spcAft>
+                <a:spcPts val="500"/>
+              </a:spcAft>
+            </a:pPr>
+            <a:r>
+              <a:rPr sz="1050" b="0">
+                <a:solidFill>
+                  <a:srgbClr val="6E6E6E"/>
+                </a:solidFill>
+                <a:latin typeface="Arial"/>
+              </a:rPr>
+              <a:t>–  the geometric tail places the detector field by ray index, not camera position: per-index null 681 nm, by position 0.45 nm — the LO is placed by position</a:t>
+            </a:r>
+          </a:p>
+          <a:p>
+            <a:pPr marL="594360" indent="-137160">
+              <a:spcAft>
+                <a:spcPts val="500"/>
+              </a:spcAft>
+            </a:pPr>
+            <a:r>
+              <a:rPr sz="1050" b="0">
+                <a:solidFill>
+                  <a:srgbClr val="6E6E6E"/>
+                </a:solidFill>
+                <a:latin typeface="Arial"/>
+              </a:rPr>
+              <a:t>–  the plain mirror train had kept a source trim solved with the polarizer plate; without it OAP1 was fed off focus (84 nm of defocus) — now trimmed to zero</a:t>
             </a:r>
           </a:p>
           <a:p>
@@ -19621,7 +20052,7 @@
                 </a:solidFill>
                 <a:latin typeface="Arial"/>
               </a:rPr>
-              <a:t> the record's polarizing train (input polarizer, analyzer) and Feng's plain splitter.  Picometers identical — the camera is well-bound; the record's train costs light only (test throughput 0.271 vs 0.408, ×1.5 laser).  The plain splitter is the layout scored.</a:t>
+              <a:t> the record's polarizing train and Feng's plain splitter read the same picometers (the camera is well-bound); the polarizing train costs light only (throughput 0.271 vs 0.408, ×1.5 laser).  The plain splitter is the layout scored.</a:t>
             </a:r>
           </a:p>
         </p:txBody>
@@ -19634,7 +20065,7 @@
         </p:nvSpPr>
         <p:spPr>
           <a:xfrm>
-            <a:off x="6400800" y="6501384"/>
+            <a:off x="6400800" y="6607810"/>
             <a:ext cx="5394960" cy="274320"/>
           </a:xfrm>
           <a:prstGeom prst="rect">
@@ -19888,7 +20319,7 @@
                 </a:solidFill>
                 <a:latin typeface="Arial"/>
               </a:rPr>
-              <a:t>Resolution of what is shown:</a:t>
+              <a:t>Resolution shown:</a:t>
             </a:r>
             <a:r>
               <a:rPr sz="1500" b="0">
@@ -19897,7 +20328,7 @@
                 </a:solidFill>
                 <a:latin typeface="Arial"/>
               </a:rPr>
-              <a:t> the model's camera grid is 1024 × 1024 with the pupil 315 px across (radius 157.45 px) — </a:t>
+              <a:t> camera grid 1024 × 1024, pupil 315 px across — </a:t>
             </a:r>
             <a:r>
               <a:rPr sz="1500" b="1">
@@ -19906,7 +20337,7 @@
                 </a:solidFill>
                 <a:latin typeface="Arial"/>
               </a:rPr>
-              <a:t>3.3 pixels per actuator across, ~11 pixels per actuator in area</a:t>
+              <a:t>3.3 pixels per actuator across, ~11 per actuator in area</a:t>
             </a:r>
             <a:r>
               <a:rPr sz="1500" b="0">
@@ -19915,7 +20346,23 @@
                 </a:solidFill>
                 <a:latin typeface="Arial"/>
               </a:rPr>
-              <a:t> (6948 lit actuators on ~77,900 pupil pixels); every real camera on the table samples finer (5–21 px per actuator, slide 10).  What resolution buys, and what it costs each gauge, is slide 17.</a:t>
+              <a:t> (6948 lit actuators on ~77,900 pupil pixels).</a:t>
+            </a:r>
+          </a:p>
+          <a:p>
+            <a:pPr marL="594360" indent="-137160">
+              <a:spcAft>
+                <a:spcPts val="500"/>
+              </a:spcAft>
+            </a:pPr>
+            <a:r>
+              <a:rPr sz="1300" b="0">
+                <a:solidFill>
+                  <a:srgbClr val="6E6E6E"/>
+                </a:solidFill>
+                <a:latin typeface="Arial"/>
+              </a:rPr>
+              <a:t>–  every real camera on the table samples finer (5–21 px per actuator, slide 10); what resolution buys and costs is slide 17</a:t>
             </a:r>
           </a:p>
         </p:txBody>
@@ -19928,7 +20375,7 @@
         </p:nvSpPr>
         <p:spPr>
           <a:xfrm>
-            <a:off x="411480" y="5812535"/>
+            <a:off x="411480" y="5659373"/>
             <a:ext cx="11368735" cy="274320"/>
           </a:xfrm>
           <a:prstGeom prst="rect">

</xml_diff>

<commit_message>
deck_cophi: Dave's second pass folded ('Capture from a cold start' titles; 14 pt on the lock-in slide's columns, the performance and hold blocks moved; the lock-in slide's left column trimmed to fit at 14 pt); edit copy synced
Co-Authored-By: Claude Fable 5.1 <noreply@anthropic.com>
</commit_message>
<xml_diff>
--- a/demo_session/deck_cophi.pptx
+++ b/demo_session/deck_cophi.pptx
@@ -7797,8 +7797,8 @@
         </p:nvSpPr>
         <p:spPr>
           <a:xfrm>
-            <a:off x="6400800" y="6916801"/>
-            <a:ext cx="5394960" cy="274320"/>
+            <a:off x="457200" y="6172200"/>
+            <a:ext cx="11338560" cy="274320"/>
           </a:xfrm>
           <a:prstGeom prst="rect">
             <a:avLst/>
@@ -7880,7 +7880,7 @@
                 </a:solidFill>
                 <a:latin typeface="Arial"/>
               </a:rPr>
-              <a:t>Capture from cold: two colors frequency-multiplexed on one camera</a:t>
+              <a:t>Capture from a cold start: two colors frequency-multiplexed on one camera</a:t>
             </a:r>
           </a:p>
           <a:p>
@@ -8157,7 +8157,7 @@
                 </a:solidFill>
                 <a:latin typeface="Arial"/>
               </a:rPr>
-              <a:t>Capture from cold: the numbers, and the parts it adds</a:t>
+              <a:t>Capture from a cold start: the numbers, and the parts it adds</a:t>
             </a:r>
           </a:p>
           <a:p>
@@ -17937,7 +17937,7 @@
               </a:spcAft>
             </a:pPr>
             <a:r>
-              <a:rPr sz="1200" b="0">
+              <a:rPr sz="1400" b="0">
                 <a:solidFill>
                   <a:srgbClr val="282828"/>
                 </a:solidFill>
@@ -17946,7 +17946,7 @@
               <a:t>•  </a:t>
             </a:r>
             <a:r>
-              <a:rPr sz="1200" b="1">
+              <a:rPr sz="1400" b="1">
                 <a:solidFill>
                   <a:srgbClr val="282828"/>
                 </a:solidFill>
@@ -17955,13 +17955,13 @@
               <a:t>Ruling:</a:t>
             </a:r>
             <a:r>
-              <a:rPr sz="1200" b="0">
+              <a:rPr sz="1400" b="0">
                 <a:solidFill>
                   <a:srgbClr val="282828"/>
                 </a:solidFill>
                 <a:latin typeface="Arial"/>
               </a:rPr>
-              <a:t> every mode we care about (EFC probes included) is commanded at full actuator resolution.  So the second implementation is a per-pixel demodulating reading at ≥ 1 element per actuator, assumed to exist at 1:1 or better.</a:t>
+              <a:t> every mode we care about (EFC probes included) runs at full actuator resolution — so the second implementation is a per-pixel demodulating reading at ≥ 1 element per actuator, assumed to exist.</a:t>
             </a:r>
           </a:p>
           <a:p>
@@ -17971,7 +17971,7 @@
               </a:spcAft>
             </a:pPr>
             <a:r>
-              <a:rPr sz="1200" b="0">
+              <a:rPr sz="1400" b="0">
                 <a:solidFill>
                   <a:srgbClr val="282828"/>
                 </a:solidFill>
@@ -17980,7 +17980,7 @@
               <a:t>•  </a:t>
             </a:r>
             <a:r>
-              <a:rPr sz="1200" b="1">
+              <a:rPr sz="1400" b="1">
                 <a:solidFill>
                   <a:srgbClr val="282828"/>
                 </a:solidFill>
@@ -17989,7 +17989,7 @@
               <a:t>Lock-in</a:t>
             </a:r>
             <a:r>
-              <a:rPr sz="1200" b="0">
+              <a:rPr sz="1400" b="0">
                 <a:solidFill>
                   <a:srgbClr val="282828"/>
                 </a:solidFill>
@@ -18005,7 +18005,7 @@
               </a:spcAft>
             </a:pPr>
             <a:r>
-              <a:rPr sz="1050" b="0">
+              <a:rPr sz="1250" b="0">
                 <a:solidFill>
                   <a:srgbClr val="6E6E6E"/>
                 </a:solidFill>
@@ -18021,13 +18021,13 @@
               </a:spcAft>
             </a:pPr>
             <a:r>
-              <a:rPr sz="1050" b="0">
+              <a:rPr sz="1250" b="0">
                 <a:solidFill>
                   <a:srgbClr val="6E6E6E"/>
                 </a:solidFill>
                 <a:latin typeface="Arial"/>
               </a:rPr>
-              <a:t>–  the two stores are I = I₀γ cos φ (in-phase) and Q = I₀γ sin φ (quadrature) — not intensities; φ = atan2(Q, I)</a:t>
+              <a:t>–  the stores are I = I₀γ cos φ (in-phase) and Q = I₀γ sin φ (quadrature) — not intensities; φ = atan2(Q, I)</a:t>
             </a:r>
           </a:p>
           <a:p>
@@ -18037,13 +18037,13 @@
               </a:spcAft>
             </a:pPr>
             <a:r>
-              <a:rPr sz="1050" b="0">
+              <a:rPr sz="1250" b="0">
                 <a:solidFill>
                   <a:srgbClr val="6E6E6E"/>
                 </a:solidFill>
                 <a:latin typeface="Arial"/>
               </a:rPr>
-              <a:t>–  the DC term never reaches the well; thousands of cycles integrate on-chip; I and Q leave at the frame rate</a:t>
+              <a:t>–  the DC term never reaches the well; I and Q leave at the frame rate</a:t>
             </a:r>
           </a:p>
           <a:p>
@@ -18053,7 +18053,7 @@
               </a:spcAft>
             </a:pPr>
             <a:r>
-              <a:rPr sz="1200" b="0">
+              <a:rPr sz="1400" b="0">
                 <a:solidFill>
                   <a:srgbClr val="282828"/>
                 </a:solidFill>
@@ -18062,7 +18062,7 @@
               <a:t>•  </a:t>
             </a:r>
             <a:r>
-              <a:rPr sz="1200" b="1">
+              <a:rPr sz="1400" b="1">
                 <a:solidFill>
                   <a:srgbClr val="282828"/>
                 </a:solidFill>
@@ -18071,13 +18071,13 @@
               <a:t>Surveyed (unverified):</a:t>
             </a:r>
             <a:r>
-              <a:rPr sz="1200" b="0">
+              <a:rPr sz="1400" b="0">
                 <a:solidFill>
                   <a:srgbClr val="282828"/>
                 </a:solidFill>
                 <a:latin typeface="Arial"/>
               </a:rPr>
-              <a:t> Heliotis heliCam C4 / C4M — 542 × 512 (1024 × 1102) pixels, lock-in at 1–250 kHz, 500 ke⁻ well, 2 × 10-bit I/Q, external reference input; four generations shipped, one vendor.</a:t>
+              <a:t> Heliotis heliCam C4 / C4M — 542 × 512 (1024 × 1102), lock-in 1–250 kHz, 500 ke⁻ well, 2 × 10-bit I/Q, external reference; one vendor, four generations.</a:t>
             </a:r>
           </a:p>
           <a:p>
@@ -18087,29 +18087,13 @@
               </a:spcAft>
             </a:pPr>
             <a:r>
-              <a:rPr sz="1050" b="0">
+              <a:rPr sz="1250" b="0">
                 <a:solidFill>
                   <a:srgbClr val="6E6E6E"/>
                 </a:solidFill>
                 <a:latin typeface="Arial"/>
               </a:rPr>
-              <a:t>–  also ranked: 128² CMOS at 20–40 kfps; time-of-flight demodulators with the beat at MHz; digital-pixel ROICs (Lincoln DFPA); coherent photonic arrays</a:t>
-            </a:r>
-          </a:p>
-          <a:p>
-            <a:pPr marL="594360" indent="-137160">
-              <a:spcAft>
-                <a:spcPts val="500"/>
-              </a:spcAft>
-            </a:pPr>
-            <a:r>
-              <a:rPr sz="1050" b="0">
-                <a:solidFill>
-                  <a:srgbClr val="6E6E6E"/>
-                </a:solidFill>
-                <a:latin typeface="Arial"/>
-              </a:rPr>
-              <a:t>–  not fit: SPAD and Geiger-mode arrays (count-rate ceilings)</a:t>
+              <a:t>–  also ranked: 128² CMOS at 20–40 kfps, time-of-flight demodulators, digital-pixel ROICs, coherent photonic arrays; not fit: SPAD / Geiger arrays (count-rate ceilings)</a:t>
             </a:r>
           </a:p>
         </p:txBody>
@@ -18693,7 +18677,7 @@
         </p:nvSpPr>
         <p:spPr>
           <a:xfrm>
-            <a:off x="457200" y="5093208"/>
+            <a:off x="420624" y="5166360"/>
             <a:ext cx="11338560" cy="274320"/>
           </a:xfrm>
           <a:prstGeom prst="rect">
@@ -18713,7 +18697,7 @@
               </a:spcAft>
             </a:pPr>
             <a:r>
-              <a:rPr sz="1500" b="0">
+              <a:rPr sz="1400" b="0">
                 <a:solidFill>
                   <a:srgbClr val="282828"/>
                 </a:solidFill>
@@ -18722,7 +18706,7 @@
               <a:t>•  </a:t>
             </a:r>
             <a:r>
-              <a:rPr sz="1500" b="1">
+              <a:rPr sz="1400" b="1">
                 <a:solidFill>
                   <a:srgbClr val="282828"/>
                 </a:solidFill>
@@ -18738,7 +18722,7 @@
               </a:spcAft>
             </a:pPr>
             <a:r>
-              <a:rPr sz="1300" b="0">
+              <a:rPr sz="1250" b="0">
                 <a:solidFill>
                   <a:srgbClr val="6E6E6E"/>
                 </a:solidFill>
@@ -18754,7 +18738,7 @@
               </a:spcAft>
             </a:pPr>
             <a:r>
-              <a:rPr sz="1500" b="0">
+              <a:rPr sz="1400" b="0">
                 <a:solidFill>
                   <a:srgbClr val="282828"/>
                 </a:solidFill>
@@ -18763,7 +18747,7 @@
               <a:t>•  </a:t>
             </a:r>
             <a:r>
-              <a:rPr sz="1500" b="1">
+              <a:rPr sz="1400" b="1">
                 <a:solidFill>
                   <a:srgbClr val="282828"/>
                 </a:solidFill>
@@ -18772,7 +18756,7 @@
               <a:t>The vendor question:</a:t>
             </a:r>
             <a:r>
-              <a:rPr sz="1500" b="0">
+              <a:rPr sz="1400" b="0">
                 <a:solidFill>
                   <a:srgbClr val="282828"/>
                 </a:solidFill>

</xml_diff>

<commit_message>
deck_cophi (Dave 2026-10-13): new slide 14 'Hold vs cycle time' (budget law sqrt(s_pm/T) x 0.577, every sensor, loop records on the curves, the optimum cycle against the thermal ramp -- cophi_hold_vs_cycle); slide 13 bullets renamed ('LO drift is not separable from DM drift', 'Fiber phase errors are not observable'); slide 17 -> 'How much resolution?'; slide 8's rig layout at full column width with the LO leg named in the caption; builder: a bullet after a sub-bullet keeps its margin; BRIEF_to_resolution_sweep for TO; 25 slides
Co-Authored-By: Claude Fable 5.1 <noreply@anthropic.com>
</commit_message>
<xml_diff>
--- a/demo_session/deck_cophi.pptx
+++ b/demo_session/deck_cophi.pptx
@@ -29,6 +29,7 @@
     <p:sldId id="277" r:id="rId28"/>
     <p:sldId id="278" r:id="rId29"/>
     <p:sldId id="279" r:id="rId30"/>
+    <p:sldId id="280" r:id="rId31"/>
   </p:sldIdLst>
   <p:sldSz cx="12191695" cy="6858000" type="screen4x3"/>
   <p:notesSz cx="6858000" cy="9144000"/>
@@ -4383,7 +4384,7 @@
             </a:r>
           </a:p>
           <a:p>
-            <a:pPr>
+            <a:pPr marL="0" indent="0">
               <a:spcAft>
                 <a:spcPts val="600"/>
               </a:spcAft>
@@ -6728,7 +6729,7 @@
             </a:r>
           </a:p>
           <a:p>
-            <a:pPr>
+            <a:pPr marL="0" indent="0">
               <a:spcAft>
                 <a:spcPts val="600"/>
               </a:spcAft>
@@ -6778,7 +6779,7 @@
             </a:r>
           </a:p>
           <a:p>
-            <a:pPr>
+            <a:pPr marL="0" indent="0">
               <a:spcAft>
                 <a:spcPts val="600"/>
               </a:spcAft>
@@ -7566,7 +7567,7 @@
                 </a:solidFill>
                 <a:latin typeface="Arial"/>
               </a:rPr>
-              <a:t>The LO is read as the DM:</a:t>
+              <a:t>LO drift is not separable from DM drift:</a:t>
             </a:r>
             <a:r>
               <a:rPr sz="1200" b="0">
@@ -7613,7 +7614,7 @@
             </a:r>
           </a:p>
           <a:p>
-            <a:pPr>
+            <a:pPr marL="0" indent="0">
               <a:spcAft>
                 <a:spcPts val="600"/>
               </a:spcAft>
@@ -7634,7 +7635,7 @@
                 </a:solidFill>
                 <a:latin typeface="Arial"/>
               </a:rPr>
-              <a:t>The fiber is the term:</a:t>
+              <a:t>Fiber phase errors are not observable:</a:t>
             </a:r>
             <a:r>
               <a:rPr sz="1200" b="0">
@@ -7697,7 +7698,7 @@
             </a:r>
           </a:p>
           <a:p>
-            <a:pPr>
+            <a:pPr marL="0" indent="0">
               <a:spcAft>
                 <a:spcPts val="600"/>
               </a:spcAft>
@@ -7754,7 +7755,7 @@
             </a:r>
           </a:p>
           <a:p>
-            <a:pPr>
+            <a:pPr marL="0" indent="0">
               <a:spcAft>
                 <a:spcPts val="600"/>
               </a:spcAft>
@@ -7837,6 +7838,339 @@
 </file>
 
 <file path=ppt/slides/slide14.xml><?xml version="1.0" encoding="utf-8"?>
+<p:sld xmlns:a="http://schemas.openxmlformats.org/drawingml/2006/main" xmlns:p="http://schemas.openxmlformats.org/presentationml/2006/main" xmlns:r="http://schemas.openxmlformats.org/officeDocument/2006/relationships">
+  <p:cSld>
+    <p:spTree>
+      <p:nvGrpSpPr>
+        <p:cNvPr id="1" name=""/>
+        <p:cNvGrpSpPr/>
+        <p:nvPr/>
+      </p:nvGrpSpPr>
+      <p:grpSpPr/>
+      <p:sp>
+        <p:nvSpPr>
+          <p:cNvPr id="2" name="TextBox 1"/>
+          <p:cNvSpPr txBox="1"/>
+          <p:nvPr/>
+        </p:nvSpPr>
+        <p:spPr>
+          <a:xfrm>
+            <a:off x="411480" y="201168"/>
+            <a:ext cx="11368735" cy="914400"/>
+          </a:xfrm>
+          <a:prstGeom prst="rect">
+            <a:avLst/>
+          </a:prstGeom>
+          <a:noFill/>
+        </p:spPr>
+        <p:txBody>
+          <a:bodyPr wrap="square">
+            <a:spAutoFit/>
+          </a:bodyPr>
+          <a:lstStyle/>
+          <a:p>
+            <a:pPr>
+              <a:spcAft>
+                <a:spcPts val="400"/>
+              </a:spcAft>
+            </a:pPr>
+            <a:r>
+              <a:rPr sz="2400" b="1">
+                <a:solidFill>
+                  <a:srgbClr val="1F4E79"/>
+                </a:solidFill>
+                <a:latin typeface="Arial"/>
+              </a:rPr>
+              <a:t>Hold vs cycle time: what the fast cycle buys</a:t>
+            </a:r>
+          </a:p>
+          <a:p>
+            <a:pPr>
+              <a:spcAft>
+                <a:spcPts val="0"/>
+              </a:spcAft>
+            </a:pPr>
+            <a:r>
+              <a:rPr sz="1250" b="0">
+                <a:solidFill>
+                  <a:srgbClr val="6E6E6E"/>
+                </a:solidFill>
+                <a:latin typeface="Arial"/>
+              </a:rPr>
+              <a:t>At a fixed cycle time a sensor averages (cycle time ÷ seconds per pm) readings, so the hold floor is √(s_pm / T) × 0.577: the lock-in's 3.4 s per pm is 115× fewer than Feng's camera — 10.7× less noise at any cycle time; the loop records sit on the budget curves</a:t>
+            </a:r>
+          </a:p>
+        </p:txBody>
+      </p:sp>
+      <p:sp>
+        <p:nvSpPr>
+          <p:cNvPr id="3" name="Rectangle 2"/>
+          <p:cNvSpPr/>
+          <p:nvPr/>
+        </p:nvSpPr>
+        <p:spPr>
+          <a:xfrm>
+            <a:off x="411480" y="1133856"/>
+            <a:ext cx="11368735" cy="20320"/>
+          </a:xfrm>
+          <a:prstGeom prst="rect">
+            <a:avLst/>
+          </a:prstGeom>
+          <a:solidFill>
+            <a:srgbClr val="B8C6D4"/>
+          </a:solidFill>
+          <a:ln>
+            <a:noFill/>
+          </a:ln>
+          <a:effectLst/>
+        </p:spPr>
+        <p:style>
+          <a:lnRef idx="1">
+            <a:schemeClr val="accent1"/>
+          </a:lnRef>
+          <a:fillRef idx="3">
+            <a:schemeClr val="accent1"/>
+          </a:fillRef>
+          <a:effectRef idx="2">
+            <a:schemeClr val="accent1"/>
+          </a:effectRef>
+          <a:fontRef idx="minor">
+            <a:schemeClr val="lt1"/>
+          </a:fontRef>
+        </p:style>
+        <p:txBody>
+          <a:bodyPr rtlCol="0" anchor="ctr"/>
+          <a:lstStyle/>
+          <a:p>
+            <a:pPr algn="ctr"/>
+          </a:p>
+        </p:txBody>
+      </p:sp>
+      <p:pic>
+        <p:nvPicPr>
+          <p:cNvPr id="4" name="Picture 3" descr="cophi_hold_vs_cycle.png"/>
+          <p:cNvPicPr>
+            <a:picLocks noChangeAspect="1"/>
+          </p:cNvPicPr>
+          <p:nvPr/>
+        </p:nvPicPr>
+        <p:blipFill>
+          <a:blip r:embed="rId2"/>
+          <a:stretch>
+            <a:fillRect/>
+          </a:stretch>
+        </p:blipFill>
+        <p:spPr>
+          <a:xfrm>
+            <a:off x="1817005" y="1298448"/>
+            <a:ext cx="8557685" cy="3537712"/>
+          </a:xfrm>
+          <a:prstGeom prst="rect">
+            <a:avLst/>
+          </a:prstGeom>
+        </p:spPr>
+      </p:pic>
+      <p:sp>
+        <p:nvSpPr>
+          <p:cNvPr id="5" name="TextBox 4"/>
+          <p:cNvSpPr txBox="1"/>
+          <p:nvPr/>
+        </p:nvSpPr>
+        <p:spPr>
+          <a:xfrm>
+            <a:off x="411480" y="4854447"/>
+            <a:ext cx="11368735" cy="394208"/>
+          </a:xfrm>
+          <a:prstGeom prst="rect">
+            <a:avLst/>
+          </a:prstGeom>
+          <a:noFill/>
+        </p:spPr>
+        <p:txBody>
+          <a:bodyPr wrap="square">
+            <a:spAutoFit/>
+          </a:bodyPr>
+          <a:lstStyle/>
+          <a:p>
+            <a:pPr algn="ctr">
+              <a:spcAft>
+                <a:spcPts val="0"/>
+              </a:spcAft>
+            </a:pPr>
+            <a:r>
+              <a:rPr sz="1000" b="0">
+                <a:solidFill>
+                  <a:srgbClr val="6E6E6E"/>
+                </a:solidFill>
+                <a:latin typeface="Arial"/>
+              </a:rPr>
+              <a:t>Left: noise-only hold vs loop cycle time, every sensor on the table (budget lines; circles = the mirror-rig loop records).  Right: with the record's thermal ramp (0.31 pm/s), whose lag grows with the cycle — each sensor has an optimum cycle time.</a:t>
+            </a:r>
+          </a:p>
+        </p:txBody>
+      </p:sp>
+      <p:sp>
+        <p:nvSpPr>
+          <p:cNvPr id="6" name="TextBox 5"/>
+          <p:cNvSpPr txBox="1"/>
+          <p:nvPr/>
+        </p:nvSpPr>
+        <p:spPr>
+          <a:xfrm>
+            <a:off x="411480" y="5285231"/>
+            <a:ext cx="5806440" cy="274320"/>
+          </a:xfrm>
+          <a:prstGeom prst="rect">
+            <a:avLst/>
+          </a:prstGeom>
+          <a:noFill/>
+        </p:spPr>
+        <p:txBody>
+          <a:bodyPr wrap="square">
+            <a:spAutoFit/>
+          </a:bodyPr>
+          <a:lstStyle/>
+          <a:p>
+            <a:pPr>
+              <a:spcAft>
+                <a:spcPts val="600"/>
+              </a:spcAft>
+            </a:pPr>
+            <a:r>
+              <a:rPr sz="1200" b="0">
+                <a:solidFill>
+                  <a:srgbClr val="282828"/>
+                </a:solidFill>
+                <a:latin typeface="Arial"/>
+              </a:rPr>
+              <a:t>•  </a:t>
+            </a:r>
+            <a:r>
+              <a:rPr sz="1200" b="1">
+                <a:solidFill>
+                  <a:srgbClr val="282828"/>
+                </a:solidFill>
+                <a:latin typeface="Arial"/>
+              </a:rPr>
+              <a:t>At 1.6 s cycles:</a:t>
+            </a:r>
+            <a:r>
+              <a:rPr sz="1200" b="0">
+                <a:solidFill>
+                  <a:srgbClr val="282828"/>
+                </a:solidFill>
+                <a:latin typeface="Arial"/>
+              </a:rPr>
+              <a:t> Feng's camera 9.0 pm, Photonfocus 2.7, lock-in 0.84 (well-free 0.27); IFO 5.8, vector ZWFS 10.4 (on their polarization cameras).  Records match the law to 8 %.</a:t>
+            </a:r>
+          </a:p>
+        </p:txBody>
+      </p:sp>
+      <p:sp>
+        <p:nvSpPr>
+          <p:cNvPr id="7" name="TextBox 6"/>
+          <p:cNvSpPr txBox="1"/>
+          <p:nvPr/>
+        </p:nvSpPr>
+        <p:spPr>
+          <a:xfrm>
+            <a:off x="6400800" y="5285231"/>
+            <a:ext cx="5394960" cy="274320"/>
+          </a:xfrm>
+          <a:prstGeom prst="rect">
+            <a:avLst/>
+          </a:prstGeom>
+          <a:noFill/>
+        </p:spPr>
+        <p:txBody>
+          <a:bodyPr wrap="square">
+            <a:spAutoFit/>
+          </a:bodyPr>
+          <a:lstStyle/>
+          <a:p>
+            <a:pPr>
+              <a:spcAft>
+                <a:spcPts val="600"/>
+              </a:spcAft>
+            </a:pPr>
+            <a:r>
+              <a:rPr sz="1200" b="0">
+                <a:solidFill>
+                  <a:srgbClr val="282828"/>
+                </a:solidFill>
+                <a:latin typeface="Arial"/>
+              </a:rPr>
+              <a:t>•  </a:t>
+            </a:r>
+            <a:r>
+              <a:rPr sz="1200" b="1">
+                <a:solidFill>
+                  <a:srgbClr val="282828"/>
+                </a:solidFill>
+                <a:latin typeface="Arial"/>
+              </a:rPr>
+              <a:t>Against a drift rate the cycle has an optimum</a:t>
+            </a:r>
+            <a:r>
+              <a:rPr sz="1200" b="0">
+                <a:solidFill>
+                  <a:srgbClr val="282828"/>
+                </a:solidFill>
+                <a:latin typeface="Arial"/>
+              </a:rPr>
+              <a:t> (right): Feng's camera 6.0 pm at 5.5 s, Photonfocus 2.7 at 2.5 s, lock-in 1.2 at 1.1 s, well-free 0.57 at 0.5 s — the fast reading holds a drift at the picometer where the slow cameras cannot.</a:t>
+            </a:r>
+          </a:p>
+        </p:txBody>
+      </p:sp>
+      <p:sp>
+        <p:nvSpPr>
+          <p:cNvPr id="8" name="TextBox 7"/>
+          <p:cNvSpPr txBox="1"/>
+          <p:nvPr/>
+        </p:nvSpPr>
+        <p:spPr>
+          <a:xfrm>
+            <a:off x="6400800" y="6254495"/>
+            <a:ext cx="5394960" cy="274320"/>
+          </a:xfrm>
+          <a:prstGeom prst="rect">
+            <a:avLst/>
+          </a:prstGeom>
+          <a:noFill/>
+        </p:spPr>
+        <p:txBody>
+          <a:bodyPr wrap="square">
+            <a:spAutoFit/>
+          </a:bodyPr>
+          <a:lstStyle/>
+          <a:p>
+            <a:pPr>
+              <a:spcAft>
+                <a:spcPts val="600"/>
+              </a:spcAft>
+            </a:pPr>
+            <a:r>
+              <a:rPr sz="1050" b="0">
+                <a:solidFill>
+                  <a:srgbClr val="6E6E6E"/>
+                </a:solidFill>
+                <a:latin typeface="Arial"/>
+              </a:rPr>
+              <a:t>cophi_hold_vs_cycle (runs/figs_hold_vs_cycle/); seconds per pm from the records (stages noise / format / lockin; camI_oap, camS_oap); the lag from stage loop's thermal row.  A budget, no new runs.</a:t>
+            </a:r>
+          </a:p>
+        </p:txBody>
+      </p:sp>
+    </p:spTree>
+  </p:cSld>
+  <p:clrMapOvr>
+    <a:masterClrMapping/>
+  </p:clrMapOvr>
+</p:sld>
+</file>
+
+<file path=ppt/slides/slide15.xml><?xml version="1.0" encoding="utf-8"?>
 <p:sld xmlns:a="http://schemas.openxmlformats.org/drawingml/2006/main" xmlns:p="http://schemas.openxmlformats.org/presentationml/2006/main" xmlns:r="http://schemas.openxmlformats.org/officeDocument/2006/relationships">
   <p:cSld>
     <p:spTree>
@@ -8113,7 +8447,7 @@
 </p:sld>
 </file>
 
-<file path=ppt/slides/slide15.xml><?xml version="1.0" encoding="utf-8"?>
+<file path=ppt/slides/slide16.xml><?xml version="1.0" encoding="utf-8"?>
 <p:sld xmlns:a="http://schemas.openxmlformats.org/drawingml/2006/main" xmlns:p="http://schemas.openxmlformats.org/presentationml/2006/main" xmlns:r="http://schemas.openxmlformats.org/officeDocument/2006/relationships">
   <p:cSld>
     <p:spTree>
@@ -8353,7 +8687,7 @@
             </a:r>
           </a:p>
           <a:p>
-            <a:pPr>
+            <a:pPr marL="0" indent="0">
               <a:spcAft>
                 <a:spcPts val="600"/>
               </a:spcAft>
@@ -8962,7 +9296,7 @@
 </p:sld>
 </file>
 
-<file path=ppt/slides/slide16.xml><?xml version="1.0" encoding="utf-8"?>
+<file path=ppt/slides/slide17.xml><?xml version="1.0" encoding="utf-8"?>
 <p:sld xmlns:a="http://schemas.openxmlformats.org/drawingml/2006/main" xmlns:p="http://schemas.openxmlformats.org/presentationml/2006/main" xmlns:r="http://schemas.openxmlformats.org/officeDocument/2006/relationships">
   <p:cSld>
     <p:spTree>
@@ -10344,7 +10678,7 @@
 </p:sld>
 </file>
 
-<file path=ppt/slides/slide17.xml><?xml version="1.0" encoding="utf-8"?>
+<file path=ppt/slides/slide18.xml><?xml version="1.0" encoding="utf-8"?>
 <p:sld xmlns:a="http://schemas.openxmlformats.org/drawingml/2006/main" xmlns:p="http://schemas.openxmlformats.org/presentationml/2006/main" xmlns:r="http://schemas.openxmlformats.org/officeDocument/2006/relationships">
   <p:cSld>
     <p:spTree>
@@ -10388,7 +10722,7 @@
                 </a:solidFill>
                 <a:latin typeface="Arial"/>
               </a:rPr>
-              <a:t>Pricing resolution: IFO, vector ZWFS, HET</a:t>
+              <a:t>How much resolution? IFO, vector ZWFS, HET</a:t>
             </a:r>
           </a:p>
           <a:p>
@@ -11634,7 +11968,7 @@
             </a:r>
           </a:p>
           <a:p>
-            <a:pPr>
+            <a:pPr marL="0" indent="0">
               <a:spcAft>
                 <a:spcPts val="600"/>
               </a:spcAft>
@@ -11716,7 +12050,7 @@
 </p:sld>
 </file>
 
-<file path=ppt/slides/slide18.xml><?xml version="1.0" encoding="utf-8"?>
+<file path=ppt/slides/slide19.xml><?xml version="1.0" encoding="utf-8"?>
 <p:sld xmlns:a="http://schemas.openxmlformats.org/drawingml/2006/main" xmlns:p="http://schemas.openxmlformats.org/presentationml/2006/main" xmlns:r="http://schemas.openxmlformats.org/officeDocument/2006/relationships">
   <p:cSld>
     <p:spTree>
@@ -12836,7 +13170,7 @@
 </p:sld>
 </file>
 
-<file path=ppt/slides/slide19.xml><?xml version="1.0" encoding="utf-8"?>
+<file path=ppt/slides/slide2.xml><?xml version="1.0" encoding="utf-8"?>
 <p:sld xmlns:a="http://schemas.openxmlformats.org/drawingml/2006/main" xmlns:p="http://schemas.openxmlformats.org/presentationml/2006/main" xmlns:r="http://schemas.openxmlformats.org/officeDocument/2006/relationships">
   <p:cSld>
     <p:spTree>
@@ -12880,7 +13214,7 @@
                 </a:solidFill>
                 <a:latin typeface="Arial"/>
               </a:rPr>
-              <a:t>Recommendations</a:t>
+              <a:t>Feng's proposal, in one slide</a:t>
             </a:r>
           </a:p>
           <a:p>
@@ -12896,7 +13230,7 @@
                 </a:solidFill>
                 <a:latin typeface="Arial"/>
               </a:rPr>
-              <a:t>COPHI is a credible fifth gauge: it matches the IFO's floor, reads exactly, and captures from cold in one reading; its cost is the fiber and the LO, its speed is the camera's</a:t>
+              <a:t>A heterodyne interferometer whose phase steps are set by frequency, not by a piezo, with a fiber-fed local oscillator at the camera, and an array detector providing many parallel channels to resolve 96 × 96 actuators</a:t>
             </a:r>
           </a:p>
         </p:txBody>
@@ -12988,7 +13322,7 @@
                 </a:solidFill>
                 <a:latin typeface="Arial"/>
               </a:rPr>
-              <a:t>Score it in the composite deck</a:t>
+              <a:t>Layout:</a:t>
             </a:r>
             <a:r>
               <a:rPr sz="1200" b="0">
@@ -12997,7 +13331,7 @@
                 </a:solidFill>
                 <a:latin typeface="Arial"/>
               </a:rPr>
-              <a:t> as the fifth column, with the converged estimator and the piston-free photon metric for every gauge (both found here, both apply to the record).</a:t>
+              <a:t> laser → 1×2 coupler → AOM-1 (80 MHz) and AOM-2 (80 MHz + 7.5 Hz), both synthesizers on a 10 MHz Rb standard; the measurement beam to the DM, the LO fiber to a splitter before the camera; the ×4 multipliers mixed to a 30 Hz camera trigger: four frames per 7.5 Hz fringe cycle – see next slide.</a:t>
             </a:r>
           </a:p>
           <a:p>
@@ -13022,7 +13356,7 @@
                 </a:solidFill>
                 <a:latin typeface="Arial"/>
               </a:rPr>
-              <a:t>Price the plain splitter</a:t>
+              <a:t>Algorithm:</a:t>
             </a:r>
             <a:r>
               <a:rPr sz="1200" b="0">
@@ -13031,7 +13365,7 @@
                 </a:solidFill>
                 <a:latin typeface="Arial"/>
               </a:rPr>
-              <a:t> (Feng's layout); the record's polarizing train costs ×1.5 of laser and nothing else.</a:t>
+              <a:t> I = I₀ (1 + γ cos(φ + 2π f t)); frames at α = 0, π/2, π, 3π/2; φ = atan2(I₄ − I₂, I₁ − I₃); surface = ½ (φ/2π) λ (double pass).  Backup: the N-frame least-squares solution (Zygo's four-step is N = 4).</a:t>
             </a:r>
           </a:p>
           <a:p>
@@ -13056,7 +13390,7 @@
                 </a:solidFill>
                 <a:latin typeface="Arial"/>
               </a:rPr>
-              <a:t>Camera:</a:t>
+              <a:t>Main purpose: stabilize the DM!</a:t>
             </a:r>
             <a:r>
               <a:rPr sz="1200" b="0">
@@ -13065,91 +13399,7 @@
                 </a:solidFill>
                 <a:latin typeface="Arial"/>
               </a:rPr>
-              <a:t> the Photonfocus-class 1k global-shutter part (42 s per pm, 3 pm held in 1.6 s cycles) over Feng's baseline (7 min, 16 s).</a:t>
-            </a:r>
-          </a:p>
-          <a:p>
-            <a:pPr marL="594360" indent="-137160">
-              <a:spcAft>
-                <a:spcPts val="500"/>
-              </a:spcAft>
-            </a:pPr>
-            <a:r>
-              <a:rPr sz="1050" b="0">
-                <a:solidFill>
-                  <a:srgbClr val="6E6E6E"/>
-                </a:solidFill>
-                <a:latin typeface="Arial"/>
-              </a:rPr>
-              <a:t>–  verify the survey against the vendor sheets before a part is named</a:t>
-            </a:r>
-          </a:p>
-          <a:p>
-            <a:pPr marL="594360" indent="-137160">
-              <a:spcAft>
-                <a:spcPts val="500"/>
-              </a:spcAft>
-            </a:pPr>
-            <a:r>
-              <a:rPr sz="1050" b="0">
-                <a:solidFill>
-                  <a:srgbClr val="6E6E6E"/>
-                </a:solidFill>
-                <a:latin typeface="Arial"/>
-              </a:rPr>
-              <a:t>–  </a:t>
-            </a:r>
-            <a:r>
-              <a:rPr sz="1050" b="1">
-                <a:solidFill>
-                  <a:srgbClr val="6E6E6E"/>
-                </a:solidFill>
-                <a:latin typeface="Arial"/>
-              </a:rPr>
-              <a:t>the lock-in camera is the fast form</a:t>
-            </a:r>
-            <a:r>
-              <a:rPr sz="1050" b="0">
-                <a:solidFill>
-                  <a:srgbClr val="6E6E6E"/>
-                </a:solidFill>
-                <a:latin typeface="Arial"/>
-              </a:rPr>
-              <a:t> (3.4 s per pm as surveyed, 0.125 s cycles) — one vendor question from a number</a:t>
-            </a:r>
-          </a:p>
-          <a:p>
-            <a:pPr>
-              <a:spcAft>
-                <a:spcPts val="600"/>
-              </a:spcAft>
-            </a:pPr>
-            <a:r>
-              <a:rPr sz="1200" b="0">
-                <a:solidFill>
-                  <a:srgbClr val="282828"/>
-                </a:solidFill>
-                <a:latin typeface="Arial"/>
-              </a:rPr>
-              <a:t>•  </a:t>
-            </a:r>
-            <a:r>
-              <a:rPr sz="1200" b="1">
-                <a:solidFill>
-                  <a:srgbClr val="282828"/>
-                </a:solidFill>
-                <a:latin typeface="Arial"/>
-              </a:rPr>
-              <a:t>Two colors from the start:</a:t>
-            </a:r>
-            <a:r>
-              <a:rPr sz="1200" b="0">
-                <a:solidFill>
-                  <a:srgbClr val="282828"/>
-                </a:solidFill>
-                <a:latin typeface="Arial"/>
-              </a:rPr>
-              <a:t> capture from cold in one reading; at 1.3 µm, telecom tunables and twice the base range — the InGaAs stage.</a:t>
+              <a:t>  Run each DM in a local loop to hold it — our job 3.  For us to figure out: the camera, the photon budget, the error terms, estimated performance.</a:t>
             </a:r>
           </a:p>
         </p:txBody>
@@ -13197,7 +13447,7 @@
                 </a:solidFill>
                 <a:latin typeface="Arial"/>
               </a:rPr>
-              <a:t>Open in the record:</a:t>
+              <a:t>Built on our DM Gauge bench:</a:t>
             </a:r>
             <a:r>
               <a:rPr sz="1200" b="0">
@@ -13206,7 +13456,7 @@
                 </a:solidFill>
                 <a:latin typeface="Arial"/>
               </a:rPr>
-              <a:t> the lens rig's +0.1–0.2 % converged gain (a matrix-model term); the per-gauge resolution sweep (slide 17); the polarization-camera timings through the noise hook (slide 16).</a:t>
+              <a:t> the bench with mirror and lens layouts, the 96 × 96 DM, swappable sensors: the core Twyman-Green interferometer (IFO), scalar and vector Zernike wavefront sensors (ZWFS), point-diffraction interferometers.</a:t>
             </a:r>
           </a:p>
           <a:p>
@@ -13231,7 +13481,7 @@
                 </a:solidFill>
                 <a:latin typeface="Arial"/>
               </a:rPr>
-              <a:t>Model next:</a:t>
+              <a:t>The same scoring:</a:t>
             </a:r>
             <a:r>
               <a:rPr sz="1200" b="0">
@@ -13240,7 +13490,75 @@
                 </a:solidFill>
                 <a:latin typeface="Arial"/>
               </a:rPr>
-              <a:t> the tail's chromatic refocus at Δλ = 20 nm (dispersive glass in the model); the LO referenced against the test arm's own flat; parts counts and TRL for all five gauges; Kent's ZWFS reconstruction when it arrives.</a:t>
+              <a:t> on a 30 nm working surface, the response matrix measured through the reading, the hold loop, the capture ladder, the photon rows.</a:t>
+            </a:r>
+          </a:p>
+          <a:p>
+            <a:pPr>
+              <a:spcAft>
+                <a:spcPts val="600"/>
+              </a:spcAft>
+            </a:pPr>
+            <a:r>
+              <a:rPr sz="1200" b="0">
+                <a:solidFill>
+                  <a:srgbClr val="282828"/>
+                </a:solidFill>
+                <a:latin typeface="Arial"/>
+              </a:rPr>
+              <a:t>•  </a:t>
+            </a:r>
+            <a:r>
+              <a:rPr sz="1200" b="1">
+                <a:solidFill>
+                  <a:srgbClr val="282828"/>
+                </a:solidFill>
+                <a:latin typeface="Arial"/>
+              </a:rPr>
+              <a:t>What is new:</a:t>
+            </a:r>
+            <a:r>
+              <a:rPr sz="1200" b="0">
+                <a:solidFill>
+                  <a:srgbClr val="282828"/>
+                </a:solidFill>
+                <a:latin typeface="Arial"/>
+              </a:rPr>
+              <a:t> the Local Oscillator (LO) arm (a fiber tip and collimator where the reference flat sat); frequency-set steps; each frame integrating a quarter of the beat; the LO's wavefront drift; the differential fiber phase within a scan; trigger jitter; a camera chosen for the job.</a:t>
+            </a:r>
+          </a:p>
+          <a:p>
+            <a:pPr>
+              <a:spcAft>
+                <a:spcPts val="600"/>
+              </a:spcAft>
+            </a:pPr>
+            <a:r>
+              <a:rPr sz="1200" b="0">
+                <a:solidFill>
+                  <a:srgbClr val="282828"/>
+                </a:solidFill>
+                <a:latin typeface="Arial"/>
+              </a:rPr>
+              <a:t>•  </a:t>
+            </a:r>
+            <a:r>
+              <a:rPr sz="1200" b="1">
+                <a:solidFill>
+                  <a:srgbClr val="282828"/>
+                </a:solidFill>
+                <a:latin typeface="Arial"/>
+              </a:rPr>
+              <a:t>What is absent:</a:t>
+            </a:r>
+            <a:r>
+              <a:rPr sz="1200" b="0">
+                <a:solidFill>
+                  <a:srgbClr val="282828"/>
+                </a:solidFill>
+                <a:latin typeface="Arial"/>
+              </a:rPr>
+              <a:t> the polarizing train — no analyzer, no quarter-wave plates, the same polarization in both arms — so the polarization gain the IFO carries (0.983–1.004) does not exist here.</a:t>
             </a:r>
           </a:p>
         </p:txBody>
@@ -13253,7 +13571,7 @@
         </p:nvSpPr>
         <p:spPr>
           <a:xfrm>
-            <a:off x="6400800" y="3002280"/>
+            <a:off x="6400800" y="5074920"/>
             <a:ext cx="5394960" cy="274320"/>
           </a:xfrm>
           <a:prstGeom prst="rect">
@@ -13279,7 +13597,7 @@
                 </a:solidFill>
                 <a:latin typeface="Arial"/>
               </a:rPr>
-              <a:t>Everything reproduces from templates/40_benches/cophi_dm96/ (cophi_run, the stage tags in each footnote); gates tCophi, tCophiBench, tConvergedEst, tDmgLoop.</a:t>
+              <a:t>Feng's slide 8 is the implementation example this deck's block diagrams follow; TOM3 (SPIE 6268) is the photodiode heritage.</a:t>
             </a:r>
           </a:p>
         </p:txBody>
@@ -13292,7 +13610,7 @@
 </p:sld>
 </file>
 
-<file path=ppt/slides/slide2.xml><?xml version="1.0" encoding="utf-8"?>
+<file path=ppt/slides/slide20.xml><?xml version="1.0" encoding="utf-8"?>
 <p:sld xmlns:a="http://schemas.openxmlformats.org/drawingml/2006/main" xmlns:p="http://schemas.openxmlformats.org/presentationml/2006/main" xmlns:r="http://schemas.openxmlformats.org/officeDocument/2006/relationships">
   <p:cSld>
     <p:spTree>
@@ -13336,7 +13654,7 @@
                 </a:solidFill>
                 <a:latin typeface="Arial"/>
               </a:rPr>
-              <a:t>Feng's proposal, in one slide</a:t>
+              <a:t>Recommendations</a:t>
             </a:r>
           </a:p>
           <a:p>
@@ -13352,7 +13670,7 @@
                 </a:solidFill>
                 <a:latin typeface="Arial"/>
               </a:rPr>
-              <a:t>A heterodyne interferometer whose phase steps are set by frequency, not by a piezo, with a fiber-fed local oscillator at the camera, and an array detector providing many parallel channels to resolve 96 × 96 actuators</a:t>
+              <a:t>COPHI is a credible fifth gauge: it matches the IFO's floor, reads exactly, and captures from cold in one reading; its cost is the fiber and the LO, its speed is the camera's</a:t>
             </a:r>
           </a:p>
         </p:txBody>
@@ -13444,7 +13762,7 @@
                 </a:solidFill>
                 <a:latin typeface="Arial"/>
               </a:rPr>
-              <a:t>Layout:</a:t>
+              <a:t>Score it in the composite deck</a:t>
             </a:r>
             <a:r>
               <a:rPr sz="1200" b="0">
@@ -13453,7 +13771,7 @@
                 </a:solidFill>
                 <a:latin typeface="Arial"/>
               </a:rPr>
-              <a:t> laser → 1×2 coupler → AOM-1 (80 MHz) and AOM-2 (80 MHz + 7.5 Hz), both synthesizers on a 10 MHz Rb standard; the measurement beam to the DM, the LO fiber to a splitter before the camera; the ×4 multipliers mixed to a 30 Hz camera trigger: four frames per 7.5 Hz fringe cycle – see next slide.</a:t>
+              <a:t> as the fifth column, with the converged estimator and the piston-free photon metric for every gauge (both found here, both apply to the record).</a:t>
             </a:r>
           </a:p>
           <a:p>
@@ -13478,7 +13796,7 @@
                 </a:solidFill>
                 <a:latin typeface="Arial"/>
               </a:rPr>
-              <a:t>Algorithm:</a:t>
+              <a:t>Price the plain splitter</a:t>
             </a:r>
             <a:r>
               <a:rPr sz="1200" b="0">
@@ -13487,7 +13805,7 @@
                 </a:solidFill>
                 <a:latin typeface="Arial"/>
               </a:rPr>
-              <a:t> I = I₀ (1 + γ cos(φ + 2π f t)); frames at α = 0, π/2, π, 3π/2; φ = atan2(I₄ − I₂, I₁ − I₃); surface = ½ (φ/2π) λ (double pass).  Backup: the N-frame least-squares solution (Zygo's four-step is N = 4).</a:t>
+              <a:t> (Feng's layout); the record's polarizing train costs ×1.5 of laser and nothing else.</a:t>
             </a:r>
           </a:p>
           <a:p>
@@ -13512,7 +13830,7 @@
                 </a:solidFill>
                 <a:latin typeface="Arial"/>
               </a:rPr>
-              <a:t>Main purpose: stabilize the DM!</a:t>
+              <a:t>Camera:</a:t>
             </a:r>
             <a:r>
               <a:rPr sz="1200" b="0">
@@ -13521,7 +13839,91 @@
                 </a:solidFill>
                 <a:latin typeface="Arial"/>
               </a:rPr>
-              <a:t>  Run each DM in a local loop to hold it — our job 3.  For us to figure out: the camera, the photon budget, the error terms, estimated performance.</a:t>
+              <a:t> the Photonfocus-class 1k global-shutter part (42 s per pm, 3 pm held in 1.6 s cycles) over Feng's baseline (7 min, 16 s).</a:t>
+            </a:r>
+          </a:p>
+          <a:p>
+            <a:pPr marL="594360" indent="-137160">
+              <a:spcAft>
+                <a:spcPts val="500"/>
+              </a:spcAft>
+            </a:pPr>
+            <a:r>
+              <a:rPr sz="1050" b="0">
+                <a:solidFill>
+                  <a:srgbClr val="6E6E6E"/>
+                </a:solidFill>
+                <a:latin typeface="Arial"/>
+              </a:rPr>
+              <a:t>–  verify the survey against the vendor sheets before a part is named</a:t>
+            </a:r>
+          </a:p>
+          <a:p>
+            <a:pPr marL="594360" indent="-137160">
+              <a:spcAft>
+                <a:spcPts val="500"/>
+              </a:spcAft>
+            </a:pPr>
+            <a:r>
+              <a:rPr sz="1050" b="0">
+                <a:solidFill>
+                  <a:srgbClr val="6E6E6E"/>
+                </a:solidFill>
+                <a:latin typeface="Arial"/>
+              </a:rPr>
+              <a:t>–  </a:t>
+            </a:r>
+            <a:r>
+              <a:rPr sz="1050" b="1">
+                <a:solidFill>
+                  <a:srgbClr val="6E6E6E"/>
+                </a:solidFill>
+                <a:latin typeface="Arial"/>
+              </a:rPr>
+              <a:t>the lock-in camera is the fast form</a:t>
+            </a:r>
+            <a:r>
+              <a:rPr sz="1050" b="0">
+                <a:solidFill>
+                  <a:srgbClr val="6E6E6E"/>
+                </a:solidFill>
+                <a:latin typeface="Arial"/>
+              </a:rPr>
+              <a:t> (3.4 s per pm as surveyed, 0.125 s cycles) — one vendor question from a number</a:t>
+            </a:r>
+          </a:p>
+          <a:p>
+            <a:pPr marL="0" indent="0">
+              <a:spcAft>
+                <a:spcPts val="600"/>
+              </a:spcAft>
+            </a:pPr>
+            <a:r>
+              <a:rPr sz="1200" b="0">
+                <a:solidFill>
+                  <a:srgbClr val="282828"/>
+                </a:solidFill>
+                <a:latin typeface="Arial"/>
+              </a:rPr>
+              <a:t>•  </a:t>
+            </a:r>
+            <a:r>
+              <a:rPr sz="1200" b="1">
+                <a:solidFill>
+                  <a:srgbClr val="282828"/>
+                </a:solidFill>
+                <a:latin typeface="Arial"/>
+              </a:rPr>
+              <a:t>Two colors from the start:</a:t>
+            </a:r>
+            <a:r>
+              <a:rPr sz="1200" b="0">
+                <a:solidFill>
+                  <a:srgbClr val="282828"/>
+                </a:solidFill>
+                <a:latin typeface="Arial"/>
+              </a:rPr>
+              <a:t> capture from cold in one reading; at 1.3 µm, telecom tunables and twice the base range — the InGaAs stage.</a:t>
             </a:r>
           </a:p>
         </p:txBody>
@@ -13569,7 +13971,7 @@
                 </a:solidFill>
                 <a:latin typeface="Arial"/>
               </a:rPr>
-              <a:t>Built on our DM Gauge bench:</a:t>
+              <a:t>Open in the record:</a:t>
             </a:r>
             <a:r>
               <a:rPr sz="1200" b="0">
@@ -13578,7 +13980,7 @@
                 </a:solidFill>
                 <a:latin typeface="Arial"/>
               </a:rPr>
-              <a:t> the bench with mirror and lens layouts, the 96 × 96 DM, swappable sensors: the core Twyman-Green interferometer (IFO), scalar and vector Zernike wavefront sensors (ZWFS), point-diffraction interferometers.</a:t>
+              <a:t> the lens rig's +0.1–0.2 % converged gain (a matrix-model term); the per-gauge resolution sweep (slide 18); the polarization-camera timings through the noise hook (slide 17).</a:t>
             </a:r>
           </a:p>
           <a:p>
@@ -13603,7 +14005,7 @@
                 </a:solidFill>
                 <a:latin typeface="Arial"/>
               </a:rPr>
-              <a:t>The same scoring:</a:t>
+              <a:t>Model next:</a:t>
             </a:r>
             <a:r>
               <a:rPr sz="1200" b="0">
@@ -13612,75 +14014,7 @@
                 </a:solidFill>
                 <a:latin typeface="Arial"/>
               </a:rPr>
-              <a:t> on a 30 nm working surface, the response matrix measured through the reading, the hold loop, the capture ladder, the photon rows.</a:t>
-            </a:r>
-          </a:p>
-          <a:p>
-            <a:pPr>
-              <a:spcAft>
-                <a:spcPts val="600"/>
-              </a:spcAft>
-            </a:pPr>
-            <a:r>
-              <a:rPr sz="1200" b="0">
-                <a:solidFill>
-                  <a:srgbClr val="282828"/>
-                </a:solidFill>
-                <a:latin typeface="Arial"/>
-              </a:rPr>
-              <a:t>•  </a:t>
-            </a:r>
-            <a:r>
-              <a:rPr sz="1200" b="1">
-                <a:solidFill>
-                  <a:srgbClr val="282828"/>
-                </a:solidFill>
-                <a:latin typeface="Arial"/>
-              </a:rPr>
-              <a:t>What is new:</a:t>
-            </a:r>
-            <a:r>
-              <a:rPr sz="1200" b="0">
-                <a:solidFill>
-                  <a:srgbClr val="282828"/>
-                </a:solidFill>
-                <a:latin typeface="Arial"/>
-              </a:rPr>
-              <a:t> the Local Oscillator (LO) arm (a fiber tip and collimator where the reference flat sat); frequency-set steps; each frame integrating a quarter of the beat; the LO's wavefront drift; the differential fiber phase within a scan; trigger jitter; a camera chosen for the job.</a:t>
-            </a:r>
-          </a:p>
-          <a:p>
-            <a:pPr>
-              <a:spcAft>
-                <a:spcPts val="600"/>
-              </a:spcAft>
-            </a:pPr>
-            <a:r>
-              <a:rPr sz="1200" b="0">
-                <a:solidFill>
-                  <a:srgbClr val="282828"/>
-                </a:solidFill>
-                <a:latin typeface="Arial"/>
-              </a:rPr>
-              <a:t>•  </a:t>
-            </a:r>
-            <a:r>
-              <a:rPr sz="1200" b="1">
-                <a:solidFill>
-                  <a:srgbClr val="282828"/>
-                </a:solidFill>
-                <a:latin typeface="Arial"/>
-              </a:rPr>
-              <a:t>What is absent:</a:t>
-            </a:r>
-            <a:r>
-              <a:rPr sz="1200" b="0">
-                <a:solidFill>
-                  <a:srgbClr val="282828"/>
-                </a:solidFill>
-                <a:latin typeface="Arial"/>
-              </a:rPr>
-              <a:t> the polarizing train — no analyzer, no quarter-wave plates, the same polarization in both arms — so the polarization gain the IFO carries (0.983–1.004) does not exist here.</a:t>
+              <a:t> the tail's chromatic refocus at Δλ = 20 nm (dispersive glass in the model); the LO referenced against the test arm's own flat; parts counts and TRL for all five gauges; Kent's ZWFS reconstruction when it arrives.</a:t>
             </a:r>
           </a:p>
         </p:txBody>
@@ -13693,7 +14027,7 @@
         </p:nvSpPr>
         <p:spPr>
           <a:xfrm>
-            <a:off x="6400800" y="5074920"/>
+            <a:off x="6400800" y="3002280"/>
             <a:ext cx="5394960" cy="274320"/>
           </a:xfrm>
           <a:prstGeom prst="rect">
@@ -13719,7 +14053,7 @@
                 </a:solidFill>
                 <a:latin typeface="Arial"/>
               </a:rPr>
-              <a:t>Feng's slide 8 is the implementation example this deck's block diagrams follow; TOM3 (SPIE 6268) is the photodiode heritage.</a:t>
+              <a:t>Everything reproduces from templates/40_benches/cophi_dm96/ (cophi_run, the stage tags in each footnote); gates tCophi, tCophiBench, tConvergedEst, tDmgLoop.</a:t>
             </a:r>
           </a:p>
         </p:txBody>
@@ -13732,7 +14066,7 @@
 </p:sld>
 </file>
 
-<file path=ppt/slides/slide20.xml><?xml version="1.0" encoding="utf-8"?>
+<file path=ppt/slides/slide21.xml><?xml version="1.0" encoding="utf-8"?>
 <p:sld xmlns:a="http://schemas.openxmlformats.org/drawingml/2006/main" xmlns:p="http://schemas.openxmlformats.org/presentationml/2006/main" xmlns:r="http://schemas.openxmlformats.org/officeDocument/2006/relationships">
   <p:cSld>
     <p:spTree>
@@ -14589,7 +14923,7 @@
 </p:sld>
 </file>
 
-<file path=ppt/slides/slide21.xml><?xml version="1.0" encoding="utf-8"?>
+<file path=ppt/slides/slide22.xml><?xml version="1.0" encoding="utf-8"?>
 <p:sld xmlns:a="http://schemas.openxmlformats.org/drawingml/2006/main" xmlns:p="http://schemas.openxmlformats.org/presentationml/2006/main" xmlns:r="http://schemas.openxmlformats.org/officeDocument/2006/relationships">
   <p:cSld>
     <p:spTree>
@@ -14690,7 +15024,7 @@
 </p:sld>
 </file>
 
-<file path=ppt/slides/slide22.xml><?xml version="1.0" encoding="utf-8"?>
+<file path=ppt/slides/slide23.xml><?xml version="1.0" encoding="utf-8"?>
 <p:sld xmlns:a="http://schemas.openxmlformats.org/drawingml/2006/main" xmlns:p="http://schemas.openxmlformats.org/presentationml/2006/main" xmlns:r="http://schemas.openxmlformats.org/officeDocument/2006/relationships">
   <p:cSld>
     <p:spTree>
@@ -14917,7 +15251,7 @@
 </p:sld>
 </file>
 
-<file path=ppt/slides/slide23.xml><?xml version="1.0" encoding="utf-8"?>
+<file path=ppt/slides/slide24.xml><?xml version="1.0" encoding="utf-8"?>
 <p:sld xmlns:a="http://schemas.openxmlformats.org/drawingml/2006/main" xmlns:p="http://schemas.openxmlformats.org/presentationml/2006/main" xmlns:r="http://schemas.openxmlformats.org/officeDocument/2006/relationships">
   <p:cSld>
     <p:spTree>
@@ -15508,7 +15842,7 @@
 </p:sld>
 </file>
 
-<file path=ppt/slides/slide24.xml><?xml version="1.0" encoding="utf-8"?>
+<file path=ppt/slides/slide25.xml><?xml version="1.0" encoding="utf-8"?>
 <p:sld xmlns:a="http://schemas.openxmlformats.org/drawingml/2006/main" xmlns:p="http://schemas.openxmlformats.org/presentationml/2006/main" xmlns:r="http://schemas.openxmlformats.org/officeDocument/2006/relationships">
   <p:cSld>
     <p:spTree>
@@ -17716,7 +18050,7 @@
                           </a:solidFill>
                           <a:latin typeface="Arial"/>
                         </a:rPr>
-                        <a:t>fiber walk, jitter, LO drift, shot + read noise, the record's drifts (slide 13); the record's loop at the camera's cadence; two colors from cold (slides 14–15)</a:t>
+                        <a:t>fiber walk, jitter, LO drift, shot + read noise, the record's drifts (slide 13); the record's loop at the camera's cadence; two colors from cold (slides 15–16)</a:t>
                       </a:r>
                     </a:p>
                   </a:txBody>
@@ -18047,7 +18381,7 @@
             </a:r>
           </a:p>
           <a:p>
-            <a:pPr>
+            <a:pPr marL="0" indent="0">
               <a:spcAft>
                 <a:spcPts val="600"/>
               </a:spcAft>
@@ -18732,7 +19066,7 @@
             </a:r>
           </a:p>
           <a:p>
-            <a:pPr>
+            <a:pPr marL="0" indent="0">
               <a:spcAft>
                 <a:spcPts val="600"/>
               </a:spcAft>
@@ -19314,7 +19648,7 @@
             </a:r>
           </a:p>
           <a:p>
-            <a:pPr>
+            <a:pPr marL="0" indent="0">
               <a:spcAft>
                 <a:spcPts val="600"/>
               </a:spcAft>
@@ -19453,7 +19787,7 @@
             </a:r>
           </a:p>
           <a:p>
-            <a:pPr>
+            <a:pPr marL="0" indent="0">
               <a:spcAft>
                 <a:spcPts val="600"/>
               </a:spcAft>
@@ -19676,8 +20010,8 @@
         </p:blipFill>
         <p:spPr>
           <a:xfrm>
-            <a:off x="1114904" y="1298448"/>
-            <a:ext cx="4399591" cy="2092451"/>
+            <a:off x="411480" y="1298448"/>
+            <a:ext cx="5760720" cy="2788920"/>
           </a:xfrm>
           <a:prstGeom prst="rect">
             <a:avLst/>
@@ -19692,8 +20026,8 @@
         </p:nvSpPr>
         <p:spPr>
           <a:xfrm>
-            <a:off x="411480" y="3409187"/>
-            <a:ext cx="5806440" cy="559307"/>
+            <a:off x="411480" y="4105655"/>
+            <a:ext cx="5760720" cy="559307"/>
           </a:xfrm>
           <a:prstGeom prst="rect">
             <a:avLst/>
@@ -19718,7 +20052,7 @@
                 </a:solidFill>
                 <a:latin typeface="Arial"/>
               </a:rPr>
-              <a:t>The mirror rig from above with the LO arm in place: source arm red, LO arm purple (fiber tip at right, collimator at the reference flat's seat), test arm to the DM blue, camera leg green</a:t>
+              <a:t>The mirror rig from above, the whole LO leg in place: source arm red; LO leg purple, from the fiber tip (right) through the LO collimator at the reference flat's seat to the beamsplitter; test arm to the DM blue; camera leg green</a:t>
             </a:r>
           </a:p>
         </p:txBody>
@@ -19731,7 +20065,7 @@
         </p:nvSpPr>
         <p:spPr>
           <a:xfrm>
-            <a:off x="411480" y="4005072"/>
+            <a:off x="411480" y="4701539"/>
             <a:ext cx="5806440" cy="274320"/>
           </a:xfrm>
           <a:prstGeom prst="rect">
@@ -19829,7 +20163,7 @@
             </a:r>
           </a:p>
           <a:p>
-            <a:pPr>
+            <a:pPr marL="0" indent="0">
               <a:spcAft>
                 <a:spcPts val="600"/>
               </a:spcAft>
@@ -19880,8 +20214,8 @@
         </p:blipFill>
         <p:spPr>
           <a:xfrm>
-            <a:off x="8120752" y="1298448"/>
-            <a:ext cx="1955054" cy="2092451"/>
+            <a:off x="8291624" y="1298448"/>
+            <a:ext cx="1613311" cy="1726692"/>
           </a:xfrm>
           <a:prstGeom prst="rect">
             <a:avLst/>
@@ -19896,7 +20230,7 @@
         </p:nvSpPr>
         <p:spPr>
           <a:xfrm>
-            <a:off x="6400800" y="3409187"/>
+            <a:off x="6400800" y="3043428"/>
             <a:ext cx="5394960" cy="559307"/>
           </a:xfrm>
           <a:prstGeom prst="rect">
@@ -19935,7 +20269,7 @@
         </p:nvSpPr>
         <p:spPr>
           <a:xfrm>
-            <a:off x="6400800" y="4005072"/>
+            <a:off x="6400800" y="3639312"/>
             <a:ext cx="5394960" cy="274320"/>
           </a:xfrm>
           <a:prstGeom prst="rect">
@@ -19986,7 +20320,7 @@
                 </a:solidFill>
                 <a:latin typeface="Arial"/>
               </a:rPr>
-              <a:t>–  the geometric tail places the detector field by ray index, not camera position: per-index null 681 nm, by position 0.45 nm — the LO is placed by position</a:t>
+              <a:t>–  the tail places the detector field by ray index, not camera position (null 681 nm by index, 0.45 nm by position) — the LO is placed by position</a:t>
             </a:r>
           </a:p>
           <a:p>
@@ -20002,11 +20336,11 @@
                 </a:solidFill>
                 <a:latin typeface="Arial"/>
               </a:rPr>
-              <a:t>–  the plain mirror train had kept a source trim solved with the polarizer plate; without it OAP1 was fed off focus (84 nm of defocus) — now trimmed to zero</a:t>
-            </a:r>
-          </a:p>
-          <a:p>
-            <a:pPr>
+              <a:t>–  the plain mirror train had kept a source trim solved with the polarizer plate: OAP1 fed off focus (84 nm defocus) — now trimmed to zero</a:t>
+            </a:r>
+          </a:p>
+          <a:p>
+            <a:pPr marL="0" indent="0">
               <a:spcAft>
                 <a:spcPts val="600"/>
               </a:spcAft>
@@ -20036,7 +20370,7 @@
                 </a:solidFill>
                 <a:latin typeface="Arial"/>
               </a:rPr>
-              <a:t> the record's polarizing train and Feng's plain splitter read the same picometers (the camera is well-bound); the polarizing train costs light only (throughput 0.271 vs 0.408, ×1.5 laser).  The plain splitter is the layout scored.</a:t>
+              <a:t> the polarizing train and Feng's plain splitter read the same picometers (the camera is well-bound); the polarizing train costs light only (throughput 0.271 vs 0.408, ×1.5 laser).  The plain splitter is scored.</a:t>
             </a:r>
           </a:p>
         </p:txBody>
@@ -20049,7 +20383,7 @@
         </p:nvSpPr>
         <p:spPr>
           <a:xfrm>
-            <a:off x="6400800" y="6607810"/>
+            <a:off x="6400800" y="6068695"/>
             <a:ext cx="5394960" cy="274320"/>
           </a:xfrm>
           <a:prstGeom prst="rect">
@@ -20346,7 +20680,7 @@
                 </a:solidFill>
                 <a:latin typeface="Arial"/>
               </a:rPr>
-              <a:t>–  every real camera on the table samples finer (5–21 px per actuator, slide 10); what resolution buys and costs is slide 17</a:t>
+              <a:t>–  every real camera on the table samples finer (5–21 px per actuator, slide 10); what resolution buys and costs is slide 18</a:t>
             </a:r>
           </a:p>
         </p:txBody>

</xml_diff>

<commit_message>
deck_cophi: Dave's third pass folded (recommendations wording + the lock-in in the subtitle; the lock-in and electronics footnote blocks re-keyed to his text; two footnotes moved); edit copy synced
Co-Authored-By: Claude Fable 5.1 <noreply@anthropic.com>
</commit_message>
<xml_diff>
--- a/demo_session/deck_cophi.pptx
+++ b/demo_session/deck_cophi.pptx
@@ -10640,7 +10640,7 @@
         <p:spPr>
           <a:xfrm>
             <a:off x="457200" y="6446520"/>
-            <a:ext cx="11368735" cy="274320"/>
+            <a:ext cx="11365992" cy="274320"/>
           </a:xfrm>
           <a:prstGeom prst="rect">
             <a:avLst/>
@@ -10665,7 +10665,7 @@
                 </a:solidFill>
                 <a:latin typeface="Arial"/>
               </a:rPr>
-              <a:t>Camera timings: TO's records on an IMX250MZR-class polarization camera (2448 × 2048, 75 fps; well ~10 ke⁻, read 2.4 e⁻, unconfirmed).  The sensors run 10–40× slower than photons ÷ sensor rate would say: the ZWFS core sets the exposure, the frame mean sits at half well, two orientations go unused.  Parts counts and TRL to follow (campaign brief sec. 9.1).</a:t>
+              <a:t>Camera timings on an IMX250MZR-class polarization camera (2448 × 2048, 75 fps; well ~10 ke⁻, read 2.4 e⁻, unconfirmed).  The sensors run 10–40× slower than photons ÷ sensor rate would say: the ZWFS core sets the exposure, the frame mean sits at half well, two orientations go unused.  Parts counts and TRL to follow (campaign brief sec. 9.1).</a:t>
             </a:r>
           </a:p>
         </p:txBody>
@@ -13670,7 +13670,7 @@
                 </a:solidFill>
                 <a:latin typeface="Arial"/>
               </a:rPr>
-              <a:t>COPHI is a credible fifth gauge: it matches the IFO's floor, reads exactly, and captures from cold in one reading; its cost is the fiber and the LO, its speed is the camera's</a:t>
+              <a:t>COPHI is a credible fifth gauge: it matches the IFO's floor, reads exactly, and captures from cold in one reading; its cost is the fiber and the LO, its speed is set by the camera's frame rate, with the lock-in detector the clear winner</a:t>
             </a:r>
           </a:p>
         </p:txBody>
@@ -13762,7 +13762,7 @@
                 </a:solidFill>
                 <a:latin typeface="Arial"/>
               </a:rPr>
-              <a:t>Score it in the composite deck</a:t>
+              <a:t>Add COPHI to the DM Gauge plan</a:t>
             </a:r>
             <a:r>
               <a:rPr sz="1200" b="0">
@@ -13796,7 +13796,7 @@
                 </a:solidFill>
                 <a:latin typeface="Arial"/>
               </a:rPr>
-              <a:t>Price the plain splitter</a:t>
+              <a:t>Consider a swappable splitter</a:t>
             </a:r>
             <a:r>
               <a:rPr sz="1200" b="0">
@@ -13805,7 +13805,7 @@
                 </a:solidFill>
                 <a:latin typeface="Arial"/>
               </a:rPr>
-              <a:t> (Feng's layout); the record's polarizing train costs ×1.5 of laser and nothing else.</a:t>
+              <a:t> (Feng's layout); the current polarizing train costs ×1.5 of laser and nothing else.</a:t>
             </a:r>
           </a:p>
           <a:p>
@@ -13839,7 +13839,7 @@
                 </a:solidFill>
                 <a:latin typeface="Arial"/>
               </a:rPr>
-              <a:t> the Photonfocus-class 1k global-shutter part (42 s per pm, 3 pm held in 1.6 s cycles) over Feng's baseline (7 min, 16 s).</a:t>
+              <a:t> the Photonfocus-class 1k global-shutter part (42 s per pm, 3 pm held in 1.6 s cycles) over Feng's baseline (7 min, 16 s); the lock-in camera faster yet.</a:t>
             </a:r>
           </a:p>
           <a:p>
@@ -13914,7 +13914,7 @@
                 </a:solidFill>
                 <a:latin typeface="Arial"/>
               </a:rPr>
-              <a:t>Two colors from the start:</a:t>
+              <a:t>Implement two colors from the start:</a:t>
             </a:r>
             <a:r>
               <a:rPr sz="1200" b="0">
@@ -14014,7 +14014,7 @@
                 </a:solidFill>
                 <a:latin typeface="Arial"/>
               </a:rPr>
-              <a:t> the tail's chromatic refocus at Δλ = 20 nm (dispersive glass in the model); the LO referenced against the test arm's own flat; parts counts and TRL for all five gauges; Kent's ZWFS reconstruction when it arrives.</a:t>
+              <a:t> the tail's chromatic refocus at Δλ = 20 nm (dispersive glass in the model); the LO referenced against the test arm's own flat; parts counts and TRL for all five gauges; Kent's ZWFS reconstruction.</a:t>
             </a:r>
           </a:p>
         </p:txBody>
@@ -19011,7 +19011,7 @@
         </p:nvSpPr>
         <p:spPr>
           <a:xfrm>
-            <a:off x="420624" y="5166360"/>
+            <a:off x="420624" y="4846320"/>
             <a:ext cx="11338560" cy="274320"/>
           </a:xfrm>
           <a:prstGeom prst="rect">
@@ -19046,7 +19046,7 @@
                 </a:solidFill>
                 <a:latin typeface="Arial"/>
               </a:rPr>
-              <a:t>Even well-capped the lock-in is ~12× the Photonfocus and ~110× Feng's baseline.</a:t>
+              <a:t>The lock-in is ~12× the Photonfocus and ~110× Feng's baseline.</a:t>
             </a:r>
           </a:p>
           <a:p>
@@ -20383,8 +20383,8 @@
         </p:nvSpPr>
         <p:spPr>
           <a:xfrm>
-            <a:off x="6400800" y="6068695"/>
-            <a:ext cx="5394960" cy="274320"/>
+            <a:off x="457200" y="6172200"/>
+            <a:ext cx="11338560" cy="274320"/>
           </a:xfrm>
           <a:prstGeom prst="rect">
             <a:avLst/>

</xml_diff>

<commit_message>
deck_cophi slide 8: lens rig left, mirror rig right (both whole-train renders from above, the LO leg named in each caption); the node panel dropped; lens render = the record's (pre-label; re-render queued behind TO's MATLAB)
Co-Authored-By: Claude Fable 5.1 <noreply@anthropic.com>
</commit_message>
<xml_diff>
--- a/demo_session/deck_cophi.pptx
+++ b/demo_session/deck_cophi.pptx
@@ -19945,7 +19945,7 @@
                 </a:solidFill>
                 <a:latin typeface="Arial"/>
               </a:rPr>
-              <a:t>A fiber tip and collimator, its powered face at the reference flat's seat; it registers on both rigs to a pixel and the flat-DM null is sub-nanometer</a:t>
+              <a:t>A fiber tip and collimator, its powered face at the reference flat's seat, on both rigs; it registers to a pixel and the flat-DM null is sub-nanometer</a:t>
             </a:r>
           </a:p>
         </p:txBody>
@@ -19996,7 +19996,7 @@
       </p:sp>
       <p:pic>
         <p:nvPicPr>
-          <p:cNvPr id="4" name="Picture 3" descr="cophi_layout_oap.png"/>
+          <p:cNvPr id="4" name="Picture 3" descr="cophi_layout_lens.png"/>
           <p:cNvPicPr>
             <a:picLocks noChangeAspect="1"/>
           </p:cNvPicPr>
@@ -20011,7 +20011,7 @@
         <p:spPr>
           <a:xfrm>
             <a:off x="411480" y="1298448"/>
-            <a:ext cx="5760720" cy="2788920"/>
+            <a:ext cx="5806440" cy="2120878"/>
           </a:xfrm>
           <a:prstGeom prst="rect">
             <a:avLst/>
@@ -20026,8 +20026,8 @@
         </p:nvSpPr>
         <p:spPr>
           <a:xfrm>
-            <a:off x="411480" y="4105655"/>
-            <a:ext cx="5760720" cy="559307"/>
+            <a:off x="411480" y="3437614"/>
+            <a:ext cx="5806440" cy="559307"/>
           </a:xfrm>
           <a:prstGeom prst="rect">
             <a:avLst/>
@@ -20052,7 +20052,7 @@
                 </a:solidFill>
                 <a:latin typeface="Arial"/>
               </a:rPr>
-              <a:t>The mirror rig from above, the whole LO leg in place: source arm red; LO leg purple, from the fiber tip (right) through the LO collimator at the reference flat's seat to the beamsplitter; test arm to the DM blue; camera leg green</a:t>
+              <a:t>Lens rig from above: source arm red (fiber tip at left, collimator L1); LO leg purple, from its fiber tip (right) through the LO collimator at the reference flat's seat to the beamsplitter; test arm to the DM blue; camera leg green</a:t>
             </a:r>
           </a:p>
         </p:txBody>
@@ -20065,7 +20065,7 @@
         </p:nvSpPr>
         <p:spPr>
           <a:xfrm>
-            <a:off x="411480" y="4701539"/>
+            <a:off x="411480" y="4033498"/>
             <a:ext cx="5806440" cy="274320"/>
           </a:xfrm>
           <a:prstGeom prst="rect">
@@ -20200,7 +20200,7 @@
       </p:sp>
       <p:pic>
         <p:nvPicPr>
-          <p:cNvPr id="7" name="Picture 6" descr="cophi_layout_node.png"/>
+          <p:cNvPr id="7" name="Picture 6" descr="cophi_layout_oap.png"/>
           <p:cNvPicPr>
             <a:picLocks noChangeAspect="1"/>
           </p:cNvPicPr>
@@ -20214,8 +20214,8 @@
         </p:blipFill>
         <p:spPr>
           <a:xfrm>
-            <a:off x="8291624" y="1298448"/>
-            <a:ext cx="1613311" cy="1726692"/>
+            <a:off x="6802353" y="1298448"/>
+            <a:ext cx="4591853" cy="2183892"/>
           </a:xfrm>
           <a:prstGeom prst="rect">
             <a:avLst/>
@@ -20230,7 +20230,7 @@
         </p:nvSpPr>
         <p:spPr>
           <a:xfrm>
-            <a:off x="6400800" y="3043428"/>
+            <a:off x="6400800" y="3500628"/>
             <a:ext cx="5394960" cy="559307"/>
           </a:xfrm>
           <a:prstGeom prst="rect">
@@ -20256,7 +20256,7 @@
                 </a:solidFill>
                 <a:latin typeface="Arial"/>
               </a:rPr>
-              <a:t>The node: the beamsplitter and compensator, the LO entering where the reference flat's return did, the recombination into the camera leg (the record's polarizing elements shown; the plain-splitter train is scored)</a:t>
+              <a:t>Mirror rig from above: source arm red; LO leg purple, from its fiber tip (right) through the LO collimator at the reference flat's seat to the beamsplitter; test arm to the DM blue; camera leg green (OAP1 collimates, OAP2 focuses)</a:t>
             </a:r>
           </a:p>
         </p:txBody>
@@ -20269,7 +20269,7 @@
         </p:nvSpPr>
         <p:spPr>
           <a:xfrm>
-            <a:off x="6400800" y="3639312"/>
+            <a:off x="6400800" y="4096512"/>
             <a:ext cx="5394960" cy="274320"/>
           </a:xfrm>
           <a:prstGeom prst="rect">
@@ -20409,7 +20409,7 @@
                 </a:solidFill>
                 <a:latin typeface="Arial"/>
               </a:rPr>
-              <a:t>Stage bench (runs/bench_{lens,oap}; the layout = bench_oap_vlayout.png, the engine's own render), gate tCophiBench 9/9 (registration, poke 1.001 converged, LO tilt, no-fringe refused by name, dark camera refused).</a:t>
+              <a:t>Stage bench (runs/bench_{lens,oap}; the layouts = bench_{lens,oap}_vlayout.png, the engine's own renders), gate tCophiBench 9/9 (registration, poke 1.001 converged, LO tilt, no-fringe refused by name, dark camera refused).</a:t>
             </a:r>
           </a:p>
         </p:txBody>

</xml_diff>

<commit_message>
deck_cophi: Dave's fourth pass folded (the sweep 'is running now'; the lock-in as its own recommendation with 'verify all performance specs with the vendor'; the photons slide's right column narrowed); edit copy synced
Co-Authored-By: Claude Fable 5.1 <noreply@anthropic.com>
</commit_message>
<xml_diff>
--- a/demo_session/deck_cophi.pptx
+++ b/demo_session/deck_cophi.pptx
@@ -6665,8 +6665,8 @@
         </p:nvSpPr>
         <p:spPr>
           <a:xfrm>
-            <a:off x="6400800" y="1298448"/>
-            <a:ext cx="5394960" cy="274320"/>
+            <a:off x="7315200" y="1298448"/>
+            <a:ext cx="4480560" cy="274320"/>
           </a:xfrm>
           <a:prstGeom prst="rect">
             <a:avLst/>
@@ -6685,7 +6685,7 @@
               </a:spcAft>
             </a:pPr>
             <a:r>
-              <a:rPr sz="1200" b="0">
+              <a:rPr sz="1150" b="0">
                 <a:solidFill>
                   <a:srgbClr val="282828"/>
                 </a:solidFill>
@@ -6694,7 +6694,7 @@
               <a:t>•  </a:t>
             </a:r>
             <a:r>
-              <a:rPr sz="1200" b="1">
+              <a:rPr sz="1150" b="1">
                 <a:solidFill>
                   <a:srgbClr val="282828"/>
                 </a:solidFill>
@@ -6703,7 +6703,7 @@
               <a:t>Read noise is in every row</a:t>
             </a:r>
             <a:r>
-              <a:rPr sz="1200" b="0">
+              <a:rPr sz="1150" b="0">
                 <a:solidFill>
                   <a:srgbClr val="282828"/>
                 </a:solidFill>
@@ -6719,7 +6719,7 @@
               </a:spcAft>
             </a:pPr>
             <a:r>
-              <a:rPr sz="1050" b="0">
+              <a:rPr sz="1000" b="0">
                 <a:solidFill>
                   <a:srgbClr val="6E6E6E"/>
                 </a:solidFill>
@@ -6735,7 +6735,7 @@
               </a:spcAft>
             </a:pPr>
             <a:r>
-              <a:rPr sz="1200" b="0">
+              <a:rPr sz="1150" b="0">
                 <a:solidFill>
                   <a:srgbClr val="282828"/>
                 </a:solidFill>
@@ -6744,7 +6744,7 @@
               <a:t>•  </a:t>
             </a:r>
             <a:r>
-              <a:rPr sz="1200" b="1">
+              <a:rPr sz="1150" b="1">
                 <a:solidFill>
                   <a:srgbClr val="282828"/>
                 </a:solidFill>
@@ -6753,7 +6753,7 @@
               <a:t>SNR at the 1 pm target:</a:t>
             </a:r>
             <a:r>
-              <a:rPr sz="1200" b="0">
+              <a:rPr sz="1150" b="0">
                 <a:solidFill>
                   <a:srgbClr val="282828"/>
                 </a:solidFill>
@@ -6769,7 +6769,7 @@
               </a:spcAft>
             </a:pPr>
             <a:r>
-              <a:rPr sz="1050" b="0">
+              <a:rPr sz="1000" b="0">
                 <a:solidFill>
                   <a:srgbClr val="6E6E6E"/>
                 </a:solidFill>
@@ -6785,7 +6785,7 @@
               </a:spcAft>
             </a:pPr>
             <a:r>
-              <a:rPr sz="1200" b="0">
+              <a:rPr sz="1150" b="0">
                 <a:solidFill>
                   <a:srgbClr val="282828"/>
                 </a:solidFill>
@@ -6794,7 +6794,7 @@
               <a:t>•  </a:t>
             </a:r>
             <a:r>
-              <a:rPr sz="1200" b="1">
+              <a:rPr sz="1150" b="1">
                 <a:solidFill>
                   <a:srgbClr val="282828"/>
                 </a:solidFill>
@@ -6803,7 +6803,7 @@
               <a:t>Model and bench agree:</a:t>
             </a:r>
             <a:r>
-              <a:rPr sz="1200" b="0">
+              <a:rPr sz="1150" b="0">
                 <a:solidFill>
                   <a:srgbClr val="282828"/>
                 </a:solidFill>
@@ -6819,7 +6819,7 @@
               </a:spcAft>
             </a:pPr>
             <a:r>
-              <a:rPr sz="1200" b="0">
+              <a:rPr sz="1150" b="0">
                 <a:solidFill>
                   <a:srgbClr val="282828"/>
                 </a:solidFill>
@@ -6828,7 +6828,7 @@
               <a:t>•  </a:t>
             </a:r>
             <a:r>
-              <a:rPr sz="1200" b="1">
+              <a:rPr sz="1150" b="1">
                 <a:solidFill>
                   <a:srgbClr val="282828"/>
                 </a:solidFill>
@@ -6837,7 +6837,7 @@
               <a:t>Rolling-shutter cameras are out:</a:t>
             </a:r>
             <a:r>
-              <a:rPr sz="1200" b="0">
+              <a:rPr sz="1150" b="0">
                 <a:solidFill>
                   <a:srgbClr val="282828"/>
                 </a:solidFill>
@@ -6853,7 +6853,7 @@
               </a:spcAft>
             </a:pPr>
             <a:r>
-              <a:rPr sz="1200" b="0">
+              <a:rPr sz="1150" b="0">
                 <a:solidFill>
                   <a:srgbClr val="282828"/>
                 </a:solidFill>
@@ -6862,7 +6862,7 @@
               <a:t>•  </a:t>
             </a:r>
             <a:r>
-              <a:rPr sz="1200" b="1">
+              <a:rPr sz="1150" b="1">
                 <a:solidFill>
                   <a:srgbClr val="282828"/>
                 </a:solidFill>
@@ -6871,7 +6871,7 @@
               <a:t>Why the camera, not the pixel count:</a:t>
             </a:r>
             <a:r>
-              <a:rPr sz="1200" b="0">
+              <a:rPr sz="1150" b="0">
                 <a:solidFill>
                   <a:srgbClr val="282828"/>
                 </a:solidFill>
@@ -6890,8 +6890,8 @@
         </p:nvSpPr>
         <p:spPr>
           <a:xfrm>
-            <a:off x="6400800" y="5361940"/>
-            <a:ext cx="5394960" cy="274320"/>
+            <a:off x="7315200" y="5358384"/>
+            <a:ext cx="4480560" cy="274320"/>
           </a:xfrm>
           <a:prstGeom prst="rect">
             <a:avLst/>
@@ -11964,7 +11964,7 @@
                 </a:solidFill>
                 <a:latin typeface="Arial"/>
               </a:rPr>
-              <a:t>a per-gauge sweep at 1, 1.5, 2 and 4 px per actuator is a one-day format run — the item that turns this table into records</a:t>
+              <a:t>a per-gauge sweep at 1, 1.5, 2 and 4 px per actuator is running now</a:t>
             </a:r>
           </a:p>
           <a:p>
@@ -13859,6 +13859,40 @@
             </a:r>
           </a:p>
           <a:p>
+            <a:pPr marL="0" indent="0">
+              <a:spcAft>
+                <a:spcPts val="600"/>
+              </a:spcAft>
+            </a:pPr>
+            <a:r>
+              <a:rPr sz="1200" b="0">
+                <a:solidFill>
+                  <a:srgbClr val="282828"/>
+                </a:solidFill>
+                <a:latin typeface="Arial"/>
+              </a:rPr>
+              <a:t>•  </a:t>
+            </a:r>
+            <a:r>
+              <a:rPr sz="1200" b="1">
+                <a:solidFill>
+                  <a:srgbClr val="282828"/>
+                </a:solidFill>
+                <a:latin typeface="Arial"/>
+              </a:rPr>
+              <a:t>The lock-in camera is the fast form:</a:t>
+            </a:r>
+            <a:r>
+              <a:rPr sz="1200" b="0">
+                <a:solidFill>
+                  <a:srgbClr val="282828"/>
+                </a:solidFill>
+                <a:latin typeface="Arial"/>
+              </a:rPr>
+              <a:t> 3.4 s per pm as surveyed, 0.125 s cycles.</a:t>
+            </a:r>
+          </a:p>
+          <a:p>
             <a:pPr marL="594360" indent="-137160">
               <a:spcAft>
                 <a:spcPts val="500"/>
@@ -13871,25 +13905,7 @@
                 </a:solidFill>
                 <a:latin typeface="Arial"/>
               </a:rPr>
-              <a:t>–  </a:t>
-            </a:r>
-            <a:r>
-              <a:rPr sz="1050" b="1">
-                <a:solidFill>
-                  <a:srgbClr val="6E6E6E"/>
-                </a:solidFill>
-                <a:latin typeface="Arial"/>
-              </a:rPr>
-              <a:t>the lock-in camera is the fast form</a:t>
-            </a:r>
-            <a:r>
-              <a:rPr sz="1050" b="0">
-                <a:solidFill>
-                  <a:srgbClr val="6E6E6E"/>
-                </a:solidFill>
-                <a:latin typeface="Arial"/>
-              </a:rPr>
-              <a:t> (3.4 s per pm as surveyed, 0.125 s cycles) — one vendor question from a number</a:t>
+              <a:t>–  verify all performance specs with the vendor</a:t>
             </a:r>
           </a:p>
           <a:p>

</xml_diff>

<commit_message>
deck_cophi: slide 18 now carries TO's resolution sweep (records + composite figure: 1 px fails, 1.5-2 px cost 1.6-2x the time, >= 3.3 unchanged, registration to 0.03 pitch at any sampling); the lock-in pixel's two-tap square-wave demodulation named (Feng) with the factor stated in sigma AND time (x1.11 / x1.23); DRAFT_email_feng_lockin
Co-Authored-By: Claude Fable 5.1 <noreply@anthropic.com>
</commit_message>
<xml_diff>
--- a/demo_session/deck_cophi.pptx
+++ b/demo_session/deck_cophi.pptx
@@ -4364,7 +4364,7 @@
                 </a:solidFill>
                 <a:latin typeface="Arial"/>
               </a:rPr>
-              <a:t>–  below ~1.5 px per actuator the actuator fit collapses (the blur demo's box kernel) — 5 px per actuator is the floor on this table</a:t>
+              <a:t>–  measured (slide 18): 1 px per actuator fails the single-actuator row, 1.5–2 px holds at 1.6–2× the time, 3.3 and 4 are the same — 5 px per actuator is the floor on this table</a:t>
             </a:r>
           </a:p>
           <a:p>
@@ -5760,7 +5760,7 @@
         </p:nvGraphicFramePr>
         <p:xfrm>
           <a:off x="411480" y="1298448"/>
-          <a:ext cx="5806438" cy="4320540"/>
+          <a:ext cx="5806438" cy="4509135"/>
         </p:xfrm>
         <a:graphic>
           <a:graphicData uri="http://schemas.openxmlformats.org/drawingml/2006/table">
@@ -5769,11 +5769,11 @@
                 <a:tableStyleId>{5C22544A-7EE6-4342-B048-85BDC9FD1C3A}</a:tableStyleId>
               </a:tblPr>
               <a:tblGrid>
-                <a:gridCol w="1471460"/>
-                <a:gridCol w="1010520"/>
-                <a:gridCol w="868693"/>
-                <a:gridCol w="407754"/>
-                <a:gridCol w="957335"/>
+                <a:gridCol w="1363792"/>
+                <a:gridCol w="936580"/>
+                <a:gridCol w="805130"/>
+                <a:gridCol w="377918"/>
+                <a:gridCol w="1232342"/>
                 <a:gridCol w="1090676"/>
               </a:tblGrid>
               <a:tr h="1034415">
@@ -6044,7 +6044,7 @@
                   </a:tcPr>
                 </a:tc>
               </a:tr>
-              <a:tr h="468630">
+              <a:tr h="657225">
                 <a:tc>
                   <a:txBody>
                     <a:bodyPr wrap="square"/>
@@ -6547,7 +6547,7 @@
                           </a:solidFill>
                           <a:latin typeface="Arial"/>
                         </a:rPr>
-                        <a:t>3.73 / 3.35 (4.4 / 4.0 at read 100; ×1.11 square-wave)</a:t>
+                        <a:t>3.73 / 3.35 (4.4 / 4.0 at read 100; ×1.23 in time for two-tap demodulation)</a:t>
                       </a:r>
                     </a:p>
                   </a:txBody>
@@ -6592,7 +6592,7 @@
         </p:nvSpPr>
         <p:spPr>
           <a:xfrm>
-            <a:off x="411480" y="5765292"/>
+            <a:off x="411480" y="5953887"/>
             <a:ext cx="5806440" cy="274320"/>
           </a:xfrm>
           <a:prstGeom prst="rect">
@@ -10722,7 +10722,7 @@
                 </a:solidFill>
                 <a:latin typeface="Arial"/>
               </a:rPr>
-              <a:t>How much resolution? IFO, vector ZWFS, HET</a:t>
+              <a:t>How much resolution? IFO, vector ZWFS, HET — the sweep's records</a:t>
             </a:r>
           </a:p>
           <a:p>
@@ -10738,7 +10738,7 @@
                 </a:solidFill>
                 <a:latin typeface="Arial"/>
               </a:rPr>
-              <a:t>Pixels per actuator above ~2 are free in photons and hold, cost data and processing, and buy the single-actuator scale; between 1 and 1.5 the actuator fit collapses; the three approaches pay differently</a:t>
+              <a:t>Camera pixels per actuator swept at 1 / 1.5 / 2 / 3.3 / 4 for all six readings, the matrix measured through the resampled reading: 1 px fails the single-actuator row, 1.5–2 px cost 1.6–2× the time, above 3.3 nothing changes</a:t>
             </a:r>
           </a:p>
         </p:txBody>
@@ -10787,1106 +10787,30 @@
           </a:p>
         </p:txBody>
       </p:sp>
-      <p:graphicFrame>
-        <p:nvGraphicFramePr>
-          <p:cNvPr id="4" name="Table 3"/>
-          <p:cNvGraphicFramePr>
-            <a:graphicFrameLocks noGrp="1"/>
-          </p:cNvGraphicFramePr>
+      <p:pic>
+        <p:nvPicPr>
+          <p:cNvPr id="4" name="Picture 3" descr="cophi_ressweep_composite.png"/>
+          <p:cNvPicPr>
+            <a:picLocks noChangeAspect="1"/>
+          </p:cNvPicPr>
           <p:nvPr/>
-        </p:nvGraphicFramePr>
-        <p:xfrm>
-          <a:off x="411480" y="1298448"/>
-          <a:ext cx="11368731" cy="2811780"/>
-        </p:xfrm>
-        <a:graphic>
-          <a:graphicData uri="http://schemas.openxmlformats.org/drawingml/2006/table">
-            <a:tbl>
-              <a:tblPr firstRow="1" bandRow="1">
-                <a:tableStyleId>{5C22544A-7EE6-4342-B048-85BDC9FD1C3A}</a:tableStyleId>
-              </a:tblPr>
-              <a:tblGrid>
-                <a:gridCol w="598354"/>
-                <a:gridCol w="3669907"/>
-                <a:gridCol w="917476"/>
-                <a:gridCol w="877586"/>
-                <a:gridCol w="1874844"/>
-                <a:gridCol w="1196708"/>
-                <a:gridCol w="1116928"/>
-                <a:gridCol w="1116928"/>
-              </a:tblGrid>
-              <a:tr h="468630">
-                <a:tc>
-                  <a:txBody>
-                    <a:bodyPr wrap="square"/>
-                    <a:lstStyle/>
-                    <a:p>
-                      <a:r>
-                        <a:rPr sz="1100" b="1">
-                          <a:solidFill>
-                            <a:srgbClr val="FFFFFF"/>
-                          </a:solidFill>
-                          <a:latin typeface="Arial"/>
-                        </a:rPr>
-                        <a:t>px per actuator</a:t>
-                      </a:r>
-                    </a:p>
-                  </a:txBody>
-                  <a:tcPr marL="54864" marR="54864" marT="18288" marB="18288">
-                    <a:solidFill>
-                      <a:srgbClr val="1F4E79"/>
-                    </a:solidFill>
-                  </a:tcPr>
-                </a:tc>
-                <a:tc>
-                  <a:txBody>
-                    <a:bodyPr wrap="square"/>
-                    <a:lstStyle/>
-                    <a:p>
-                      <a:r>
-                        <a:rPr sz="1100" b="1">
-                          <a:solidFill>
-                            <a:srgbClr val="FFFFFF"/>
-                          </a:solidFill>
-                          <a:latin typeface="Arial"/>
-                        </a:rPr>
-                        <a:t>the fit</a:t>
-                      </a:r>
-                    </a:p>
-                  </a:txBody>
-                  <a:tcPr marL="54864" marR="54864" marT="18288" marB="18288">
-                    <a:solidFill>
-                      <a:srgbClr val="1F4E79"/>
-                    </a:solidFill>
-                  </a:tcPr>
-                </a:tc>
-                <a:tc>
-                  <a:txBody>
-                    <a:bodyPr wrap="square"/>
-                    <a:lstStyle/>
-                    <a:p>
-                      <a:r>
-                        <a:rPr sz="1100" b="1">
-                          <a:solidFill>
-                            <a:srgbClr val="FFFFFF"/>
-                          </a:solidFill>
-                          <a:latin typeface="Arial"/>
-                        </a:rPr>
-                        <a:t>hold at 3 pm</a:t>
-                      </a:r>
-                    </a:p>
-                  </a:txBody>
-                  <a:tcPr marL="54864" marR="54864" marT="18288" marB="18288">
-                    <a:solidFill>
-                      <a:srgbClr val="1F4E79"/>
-                    </a:solidFill>
-                  </a:tcPr>
-                </a:tc>
-                <a:tc>
-                  <a:txBody>
-                    <a:bodyPr wrap="square"/>
-                    <a:lstStyle/>
-                    <a:p>
-                      <a:r>
-                        <a:rPr sz="1100" b="1">
-                          <a:solidFill>
-                            <a:srgbClr val="FFFFFF"/>
-                          </a:solidFill>
-                          <a:latin typeface="Arial"/>
-                        </a:rPr>
-                        <a:t>speed, s per pm</a:t>
-                      </a:r>
-                    </a:p>
-                  </a:txBody>
-                  <a:tcPr marL="54864" marR="54864" marT="18288" marB="18288">
-                    <a:solidFill>
-                      <a:srgbClr val="1F4E79"/>
-                    </a:solidFill>
-                  </a:tcPr>
-                </a:tc>
-                <a:tc>
-                  <a:txBody>
-                    <a:bodyPr wrap="square"/>
-                    <a:lstStyle/>
-                    <a:p>
-                      <a:r>
-                        <a:rPr sz="1100" b="1">
-                          <a:solidFill>
-                            <a:srgbClr val="FFFFFF"/>
-                          </a:solidFill>
-                          <a:latin typeface="Arial"/>
-                        </a:rPr>
-                        <a:t>complexity</a:t>
-                      </a:r>
-                    </a:p>
-                  </a:txBody>
-                  <a:tcPr marL="54864" marR="54864" marT="18288" marB="18288">
-                    <a:solidFill>
-                      <a:srgbClr val="1F4E79"/>
-                    </a:solidFill>
-                  </a:tcPr>
-                </a:tc>
-                <a:tc>
-                  <a:txBody>
-                    <a:bodyPr wrap="square"/>
-                    <a:lstStyle/>
-                    <a:p>
-                      <a:r>
-                        <a:rPr sz="1100" b="1">
-                          <a:solidFill>
-                            <a:srgbClr val="FFFFFF"/>
-                          </a:solidFill>
-                          <a:latin typeface="Arial"/>
-                        </a:rPr>
-                        <a:t>IFO (pol. camera)</a:t>
-                      </a:r>
-                    </a:p>
-                  </a:txBody>
-                  <a:tcPr marL="54864" marR="54864" marT="18288" marB="18288">
-                    <a:solidFill>
-                      <a:srgbClr val="1F4E79"/>
-                    </a:solidFill>
-                  </a:tcPr>
-                </a:tc>
-                <a:tc>
-                  <a:txBody>
-                    <a:bodyPr wrap="square"/>
-                    <a:lstStyle/>
-                    <a:p>
-                      <a:r>
-                        <a:rPr sz="1100" b="1">
-                          <a:solidFill>
-                            <a:srgbClr val="FFFFFF"/>
-                          </a:solidFill>
-                          <a:latin typeface="Arial"/>
-                        </a:rPr>
-                        <a:t>vector ZWFS (pol. camera)</a:t>
-                      </a:r>
-                    </a:p>
-                  </a:txBody>
-                  <a:tcPr marL="54864" marR="54864" marT="18288" marB="18288">
-                    <a:solidFill>
-                      <a:srgbClr val="1F4E79"/>
-                    </a:solidFill>
-                  </a:tcPr>
-                </a:tc>
-                <a:tc>
-                  <a:txBody>
-                    <a:bodyPr wrap="square"/>
-                    <a:lstStyle/>
-                    <a:p>
-                      <a:r>
-                        <a:rPr sz="1100" b="1">
-                          <a:solidFill>
-                            <a:srgbClr val="FFFFFF"/>
-                          </a:solidFill>
-                          <a:latin typeface="Arial"/>
-                        </a:rPr>
-                        <a:t>HET camera / lock-in</a:t>
-                      </a:r>
-                    </a:p>
-                  </a:txBody>
-                  <a:tcPr marL="54864" marR="54864" marT="18288" marB="18288">
-                    <a:solidFill>
-                      <a:srgbClr val="1F4E79"/>
-                    </a:solidFill>
-                  </a:tcPr>
-                </a:tc>
-              </a:tr>
-              <a:tr h="468630">
-                <a:tc>
-                  <a:txBody>
-                    <a:bodyPr wrap="square"/>
-                    <a:lstStyle/>
-                    <a:p>
-                      <a:r>
-                        <a:rPr sz="1100" b="0">
-                          <a:solidFill>
-                            <a:srgbClr val="282828"/>
-                          </a:solidFill>
-                          <a:latin typeface="Arial"/>
-                        </a:rPr>
-                        <a:t>&lt; 1</a:t>
-                      </a:r>
-                    </a:p>
-                  </a:txBody>
-                  <a:tcPr marL="54864" marR="54864" marT="18288" marB="18288">
-                    <a:solidFill>
-                      <a:srgbClr val="FFFFFF"/>
-                    </a:solidFill>
-                  </a:tcPr>
-                </a:tc>
-                <a:tc>
-                  <a:txBody>
-                    <a:bodyPr wrap="square"/>
-                    <a:lstStyle/>
-                    <a:p>
-                      <a:r>
-                        <a:rPr sz="1100" b="0">
-                          <a:solidFill>
-                            <a:srgbClr val="282828"/>
-                          </a:solidFill>
-                          <a:latin typeface="Arial"/>
-                        </a:rPr>
-                        <a:t>modes only</a:t>
-                      </a:r>
-                    </a:p>
-                  </a:txBody>
-                  <a:tcPr marL="54864" marR="54864" marT="18288" marB="18288">
-                    <a:solidFill>
-                      <a:srgbClr val="FFFFFF"/>
-                    </a:solidFill>
-                  </a:tcPr>
-                </a:tc>
-                <a:tc>
-                  <a:txBody>
-                    <a:bodyPr wrap="square"/>
-                    <a:lstStyle/>
-                    <a:p>
-                      <a:r>
-                        <a:rPr sz="1100" b="0">
-                          <a:solidFill>
-                            <a:srgbClr val="282828"/>
-                          </a:solidFill>
-                          <a:latin typeface="Arial"/>
-                        </a:rPr>
-                        <a:t>—</a:t>
-                      </a:r>
-                    </a:p>
-                  </a:txBody>
-                  <a:tcPr marL="54864" marR="54864" marT="18288" marB="18288">
-                    <a:solidFill>
-                      <a:srgbClr val="FFFFFF"/>
-                    </a:solidFill>
-                  </a:tcPr>
-                </a:tc>
-                <a:tc>
-                  <a:txBody>
-                    <a:bodyPr wrap="square"/>
-                    <a:lstStyle/>
-                    <a:p>
-                      <a:r>
-                        <a:rPr sz="1100" b="0">
-                          <a:solidFill>
-                            <a:srgbClr val="282828"/>
-                          </a:solidFill>
-                          <a:latin typeface="Arial"/>
-                        </a:rPr>
-                        <a:t>—</a:t>
-                      </a:r>
-                    </a:p>
-                  </a:txBody>
-                  <a:tcPr marL="54864" marR="54864" marT="18288" marB="18288">
-                    <a:solidFill>
-                      <a:srgbClr val="FFFFFF"/>
-                    </a:solidFill>
-                  </a:tcPr>
-                </a:tc>
-                <a:tc>
-                  <a:txBody>
-                    <a:bodyPr wrap="square"/>
-                    <a:lstStyle/>
-                    <a:p>
-                      <a:r>
-                        <a:rPr sz="1100" b="0">
-                          <a:solidFill>
-                            <a:srgbClr val="282828"/>
-                          </a:solidFill>
-                          <a:latin typeface="Arial"/>
-                        </a:rPr>
-                        <a:t>least</a:t>
-                      </a:r>
-                    </a:p>
-                  </a:txBody>
-                  <a:tcPr marL="54864" marR="54864" marT="18288" marB="18288">
-                    <a:solidFill>
-                      <a:srgbClr val="FFFFFF"/>
-                    </a:solidFill>
-                  </a:tcPr>
-                </a:tc>
-                <a:tc>
-                  <a:txBody>
-                    <a:bodyPr wrap="square"/>
-                    <a:lstStyle/>
-                    <a:p>
-                      <a:r>
-                        <a:rPr sz="1100" b="0">
-                          <a:solidFill>
-                            <a:srgbClr val="282828"/>
-                          </a:solidFill>
-                          <a:latin typeface="Arial"/>
-                        </a:rPr>
-                        <a:t>not a gauge</a:t>
-                      </a:r>
-                    </a:p>
-                  </a:txBody>
-                  <a:tcPr marL="54864" marR="54864" marT="18288" marB="18288">
-                    <a:solidFill>
-                      <a:srgbClr val="FFFFFF"/>
-                    </a:solidFill>
-                  </a:tcPr>
-                </a:tc>
-                <a:tc>
-                  <a:txBody>
-                    <a:bodyPr wrap="square"/>
-                    <a:lstStyle/>
-                    <a:p>
-                      <a:r>
-                        <a:rPr sz="1100" b="0">
-                          <a:solidFill>
-                            <a:srgbClr val="282828"/>
-                          </a:solidFill>
-                          <a:latin typeface="Arial"/>
-                        </a:rPr>
-                        <a:t>not a gauge</a:t>
-                      </a:r>
-                    </a:p>
-                  </a:txBody>
-                  <a:tcPr marL="54864" marR="54864" marT="18288" marB="18288">
-                    <a:solidFill>
-                      <a:srgbClr val="FFFFFF"/>
-                    </a:solidFill>
-                  </a:tcPr>
-                </a:tc>
-                <a:tc>
-                  <a:txBody>
-                    <a:bodyPr wrap="square"/>
-                    <a:lstStyle/>
-                    <a:p>
-                      <a:r>
-                        <a:rPr sz="1100" b="0">
-                          <a:solidFill>
-                            <a:srgbClr val="282828"/>
-                          </a:solidFill>
-                          <a:latin typeface="Arial"/>
-                        </a:rPr>
-                        <a:t>not modeled (ruling 6)</a:t>
-                      </a:r>
-                    </a:p>
-                  </a:txBody>
-                  <a:tcPr marL="54864" marR="54864" marT="18288" marB="18288">
-                    <a:solidFill>
-                      <a:srgbClr val="FFFFFF"/>
-                    </a:solidFill>
-                  </a:tcPr>
-                </a:tc>
-              </a:tr>
-              <a:tr h="468630">
-                <a:tc>
-                  <a:txBody>
-                    <a:bodyPr wrap="square"/>
-                    <a:lstStyle/>
-                    <a:p>
-                      <a:r>
-                        <a:rPr sz="1100" b="0">
-                          <a:solidFill>
-                            <a:srgbClr val="282828"/>
-                          </a:solidFill>
-                          <a:latin typeface="Arial"/>
-                        </a:rPr>
-                        <a:t>1 – 1.5</a:t>
-                      </a:r>
-                    </a:p>
-                  </a:txBody>
-                  <a:tcPr marL="54864" marR="54864" marT="18288" marB="18288">
-                    <a:solidFill>
-                      <a:srgbClr val="ECF1F6"/>
-                    </a:solidFill>
-                  </a:tcPr>
-                </a:tc>
-                <a:tc>
-                  <a:txBody>
-                    <a:bodyPr wrap="square"/>
-                    <a:lstStyle/>
-                    <a:p>
-                      <a:r>
-                        <a:rPr sz="1100" b="0">
-                          <a:solidFill>
-                            <a:srgbClr val="282828"/>
-                          </a:solidFill>
-                          <a:latin typeface="Arial"/>
-                        </a:rPr>
-                        <a:t>collapses (fewer readings than lit actuators; a registration error reads the wrong actuator)</a:t>
-                      </a:r>
-                    </a:p>
-                  </a:txBody>
-                  <a:tcPr marL="54864" marR="54864" marT="18288" marB="18288">
-                    <a:solidFill>
-                      <a:srgbClr val="ECF1F6"/>
-                    </a:solidFill>
-                  </a:tcPr>
-                </a:tc>
-                <a:tc>
-                  <a:txBody>
-                    <a:bodyPr wrap="square"/>
-                    <a:lstStyle/>
-                    <a:p>
-                      <a:r>
-                        <a:rPr sz="1100" b="0">
-                          <a:solidFill>
-                            <a:srgbClr val="282828"/>
-                          </a:solidFill>
-                          <a:latin typeface="Arial"/>
-                        </a:rPr>
-                        <a:t>fails</a:t>
-                      </a:r>
-                    </a:p>
-                  </a:txBody>
-                  <a:tcPr marL="54864" marR="54864" marT="18288" marB="18288">
-                    <a:solidFill>
-                      <a:srgbClr val="ECF1F6"/>
-                    </a:solidFill>
-                  </a:tcPr>
-                </a:tc>
-                <a:tc>
-                  <a:txBody>
-                    <a:bodyPr wrap="square"/>
-                    <a:lstStyle/>
-                    <a:p>
-                      <a:r>
-                        <a:rPr sz="1100" b="0">
-                          <a:solidFill>
-                            <a:srgbClr val="282828"/>
-                          </a:solidFill>
-                          <a:latin typeface="Arial"/>
-                        </a:rPr>
-                        <a:t>—</a:t>
-                      </a:r>
-                    </a:p>
-                  </a:txBody>
-                  <a:tcPr marL="54864" marR="54864" marT="18288" marB="18288">
-                    <a:solidFill>
-                      <a:srgbClr val="ECF1F6"/>
-                    </a:solidFill>
-                  </a:tcPr>
-                </a:tc>
-                <a:tc>
-                  <a:txBody>
-                    <a:bodyPr wrap="square"/>
-                    <a:lstStyle/>
-                    <a:p>
-                      <a:r>
-                        <a:rPr sz="1100" b="0">
-                          <a:solidFill>
-                            <a:srgbClr val="282828"/>
-                          </a:solidFill>
-                          <a:latin typeface="Arial"/>
-                        </a:rPr>
-                        <a:t>—</a:t>
-                      </a:r>
-                    </a:p>
-                  </a:txBody>
-                  <a:tcPr marL="54864" marR="54864" marT="18288" marB="18288">
-                    <a:solidFill>
-                      <a:srgbClr val="ECF1F6"/>
-                    </a:solidFill>
-                  </a:tcPr>
-                </a:tc>
-                <a:tc>
-                  <a:txBody>
-                    <a:bodyPr wrap="square"/>
-                    <a:lstStyle/>
-                    <a:p>
-                      <a:r>
-                        <a:rPr sz="1100" b="0">
-                          <a:solidFill>
-                            <a:srgbClr val="282828"/>
-                          </a:solidFill>
-                          <a:latin typeface="Arial"/>
-                        </a:rPr>
-                        <a:t>blur demo: box-kernel collapse</a:t>
-                      </a:r>
-                    </a:p>
-                  </a:txBody>
-                  <a:tcPr marL="54864" marR="54864" marT="18288" marB="18288">
-                    <a:solidFill>
-                      <a:srgbClr val="ECF1F6"/>
-                    </a:solidFill>
-                  </a:tcPr>
-                </a:tc>
-                <a:tc>
-                  <a:txBody>
-                    <a:bodyPr wrap="square"/>
-                    <a:lstStyle/>
-                    <a:p>
-                      <a:r>
-                        <a:rPr sz="1100" b="0">
-                          <a:solidFill>
-                            <a:srgbClr val="282828"/>
-                          </a:solidFill>
-                          <a:latin typeface="Arial"/>
-                        </a:rPr>
-                        <a:t>same</a:t>
-                      </a:r>
-                    </a:p>
-                  </a:txBody>
-                  <a:tcPr marL="54864" marR="54864" marT="18288" marB="18288">
-                    <a:solidFill>
-                      <a:srgbClr val="ECF1F6"/>
-                    </a:solidFill>
-                  </a:tcPr>
-                </a:tc>
-                <a:tc>
-                  <a:txBody>
-                    <a:bodyPr wrap="square"/>
-                    <a:lstStyle/>
-                    <a:p>
-                      <a:r>
-                        <a:rPr sz="1100" b="0">
-                          <a:solidFill>
-                            <a:srgbClr val="282828"/>
-                          </a:solidFill>
-                          <a:latin typeface="Arial"/>
-                        </a:rPr>
-                        <a:t>same</a:t>
-                      </a:r>
-                    </a:p>
-                  </a:txBody>
-                  <a:tcPr marL="54864" marR="54864" marT="18288" marB="18288">
-                    <a:solidFill>
-                      <a:srgbClr val="ECF1F6"/>
-                    </a:solidFill>
-                  </a:tcPr>
-                </a:tc>
-              </a:tr>
-              <a:tr h="468630">
-                <a:tc>
-                  <a:txBody>
-                    <a:bodyPr wrap="square"/>
-                    <a:lstStyle/>
-                    <a:p>
-                      <a:r>
-                        <a:rPr sz="1100" b="0">
-                          <a:solidFill>
-                            <a:srgbClr val="282828"/>
-                          </a:solidFill>
-                          <a:latin typeface="Arial"/>
-                        </a:rPr>
-                        <a:t>~2</a:t>
-                      </a:r>
-                    </a:p>
-                  </a:txBody>
-                  <a:tcPr marL="54864" marR="54864" marT="18288" marB="18288">
-                    <a:solidFill>
-                      <a:srgbClr val="FFFFFF"/>
-                    </a:solidFill>
-                  </a:tcPr>
-                </a:tc>
-                <a:tc>
-                  <a:txBody>
-                    <a:bodyPr wrap="square"/>
-                    <a:lstStyle/>
-                    <a:p>
-                      <a:r>
-                        <a:rPr sz="1100" b="0">
-                          <a:solidFill>
-                            <a:srgbClr val="282828"/>
-                          </a:solidFill>
-                          <a:latin typeface="Arial"/>
-                        </a:rPr>
-                        <a:t>complete; blur and registration absorbed by the matrix measured on the surface</a:t>
-                      </a:r>
-                    </a:p>
-                  </a:txBody>
-                  <a:tcPr marL="54864" marR="54864" marT="18288" marB="18288">
-                    <a:solidFill>
-                      <a:srgbClr val="FFFFFF"/>
-                    </a:solidFill>
-                  </a:tcPr>
-                </a:tc>
-                <a:tc>
-                  <a:txBody>
-                    <a:bodyPr wrap="square"/>
-                    <a:lstStyle/>
-                    <a:p>
-                      <a:r>
-                        <a:rPr sz="1100" b="0">
-                          <a:solidFill>
-                            <a:srgbClr val="282828"/>
-                          </a:solidFill>
-                          <a:latin typeface="Arial"/>
-                        </a:rPr>
-                        <a:t>held (records at 3.3–4)</a:t>
-                      </a:r>
-                    </a:p>
-                  </a:txBody>
-                  <a:tcPr marL="54864" marR="54864" marT="18288" marB="18288">
-                    <a:solidFill>
-                      <a:srgbClr val="FFFFFF"/>
-                    </a:solidFill>
-                  </a:tcPr>
-                </a:tc>
-                <a:tc>
-                  <a:txBody>
-                    <a:bodyPr wrap="square"/>
-                    <a:lstStyle/>
-                    <a:p>
-                      <a:r>
-                        <a:rPr sz="1100" b="0">
-                          <a:solidFill>
-                            <a:srgbClr val="282828"/>
-                          </a:solidFill>
-                          <a:latin typeface="Arial"/>
-                        </a:rPr>
-                        <a:t>unchanged (well-bound)</a:t>
-                      </a:r>
-                    </a:p>
-                  </a:txBody>
-                  <a:tcPr marL="54864" marR="54864" marT="18288" marB="18288">
-                    <a:solidFill>
-                      <a:srgbClr val="FFFFFF"/>
-                    </a:solidFill>
-                  </a:tcPr>
-                </a:tc>
-                <a:tc>
-                  <a:txBody>
-                    <a:bodyPr wrap="square"/>
-                    <a:lstStyle/>
-                    <a:p>
-                      <a:r>
-                        <a:rPr sz="1100" b="0">
-                          <a:solidFill>
-                            <a:srgbClr val="282828"/>
-                          </a:solidFill>
-                          <a:latin typeface="Arial"/>
-                        </a:rPr>
-                        <a:t>0.04 Mpx</a:t>
-                      </a:r>
-                    </a:p>
-                  </a:txBody>
-                  <a:tcPr marL="54864" marR="54864" marT="18288" marB="18288">
-                    <a:solidFill>
-                      <a:srgbClr val="FFFFFF"/>
-                    </a:solidFill>
-                  </a:tcPr>
-                </a:tc>
-                <a:tc>
-                  <a:txBody>
-                    <a:bodyPr wrap="square"/>
-                    <a:lstStyle/>
-                    <a:p>
-                      <a:r>
-                        <a:rPr sz="1100" b="0">
-                          <a:solidFill>
-                            <a:srgbClr val="282828"/>
-                          </a:solidFill>
-                          <a:latin typeface="Arial"/>
-                        </a:rPr>
-                        <a:t>2 pm floor (record, 4 px)</a:t>
-                      </a:r>
-                    </a:p>
-                  </a:txBody>
-                  <a:tcPr marL="54864" marR="54864" marT="18288" marB="18288">
-                    <a:solidFill>
-                      <a:srgbClr val="FFFFFF"/>
-                    </a:solidFill>
-                  </a:tcPr>
-                </a:tc>
-                <a:tc>
-                  <a:txBody>
-                    <a:bodyPr wrap="square"/>
-                    <a:lstStyle/>
-                    <a:p>
-                      <a:r>
-                        <a:rPr sz="1100" b="0">
-                          <a:solidFill>
-                            <a:srgbClr val="282828"/>
-                          </a:solidFill>
-                          <a:latin typeface="Arial"/>
-                        </a:rPr>
-                        <a:t>2 pm floor (record)</a:t>
-                      </a:r>
-                    </a:p>
-                  </a:txBody>
-                  <a:tcPr marL="54864" marR="54864" marT="18288" marB="18288">
-                    <a:solidFill>
-                      <a:srgbClr val="FFFFFF"/>
-                    </a:solidFill>
-                  </a:tcPr>
-                </a:tc>
-                <a:tc>
-                  <a:txBody>
-                    <a:bodyPr wrap="square"/>
-                    <a:lstStyle/>
-                    <a:p>
-                      <a:r>
-                        <a:rPr sz="1100" b="0">
-                          <a:solidFill>
-                            <a:srgbClr val="282828"/>
-                          </a:solidFill>
-                          <a:latin typeface="Arial"/>
-                        </a:rPr>
-                        <a:t>2 pm floor; lock-in C4 = 5.3</a:t>
-                      </a:r>
-                    </a:p>
-                  </a:txBody>
-                  <a:tcPr marL="54864" marR="54864" marT="18288" marB="18288">
-                    <a:solidFill>
-                      <a:srgbClr val="FFFFFF"/>
-                    </a:solidFill>
-                  </a:tcPr>
-                </a:tc>
-              </a:tr>
-              <a:tr h="468630">
-                <a:tc>
-                  <a:txBody>
-                    <a:bodyPr wrap="square"/>
-                    <a:lstStyle/>
-                    <a:p>
-                      <a:r>
-                        <a:rPr sz="1100" b="0">
-                          <a:solidFill>
-                            <a:srgbClr val="282828"/>
-                          </a:solidFill>
-                          <a:latin typeface="Arial"/>
-                        </a:rPr>
-                        <a:t>5 – 10</a:t>
-                      </a:r>
-                    </a:p>
-                  </a:txBody>
-                  <a:tcPr marL="54864" marR="54864" marT="18288" marB="18288">
-                    <a:solidFill>
-                      <a:srgbClr val="ECF1F6"/>
-                    </a:solidFill>
-                  </a:tcPr>
-                </a:tc>
-                <a:tc>
-                  <a:txBody>
-                    <a:bodyPr wrap="square"/>
-                    <a:lstStyle/>
-                    <a:p>
-                      <a:r>
-                        <a:rPr sz="1100" b="0">
-                          <a:solidFill>
-                            <a:srgbClr val="282828"/>
-                          </a:solidFill>
-                          <a:latin typeface="Arial"/>
-                        </a:rPr>
-                        <a:t>single actuators resolved with margin; ±1 px = ±0.1 pitch registration</a:t>
-                      </a:r>
-                    </a:p>
-                  </a:txBody>
-                  <a:tcPr marL="54864" marR="54864" marT="18288" marB="18288">
-                    <a:solidFill>
-                      <a:srgbClr val="ECF1F6"/>
-                    </a:solidFill>
-                  </a:tcPr>
-                </a:tc>
-                <a:tc>
-                  <a:txBody>
-                    <a:bodyPr wrap="square"/>
-                    <a:lstStyle/>
-                    <a:p>
-                      <a:r>
-                        <a:rPr sz="1100" b="0">
-                          <a:solidFill>
-                            <a:srgbClr val="282828"/>
-                          </a:solidFill>
-                          <a:latin typeface="Arial"/>
-                        </a:rPr>
-                        <a:t>same</a:t>
-                      </a:r>
-                    </a:p>
-                  </a:txBody>
-                  <a:tcPr marL="54864" marR="54864" marT="18288" marB="18288">
-                    <a:solidFill>
-                      <a:srgbClr val="ECF1F6"/>
-                    </a:solidFill>
-                  </a:tcPr>
-                </a:tc>
-                <a:tc>
-                  <a:txBody>
-                    <a:bodyPr wrap="square"/>
-                    <a:lstStyle/>
-                    <a:p>
-                      <a:r>
-                        <a:rPr sz="1100" b="0">
-                          <a:solidFill>
-                            <a:srgbClr val="282828"/>
-                          </a:solidFill>
-                          <a:latin typeface="Arial"/>
-                        </a:rPr>
-                        <a:t>same</a:t>
-                      </a:r>
-                    </a:p>
-                  </a:txBody>
-                  <a:tcPr marL="54864" marR="54864" marT="18288" marB="18288">
-                    <a:solidFill>
-                      <a:srgbClr val="ECF1F6"/>
-                    </a:solidFill>
-                  </a:tcPr>
-                </a:tc>
-                <a:tc>
-                  <a:txBody>
-                    <a:bodyPr wrap="square"/>
-                    <a:lstStyle/>
-                    <a:p>
-                      <a:r>
-                        <a:rPr sz="1100" b="0">
-                          <a:solidFill>
-                            <a:srgbClr val="282828"/>
-                          </a:solidFill>
-                          <a:latin typeface="Arial"/>
-                        </a:rPr>
-                        <a:t>0.25–1 Mpx, ~0.5 Gb/s; per-pixel solve ∝ pixels</a:t>
-                      </a:r>
-                    </a:p>
-                  </a:txBody>
-                  <a:tcPr marL="54864" marR="54864" marT="18288" marB="18288">
-                    <a:solidFill>
-                      <a:srgbClr val="ECF1F6"/>
-                    </a:solidFill>
-                  </a:tcPr>
-                </a:tc>
-                <a:tc>
-                  <a:txBody>
-                    <a:bodyPr wrap="square"/>
-                    <a:lstStyle/>
-                    <a:p>
-                      <a:r>
-                        <a:rPr sz="1100" b="0">
-                          <a:solidFill>
-                            <a:srgbClr val="282828"/>
-                          </a:solidFill>
-                          <a:latin typeface="Arial"/>
-                        </a:rPr>
-                        <a:t>✓ 1k²</a:t>
-                      </a:r>
-                    </a:p>
-                  </a:txBody>
-                  <a:tcPr marL="54864" marR="54864" marT="18288" marB="18288">
-                    <a:solidFill>
-                      <a:srgbClr val="ECF1F6"/>
-                    </a:solidFill>
-                  </a:tcPr>
-                </a:tc>
-                <a:tc>
-                  <a:txBody>
-                    <a:bodyPr wrap="square"/>
-                    <a:lstStyle/>
-                    <a:p>
-                      <a:r>
-                        <a:rPr sz="1100" b="0">
-                          <a:solidFill>
-                            <a:srgbClr val="282828"/>
-                          </a:solidFill>
-                          <a:latin typeface="Arial"/>
-                        </a:rPr>
-                        <a:t>✓ two images per pol. camera</a:t>
-                      </a:r>
-                    </a:p>
-                  </a:txBody>
-                  <a:tcPr marL="54864" marR="54864" marT="18288" marB="18288">
-                    <a:solidFill>
-                      <a:srgbClr val="ECF1F6"/>
-                    </a:solidFill>
-                  </a:tcPr>
-                </a:tc>
-                <a:tc>
-                  <a:txBody>
-                    <a:bodyPr wrap="square"/>
-                    <a:lstStyle/>
-                    <a:p>
-                      <a:r>
-                        <a:rPr sz="1100" b="0">
-                          <a:solidFill>
-                            <a:srgbClr val="282828"/>
-                          </a:solidFill>
-                          <a:latin typeface="Arial"/>
-                        </a:rPr>
-                        <a:t>Feng 9.4; C4M 10.6</a:t>
-                      </a:r>
-                    </a:p>
-                  </a:txBody>
-                  <a:tcPr marL="54864" marR="54864" marT="18288" marB="18288">
-                    <a:solidFill>
-                      <a:srgbClr val="ECF1F6"/>
-                    </a:solidFill>
-                  </a:tcPr>
-                </a:tc>
-              </a:tr>
-              <a:tr h="468630">
-                <a:tc>
-                  <a:txBody>
-                    <a:bodyPr wrap="square"/>
-                    <a:lstStyle/>
-                    <a:p>
-                      <a:r>
-                        <a:rPr sz="1100" b="0">
-                          <a:solidFill>
-                            <a:srgbClr val="282828"/>
-                          </a:solidFill>
-                          <a:latin typeface="Arial"/>
-                        </a:rPr>
-                        <a:t>20</a:t>
-                      </a:r>
-                    </a:p>
-                  </a:txBody>
-                  <a:tcPr marL="54864" marR="54864" marT="18288" marB="18288">
-                    <a:solidFill>
-                      <a:srgbClr val="FFFFFF"/>
-                    </a:solidFill>
-                  </a:tcPr>
-                </a:tc>
-                <a:tc>
-                  <a:txBody>
-                    <a:bodyPr wrap="square"/>
-                    <a:lstStyle/>
-                    <a:p>
-                      <a:r>
-                        <a:rPr sz="1100" b="0">
-                          <a:solidFill>
-                            <a:srgbClr val="282828"/>
-                          </a:solidFill>
-                          <a:latin typeface="Arial"/>
-                        </a:rPr>
-                        <a:t>no gauge gain; read noise per sample ↑ (binning restores it)</a:t>
-                      </a:r>
-                    </a:p>
-                  </a:txBody>
-                  <a:tcPr marL="54864" marR="54864" marT="18288" marB="18288">
-                    <a:solidFill>
-                      <a:srgbClr val="FFFFFF"/>
-                    </a:solidFill>
-                  </a:tcPr>
-                </a:tc>
-                <a:tc>
-                  <a:txBody>
-                    <a:bodyPr wrap="square"/>
-                    <a:lstStyle/>
-                    <a:p>
-                      <a:r>
-                        <a:rPr sz="1100" b="0">
-                          <a:solidFill>
-                            <a:srgbClr val="282828"/>
-                          </a:solidFill>
-                          <a:latin typeface="Arial"/>
-                        </a:rPr>
-                        <a:t>same</a:t>
-                      </a:r>
-                    </a:p>
-                  </a:txBody>
-                  <a:tcPr marL="54864" marR="54864" marT="18288" marB="18288">
-                    <a:solidFill>
-                      <a:srgbClr val="FFFFFF"/>
-                    </a:solidFill>
-                  </a:tcPr>
-                </a:tc>
-                <a:tc>
-                  <a:txBody>
-                    <a:bodyPr wrap="square"/>
-                    <a:lstStyle/>
-                    <a:p>
-                      <a:r>
-                        <a:rPr sz="1100" b="0">
-                          <a:solidFill>
-                            <a:srgbClr val="282828"/>
-                          </a:solidFill>
-                          <a:latin typeface="Arial"/>
-                        </a:rPr>
-                        <a:t>same</a:t>
-                      </a:r>
-                    </a:p>
-                  </a:txBody>
-                  <a:tcPr marL="54864" marR="54864" marT="18288" marB="18288">
-                    <a:solidFill>
-                      <a:srgbClr val="FFFFFF"/>
-                    </a:solidFill>
-                  </a:tcPr>
-                </a:tc>
-                <a:tc>
-                  <a:txBody>
-                    <a:bodyPr wrap="square"/>
-                    <a:lstStyle/>
-                    <a:p>
-                      <a:r>
-                        <a:rPr sz="1100" b="0">
-                          <a:solidFill>
-                            <a:srgbClr val="282828"/>
-                          </a:solidFill>
-                          <a:latin typeface="Arial"/>
-                        </a:rPr>
-                        <a:t>5 Mpx, 2–5 Gb/s</a:t>
-                      </a:r>
-                    </a:p>
-                  </a:txBody>
-                  <a:tcPr marL="54864" marR="54864" marT="18288" marB="18288">
-                    <a:solidFill>
-                      <a:srgbClr val="FFFFFF"/>
-                    </a:solidFill>
-                  </a:tcPr>
-                </a:tc>
-                <a:tc>
-                  <a:txBody>
-                    <a:bodyPr wrap="square"/>
-                    <a:lstStyle/>
-                    <a:p>
-                      <a:r>
-                        <a:rPr sz="1100" b="0">
-                          <a:solidFill>
-                            <a:srgbClr val="282828"/>
-                          </a:solidFill>
-                          <a:latin typeface="Arial"/>
-                        </a:rPr>
-                        <a:t>pco.edge class</a:t>
-                      </a:r>
-                    </a:p>
-                  </a:txBody>
-                  <a:tcPr marL="54864" marR="54864" marT="18288" marB="18288">
-                    <a:solidFill>
-                      <a:srgbClr val="FFFFFF"/>
-                    </a:solidFill>
-                  </a:tcPr>
-                </a:tc>
-                <a:tc>
-                  <a:txBody>
-                    <a:bodyPr wrap="square"/>
-                    <a:lstStyle/>
-                    <a:p>
-                      <a:r>
-                        <a:rPr sz="1100" b="0">
-                          <a:solidFill>
-                            <a:srgbClr val="282828"/>
-                          </a:solidFill>
-                          <a:latin typeface="Arial"/>
-                        </a:rPr>
-                        <a:t>—</a:t>
-                      </a:r>
-                    </a:p>
-                  </a:txBody>
-                  <a:tcPr marL="54864" marR="54864" marT="18288" marB="18288">
-                    <a:solidFill>
-                      <a:srgbClr val="FFFFFF"/>
-                    </a:solidFill>
-                  </a:tcPr>
-                </a:tc>
-                <a:tc>
-                  <a:txBody>
-                    <a:bodyPr wrap="square"/>
-                    <a:lstStyle/>
-                    <a:p>
-                      <a:r>
-                        <a:rPr sz="1100" b="0">
-                          <a:solidFill>
-                            <a:srgbClr val="282828"/>
-                          </a:solidFill>
-                          <a:latin typeface="Arial"/>
-                        </a:rPr>
-                        <a:t>pco.edge GS 21</a:t>
-                      </a:r>
-                    </a:p>
-                  </a:txBody>
-                  <a:tcPr marL="54864" marR="54864" marT="18288" marB="18288">
-                    <a:solidFill>
-                      <a:srgbClr val="FFFFFF"/>
-                    </a:solidFill>
-                  </a:tcPr>
-                </a:tc>
-              </a:tr>
-            </a:tbl>
-          </a:graphicData>
-        </a:graphic>
-      </p:graphicFrame>
+        </p:nvPicPr>
+        <p:blipFill>
+          <a:blip r:embed="rId2"/>
+          <a:stretch>
+            <a:fillRect/>
+          </a:stretch>
+        </p:blipFill>
+        <p:spPr>
+          <a:xfrm>
+            <a:off x="2756478" y="1298448"/>
+            <a:ext cx="6678737" cy="2897632"/>
+          </a:xfrm>
+          <a:prstGeom prst="rect">
+            <a:avLst/>
+          </a:prstGeom>
+        </p:spPr>
+      </p:pic>
       <p:sp>
         <p:nvSpPr>
           <p:cNvPr id="5" name="TextBox 4"/>
@@ -11895,8 +10819,8 @@
         </p:nvSpPr>
         <p:spPr>
           <a:xfrm>
-            <a:off x="411480" y="4256532"/>
-            <a:ext cx="11368735" cy="274320"/>
+            <a:off x="411480" y="4214368"/>
+            <a:ext cx="11368735" cy="394208"/>
           </a:xfrm>
           <a:prstGeom prst="rect">
             <a:avLst/>
@@ -11909,96 +10833,19 @@
           </a:bodyPr>
           <a:lstStyle/>
           <a:p>
-            <a:pPr>
+            <a:pPr algn="ctr">
               <a:spcAft>
-                <a:spcPts val="600"/>
+                <a:spcPts val="0"/>
               </a:spcAft>
             </a:pPr>
             <a:r>
-              <a:rPr sz="1500" b="0">
-                <a:solidFill>
-                  <a:srgbClr val="282828"/>
-                </a:solidFill>
-                <a:latin typeface="Arial"/>
-              </a:rPr>
-              <a:t>•  </a:t>
-            </a:r>
-            <a:r>
-              <a:rPr sz="1500" b="1">
-                <a:solidFill>
-                  <a:srgbClr val="282828"/>
-                </a:solidFill>
-                <a:latin typeface="Arial"/>
-              </a:rPr>
-              <a:t>Measured vs inferred:</a:t>
-            </a:r>
-            <a:r>
-              <a:rPr sz="1500" b="0">
-                <a:solidFill>
-                  <a:srgbClr val="282828"/>
-                </a:solidFill>
-                <a:latin typeface="Arial"/>
-              </a:rPr>
-              <a:t> every record is at 3.3–4 px per actuator (the IFO's mirror-rig image, distorted by more than a pitch at the edge, still reads to 2 pm); the collapse band is the blur demo's; the 5–20 rows follow from the well-bound photon rule and the data rates.</a:t>
-            </a:r>
-          </a:p>
-          <a:p>
-            <a:pPr marL="594360" indent="-137160">
-              <a:spcAft>
-                <a:spcPts val="500"/>
-              </a:spcAft>
-            </a:pPr>
-            <a:r>
-              <a:rPr sz="1300" b="0">
+              <a:rPr sz="1000" b="0">
                 <a:solidFill>
                   <a:srgbClr val="6E6E6E"/>
                 </a:solidFill>
                 <a:latin typeface="Arial"/>
               </a:rPr>
-              <a:t>–  </a:t>
-            </a:r>
-            <a:r>
-              <a:rPr sz="1300" b="1">
-                <a:solidFill>
-                  <a:srgbClr val="6E6E6E"/>
-                </a:solidFill>
-                <a:latin typeface="Arial"/>
-              </a:rPr>
-              <a:t>a per-gauge sweep at 1, 1.5, 2 and 4 px per actuator is running now</a:t>
-            </a:r>
-          </a:p>
-          <a:p>
-            <a:pPr marL="0" indent="0">
-              <a:spcAft>
-                <a:spcPts val="600"/>
-              </a:spcAft>
-            </a:pPr>
-            <a:r>
-              <a:rPr sz="1500" b="0">
-                <a:solidFill>
-                  <a:srgbClr val="282828"/>
-                </a:solidFill>
-                <a:latin typeface="Arial"/>
-              </a:rPr>
-              <a:t>•  </a:t>
-            </a:r>
-            <a:r>
-              <a:rPr sz="1500" b="1">
-                <a:solidFill>
-                  <a:srgbClr val="282828"/>
-                </a:solidFill>
-                <a:latin typeface="Arial"/>
-              </a:rPr>
-              <a:t>Where the three differ:</a:t>
-            </a:r>
-            <a:r>
-              <a:rPr sz="1500" b="0">
-                <a:solidFill>
-                  <a:srgbClr val="282828"/>
-                </a:solidFill>
-                <a:latin typeface="Arial"/>
-              </a:rPr>
-              <a:t> the IFO and HET read against a reference and are indifferent above 2 px; the vector ZWFS solves pixel by pixel from two images, wants ≥ 4, and pays processing for more; the lock-in fixes HET's sampling at the device (5.3 / 10.6) with the processing on-chip.  Regularization and calibration do not change with pixel count above 2.</a:t>
+              <a:t>Left: noise-only hold at each sensor's own loop cycle; right: averaging time to 1 pm per actuator — both vs camera pixels per actuator pitch, one line per reading; shaded = the single-actuator row fails; hollow = the ZWFS on a point-sampled grid, not camera pixels.</a:t>
             </a:r>
           </a:p>
         </p:txBody>
@@ -12011,8 +10858,8 @@
         </p:nvSpPr>
         <p:spPr>
           <a:xfrm>
-            <a:off x="411480" y="6401562"/>
-            <a:ext cx="11368735" cy="274320"/>
+            <a:off x="411480" y="4645152"/>
+            <a:ext cx="5806440" cy="274320"/>
           </a:xfrm>
           <a:prstGeom prst="rect">
             <a:avLst/>
@@ -12031,13 +10878,211 @@
               </a:spcAft>
             </a:pPr>
             <a:r>
+              <a:rPr sz="1200" b="0">
+                <a:solidFill>
+                  <a:srgbClr val="282828"/>
+                </a:solidFill>
+                <a:latin typeface="Arial"/>
+              </a:rPr>
+              <a:t>•  </a:t>
+            </a:r>
+            <a:r>
+              <a:rPr sz="1200" b="1">
+                <a:solidFill>
+                  <a:srgbClr val="282828"/>
+                </a:solidFill>
+                <a:latin typeface="Arial"/>
+              </a:rPr>
+              <a:t>1 px per actuator fails every reading the same way:</a:t>
+            </a:r>
+            <a:r>
+              <a:rPr sz="1200" b="0">
+                <a:solidFill>
+                  <a:srgbClr val="282828"/>
+                </a:solidFill>
+                <a:latin typeface="Arial"/>
+              </a:rPr>
+              <a:t> single-actuator floor 13–32 pm (from 1.2–2.6), converged gain off 0.4–0.5 %; the "wrong actuator" never happens — the fit degrades, it does not swap.</a:t>
+            </a:r>
+          </a:p>
+          <a:p>
+            <a:pPr>
+              <a:spcAft>
+                <a:spcPts val="600"/>
+              </a:spcAft>
+            </a:pPr>
+            <a:r>
+              <a:rPr sz="1200" b="0">
+                <a:solidFill>
+                  <a:srgbClr val="282828"/>
+                </a:solidFill>
+                <a:latin typeface="Arial"/>
+              </a:rPr>
+              <a:t>•  </a:t>
+            </a:r>
+            <a:r>
+              <a:rPr sz="1200" b="1">
+                <a:solidFill>
+                  <a:srgbClr val="282828"/>
+                </a:solidFill>
+                <a:latin typeface="Arial"/>
+              </a:rPr>
+              <a:t>1.5–2 px holds but pays in time:</a:t>
+            </a:r>
+            <a:r>
+              <a:rPr sz="1200" b="0">
+                <a:solidFill>
+                  <a:srgbClr val="282828"/>
+                </a:solidFill>
+                <a:latin typeface="Arial"/>
+              </a:rPr>
+              <a:t> HET 69–74 s per pm against 36 at 3.3 (Photonfocus); IFO 266–302 against 161; vector ZWFS 1040–1150 against 639 — 1.6–2×, because a coarser pixel INTEGRATES the fringe (the point-sampled ZWFS at 1.65, hollow, costs nothing).</a:t>
+            </a:r>
+          </a:p>
+        </p:txBody>
+      </p:sp>
+      <p:sp>
+        <p:nvSpPr>
+          <p:cNvPr id="7" name="TextBox 6"/>
+          <p:cNvSpPr txBox="1"/>
+          <p:nvPr/>
+        </p:nvSpPr>
+        <p:spPr>
+          <a:xfrm>
+            <a:off x="6400800" y="4645152"/>
+            <a:ext cx="5394960" cy="274320"/>
+          </a:xfrm>
+          <a:prstGeom prst="rect">
+            <a:avLst/>
+          </a:prstGeom>
+          <a:noFill/>
+        </p:spPr>
+        <p:txBody>
+          <a:bodyPr wrap="square">
+            <a:spAutoFit/>
+          </a:bodyPr>
+          <a:lstStyle/>
+          <a:p>
+            <a:pPr>
+              <a:spcAft>
+                <a:spcPts val="600"/>
+              </a:spcAft>
+            </a:pPr>
+            <a:r>
+              <a:rPr sz="1200" b="0">
+                <a:solidFill>
+                  <a:srgbClr val="282828"/>
+                </a:solidFill>
+                <a:latin typeface="Arial"/>
+              </a:rPr>
+              <a:t>•  </a:t>
+            </a:r>
+            <a:r>
+              <a:rPr sz="1200" b="1">
+                <a:solidFill>
+                  <a:srgbClr val="282828"/>
+                </a:solidFill>
+                <a:latin typeface="Arial"/>
+              </a:rPr>
+              <a:t>Above 3.3 px nothing changes</a:t>
+            </a:r>
+            <a:r>
+              <a:rPr sz="1200" b="0">
+                <a:solidFill>
+                  <a:srgbClr val="282828"/>
+                </a:solidFill>
+                <a:latin typeface="Arial"/>
+              </a:rPr>
+              <a:t> (4 = 3.3 to the digit); the records at 3.3 stand.</a:t>
+            </a:r>
+          </a:p>
+          <a:p>
+            <a:pPr marL="594360" indent="-137160">
+              <a:spcAft>
+                <a:spcPts val="500"/>
+              </a:spcAft>
+            </a:pPr>
+            <a:r>
               <a:rPr sz="1050" b="0">
                 <a:solidFill>
                   <a:srgbClr val="6E6E6E"/>
                 </a:solidFill>
                 <a:latin typeface="Arial"/>
               </a:rPr>
-              <a:t>Blur demo (pupil_blur_demo, REPORT_pupil_blur); gauge deck (IFO, vZWFS); stages noise and format (HET); ruling 6 (2026-10-11).  Data rates: pixels × 16 bit × frame rate.</a:t>
+              <a:t>–  registration: a ±0.1-pitch shift after calibration costs gain 0.95 and a 16–18 pm floor at EVERY sampling ≥ 1.5 — the camera must stay registered to ~0.03 pitch, whatever the pixel count</a:t>
+            </a:r>
+          </a:p>
+          <a:p>
+            <a:pPr marL="0" indent="0">
+              <a:spcAft>
+                <a:spcPts val="600"/>
+              </a:spcAft>
+            </a:pPr>
+            <a:r>
+              <a:rPr sz="1200" b="0">
+                <a:solidFill>
+                  <a:srgbClr val="282828"/>
+                </a:solidFill>
+                <a:latin typeface="Arial"/>
+              </a:rPr>
+              <a:t>•  </a:t>
+            </a:r>
+            <a:r>
+              <a:rPr sz="1200" b="1">
+                <a:solidFill>
+                  <a:srgbClr val="282828"/>
+                </a:solidFill>
+                <a:latin typeface="Arial"/>
+              </a:rPr>
+              <a:t>The lock-in's advantage survives the sweep:</a:t>
+            </a:r>
+            <a:r>
+              <a:rPr sz="1200" b="0">
+                <a:solidFill>
+                  <a:srgbClr val="282828"/>
+                </a:solidFill>
+                <a:latin typeface="Arial"/>
+              </a:rPr>
+              <a:t> 3.4 / 5.4 / 6.3 s per pm at 3.3 / 2 / 1.5 px, holding 3.1 / 4.0 / 4.3 pm at 0.125 s cycles — 10× the Photonfocus at every sampling.</a:t>
+            </a:r>
+          </a:p>
+        </p:txBody>
+      </p:sp>
+      <p:sp>
+        <p:nvSpPr>
+          <p:cNvPr id="8" name="TextBox 7"/>
+          <p:cNvSpPr txBox="1"/>
+          <p:nvPr/>
+        </p:nvSpPr>
+        <p:spPr>
+          <a:xfrm>
+            <a:off x="6400800" y="6600317"/>
+            <a:ext cx="5394960" cy="274320"/>
+          </a:xfrm>
+          <a:prstGeom prst="rect">
+            <a:avLst/>
+          </a:prstGeom>
+          <a:noFill/>
+        </p:spPr>
+        <p:txBody>
+          <a:bodyPr wrap="square">
+            <a:spAutoFit/>
+          </a:bodyPr>
+          <a:lstStyle/>
+          <a:p>
+            <a:pPr>
+              <a:spcAft>
+                <a:spcPts val="600"/>
+              </a:spcAft>
+            </a:pPr>
+            <a:r>
+              <a:rPr sz="1050" b="0">
+                <a:solidFill>
+                  <a:srgbClr val="6E6E6E"/>
+                </a:solidFill>
+                <a:latin typeface="Arial"/>
+              </a:rPr>
+              <a:t>ressweep_run / ressweep_zrun / ressweep_figs (cophi_dm96/runs/ressweep_*, TO 2026-10-13); mechanism dmg_camres (frames box-integrated onto camera pixels, the matrix measured through them); gate tResolutionSweep 7/7.</a:t>
             </a:r>
           </a:p>
         </p:txBody>
@@ -12169,7 +11214,7 @@
         </p:nvGraphicFramePr>
         <p:xfrm>
           <a:off x="411480" y="1298448"/>
-          <a:ext cx="11368734" cy="4034790"/>
+          <a:ext cx="11368734" cy="4223385"/>
         </p:xfrm>
         <a:graphic>
           <a:graphicData uri="http://schemas.openxmlformats.org/drawingml/2006/table">
@@ -12510,7 +11555,7 @@
                   </a:tcPr>
                 </a:tc>
               </a:tr>
-              <a:tr h="468630">
+              <a:tr h="657225">
                 <a:tc>
                   <a:txBody>
                     <a:bodyPr wrap="square"/>
@@ -12611,7 +11656,7 @@
                           </a:solidFill>
                           <a:latin typeface="Arial"/>
                         </a:rPr>
-                        <a:t>3.35 / 3.73 (×1.11 square-wave)</a:t>
+                        <a:t>3.35 / 3.73 (×1.23 in time for two-tap demodulation)</a:t>
                       </a:r>
                     </a:p>
                   </a:txBody>
@@ -13996,7 +13041,7 @@
                 </a:solidFill>
                 <a:latin typeface="Arial"/>
               </a:rPr>
-              <a:t> the lens rig's +0.1–0.2 % converged gain (a matrix-model term); the per-gauge resolution sweep (slide 18); the polarization-camera timings through the noise hook (slide 17).</a:t>
+              <a:t> the lens rig's +0.1–0.2 % converged gain (a matrix-model term); the polarization-camera timings through the noise hook (slide 17); the lock-in's demodulation form from the vendor (two-tap square-wave assumed).</a:t>
             </a:r>
           </a:p>
           <a:p>
@@ -14043,7 +13088,7 @@
         </p:nvSpPr>
         <p:spPr>
           <a:xfrm>
-            <a:off x="6400800" y="3002280"/>
+            <a:off x="6400800" y="3200400"/>
             <a:ext cx="5394960" cy="274320"/>
           </a:xfrm>
           <a:prstGeom prst="rect">
@@ -18397,6 +17442,22 @@
             </a:r>
           </a:p>
           <a:p>
+            <a:pPr marL="594360" indent="-137160">
+              <a:spcAft>
+                <a:spcPts val="500"/>
+              </a:spcAft>
+            </a:pPr>
+            <a:r>
+              <a:rPr sz="1250" b="0">
+                <a:solidFill>
+                  <a:srgbClr val="6E6E6E"/>
+                </a:solidFill>
+                <a:latin typeface="Arial"/>
+              </a:rPr>
+              <a:t>–  a real lock-in pixel (CSEM lineage, heliCam) steers charge between two taps by a square-wave reference — Feng's four-step inside the pixel; the bucket penalty is ×1.11 in σ, carried in every lock-in row</a:t>
+            </a:r>
+          </a:p>
+          <a:p>
             <a:pPr marL="0" indent="0">
               <a:spcAft>
                 <a:spcPts val="600"/>
@@ -18458,7 +17519,7 @@
         </p:nvGraphicFramePr>
         <p:xfrm>
           <a:off x="6400800" y="1298448"/>
-          <a:ext cx="5394959" cy="3646170"/>
+          <a:ext cx="5394959" cy="4160520"/>
         </p:xfrm>
         <a:graphic>
           <a:graphicData uri="http://schemas.openxmlformats.org/drawingml/2006/table">
@@ -18467,11 +17528,11 @@
                 <a:tableStyleId>{5C22544A-7EE6-4342-B048-85BDC9FD1C3A}</a:tableStyleId>
               </a:tblPr>
               <a:tblGrid>
-                <a:gridCol w="1604535"/>
-                <a:gridCol w="720878"/>
-                <a:gridCol w="3069546"/>
+                <a:gridCol w="1363561"/>
+                <a:gridCol w="612614"/>
+                <a:gridCol w="3418784"/>
               </a:tblGrid>
-              <a:tr h="605790">
+              <a:tr h="777240">
                 <a:tc>
                   <a:txBody>
                     <a:bodyPr wrap="square"/>
@@ -18811,7 +17872,7 @@
                   </a:tcPr>
                 </a:tc>
               </a:tr>
-              <a:tr h="605790">
+              <a:tr h="777240">
                 <a:tc>
                   <a:txBody>
                     <a:bodyPr wrap="square"/>
@@ -18868,7 +17929,7 @@
                           </a:solidFill>
                           <a:latin typeface="Arial"/>
                         </a:rPr>
-                        <a:t>3.35 / 3.73 (read 0, mirror / lens; 4.0 / 4.4 at read 100 assumed); ×1.11 for square-wave demodulation — well-capped at the I/Q rate</a:t>
+                        <a:t>3.35 / 3.73 (read 0, mirror / lens; 4.0 / 4.4 at read 100 assumed); ×1.11 in σ (×1.23 in time) for the pixel's two-tap square-wave demodulation — well-capped at the I/Q rate</a:t>
                       </a:r>
                     </a:p>
                   </a:txBody>
@@ -18879,7 +17940,7 @@
                   </a:tcPr>
                 </a:tc>
               </a:tr>
-              <a:tr h="605790">
+              <a:tr h="777240">
                 <a:tc>
                   <a:txBody>
                     <a:bodyPr wrap="square"/>

</xml_diff>

<commit_message>
deck_cophi slide 8: the lens-rig render re-cropped from the relabeled record (LO collimator + fiber tip named; the collimator/beamsplitter label collision fixed at the source)
Co-Authored-By: Claude Fable 5.1 <noreply@anthropic.com>
</commit_message>
<xml_diff>
--- a/demo_session/deck_cophi.pptx
+++ b/demo_session/deck_cophi.pptx
@@ -19088,7 +19088,7 @@
         <p:spPr>
           <a:xfrm>
             <a:off x="411480" y="1298448"/>
-            <a:ext cx="5806440" cy="2120878"/>
+            <a:ext cx="5806440" cy="1906098"/>
           </a:xfrm>
           <a:prstGeom prst="rect">
             <a:avLst/>
@@ -19103,7 +19103,7 @@
         </p:nvSpPr>
         <p:spPr>
           <a:xfrm>
-            <a:off x="411480" y="3437614"/>
+            <a:off x="411480" y="3222834"/>
             <a:ext cx="5806440" cy="559307"/>
           </a:xfrm>
           <a:prstGeom prst="rect">
@@ -19142,7 +19142,7 @@
         </p:nvSpPr>
         <p:spPr>
           <a:xfrm>
-            <a:off x="411480" y="4033498"/>
+            <a:off x="411480" y="3818718"/>
             <a:ext cx="5806440" cy="274320"/>
           </a:xfrm>
           <a:prstGeom prst="rect">

</xml_diff>

<commit_message>
deck_cophi slides 6-7 (Dave): the lock-in block diagram now carries the pixel chain in series (photodiode -> gates fed by the beat reference -> nodes -> A-B, C-D -> I/Q out) with slide 6's inputs and outputs, the stale 1.1 s note corrected; slide 6's figure title lowered and the canvas tightened so the graphic fills more of the slide
Co-Authored-By: Claude Fable 5.1 <noreply@anthropic.com>
</commit_message>
<xml_diff>
--- a/demo_session/deck_cophi.pptx
+++ b/demo_session/deck_cophi.pptx
@@ -18661,8 +18661,8 @@
         </p:blipFill>
         <p:spPr>
           <a:xfrm>
-            <a:off x="1219047" y="1298448"/>
-            <a:ext cx="9753600" cy="4572000"/>
+            <a:off x="978891" y="1298448"/>
+            <a:ext cx="10233911" cy="4572000"/>
           </a:xfrm>
           <a:prstGeom prst="rect">
             <a:avLst/>
@@ -18972,7 +18972,7 @@
         </p:nvSpPr>
         <p:spPr>
           <a:xfrm>
-            <a:off x="4251960" y="1234440"/>
+            <a:off x="411480" y="6720840"/>
             <a:ext cx="5806440" cy="274320"/>
           </a:xfrm>
           <a:prstGeom prst="rect">
@@ -19016,7 +19016,7 @@
                 </a:solidFill>
                 <a:latin typeface="Arial"/>
               </a:rPr>
-              <a:t> synthesizer 2 at 80 MHz + 5 kHz; the ×4 / 30 Hz trigger chain becomes the 5 kHz reference; the camera is the lock-in device; the processing is atan2(Q, I) per frame, decimated to the loop rate.  Fiber, LO and hold loop are unchanged.</a:t>
+              <a:t> synthesizer 2 at 80 MHz + 5 kHz; the ×4 / 30 Hz trigger chain becomes the 5 kHz reference, fed to the pixels' transfer gates; the camera is drawn as the chain inside one pixel (slide 6: photodiode → gates → nodes → A − B, C − D) in series with the frame grabber; the processing is atan2(Q, I) per sample, decimated to the loop rate.  Fiber, LO and hold loop are unchanged.</a:t>
             </a:r>
           </a:p>
         </p:txBody>
@@ -19068,8 +19068,8 @@
         </p:nvSpPr>
         <p:spPr>
           <a:xfrm>
-            <a:off x="6172200" y="6611112"/>
-            <a:ext cx="5650992" cy="274320"/>
+            <a:off x="6400800" y="2660904"/>
+            <a:ext cx="5394960" cy="274320"/>
           </a:xfrm>
           <a:prstGeom prst="rect">
             <a:avLst/>
@@ -19094,7 +19094,7 @@
                 </a:solidFill>
                 <a:latin typeface="Arial"/>
               </a:rPr>
-              <a:t>make_cophi_block_fig.py (lock-in variant); the well-free device is the dashed alternative.</a:t>
+              <a:t>make_cophi_block_fig.py (lock-in variant); the pixel chain's inputs and outputs are slide 6's.</a:t>
             </a:r>
           </a:p>
         </p:txBody>

</xml_diff>

<commit_message>
deck_cophi: the slide 5 / 7 overlaps (Dave) -- slide 5's extra sub-bullet (now slide 6's content) removed and the lock-in table's long cells shortened so it clears the pinned block; slide 7's two sidecar keys re-keyed to the reworded blocks (a reworded block had lost its geometry again)
Co-Authored-By: Claude Fable 5.1 <noreply@anthropic.com>
</commit_message>
<xml_diff>
--- a/demo_session/deck_cophi.pptx
+++ b/demo_session/deck_cophi.pptx
@@ -17753,22 +17753,6 @@
             </a:r>
           </a:p>
           <a:p>
-            <a:pPr marL="594360" indent="-137160">
-              <a:spcAft>
-                <a:spcPts val="500"/>
-              </a:spcAft>
-            </a:pPr>
-            <a:r>
-              <a:rPr sz="1250" b="0">
-                <a:solidFill>
-                  <a:srgbClr val="6E6E6E"/>
-                </a:solidFill>
-                <a:latin typeface="Arial"/>
-              </a:rPr>
-              <a:t>–  a real lock-in pixel (CSEM lineage, heliCam) steers charge between two taps by a square-wave reference — Feng's four-step inside the pixel; the bucket penalty is ×1.11 in σ, carried in every lock-in row</a:t>
-            </a:r>
-          </a:p>
-          <a:p>
             <a:pPr marL="0" indent="0">
               <a:spcAft>
                 <a:spcPts val="600"/>
@@ -17830,7 +17814,7 @@
         </p:nvGraphicFramePr>
         <p:xfrm>
           <a:off x="6400800" y="1298448"/>
-          <a:ext cx="5394959" cy="4160520"/>
+          <a:ext cx="5394958" cy="3817620"/>
         </p:xfrm>
         <a:graphic>
           <a:graphicData uri="http://schemas.openxmlformats.org/drawingml/2006/table">
@@ -17839,11 +17823,11 @@
                 <a:tableStyleId>{5C22544A-7EE6-4342-B048-85BDC9FD1C3A}</a:tableStyleId>
               </a:tblPr>
               <a:tblGrid>
-                <a:gridCol w="1363561"/>
-                <a:gridCol w="612614"/>
-                <a:gridCol w="3418784"/>
+                <a:gridCol w="1165745"/>
+                <a:gridCol w="840420"/>
+                <a:gridCol w="3388793"/>
               </a:tblGrid>
-              <a:tr h="777240">
+              <a:tr h="605790">
                 <a:tc>
                   <a:txBody>
                     <a:bodyPr wrap="square"/>
@@ -18047,7 +18031,7 @@
                   </a:tcPr>
                 </a:tc>
               </a:tr>
-              <a:tr h="262890">
+              <a:tr h="434340">
                 <a:tc>
                   <a:txBody>
                     <a:bodyPr wrap="square"/>
@@ -18172,7 +18156,7 @@
                           </a:solidFill>
                           <a:latin typeface="Arial"/>
                         </a:rPr>
-                        <a:t>57.9 / 61.1 pm per 1 ms I/Q sample, mirror / lens (63 / 66 at an assumed 100 e⁻ read)</a:t>
+                        <a:t>57.9 / 61.1 pm per 1 ms sample, mirror / lens (63 / 66 at 100 e⁻ read)</a:t>
                       </a:r>
                     </a:p>
                   </a:txBody>
@@ -18183,7 +18167,7 @@
                   </a:tcPr>
                 </a:tc>
               </a:tr>
-              <a:tr h="777240">
+              <a:tr h="605790">
                 <a:tc>
                   <a:txBody>
                     <a:bodyPr wrap="square"/>
@@ -18240,7 +18224,7 @@
                           </a:solidFill>
                           <a:latin typeface="Arial"/>
                         </a:rPr>
-                        <a:t>3.35 / 3.73 (read 0, mirror / lens; 4.0 / 4.4 at read 100 assumed); ×1.11 in σ (×1.23 in time) for the pixel's two-tap square-wave demodulation — well-capped at the I/Q rate</a:t>
+                        <a:t>3.35 / 3.73 (mirror / lens; 4.0 / 4.4 at 100 e⁻ read); ×1.23 in time for the two-tap square wave; well-capped at the I/Q rate</a:t>
                       </a:r>
                     </a:p>
                   </a:txBody>
@@ -18251,7 +18235,7 @@
                   </a:tcPr>
                 </a:tc>
               </a:tr>
-              <a:tr h="777240">
+              <a:tr h="605790">
                 <a:tc>
                   <a:txBody>
                     <a:bodyPr wrap="square"/>
@@ -18264,7 +18248,7 @@
                           </a:solidFill>
                           <a:latin typeface="Arial"/>
                         </a:rPr>
-                        <a:t>if well-free: 10⁹ / 10¹⁰ e⁻/s per element (the sheet's own 2.5 × 10⁹)</a:t>
+                        <a:t>if well-free: 10⁹ / 10¹⁰ e⁻/s per element</a:t>
                       </a:r>
                     </a:p>
                   </a:txBody>
@@ -18308,7 +18292,7 @@
                           </a:solidFill>
                           <a:latin typeface="Arial"/>
                         </a:rPr>
-                        <a:t>0.84 / 0.084 s (0.34 s at 2.5 × 10⁹) — analytic, one store per sample</a:t>
+                        <a:t>0.84 / 0.084 s (0.34 at 2.5 × 10⁹); analytic</a:t>
                       </a:r>
                     </a:p>
                   </a:txBody>
@@ -18972,7 +18956,7 @@
         </p:nvSpPr>
         <p:spPr>
           <a:xfrm>
-            <a:off x="411480" y="6720840"/>
+            <a:off x="4251960" y="1234440"/>
             <a:ext cx="5806440" cy="274320"/>
           </a:xfrm>
           <a:prstGeom prst="rect">
@@ -19068,8 +19052,8 @@
         </p:nvSpPr>
         <p:spPr>
           <a:xfrm>
-            <a:off x="6400800" y="2660904"/>
-            <a:ext cx="5394960" cy="274320"/>
+            <a:off x="6172200" y="6611112"/>
+            <a:ext cx="5650992" cy="274320"/>
           </a:xfrm>
           <a:prstGeom prst="rect">
             <a:avLst/>

</xml_diff>

<commit_message>
deck_cophi: Dave's slide-6 geometry folded (the LID figure at full width with his crops; the footnote moved); edit copy synced
Co-Authored-By: Claude Fable 5.1 <noreply@anthropic.com>
</commit_message>
<xml_diff>
--- a/demo_session/deck_cophi.pptx
+++ b/demo_session/deck_cophi.pptx
@@ -18639,14 +18639,15 @@
         </p:nvPicPr>
         <p:blipFill>
           <a:blip r:embed="rId2"/>
+          <a:srcRect l="840" t="3790" b="4730"/>
           <a:stretch>
             <a:fillRect/>
           </a:stretch>
         </p:blipFill>
         <p:spPr>
           <a:xfrm>
-            <a:off x="978891" y="1298448"/>
-            <a:ext cx="10233911" cy="4572000"/>
+            <a:off x="411480" y="1188720"/>
+            <a:ext cx="11365992" cy="4681728"/>
           </a:xfrm>
           <a:prstGeom prst="rect">
             <a:avLst/>
@@ -18775,8 +18776,8 @@
         </p:nvSpPr>
         <p:spPr>
           <a:xfrm>
-            <a:off x="6400800" y="6641592"/>
-            <a:ext cx="5394960" cy="274320"/>
+            <a:off x="4343400" y="6565392"/>
+            <a:ext cx="7452360" cy="274320"/>
           </a:xfrm>
           <a:prstGeom prst="rect">
             <a:avLst/>

</xml_diff>

<commit_message>
deck_cophi: Dave's pass folded -- 'Questions for the vendor' (slide 5); geometry on the lock-in block diagram (text blocks), the algebra slide (figure full width, both columns lower) and the resolution slide's footnote; edit copy synced
Co-Authored-By: Claude Fable 5.1 <noreply@anthropic.com>
</commit_message>
<xml_diff>
--- a/demo_session/deck_cophi.pptx
+++ b/demo_session/deck_cophi.pptx
@@ -11367,8 +11367,8 @@
         </p:nvSpPr>
         <p:spPr>
           <a:xfrm>
-            <a:off x="6400800" y="6600317"/>
-            <a:ext cx="5394960" cy="274320"/>
+            <a:off x="457200" y="6400800"/>
+            <a:ext cx="11338560" cy="274320"/>
           </a:xfrm>
           <a:prstGeom prst="rect">
             <a:avLst/>
@@ -18459,7 +18459,7 @@
                 </a:solidFill>
                 <a:latin typeface="Arial"/>
               </a:rPr>
-              <a:t>The vendor question:</a:t>
+              <a:t>Questions for the vendor:</a:t>
             </a:r>
             <a:r>
               <a:rPr sz="1400" b="0">
@@ -18468,7 +18468,7 @@
                 </a:solidFill>
                 <a:latin typeface="Arial"/>
               </a:rPr>
-              <a:t> phase noise per pixel vs flux at t_c = 100 ms, and whether the full well bounds each internal 1 MSa/s sample or the 5.6 kSa/s output — for Heliotis, through Dave.</a:t>
+              <a:t> phase noise per pixel vs flux at t_c = 100 ms, and whether the full well bounds each internal 1 MSa/s sample or the 5.6 kSa/s output</a:t>
             </a:r>
           </a:p>
         </p:txBody>
@@ -18957,7 +18957,7 @@
         </p:nvSpPr>
         <p:spPr>
           <a:xfrm>
-            <a:off x="4251960" y="1234440"/>
+            <a:off x="3200400" y="1133856"/>
             <a:ext cx="5806440" cy="274320"/>
           </a:xfrm>
           <a:prstGeom prst="rect">
@@ -19014,7 +19014,7 @@
         </p:nvSpPr>
         <p:spPr>
           <a:xfrm>
-            <a:off x="4206240" y="2286000"/>
+            <a:off x="3200400" y="2240280"/>
             <a:ext cx="6080760" cy="274320"/>
           </a:xfrm>
           <a:prstGeom prst="rect">
@@ -19217,8 +19217,8 @@
         </p:blipFill>
         <p:spPr>
           <a:xfrm>
-            <a:off x="761847" y="1298448"/>
-            <a:ext cx="10668000" cy="3200400"/>
+            <a:off x="301752" y="1152144"/>
+            <a:ext cx="11585448" cy="3648456"/>
           </a:xfrm>
           <a:prstGeom prst="rect">
             <a:avLst/>
@@ -19233,7 +19233,7 @@
         </p:nvSpPr>
         <p:spPr>
           <a:xfrm>
-            <a:off x="411480" y="4498848"/>
+            <a:off x="411480" y="4572000"/>
             <a:ext cx="5806440" cy="274320"/>
           </a:xfrm>
           <a:prstGeom prst="rect">
@@ -19374,7 +19374,7 @@
         </p:nvSpPr>
         <p:spPr>
           <a:xfrm>
-            <a:off x="6400800" y="4498848"/>
+            <a:off x="6400800" y="4572000"/>
             <a:ext cx="5394960" cy="274320"/>
           </a:xfrm>
           <a:prstGeom prst="rect">
@@ -19513,7 +19513,7 @@
         </p:nvSpPr>
         <p:spPr>
           <a:xfrm>
-            <a:off x="6400800" y="7229094"/>
+            <a:off x="6400800" y="7302246"/>
             <a:ext cx="5394960" cy="274320"/>
           </a:xfrm>
           <a:prstGeom prst="rect">

</xml_diff>

<commit_message>
deck_cophi slide 7: the pixel chain ends in the sensor's own ADCs (2 x 10 bit per pixel) -- digital I/Q leaves the camera; the 'frame grabber' is a GigE receiver (Dave's question)
Co-Authored-By: Claude Fable 5.1 <noreply@anthropic.com>
</commit_message>
<xml_diff>
--- a/demo_session/deck_cophi.pptx
+++ b/demo_session/deck_cophi.pptx
@@ -18957,7 +18957,7 @@
         </p:nvSpPr>
         <p:spPr>
           <a:xfrm>
-            <a:off x="3200400" y="1133856"/>
+            <a:off x="411480" y="6720840"/>
             <a:ext cx="5806440" cy="274320"/>
           </a:xfrm>
           <a:prstGeom prst="rect">
@@ -19001,7 +19001,7 @@
                 </a:solidFill>
                 <a:latin typeface="Arial"/>
               </a:rPr>
-              <a:t> synthesizer 2 at 80 MHz + 5 kHz; the ×4 / 30 Hz trigger chain becomes the 5 kHz reference, fed to the pixels' transfer gates; the camera is drawn as the chain inside one pixel (slide 6: photodiode → gates → nodes → A − B, C − D) in series with the frame grabber; the processing is atan2(Q, I) per sample, decimated to the loop rate.  Fiber, LO and hold loop are unchanged.</a:t>
+              <a:t> synthesizer 2 at 80 MHz + 5 kHz; the ×4 / 30 Hz trigger chain becomes the 5 kHz reference, fed to the pixels' transfer gates; the camera is drawn as the chain inside one pixel (slide 6: photodiode → gates → nodes → A − B, C − D → the sensor's own ADCs, 2 × 10 bit per pixel) so only digital I/Q leaves the camera, into a GigE receiver; the processing is atan2(Q, I) per sample, decimated to the loop rate.  Fiber, LO and hold loop are unchanged.</a:t>
             </a:r>
           </a:p>
         </p:txBody>

</xml_diff>

<commit_message>
deck_cophi block diagrams (Dave): less white space -- the RF column compacted and the figure margins cropped (aspect 1.73 -> 1.98, text ~15 % larger on the slide); slide 6's A-B -> I wire now reaches the ADC box; the text blocks on slides 3, 7, 16 moved into the diagrams' empty bands (none off the slide); builder: sidecar keys also match on their first 40 characters, so a reworded block keeps its geometry
Co-Authored-By: Claude Fable 5.1 <noreply@anthropic.com>
</commit_message>
<xml_diff>
--- a/demo_session/deck_cophi.pptx
+++ b/demo_session/deck_cophi.pptx
@@ -5822,7 +5822,7 @@
         </p:nvSpPr>
         <p:spPr>
           <a:xfrm>
-            <a:off x="411480" y="4135374"/>
+            <a:off x="411480" y="5257800"/>
             <a:ext cx="11368735" cy="274320"/>
           </a:xfrm>
           <a:prstGeom prst="rect">
@@ -5842,7 +5842,7 @@
               </a:spcAft>
             </a:pPr>
             <a:r>
-              <a:rPr sz="1500" b="0">
+              <a:rPr sz="1200" b="0">
                 <a:solidFill>
                   <a:srgbClr val="282828"/>
                 </a:solidFill>
@@ -5851,7 +5851,7 @@
               <a:t>•  </a:t>
             </a:r>
             <a:r>
-              <a:rPr sz="1500" b="1">
+              <a:rPr sz="1200" b="1">
                 <a:solidFill>
                   <a:srgbClr val="282828"/>
                 </a:solidFill>
@@ -5860,7 +5860,7 @@
               <a:t>The one-step rows sit 0.5 % low for HET on both rigs — the estimator, not the reading:</a:t>
             </a:r>
             <a:r>
-              <a:rPr sz="1500" b="0">
+              <a:rPr sz="1200" b="0">
                 <a:solidFill>
                   <a:srgbClr val="282828"/>
                 </a:solidFill>
@@ -5876,7 +5876,7 @@
               </a:spcAft>
             </a:pPr>
             <a:r>
-              <a:rPr sz="1500" b="0">
+              <a:rPr sz="1200" b="0">
                 <a:solidFill>
                   <a:srgbClr val="282828"/>
                 </a:solidFill>
@@ -5885,7 +5885,7 @@
               <a:t>•  </a:t>
             </a:r>
             <a:r>
-              <a:rPr sz="1500" b="1">
+              <a:rPr sz="1200" b="1">
                 <a:solidFill>
                   <a:srgbClr val="282828"/>
                 </a:solidFill>
@@ -5894,7 +5894,7 @@
               <a:t>Driven to convergence (the servo use), HET reads exactly on the mirror rig, and the IFO shows its polarization gain in the open:</a:t>
             </a:r>
             <a:r>
-              <a:rPr sz="1500" b="0">
+              <a:rPr sz="1200" b="0">
                 <a:solidFill>
                   <a:srgbClr val="282828"/>
                 </a:solidFill>
@@ -5913,7 +5913,7 @@
         </p:nvSpPr>
         <p:spPr>
           <a:xfrm>
-            <a:off x="411480" y="5938266"/>
+            <a:off x="411480" y="6565392"/>
             <a:ext cx="11368735" cy="274320"/>
           </a:xfrm>
           <a:prstGeom prst="rect">
@@ -8607,8 +8607,8 @@
         </p:blipFill>
         <p:spPr>
           <a:xfrm>
-            <a:off x="731520" y="1179576"/>
-            <a:ext cx="9098280" cy="5623560"/>
+            <a:off x="731520" y="2286000"/>
+            <a:ext cx="10972800" cy="4389120"/>
           </a:xfrm>
           <a:prstGeom prst="rect">
             <a:avLst/>
@@ -8623,8 +8623,8 @@
         </p:nvSpPr>
         <p:spPr>
           <a:xfrm>
-            <a:off x="3657600" y="1152144"/>
-            <a:ext cx="8229600" cy="274320"/>
+            <a:off x="411480" y="1115568"/>
+            <a:ext cx="11338560" cy="274320"/>
           </a:xfrm>
           <a:prstGeom prst="rect">
             <a:avLst/>
@@ -8643,7 +8643,7 @@
               </a:spcAft>
             </a:pPr>
             <a:r>
-              <a:rPr sz="1200" b="0">
+              <a:rPr sz="1500" b="0">
                 <a:solidFill>
                   <a:srgbClr val="282828"/>
                 </a:solidFill>
@@ -8652,7 +8652,7 @@
               <a:t>•  </a:t>
             </a:r>
             <a:r>
-              <a:rPr sz="1200" b="1">
+              <a:rPr sz="1500" b="1">
                 <a:solidFill>
                   <a:srgbClr val="282828"/>
                 </a:solidFill>
@@ -8661,7 +8661,7 @@
               <a:t>Two colors, one camera, one 8-frame set:</a:t>
             </a:r>
             <a:r>
-              <a:rPr sz="1200" b="0">
+              <a:rPr sz="1500" b="0">
                 <a:solidFill>
                   <a:srgbClr val="282828"/>
                 </a:solidFill>
@@ -8680,7 +8680,7 @@
         </p:nvSpPr>
         <p:spPr>
           <a:xfrm>
-            <a:off x="5257800" y="2468880"/>
+            <a:off x="411480" y="1828800"/>
             <a:ext cx="5852160" cy="274320"/>
           </a:xfrm>
           <a:prstGeom prst="rect">
@@ -8719,8 +8719,8 @@
         </p:nvSpPr>
         <p:spPr>
           <a:xfrm>
-            <a:off x="4572000" y="1828800"/>
-            <a:ext cx="7315200" cy="274320"/>
+            <a:off x="6400800" y="1828800"/>
+            <a:ext cx="5394960" cy="274320"/>
           </a:xfrm>
           <a:prstGeom prst="rect">
             <a:avLst/>
@@ -16344,7 +16344,7 @@
         </p:nvSpPr>
         <p:spPr>
           <a:xfrm>
-            <a:off x="3429000" y="1426464"/>
+            <a:off x="5486400" y="1371600"/>
             <a:ext cx="5852160" cy="274320"/>
           </a:xfrm>
           <a:prstGeom prst="rect">
@@ -16383,8 +16383,8 @@
         </p:nvSpPr>
         <p:spPr>
           <a:xfrm>
-            <a:off x="6400800" y="1999488"/>
-            <a:ext cx="5394960" cy="274320"/>
+            <a:off x="6172200" y="2103120"/>
+            <a:ext cx="4343400" cy="274320"/>
           </a:xfrm>
           <a:prstGeom prst="rect">
             <a:avLst/>
@@ -18957,8 +18957,8 @@
         </p:nvSpPr>
         <p:spPr>
           <a:xfrm>
-            <a:off x="411480" y="6720840"/>
-            <a:ext cx="5806440" cy="274320"/>
+            <a:off x="5760720" y="1115568"/>
+            <a:ext cx="6035040" cy="274320"/>
           </a:xfrm>
           <a:prstGeom prst="rect">
             <a:avLst/>
@@ -19001,7 +19001,7 @@
                 </a:solidFill>
                 <a:latin typeface="Arial"/>
               </a:rPr>
-              <a:t> synthesizer 2 at 80 MHz + 5 kHz; the ×4 / 30 Hz trigger chain becomes the 5 kHz reference, fed to the pixels' transfer gates; the camera is drawn as the chain inside one pixel (slide 6: photodiode → gates → nodes → A − B, C − D → the sensor's own ADCs, 2 × 10 bit per pixel) so only digital I/Q leaves the camera, into a GigE receiver; the processing is atan2(Q, I) per sample, decimated to the loop rate.  Fiber, LO and hold loop are unchanged.</a:t>
+              <a:t> synthesizer 2 at 80 MHz + 5 kHz; the trigger chain becomes the 5 kHz reference to the pixels' gates; the camera is one pixel's chain (slide 6) ending in the sensor's ADCs — digital I/Q out to a GigE receiver; atan2(Q, I) per sample.  Fiber, LO, loop unchanged.</a:t>
             </a:r>
           </a:p>
         </p:txBody>
@@ -19014,8 +19014,8 @@
         </p:nvSpPr>
         <p:spPr>
           <a:xfrm>
-            <a:off x="3200400" y="2240280"/>
-            <a:ext cx="6080760" cy="274320"/>
+            <a:off x="5760720" y="2103120"/>
+            <a:ext cx="6035040" cy="274320"/>
           </a:xfrm>
           <a:prstGeom prst="rect">
             <a:avLst/>

</xml_diff>

<commit_message>
deck_cophi slides 5-6: the clarifications folded (read noise paid once per N-cycle sample, 1/N in variance per photon, shot noise unchanged; the vendor question restated as node depth before the difference vs continuous draining; the vendor list on slide 5 restated); the LID figure a little shorter to make room
Co-Authored-By: Claude Fable 5.1 <noreply@anthropic.com>
</commit_message>
<xml_diff>
--- a/demo_session/deck_cophi.pptx
+++ b/demo_session/deck_cophi.pptx
@@ -18468,7 +18468,7 @@
                 </a:solidFill>
                 <a:latin typeface="Arial"/>
               </a:rPr>
-              <a:t> phase noise per pixel vs flux at t_c = 100 ms, and whether the full well bounds each internal 1 MSa/s sample or the 5.6 kSa/s output</a:t>
+              <a:t> do the nodes hold the full DC before A − B is formed, or only the difference (slide 6)? is the 1 MSa/s internal sampling an analog accumulation read once per output sample? phase noise per pixel vs flux at t_c = 100 ms</a:t>
             </a:r>
           </a:p>
         </p:txBody>
@@ -18647,7 +18647,7 @@
         <p:spPr>
           <a:xfrm>
             <a:off x="411480" y="1188720"/>
-            <a:ext cx="11365992" cy="4681728"/>
+            <a:ext cx="11365992" cy="3931920"/>
           </a:xfrm>
           <a:prstGeom prst="rect">
             <a:avLst/>
@@ -18662,7 +18662,7 @@
         </p:nvSpPr>
         <p:spPr>
           <a:xfrm>
-            <a:off x="411480" y="5870448"/>
+            <a:off x="411480" y="5120640"/>
             <a:ext cx="5806440" cy="274320"/>
           </a:xfrm>
           <a:prstGeom prst="rect">
@@ -18719,7 +18719,7 @@
         </p:nvSpPr>
         <p:spPr>
           <a:xfrm>
-            <a:off x="6400800" y="5870448"/>
+            <a:off x="6400800" y="5120640"/>
             <a:ext cx="5394960" cy="274320"/>
           </a:xfrm>
           <a:prstGeom prst="rect">
@@ -18763,7 +18763,39 @@
                 </a:solidFill>
                 <a:latin typeface="Arial"/>
               </a:rPr>
-              <a:t> N cycles per sample, not a quarter cycle; the DC cancels in the difference (does it fill the nodes? vendor question 2); the square wave costs ×1.11 in σ (eq. 6).</a:t>
+              <a:t> N cycles per sample, not a quarter cycle; the square wave costs ×1.11 in σ (eq. 6).</a:t>
+            </a:r>
+          </a:p>
+          <a:p>
+            <a:pPr marL="594360" indent="-137160">
+              <a:spcAft>
+                <a:spcPts val="500"/>
+              </a:spcAft>
+            </a:pPr>
+            <a:r>
+              <a:rPr sz="1050" b="0">
+                <a:solidFill>
+                  <a:srgbClr val="6E6E6E"/>
+                </a:solidFill>
+                <a:latin typeface="Arial"/>
+              </a:rPr>
+              <a:t>–  read noise is paid once per N-cycle sample, not per bucket: 1/N in variance per photon; shot noise unchanged (every photoelectron counts, stored or drained)</a:t>
+            </a:r>
+          </a:p>
+          <a:p>
+            <a:pPr marL="594360" indent="-137160">
+              <a:spcAft>
+                <a:spcPts val="500"/>
+              </a:spcAft>
+            </a:pPr>
+            <a:r>
+              <a:rPr sz="1050" b="0">
+                <a:solidFill>
+                  <a:srgbClr val="6E6E6E"/>
+                </a:solidFill>
+                <a:latin typeface="Arial"/>
+              </a:rPr>
+              <a:t>–  the vendor question: must the nodes hold the full DC before A − B is formed (the well caps photons per sample — our numbers), or is the common part drained so they hold only the difference (~10× more photons)?</a:t>
             </a:r>
           </a:p>
         </p:txBody>
@@ -18776,7 +18808,7 @@
         </p:nvSpPr>
         <p:spPr>
           <a:xfrm>
-            <a:off x="4343400" y="6565392"/>
+            <a:off x="4343400" y="6601968"/>
             <a:ext cx="7452360" cy="274320"/>
           </a:xfrm>
           <a:prstGeom prst="rect">

</xml_diff>

<commit_message>
deck_cophi slide 6 + the Feng draft: per PHOTON the lock-in changes only the read-noise term (1/N) and the square-wave factor; per SECOND it uses ~17x the photons (the well empties every sample) -- averaging reduces photon noise only through more photons, as for any camera
Co-Authored-By: Claude Fable 5.1 <noreply@anthropic.com>
</commit_message>
<xml_diff>
--- a/demo_session/deck_cophi.pptx
+++ b/demo_session/deck_cophi.pptx
@@ -18779,7 +18779,7 @@
                 </a:solidFill>
                 <a:latin typeface="Arial"/>
               </a:rPr>
-              <a:t>–  read noise is paid once per N-cycle sample, not per bucket: 1/N in variance per photon; shot noise unchanged (every photoelectron counts, stored or drained)</a:t>
+              <a:t>–  per PHOTON: read noise is paid once per N-cycle sample, not per bucket (1/N in variance); shot noise is unchanged — averaging more samples helps only by bringing more photons, as it would any camera</a:t>
             </a:r>
           </a:p>
           <a:p>
@@ -18795,7 +18795,7 @@
                 </a:solidFill>
                 <a:latin typeface="Arial"/>
               </a:rPr>
-              <a:t>–  the vendor question: must the nodes hold the full DC before A − B is formed (the well caps photons per sample — our numbers), or is the common part drained so they hold only the difference (~10× more photons)?</a:t>
+              <a:t>–  per SECOND: the well empties every 1 ms sample — 5 × 10⁸ e⁻/s per pixel usable vs the Photonfocus's 3 × 10⁷ (200 ke × 150 fps); that 17× in photons is most of 42 → 3.4 s per pm (the vendor's drain question: slide 5)</a:t>
             </a:r>
           </a:p>
         </p:txBody>

</xml_diff>

<commit_message>
deck_cophi: Dave's clean-up pass folded (slide 6: 'The ADC is on chip' bullet, the frame-camera bullet trimmed to the throughput line; eight footnote / block moves on slides 6, 11, 12, 15, 19, 21); the LID figure back to 4.8 in with the text below it; the Feng draft as Dave rewrote it
Co-Authored-By: Claude Fable 5.1 <noreply@anthropic.com>
</commit_message>
<xml_diff>
--- a/demo_session/deck_cophi.pptx
+++ b/demo_session/deck_cophi.pptx
@@ -4738,8 +4738,8 @@
         </p:nvSpPr>
         <p:spPr>
           <a:xfrm>
-            <a:off x="411480" y="6834505"/>
-            <a:ext cx="11368735" cy="274320"/>
+            <a:off x="411480" y="6428232"/>
+            <a:ext cx="11365992" cy="274320"/>
           </a:xfrm>
           <a:prstGeom prst="rect">
             <a:avLst/>
@@ -5822,8 +5822,8 @@
         </p:nvSpPr>
         <p:spPr>
           <a:xfrm>
-            <a:off x="411480" y="5257800"/>
-            <a:ext cx="11368735" cy="274320"/>
+            <a:off x="411480" y="4572000"/>
+            <a:ext cx="11365992" cy="274320"/>
           </a:xfrm>
           <a:prstGeom prst="rect">
             <a:avLst/>
@@ -5842,7 +5842,7 @@
               </a:spcAft>
             </a:pPr>
             <a:r>
-              <a:rPr sz="1200" b="0">
+              <a:rPr sz="1400" b="0">
                 <a:solidFill>
                   <a:srgbClr val="282828"/>
                 </a:solidFill>
@@ -5851,7 +5851,7 @@
               <a:t>•  </a:t>
             </a:r>
             <a:r>
-              <a:rPr sz="1200" b="1">
+              <a:rPr sz="1400" b="1">
                 <a:solidFill>
                   <a:srgbClr val="282828"/>
                 </a:solidFill>
@@ -5860,7 +5860,7 @@
               <a:t>The one-step rows sit 0.5 % low for HET on both rigs — the estimator, not the reading:</a:t>
             </a:r>
             <a:r>
-              <a:rPr sz="1200" b="0">
+              <a:rPr sz="1400" b="0">
                 <a:solidFill>
                   <a:srgbClr val="282828"/>
                 </a:solidFill>
@@ -5876,7 +5876,7 @@
               </a:spcAft>
             </a:pPr>
             <a:r>
-              <a:rPr sz="1200" b="0">
+              <a:rPr sz="1400" b="0">
                 <a:solidFill>
                   <a:srgbClr val="282828"/>
                 </a:solidFill>
@@ -5885,7 +5885,7 @@
               <a:t>•  </a:t>
             </a:r>
             <a:r>
-              <a:rPr sz="1200" b="1">
+              <a:rPr sz="1400" b="1">
                 <a:solidFill>
                   <a:srgbClr val="282828"/>
                 </a:solidFill>
@@ -5894,7 +5894,7 @@
               <a:t>Driven to convergence (the servo use), HET reads exactly on the mirror rig, and the IFO shows its polarization gain in the open:</a:t>
             </a:r>
             <a:r>
-              <a:rPr sz="1200" b="0">
+              <a:rPr sz="1400" b="0">
                 <a:solidFill>
                   <a:srgbClr val="282828"/>
                 </a:solidFill>
@@ -5913,8 +5913,8 @@
         </p:nvSpPr>
         <p:spPr>
           <a:xfrm>
-            <a:off x="411480" y="6565392"/>
-            <a:ext cx="11368735" cy="274320"/>
+            <a:off x="411480" y="6172200"/>
+            <a:ext cx="11365992" cy="274320"/>
           </a:xfrm>
           <a:prstGeom prst="rect">
             <a:avLst/>
@@ -8442,8 +8442,8 @@
         </p:nvSpPr>
         <p:spPr>
           <a:xfrm>
-            <a:off x="6400800" y="6254495"/>
-            <a:ext cx="5394960" cy="274320"/>
+            <a:off x="457200" y="6254496"/>
+            <a:ext cx="11338560" cy="274320"/>
           </a:xfrm>
           <a:prstGeom prst="rect">
             <a:avLst/>
@@ -12927,8 +12927,8 @@
         </p:nvSpPr>
         <p:spPr>
           <a:xfrm>
-            <a:off x="411480" y="6986270"/>
-            <a:ext cx="11368735" cy="274320"/>
+            <a:off x="420624" y="6336792"/>
+            <a:ext cx="11365992" cy="274320"/>
           </a:xfrm>
           <a:prstGeom prst="rect">
             <a:avLst/>
@@ -14256,8 +14256,8 @@
         </p:nvSpPr>
         <p:spPr>
           <a:xfrm>
-            <a:off x="411480" y="6708267"/>
-            <a:ext cx="11368735" cy="274320"/>
+            <a:off x="420624" y="6382512"/>
+            <a:ext cx="11365992" cy="274320"/>
           </a:xfrm>
           <a:prstGeom prst="rect">
             <a:avLst/>
@@ -18647,7 +18647,7 @@
         <p:spPr>
           <a:xfrm>
             <a:off x="411480" y="1188720"/>
-            <a:ext cx="11365992" cy="3931920"/>
+            <a:ext cx="11365992" cy="4389120"/>
           </a:xfrm>
           <a:prstGeom prst="rect">
             <a:avLst/>
@@ -18662,7 +18662,7 @@
         </p:nvSpPr>
         <p:spPr>
           <a:xfrm>
-            <a:off x="411480" y="5120640"/>
+            <a:off x="365760" y="5705856"/>
             <a:ext cx="5806440" cy="274320"/>
           </a:xfrm>
           <a:prstGeom prst="rect">
@@ -18709,6 +18709,40 @@
               <a:t> a square wave at the beat f_b = |f₁ − f₂| (5 kHz), locked to the AOMs through the Rb clock, fed to the camera's reference input — one clock; software does only atan2(Q, I).</a:t>
             </a:r>
           </a:p>
+          <a:p>
+            <a:pPr>
+              <a:spcAft>
+                <a:spcPts val="600"/>
+              </a:spcAft>
+            </a:pPr>
+            <a:r>
+              <a:rPr sz="1200" b="0">
+                <a:solidFill>
+                  <a:srgbClr val="282828"/>
+                </a:solidFill>
+                <a:latin typeface="Arial"/>
+              </a:rPr>
+              <a:t>•  </a:t>
+            </a:r>
+            <a:r>
+              <a:rPr sz="1200" b="1">
+                <a:solidFill>
+                  <a:srgbClr val="282828"/>
+                </a:solidFill>
+                <a:latin typeface="Arial"/>
+              </a:rPr>
+              <a:t>The ADC is on chip:</a:t>
+            </a:r>
+            <a:r>
+              <a:rPr sz="1200" b="0">
+                <a:solidFill>
+                  <a:srgbClr val="282828"/>
+                </a:solidFill>
+                <a:latin typeface="Arial"/>
+              </a:rPr>
+              <a:t> readouts are digital I and Q.</a:t>
+            </a:r>
+          </a:p>
         </p:txBody>
       </p:sp>
       <p:sp>
@@ -18719,8 +18753,8 @@
         </p:nvSpPr>
         <p:spPr>
           <a:xfrm>
-            <a:off x="6400800" y="5120640"/>
-            <a:ext cx="5394960" cy="274320"/>
+            <a:off x="6382512" y="5715000"/>
+            <a:ext cx="5733288" cy="274320"/>
           </a:xfrm>
           <a:prstGeom prst="rect">
             <a:avLst/>
@@ -18763,7 +18797,7 @@
                 </a:solidFill>
                 <a:latin typeface="Arial"/>
               </a:rPr>
-              <a:t> N cycles per sample, not a quarter cycle; the square wave costs ×1.11 in σ (eq. 6).</a:t>
+              <a:t> N cycles per sample, not 1 sample per quarter cycle.</a:t>
             </a:r>
           </a:p>
           <a:p>
@@ -18779,23 +18813,7 @@
                 </a:solidFill>
                 <a:latin typeface="Arial"/>
               </a:rPr>
-              <a:t>–  per PHOTON: read noise is paid once per N-cycle sample, not per bucket (1/N in variance); shot noise is unchanged — averaging more samples helps only by bringing more photons, as it would any camera</a:t>
-            </a:r>
-          </a:p>
-          <a:p>
-            <a:pPr marL="594360" indent="-137160">
-              <a:spcAft>
-                <a:spcPts val="500"/>
-              </a:spcAft>
-            </a:pPr>
-            <a:r>
-              <a:rPr sz="1050" b="0">
-                <a:solidFill>
-                  <a:srgbClr val="6E6E6E"/>
-                </a:solidFill>
-                <a:latin typeface="Arial"/>
-              </a:rPr>
-              <a:t>–  per SECOND: the well empties every 1 ms sample — 5 × 10⁸ e⁻/s per pixel usable vs the Photonfocus's 3 × 10⁷ (200 ke × 150 fps); that 17× in photons is most of 42 → 3.4 s per pm (the vendor's drain question: slide 5)</a:t>
+              <a:t>–  the well empties every 1 ms sample — 5 × 10⁸ e⁻/s per pixel usable vs the Photonfocus's 3 × 10⁷ (200 ke × 150 fps); that 17× in photons is most of 42 → 3.4 s per pm (the vendor's drain question: slide 5)</a:t>
             </a:r>
           </a:p>
         </p:txBody>

</xml_diff>

<commit_message>
deck_cophi: the two-color lock-in form stated as TIME-multiplexed (one color per 1 ms sample, AOMs gated; both-on needs integer-kHz beats and costs sqrt2 + half the well -- not modeled) on slides 16/17; block diagrams compacted (W 32 -> 28.3, the RF stack and the loop row folded, text x1.22; aspect 2.0) and placed at true aspect, legends below (Dave's slide-16 geometry folded)
Dave 2026-10-17: "does this scheme really work, or are the two colors using the same accumulators?"  The capture
model (cophi_capture.m frames2x_, iq) builds each color's I/Q sample from that color's field alone, i.e. the light
is gated -- the slide said "one reference at a time", which reads as both-on.  Now said plainly, with the both-on
alternative's conditions and cost in a sub-bullet.  Figures: make_cophi_block_fig.py.

Co-Authored-By: Claude Fable 5.1 <noreply@anthropic.com>
</commit_message>
<xml_diff>
--- a/demo_session/deck_cophi.pptx
+++ b/demo_session/deck_cophi.pptx
@@ -8600,15 +8600,15 @@
         </p:nvPicPr>
         <p:blipFill>
           <a:blip r:embed="rId2"/>
-          <a:srcRect t="3060" b="2370"/>
+          <a:srcRect/>
           <a:stretch>
             <a:fillRect/>
           </a:stretch>
         </p:blipFill>
         <p:spPr>
           <a:xfrm>
-            <a:off x="731520" y="2286000"/>
-            <a:ext cx="10972800" cy="4389120"/>
+            <a:off x="2194560" y="1874519"/>
+            <a:ext cx="7799831" cy="4572000"/>
           </a:xfrm>
           <a:prstGeom prst="rect">
             <a:avLst/>
@@ -8667,7 +8667,7 @@
                 </a:solidFill>
                 <a:latin typeface="Arial"/>
               </a:rPr>
-              <a:t> beats of 7.5 Hz and 3.75 Hz are 4 and 8 frames at the same 30 fps, so each color is demodulated at its own bucket centers from the same frames; the colors do not interfere (THz apart).</a:t>
+              <a:t> beats of 7.5 Hz and 3.75 Hz are 4 and 8 frames at the same 30 fps, so each color is demodulated at its own bucket centers from the same frames; the colors do not interfere (THz apart).  Lock-in form: time-multiplexed, one color per 1 ms sample (slide 17).</a:t>
             </a:r>
           </a:p>
         </p:txBody>
@@ -8680,8 +8680,8 @@
         </p:nvSpPr>
         <p:spPr>
           <a:xfrm>
-            <a:off x="411480" y="1828800"/>
-            <a:ext cx="5852160" cy="274320"/>
+            <a:off x="411480" y="6473952"/>
+            <a:ext cx="8686800" cy="274320"/>
           </a:xfrm>
           <a:prstGeom prst="rect">
             <a:avLst/>
@@ -8719,8 +8719,8 @@
         </p:nvSpPr>
         <p:spPr>
           <a:xfrm>
-            <a:off x="6400800" y="1828800"/>
-            <a:ext cx="5394960" cy="274320"/>
+            <a:off x="411480" y="6656832"/>
+            <a:ext cx="11338560" cy="274320"/>
           </a:xfrm>
           <a:prstGeom prst="rect">
             <a:avLst/>
@@ -9062,7 +9062,23 @@
                 </a:solidFill>
                 <a:latin typeface="Arial"/>
               </a:rPr>
-              <a:t> one reference at a time, so the two colors alternate on I/Q samples (2 ms per pair) — zero wrong orders to 480 nm rms, 0.12 nm per pixel; temporal unwrapping at 1 kHz tolerates 158 µm/s.</a:t>
+              <a:t> the two colors take alternate 1 ms samples, each color's AOM pair gated on for its sample, so ONE color is on the sensor at a time (500 Hz per color, 2 ms per pair) — zero wrong orders to 480 nm rms, 0.12 nm per pixel; temporal unwrapping at 1 kHz tolerates 158 µm/s.</a:t>
+            </a:r>
+          </a:p>
+          <a:p>
+            <a:pPr marL="594360" indent="-137160">
+              <a:spcAft>
+                <a:spcPts val="500"/>
+              </a:spcAft>
+            </a:pPr>
+            <a:r>
+              <a:rPr sz="1050" b="0">
+                <a:solidFill>
+                  <a:srgbClr val="6E6E6E"/>
+                </a:solidFill>
+                <a:latin typeface="Arial"/>
+              </a:rPr>
+              <a:t>–  the pixel has one reference and one pair of accumulators: both colors on at once would put the second beat and the second color's DC into A−B and C−D.  That form works only with beats an integer number of kHz apart (the cross term then integrates to zero over the 1 ms sample, square-wave harmonics included) and costs √2 in shot noise and half the well per color; not modeled.</a:t>
             </a:r>
           </a:p>
         </p:txBody>
@@ -16264,15 +16280,15 @@
         </p:nvPicPr>
         <p:blipFill>
           <a:blip r:embed="rId2"/>
-          <a:srcRect t="3660" b="2840"/>
+          <a:srcRect/>
           <a:stretch>
             <a:fillRect/>
           </a:stretch>
         </p:blipFill>
         <p:spPr>
           <a:xfrm>
-            <a:off x="914400" y="1408176"/>
-            <a:ext cx="9994392" cy="5394960"/>
+            <a:off x="1188720" y="1572768"/>
+            <a:ext cx="9820656" cy="4937760"/>
           </a:xfrm>
           <a:prstGeom prst="rect">
             <a:avLst/>
@@ -16344,7 +16360,7 @@
         </p:nvSpPr>
         <p:spPr>
           <a:xfrm>
-            <a:off x="5486400" y="1371600"/>
+            <a:off x="5806440" y="1353312"/>
             <a:ext cx="5852160" cy="274320"/>
           </a:xfrm>
           <a:prstGeom prst="rect">
@@ -16383,8 +16399,8 @@
         </p:nvSpPr>
         <p:spPr>
           <a:xfrm>
-            <a:off x="6172200" y="2103120"/>
-            <a:ext cx="4343400" cy="274320"/>
+            <a:off x="411480" y="6510528"/>
+            <a:ext cx="11338560" cy="274320"/>
           </a:xfrm>
           <a:prstGeom prst="rect">
             <a:avLst/>
@@ -18984,15 +19000,15 @@
         </p:nvPicPr>
         <p:blipFill>
           <a:blip r:embed="rId2"/>
-          <a:srcRect t="3010" b="2600"/>
+          <a:srcRect/>
           <a:stretch>
             <a:fillRect/>
           </a:stretch>
         </p:blipFill>
         <p:spPr>
           <a:xfrm>
-            <a:off x="740664" y="1106424"/>
-            <a:ext cx="10296144" cy="5614416"/>
+            <a:off x="1380744" y="1719072"/>
+            <a:ext cx="9436608" cy="4754880"/>
           </a:xfrm>
           <a:prstGeom prst="rect">
             <a:avLst/>
@@ -19007,8 +19023,8 @@
         </p:nvSpPr>
         <p:spPr>
           <a:xfrm>
-            <a:off x="5760720" y="1115568"/>
-            <a:ext cx="6035040" cy="274320"/>
+            <a:off x="411480" y="1115568"/>
+            <a:ext cx="11338560" cy="274320"/>
           </a:xfrm>
           <a:prstGeom prst="rect">
             <a:avLst/>
@@ -19027,7 +19043,7 @@
               </a:spcAft>
             </a:pPr>
             <a:r>
-              <a:rPr sz="1200" b="0">
+              <a:rPr sz="1500" b="0">
                 <a:solidFill>
                   <a:srgbClr val="282828"/>
                 </a:solidFill>
@@ -19036,7 +19052,7 @@
               <a:t>•  </a:t>
             </a:r>
             <a:r>
-              <a:rPr sz="1200" b="1">
+              <a:rPr sz="1500" b="1">
                 <a:solidFill>
                   <a:srgbClr val="282828"/>
                 </a:solidFill>
@@ -19045,7 +19061,7 @@
               <a:t>What changes from slide 3:</a:t>
             </a:r>
             <a:r>
-              <a:rPr sz="1200" b="0">
+              <a:rPr sz="1500" b="0">
                 <a:solidFill>
                   <a:srgbClr val="282828"/>
                 </a:solidFill>
@@ -19064,8 +19080,8 @@
         </p:nvSpPr>
         <p:spPr>
           <a:xfrm>
-            <a:off x="5760720" y="2103120"/>
-            <a:ext cx="6035040" cy="274320"/>
+            <a:off x="411480" y="6473952"/>
+            <a:ext cx="8686800" cy="274320"/>
           </a:xfrm>
           <a:prstGeom prst="rect">
             <a:avLst/>
@@ -19103,8 +19119,8 @@
         </p:nvSpPr>
         <p:spPr>
           <a:xfrm>
-            <a:off x="6172200" y="6611112"/>
-            <a:ext cx="5650992" cy="274320"/>
+            <a:off x="411480" y="6656832"/>
+            <a:ext cx="11338560" cy="274320"/>
           </a:xfrm>
           <a:prstGeom prst="rect">
             <a:avLst/>

</xml_diff>